<commit_message>
docs: refresh draft deck with accepted Play and BFSI evidence
</commit_message>
<xml_diff>
--- a/docs/submission/assets/movebooks-submission-draft.pptx
+++ b/docs/submission/assets/movebooks-submission-draft.pptx
@@ -2,27 +2,27 @@
 <file path=ppt/presentation.xml><?xml version="1.0" encoding="utf-8"?>
 <p:presentation xmlns:p="http://schemas.openxmlformats.org/presentationml/2006/main">
   <p:sldMasterIdLst>
-    <p:sldMasterId xmlns:r="http://schemas.openxmlformats.org/officeDocument/2006/relationships" id="2147483648" r:id="R7781c3077c2e4047"/>
+    <p:sldMasterId xmlns:r="http://schemas.openxmlformats.org/officeDocument/2006/relationships" id="2147483648" r:id="Rcb1183d9bd9d47c4"/>
   </p:sldMasterIdLst>
   <p:notesMasterIdLst>
-    <p:notesMasterId xmlns:r="http://schemas.openxmlformats.org/officeDocument/2006/relationships" r:id="R8eb16313d0cc4684"/>
+    <p:notesMasterId xmlns:r="http://schemas.openxmlformats.org/officeDocument/2006/relationships" r:id="R6efde62b410f4434"/>
   </p:notesMasterIdLst>
   <p:sldIdLst>
-    <p:sldId xmlns:r="http://schemas.openxmlformats.org/officeDocument/2006/relationships" id="256" r:id="R3c81e3422d7c4fed"/>
-    <p:sldId xmlns:r="http://schemas.openxmlformats.org/officeDocument/2006/relationships" id="257" r:id="Rbe214702dd824c5d"/>
-    <p:sldId xmlns:r="http://schemas.openxmlformats.org/officeDocument/2006/relationships" id="258" r:id="R14a19fffdc044ee2"/>
-    <p:sldId xmlns:r="http://schemas.openxmlformats.org/officeDocument/2006/relationships" id="259" r:id="R597d8330f35f4cba"/>
-    <p:sldId xmlns:r="http://schemas.openxmlformats.org/officeDocument/2006/relationships" id="260" r:id="R2700e19f883a4cb7"/>
-    <p:sldId xmlns:r="http://schemas.openxmlformats.org/officeDocument/2006/relationships" id="261" r:id="R1997e3b42c6240c8"/>
-    <p:sldId xmlns:r="http://schemas.openxmlformats.org/officeDocument/2006/relationships" id="262" r:id="R2cf020bc8a6146a7"/>
-    <p:sldId xmlns:r="http://schemas.openxmlformats.org/officeDocument/2006/relationships" id="263" r:id="R6d241036d35b44f1"/>
-    <p:sldId xmlns:r="http://schemas.openxmlformats.org/officeDocument/2006/relationships" id="264" r:id="Re1ade6232bf74ed7"/>
-    <p:sldId xmlns:r="http://schemas.openxmlformats.org/officeDocument/2006/relationships" id="265" r:id="Rbe07903e321b458a"/>
-    <p:sldId xmlns:r="http://schemas.openxmlformats.org/officeDocument/2006/relationships" id="266" r:id="R8fa9a211e8f44819"/>
-    <p:sldId xmlns:r="http://schemas.openxmlformats.org/officeDocument/2006/relationships" id="267" r:id="R1fa3695e18454296"/>
-    <p:sldId xmlns:r="http://schemas.openxmlformats.org/officeDocument/2006/relationships" id="268" r:id="R3aae85b3a852454f"/>
-    <p:sldId xmlns:r="http://schemas.openxmlformats.org/officeDocument/2006/relationships" id="269" r:id="Rbf9d3d631579453d"/>
-    <p:sldId xmlns:r="http://schemas.openxmlformats.org/officeDocument/2006/relationships" id="270" r:id="R16a22f392fe4435c"/>
+    <p:sldId xmlns:r="http://schemas.openxmlformats.org/officeDocument/2006/relationships" id="256" r:id="R7de357b247ec4de1"/>
+    <p:sldId xmlns:r="http://schemas.openxmlformats.org/officeDocument/2006/relationships" id="257" r:id="R70da24bae9ae44c0"/>
+    <p:sldId xmlns:r="http://schemas.openxmlformats.org/officeDocument/2006/relationships" id="258" r:id="R455e4d4f22924660"/>
+    <p:sldId xmlns:r="http://schemas.openxmlformats.org/officeDocument/2006/relationships" id="259" r:id="R40c4979afd2f48a2"/>
+    <p:sldId xmlns:r="http://schemas.openxmlformats.org/officeDocument/2006/relationships" id="260" r:id="R622a13962d0642f2"/>
+    <p:sldId xmlns:r="http://schemas.openxmlformats.org/officeDocument/2006/relationships" id="261" r:id="R304b28327341439b"/>
+    <p:sldId xmlns:r="http://schemas.openxmlformats.org/officeDocument/2006/relationships" id="262" r:id="R71c06b126a844ad1"/>
+    <p:sldId xmlns:r="http://schemas.openxmlformats.org/officeDocument/2006/relationships" id="263" r:id="R5cd17f329836489d"/>
+    <p:sldId xmlns:r="http://schemas.openxmlformats.org/officeDocument/2006/relationships" id="264" r:id="R90ce74ebf96f411e"/>
+    <p:sldId xmlns:r="http://schemas.openxmlformats.org/officeDocument/2006/relationships" id="265" r:id="R222ce543f56d4cdc"/>
+    <p:sldId xmlns:r="http://schemas.openxmlformats.org/officeDocument/2006/relationships" id="266" r:id="Ref6884faa1f54864"/>
+    <p:sldId xmlns:r="http://schemas.openxmlformats.org/officeDocument/2006/relationships" id="267" r:id="Raf40e6060f6d423d"/>
+    <p:sldId xmlns:r="http://schemas.openxmlformats.org/officeDocument/2006/relationships" id="268" r:id="R52290c55c1c9413f"/>
+    <p:sldId xmlns:r="http://schemas.openxmlformats.org/officeDocument/2006/relationships" id="269" r:id="R79187c5a9bec4eb9"/>
+    <p:sldId xmlns:r="http://schemas.openxmlformats.org/officeDocument/2006/relationships" id="270" r:id="R9d0f61dca8c944a2"/>
   </p:sldIdLst>
   <p:sldSz cx="12192000" cy="6858000"/>
   <p:notesSz cx="6858000" cy="9144000"/>
@@ -736,7 +736,7 @@
           <a:lstStyle xmlns:a="http://schemas.openxmlformats.org/drawingml/2006/main"/>
           <a:p xmlns:a="http://schemas.openxmlformats.org/drawingml/2006/main">
             <a:r>
-              <a:t>Source: root integration-owner report baseline local backend521 passed58 skipped,17 October2026; named tests. Candidate run and external benchmarking pending.</a:t>
+              <a:t>Source: root integration-owner report candidate local backend553 passed58 skipped,17 October2026; named tests. Candidate run and external benchmarking pending.</a:t>
             </a:r>
           </a:p>
         </p:txBody>
@@ -1016,7 +1016,7 @@
           <a:lstStyle xmlns:a="http://schemas.openxmlformats.org/drawingml/2006/main"/>
           <a:p xmlns:a="http://schemas.openxmlformats.org/drawingml/2006/main">
             <a:r>
-              <a:t>Source: product directive; docs/PRODUCT_CONSTITUTION.md. Problem needs are strategy hypotheses, not completed customer research. Exact official BFSI challenge wording pending.</a:t>
+              <a:t>Source: product directive; docs/PRODUCT_CONSTITUTION.md. Problem needs are strategy hypotheses, not completed customer research. User-confirmed challenge: BFSI: Intelligent Risk, Fraud &amp; Financial Experiences. Full statement in docs/submission/problem-statement.md.</a:t>
             </a:r>
           </a:p>
         </p:txBody>
@@ -1226,7 +1226,7 @@
           <a:lstStyle xmlns:a="http://schemas.openxmlformats.org/drawingml/2006/main"/>
           <a:p xmlns:a="http://schemas.openxmlformats.org/drawingml/2006/main">
             <a:r>
-              <a:t>Source: docs/product-management/feature-contracts.md. New Play and browser-local intake candidate acceptance pending.</a:t>
+              <a:t>Source: docs/submission/browser-play/play-desktop-opening.png and browser-evidence.json. Authentic local combined-candidate Play screenshot accepted by integration owner, 14 browser checks passed. Local candidate only, not deployed. No live Gemini claim.</a:t>
             </a:r>
           </a:p>
         </p:txBody>
@@ -1483,7 +1483,7 @@
           <p:cNvPr id="3" name="Title">
             <a:extLst xmlns:a="http://schemas.openxmlformats.org/drawingml/2006/main">
               <a:ext uri="{FF2B5EF4-FFF2-40B4-BE49-F238E27FC236}">
-                <a16:creationId xmlns:a16="http://schemas.microsoft.com/office/drawing/2014/main" id="{85BB7930-3B88-446D-99E6-B4DA822C326B}"/>
+                <a16:creationId xmlns:a16="http://schemas.microsoft.com/office/drawing/2014/main" id="{E0B8169A-DD39-45A2-9B1D-E858487E03AE}"/>
               </a:ext>
             </a:extLst>
           </p:cNvPr>
@@ -1712,7 +1712,7 @@
           <p:cNvPr id="2" name="Subtitle">
             <a:extLst xmlns:a="http://schemas.openxmlformats.org/drawingml/2006/main">
               <a:ext uri="{FF2B5EF4-FFF2-40B4-BE49-F238E27FC236}">
-                <a16:creationId xmlns:a16="http://schemas.microsoft.com/office/drawing/2014/main" id="{EBBF1E96-5D5D-40A4-9214-61AF28AC14E5}"/>
+                <a16:creationId xmlns:a16="http://schemas.microsoft.com/office/drawing/2014/main" id="{B78F3264-7CA1-4019-81F4-F6755E3E883C}"/>
               </a:ext>
             </a:extLst>
           </p:cNvPr>
@@ -1958,7 +1958,7 @@
           <p:cNvPr id="2" name="Section title">
             <a:extLst xmlns:a="http://schemas.openxmlformats.org/drawingml/2006/main">
               <a:ext uri="{FF2B5EF4-FFF2-40B4-BE49-F238E27FC236}">
-                <a16:creationId xmlns:a16="http://schemas.microsoft.com/office/drawing/2014/main" id="{C20C4577-6C66-43CB-B359-C233824B17CE}"/>
+                <a16:creationId xmlns:a16="http://schemas.microsoft.com/office/drawing/2014/main" id="{53039007-0934-4E96-9DBE-1550033F2218}"/>
               </a:ext>
             </a:extLst>
           </p:cNvPr>
@@ -2204,7 +2204,7 @@
           <p:cNvPr id="3" name="Title">
             <a:extLst xmlns:a="http://schemas.openxmlformats.org/drawingml/2006/main">
               <a:ext uri="{FF2B5EF4-FFF2-40B4-BE49-F238E27FC236}">
-                <a16:creationId xmlns:a16="http://schemas.microsoft.com/office/drawing/2014/main" id="{7643C75A-D26A-4AD0-AF1C-E6BCA091C8F0}"/>
+                <a16:creationId xmlns:a16="http://schemas.microsoft.com/office/drawing/2014/main" id="{4B255BF4-0E28-4113-85B6-AD626A3DBA94}"/>
               </a:ext>
             </a:extLst>
           </p:cNvPr>
@@ -2433,7 +2433,7 @@
           <p:cNvPr id="2" name="Body">
             <a:extLst xmlns:a="http://schemas.openxmlformats.org/drawingml/2006/main">
               <a:ext uri="{FF2B5EF4-FFF2-40B4-BE49-F238E27FC236}">
-                <a16:creationId xmlns:a16="http://schemas.microsoft.com/office/drawing/2014/main" id="{6E22C896-9B59-438C-8576-42C469D77BCF}"/>
+                <a16:creationId xmlns:a16="http://schemas.microsoft.com/office/drawing/2014/main" id="{FAFD87E8-4694-4B7D-B2C1-37B3E0BBA32D}"/>
               </a:ext>
             </a:extLst>
           </p:cNvPr>
@@ -2679,7 +2679,7 @@
           <p:cNvPr id="4" name="Title">
             <a:extLst xmlns:a="http://schemas.openxmlformats.org/drawingml/2006/main">
               <a:ext uri="{FF2B5EF4-FFF2-40B4-BE49-F238E27FC236}">
-                <a16:creationId xmlns:a16="http://schemas.microsoft.com/office/drawing/2014/main" id="{7EA1BDD3-2609-42CA-9650-13873BF00AF6}"/>
+                <a16:creationId xmlns:a16="http://schemas.microsoft.com/office/drawing/2014/main" id="{99A4B40B-E176-4E59-A79A-09FCADF58D56}"/>
               </a:ext>
             </a:extLst>
           </p:cNvPr>
@@ -2908,7 +2908,7 @@
           <p:cNvPr id="2" name="Left column">
             <a:extLst xmlns:a="http://schemas.openxmlformats.org/drawingml/2006/main">
               <a:ext uri="{FF2B5EF4-FFF2-40B4-BE49-F238E27FC236}">
-                <a16:creationId xmlns:a16="http://schemas.microsoft.com/office/drawing/2014/main" id="{10772C86-89D3-471C-8B0D-F59630D153E4}"/>
+                <a16:creationId xmlns:a16="http://schemas.microsoft.com/office/drawing/2014/main" id="{E73189C2-95BE-4C50-BA42-9F1FDA512B40}"/>
               </a:ext>
             </a:extLst>
           </p:cNvPr>
@@ -3137,7 +3137,7 @@
           <p:cNvPr id="3" name="Right column">
             <a:extLst xmlns:a="http://schemas.openxmlformats.org/drawingml/2006/main">
               <a:ext uri="{FF2B5EF4-FFF2-40B4-BE49-F238E27FC236}">
-                <a16:creationId xmlns:a16="http://schemas.microsoft.com/office/drawing/2014/main" id="{59623972-51D6-4CDD-BF5B-FC3710184346}"/>
+                <a16:creationId xmlns:a16="http://schemas.microsoft.com/office/drawing/2014/main" id="{5FDF95C6-F4CD-433C-8CC1-6D6D04F349F0}"/>
               </a:ext>
             </a:extLst>
           </p:cNvPr>
@@ -3383,7 +3383,7 @@
           <p:cNvPr id="3" name="Title">
             <a:extLst xmlns:a="http://schemas.openxmlformats.org/drawingml/2006/main">
               <a:ext uri="{FF2B5EF4-FFF2-40B4-BE49-F238E27FC236}">
-                <a16:creationId xmlns:a16="http://schemas.microsoft.com/office/drawing/2014/main" id="{919302A8-637B-4D91-83FB-E49AAE15323A}"/>
+                <a16:creationId xmlns:a16="http://schemas.microsoft.com/office/drawing/2014/main" id="{36BCE56E-F7AE-49C0-8F4C-CC90C356F009}"/>
               </a:ext>
             </a:extLst>
           </p:cNvPr>
@@ -3612,7 +3612,7 @@
           <p:cNvPr id="2" name="Left column">
             <a:extLst xmlns:a="http://schemas.openxmlformats.org/drawingml/2006/main">
               <a:ext uri="{FF2B5EF4-FFF2-40B4-BE49-F238E27FC236}">
-                <a16:creationId xmlns:a16="http://schemas.microsoft.com/office/drawing/2014/main" id="{A48A62F3-06F0-4307-9030-C803E33236AF}"/>
+                <a16:creationId xmlns:a16="http://schemas.microsoft.com/office/drawing/2014/main" id="{7CEAE731-EFB6-4FF8-99E7-200D30B7A94B}"/>
               </a:ext>
             </a:extLst>
           </p:cNvPr>
@@ -3879,12 +3879,12 @@
   </p:cSld>
   <p:clrMap bg1="lt1" tx1="dk1" bg2="lt2" tx2="dk2" accent1="accent1" accent2="accent2" accent3="accent3" accent4="accent4" accent5="accent5" accent6="accent6" hlink="hlink" folHlink="folHlink"/>
   <p:sldLayoutIdLst>
-    <p:sldLayoutId xmlns:r="http://schemas.openxmlformats.org/officeDocument/2006/relationships" id="2147483649" r:id="R78ba8e3e01864341"/>
-    <p:sldLayoutId xmlns:r="http://schemas.openxmlformats.org/officeDocument/2006/relationships" id="2147483650" r:id="R77f680e518a341f2"/>
-    <p:sldLayoutId xmlns:r="http://schemas.openxmlformats.org/officeDocument/2006/relationships" id="2147483651" r:id="R1d599d6b008b4dc8"/>
-    <p:sldLayoutId xmlns:r="http://schemas.openxmlformats.org/officeDocument/2006/relationships" id="2147483652" r:id="Rb093f780f0ed4d5f"/>
-    <p:sldLayoutId xmlns:r="http://schemas.openxmlformats.org/officeDocument/2006/relationships" id="2147483653" r:id="Reb83e151e7764a08"/>
-    <p:sldLayoutId xmlns:r="http://schemas.openxmlformats.org/officeDocument/2006/relationships" id="2147483654" r:id="Re11aea041d4a4509"/>
+    <p:sldLayoutId xmlns:r="http://schemas.openxmlformats.org/officeDocument/2006/relationships" id="2147483649" r:id="R55ce00d2912a42db"/>
+    <p:sldLayoutId xmlns:r="http://schemas.openxmlformats.org/officeDocument/2006/relationships" id="2147483650" r:id="Recf6a2b8388a45eb"/>
+    <p:sldLayoutId xmlns:r="http://schemas.openxmlformats.org/officeDocument/2006/relationships" id="2147483651" r:id="R3a3e53c1bb604b07"/>
+    <p:sldLayoutId xmlns:r="http://schemas.openxmlformats.org/officeDocument/2006/relationships" id="2147483652" r:id="R16ce3956bf5f4384"/>
+    <p:sldLayoutId xmlns:r="http://schemas.openxmlformats.org/officeDocument/2006/relationships" id="2147483653" r:id="Rfdf9508ff59244a6"/>
+    <p:sldLayoutId xmlns:r="http://schemas.openxmlformats.org/officeDocument/2006/relationships" id="2147483654" r:id="R719d4b9966e94a5f"/>
   </p:sldLayoutIdLst>
   <p:txStyles>
     <p:titleStyle>
@@ -4435,7 +4435,7 @@
           <p:cNvPr id="8" name="">
             <a:extLst xmlns:a="http://schemas.openxmlformats.org/drawingml/2006/main">
               <a:ext uri="{FF2B5EF4-FFF2-40B4-BE49-F238E27FC236}">
-                <a16:creationId xmlns:a16="http://schemas.microsoft.com/office/drawing/2014/main" id="{9CC2C5D3-7188-4D34-90D5-2D3F6245E062}"/>
+                <a16:creationId xmlns:a16="http://schemas.microsoft.com/office/drawing/2014/main" id="{F4290E5B-0651-43DD-89A5-C8FF1C989311}"/>
               </a:ext>
             </a:extLst>
           </p:cNvPr>
@@ -4591,7 +4591,7 @@
           <p:cNvPr id="2" name="">
             <a:extLst xmlns:a="http://schemas.openxmlformats.org/drawingml/2006/main">
               <a:ext uri="{FF2B5EF4-FFF2-40B4-BE49-F238E27FC236}">
-                <a16:creationId xmlns:a16="http://schemas.microsoft.com/office/drawing/2014/main" id="{E8A8A52D-CA72-461B-B3DB-C428FD4E9B52}"/>
+                <a16:creationId xmlns:a16="http://schemas.microsoft.com/office/drawing/2014/main" id="{C57AFB26-F14B-4EB3-9AFB-37D4123AC9B8}"/>
               </a:ext>
             </a:extLst>
           </p:cNvPr>
@@ -4747,7 +4747,7 @@
           <p:cNvPr id="3" name="">
             <a:extLst xmlns:a="http://schemas.openxmlformats.org/drawingml/2006/main">
               <a:ext uri="{FF2B5EF4-FFF2-40B4-BE49-F238E27FC236}">
-                <a16:creationId xmlns:a16="http://schemas.microsoft.com/office/drawing/2014/main" id="{C19B9E9F-4873-4EB7-9122-981FAAFAAB26}"/>
+                <a16:creationId xmlns:a16="http://schemas.microsoft.com/office/drawing/2014/main" id="{A3F31763-7684-47AA-B56A-A4E93D22D2B9}"/>
               </a:ext>
             </a:extLst>
           </p:cNvPr>
@@ -4903,7 +4903,7 @@
           <p:cNvPr id="4" name="">
             <a:extLst xmlns:a="http://schemas.openxmlformats.org/drawingml/2006/main">
               <a:ext uri="{FF2B5EF4-FFF2-40B4-BE49-F238E27FC236}">
-                <a16:creationId xmlns:a16="http://schemas.microsoft.com/office/drawing/2014/main" id="{00FCA101-5103-474B-B0B4-AE31F9F386E2}"/>
+                <a16:creationId xmlns:a16="http://schemas.microsoft.com/office/drawing/2014/main" id="{1BA7FE4F-4F72-47FB-816E-79E1BF7CE9DD}"/>
               </a:ext>
             </a:extLst>
           </p:cNvPr>
@@ -5082,7 +5082,7 @@
           <p:cNvPr id="5" name="">
             <a:extLst xmlns:a="http://schemas.openxmlformats.org/drawingml/2006/main">
               <a:ext uri="{FF2B5EF4-FFF2-40B4-BE49-F238E27FC236}">
-                <a16:creationId xmlns:a16="http://schemas.microsoft.com/office/drawing/2014/main" id="{81FA6F0D-3919-4514-89A1-8FFEFB30B040}"/>
+                <a16:creationId xmlns:a16="http://schemas.microsoft.com/office/drawing/2014/main" id="{DC93B400-D69B-421D-A5FF-5200DC200C19}"/>
               </a:ext>
             </a:extLst>
           </p:cNvPr>
@@ -5238,7 +5238,7 @@
           <p:cNvPr id="6" name="">
             <a:extLst xmlns:a="http://schemas.openxmlformats.org/drawingml/2006/main">
               <a:ext uri="{FF2B5EF4-FFF2-40B4-BE49-F238E27FC236}">
-                <a16:creationId xmlns:a16="http://schemas.microsoft.com/office/drawing/2014/main" id="{0043D1B4-7A8C-41CF-B9CD-40F17BF632F5}"/>
+                <a16:creationId xmlns:a16="http://schemas.microsoft.com/office/drawing/2014/main" id="{8CE54ACC-C4F4-4B86-93BA-ECB42A2D24EA}"/>
               </a:ext>
             </a:extLst>
           </p:cNvPr>
@@ -5417,7 +5417,7 @@
           <p:cNvPr id="7" name="">
             <a:extLst xmlns:a="http://schemas.openxmlformats.org/drawingml/2006/main">
               <a:ext uri="{FF2B5EF4-FFF2-40B4-BE49-F238E27FC236}">
-                <a16:creationId xmlns:a16="http://schemas.microsoft.com/office/drawing/2014/main" id="{AB29D8A5-3D82-45F4-81D0-36B8AE02B400}"/>
+                <a16:creationId xmlns:a16="http://schemas.microsoft.com/office/drawing/2014/main" id="{C8E9DF62-2F32-4965-8705-656D989973F1}"/>
               </a:ext>
             </a:extLst>
           </p:cNvPr>
@@ -5427,7 +5427,7 @@
           <p:nvPr/>
         </p:nvPicPr>
         <p:blipFill>
-          <a:blip xmlns:r="http://schemas.openxmlformats.org/officeDocument/2006/relationships" xmlns:a="http://schemas.openxmlformats.org/drawingml/2006/main" r:embed="Ra69f9c02deba47fa"/>
+          <a:blip xmlns:r="http://schemas.openxmlformats.org/officeDocument/2006/relationships" xmlns:a="http://schemas.openxmlformats.org/drawingml/2006/main" r:embed="Rbbd80fc731d64507"/>
           <a:stretch xmlns:a="http://schemas.openxmlformats.org/drawingml/2006/main"/>
         </p:blipFill>
         <p:spPr>
@@ -5443,7 +5443,7 @@
     </p:spTree>
     <p:extLst>
       <p:ext uri="{BB962C8B-B14F-4D97-AF65-F5344CB8AC3E}">
-        <p14:creationId xmlns:p14="http://schemas.microsoft.com/office/powerpoint/2010/main" val="1264428805"/>
+        <p14:creationId xmlns:p14="http://schemas.microsoft.com/office/powerpoint/2010/main" val="889947719"/>
       </p:ext>
     </p:extLst>
   </p:cSld>
@@ -5474,7 +5474,7 @@
           <p:cNvPr id="8" name="">
             <a:extLst xmlns:a="http://schemas.openxmlformats.org/drawingml/2006/main">
               <a:ext uri="{FF2B5EF4-FFF2-40B4-BE49-F238E27FC236}">
-                <a16:creationId xmlns:a16="http://schemas.microsoft.com/office/drawing/2014/main" id="{5F1064BE-AD67-451E-9307-207DEB183A30}"/>
+                <a16:creationId xmlns:a16="http://schemas.microsoft.com/office/drawing/2014/main" id="{226FD625-4CF1-402D-9CC1-B4329FDD5B14}"/>
               </a:ext>
             </a:extLst>
           </p:cNvPr>
@@ -5630,7 +5630,7 @@
           <p:cNvPr id="2" name="">
             <a:extLst xmlns:a="http://schemas.openxmlformats.org/drawingml/2006/main">
               <a:ext uri="{FF2B5EF4-FFF2-40B4-BE49-F238E27FC236}">
-                <a16:creationId xmlns:a16="http://schemas.microsoft.com/office/drawing/2014/main" id="{642B3BDE-4F19-489E-8613-BB8E8C7C1C4E}"/>
+                <a16:creationId xmlns:a16="http://schemas.microsoft.com/office/drawing/2014/main" id="{718A0181-74A4-421B-8689-3A9CB0CAE52C}"/>
               </a:ext>
             </a:extLst>
           </p:cNvPr>
@@ -5786,7 +5786,7 @@
           <p:cNvPr id="3" name="">
             <a:extLst xmlns:a="http://schemas.openxmlformats.org/drawingml/2006/main">
               <a:ext uri="{FF2B5EF4-FFF2-40B4-BE49-F238E27FC236}">
-                <a16:creationId xmlns:a16="http://schemas.microsoft.com/office/drawing/2014/main" id="{82004006-72F4-4078-9F52-C3BFA01560A6}"/>
+                <a16:creationId xmlns:a16="http://schemas.microsoft.com/office/drawing/2014/main" id="{8080D5AB-E866-43ED-B2B2-2305F9438F05}"/>
               </a:ext>
             </a:extLst>
           </p:cNvPr>
@@ -5942,7 +5942,7 @@
           <p:cNvPr id="4" name="">
             <a:extLst xmlns:a="http://schemas.openxmlformats.org/drawingml/2006/main">
               <a:ext uri="{FF2B5EF4-FFF2-40B4-BE49-F238E27FC236}">
-                <a16:creationId xmlns:a16="http://schemas.microsoft.com/office/drawing/2014/main" id="{B63BD103-FDB2-4CFE-B466-DEDFC248358C}"/>
+                <a16:creationId xmlns:a16="http://schemas.microsoft.com/office/drawing/2014/main" id="{30DC7EA7-A8EB-44D1-B396-3F1C6C585816}"/>
               </a:ext>
             </a:extLst>
           </p:cNvPr>
@@ -6098,7 +6098,7 @@
           <p:cNvPr id="5" name="">
             <a:extLst xmlns:a="http://schemas.openxmlformats.org/drawingml/2006/main">
               <a:ext uri="{FF2B5EF4-FFF2-40B4-BE49-F238E27FC236}">
-                <a16:creationId xmlns:a16="http://schemas.microsoft.com/office/drawing/2014/main" id="{935E8340-EAB3-492D-A9F5-CBF4216C5451}"/>
+                <a16:creationId xmlns:a16="http://schemas.microsoft.com/office/drawing/2014/main" id="{6981E04A-081D-4979-BB27-0218114E9A6C}"/>
               </a:ext>
             </a:extLst>
           </p:cNvPr>
@@ -6254,7 +6254,7 @@
           <p:cNvPr id="6" name="">
             <a:extLst xmlns:a="http://schemas.openxmlformats.org/drawingml/2006/main">
               <a:ext uri="{FF2B5EF4-FFF2-40B4-BE49-F238E27FC236}">
-                <a16:creationId xmlns:a16="http://schemas.microsoft.com/office/drawing/2014/main" id="{BB368122-6C42-414E-9B30-31D240678552}"/>
+                <a16:creationId xmlns:a16="http://schemas.microsoft.com/office/drawing/2014/main" id="{CB2A478C-BB92-42B5-B677-73ABE65D28D8}"/>
               </a:ext>
             </a:extLst>
           </p:cNvPr>
@@ -6410,7 +6410,7 @@
           <p:cNvPr id="7" name="">
             <a:extLst xmlns:a="http://schemas.openxmlformats.org/drawingml/2006/main">
               <a:ext uri="{FF2B5EF4-FFF2-40B4-BE49-F238E27FC236}">
-                <a16:creationId xmlns:a16="http://schemas.microsoft.com/office/drawing/2014/main" id="{F50303E8-CF6E-4784-88C2-2B7B600CEDDB}"/>
+                <a16:creationId xmlns:a16="http://schemas.microsoft.com/office/drawing/2014/main" id="{8E31CBFE-36BB-4B7A-A0AF-ED3F26A90708}"/>
               </a:ext>
             </a:extLst>
           </p:cNvPr>
@@ -6564,7 +6564,7 @@
     </p:spTree>
     <p:extLst>
       <p:ext uri="{BB962C8B-B14F-4D97-AF65-F5344CB8AC3E}">
-        <p14:creationId xmlns:p14="http://schemas.microsoft.com/office/powerpoint/2010/main" val="1952011445"/>
+        <p14:creationId xmlns:p14="http://schemas.microsoft.com/office/powerpoint/2010/main" val="532238422"/>
       </p:ext>
     </p:extLst>
   </p:cSld>
@@ -6595,7 +6595,7 @@
           <p:cNvPr id="9" name="">
             <a:extLst xmlns:a="http://schemas.openxmlformats.org/drawingml/2006/main">
               <a:ext uri="{FF2B5EF4-FFF2-40B4-BE49-F238E27FC236}">
-                <a16:creationId xmlns:a16="http://schemas.microsoft.com/office/drawing/2014/main" id="{7FBB5B5B-7CC3-4BA7-87E4-1812028DD52B}"/>
+                <a16:creationId xmlns:a16="http://schemas.microsoft.com/office/drawing/2014/main" id="{5EFE77E5-FD09-4882-884D-50F63857D6C3}"/>
               </a:ext>
             </a:extLst>
           </p:cNvPr>
@@ -6751,7 +6751,7 @@
           <p:cNvPr id="2" name="">
             <a:extLst xmlns:a="http://schemas.openxmlformats.org/drawingml/2006/main">
               <a:ext uri="{FF2B5EF4-FFF2-40B4-BE49-F238E27FC236}">
-                <a16:creationId xmlns:a16="http://schemas.microsoft.com/office/drawing/2014/main" id="{77438A95-4DA4-4DAB-8A40-867097A2B2DF}"/>
+                <a16:creationId xmlns:a16="http://schemas.microsoft.com/office/drawing/2014/main" id="{CD50C78B-B4C9-45D7-A1F6-F76FFCD4E4BB}"/>
               </a:ext>
             </a:extLst>
           </p:cNvPr>
@@ -6907,7 +6907,7 @@
           <p:cNvPr id="3" name="">
             <a:extLst xmlns:a="http://schemas.openxmlformats.org/drawingml/2006/main">
               <a:ext uri="{FF2B5EF4-FFF2-40B4-BE49-F238E27FC236}">
-                <a16:creationId xmlns:a16="http://schemas.microsoft.com/office/drawing/2014/main" id="{32A2FCA1-8A6F-47D4-B4B4-C5A11F85FECC}"/>
+                <a16:creationId xmlns:a16="http://schemas.microsoft.com/office/drawing/2014/main" id="{FE0FDF8E-EDA6-4E7B-A32A-CB16AA726D92}"/>
               </a:ext>
             </a:extLst>
           </p:cNvPr>
@@ -7063,7 +7063,7 @@
           <p:cNvPr id="4" name="">
             <a:extLst xmlns:a="http://schemas.openxmlformats.org/drawingml/2006/main">
               <a:ext uri="{FF2B5EF4-FFF2-40B4-BE49-F238E27FC236}">
-                <a16:creationId xmlns:a16="http://schemas.microsoft.com/office/drawing/2014/main" id="{73166EAD-B99F-4E2F-9BF5-494FFE7F929C}"/>
+                <a16:creationId xmlns:a16="http://schemas.microsoft.com/office/drawing/2014/main" id="{DCC3DAEF-9333-4755-B66B-8AE69DD7F27D}"/>
               </a:ext>
             </a:extLst>
           </p:cNvPr>
@@ -7219,7 +7219,7 @@
           <p:cNvPr id="5" name="">
             <a:extLst xmlns:a="http://schemas.openxmlformats.org/drawingml/2006/main">
               <a:ext uri="{FF2B5EF4-FFF2-40B4-BE49-F238E27FC236}">
-                <a16:creationId xmlns:a16="http://schemas.microsoft.com/office/drawing/2014/main" id="{5E3FB28B-7EC1-4884-BE6E-F2D68D5DE764}"/>
+                <a16:creationId xmlns:a16="http://schemas.microsoft.com/office/drawing/2014/main" id="{0FA90CC5-3B52-474F-9ECF-EC48B57D5223}"/>
               </a:ext>
             </a:extLst>
           </p:cNvPr>
@@ -7375,7 +7375,7 @@
           <p:cNvPr id="6" name="">
             <a:extLst xmlns:a="http://schemas.openxmlformats.org/drawingml/2006/main">
               <a:ext uri="{FF2B5EF4-FFF2-40B4-BE49-F238E27FC236}">
-                <a16:creationId xmlns:a16="http://schemas.microsoft.com/office/drawing/2014/main" id="{C5B204B3-0EAD-402C-A813-EC616B778220}"/>
+                <a16:creationId xmlns:a16="http://schemas.microsoft.com/office/drawing/2014/main" id="{0A13E2DC-1866-4B4A-A90D-ECA6C7E356A2}"/>
               </a:ext>
             </a:extLst>
           </p:cNvPr>
@@ -7531,7 +7531,7 @@
           <p:cNvPr id="7" name="">
             <a:extLst xmlns:a="http://schemas.openxmlformats.org/drawingml/2006/main">
               <a:ext uri="{FF2B5EF4-FFF2-40B4-BE49-F238E27FC236}">
-                <a16:creationId xmlns:a16="http://schemas.microsoft.com/office/drawing/2014/main" id="{D9062884-5CA1-4A0A-8B24-81C4EA7880E0}"/>
+                <a16:creationId xmlns:a16="http://schemas.microsoft.com/office/drawing/2014/main" id="{F15A5C71-61AD-4215-AE39-010C263A907A}"/>
               </a:ext>
             </a:extLst>
           </p:cNvPr>
@@ -7687,7 +7687,7 @@
           <p:cNvPr id="8" name="">
             <a:extLst xmlns:a="http://schemas.openxmlformats.org/drawingml/2006/main">
               <a:ext uri="{FF2B5EF4-FFF2-40B4-BE49-F238E27FC236}">
-                <a16:creationId xmlns:a16="http://schemas.microsoft.com/office/drawing/2014/main" id="{E0939819-2743-438D-A83F-E77D0241A9F3}"/>
+                <a16:creationId xmlns:a16="http://schemas.microsoft.com/office/drawing/2014/main" id="{EB7F9234-B1BE-437C-A23D-D2F305AA3947}"/>
               </a:ext>
             </a:extLst>
           </p:cNvPr>
@@ -7841,7 +7841,7 @@
     </p:spTree>
     <p:extLst>
       <p:ext uri="{BB962C8B-B14F-4D97-AF65-F5344CB8AC3E}">
-        <p14:creationId xmlns:p14="http://schemas.microsoft.com/office/powerpoint/2010/main" val="755257108"/>
+        <p14:creationId xmlns:p14="http://schemas.microsoft.com/office/powerpoint/2010/main" val="1335565359"/>
       </p:ext>
     </p:extLst>
   </p:cSld>
@@ -7872,7 +7872,7 @@
           <p:cNvPr id="7" name="">
             <a:extLst xmlns:a="http://schemas.openxmlformats.org/drawingml/2006/main">
               <a:ext uri="{FF2B5EF4-FFF2-40B4-BE49-F238E27FC236}">
-                <a16:creationId xmlns:a16="http://schemas.microsoft.com/office/drawing/2014/main" id="{72C9FA9B-F1E2-4C18-8CE1-31C6DE1F8C65}"/>
+                <a16:creationId xmlns:a16="http://schemas.microsoft.com/office/drawing/2014/main" id="{998BD62E-0607-45A4-A65F-8325DA9F100C}"/>
               </a:ext>
             </a:extLst>
           </p:cNvPr>
@@ -8028,7 +8028,7 @@
           <p:cNvPr id="2" name="">
             <a:extLst xmlns:a="http://schemas.openxmlformats.org/drawingml/2006/main">
               <a:ext uri="{FF2B5EF4-FFF2-40B4-BE49-F238E27FC236}">
-                <a16:creationId xmlns:a16="http://schemas.microsoft.com/office/drawing/2014/main" id="{40755A97-65C2-4E46-AE2A-21EAB92B02F8}"/>
+                <a16:creationId xmlns:a16="http://schemas.microsoft.com/office/drawing/2014/main" id="{CA3B5DE5-F2AF-4F83-BCA9-D8CA570E7FB9}"/>
               </a:ext>
             </a:extLst>
           </p:cNvPr>
@@ -8184,7 +8184,7 @@
           <p:cNvPr id="3" name="">
             <a:extLst xmlns:a="http://schemas.openxmlformats.org/drawingml/2006/main">
               <a:ext uri="{FF2B5EF4-FFF2-40B4-BE49-F238E27FC236}">
-                <a16:creationId xmlns:a16="http://schemas.microsoft.com/office/drawing/2014/main" id="{13BA4490-6B7D-4115-AA0C-5EEBD0E68449}"/>
+                <a16:creationId xmlns:a16="http://schemas.microsoft.com/office/drawing/2014/main" id="{7CCCAA73-D603-4CB3-9E0B-4364A329B37E}"/>
               </a:ext>
             </a:extLst>
           </p:cNvPr>
@@ -8340,7 +8340,7 @@
           <p:cNvPr id="4" name="">
             <a:extLst xmlns:a="http://schemas.openxmlformats.org/drawingml/2006/main">
               <a:ext uri="{FF2B5EF4-FFF2-40B4-BE49-F238E27FC236}">
-                <a16:creationId xmlns:a16="http://schemas.microsoft.com/office/drawing/2014/main" id="{2C3C2C90-3644-4725-A2FE-873A9A9BA149}"/>
+                <a16:creationId xmlns:a16="http://schemas.microsoft.com/office/drawing/2014/main" id="{5E737FEA-9C6E-41BF-8A5A-A8F867FA795F}"/>
               </a:ext>
             </a:extLst>
           </p:cNvPr>
@@ -8350,7 +8350,7 @@
           <p:nvPr/>
         </p:nvPicPr>
         <p:blipFill>
-          <a:blip xmlns:r="http://schemas.openxmlformats.org/officeDocument/2006/relationships" xmlns:a="http://schemas.openxmlformats.org/drawingml/2006/main" r:embed="R14172887eb8945f2"/>
+          <a:blip xmlns:r="http://schemas.openxmlformats.org/officeDocument/2006/relationships" xmlns:a="http://schemas.openxmlformats.org/drawingml/2006/main" r:embed="Rec924c103df74625"/>
           <a:stretch xmlns:a="http://schemas.openxmlformats.org/drawingml/2006/main"/>
         </p:blipFill>
         <p:spPr>
@@ -8368,7 +8368,7 @@
           <p:cNvPr id="5" name="">
             <a:extLst xmlns:a="http://schemas.openxmlformats.org/drawingml/2006/main">
               <a:ext uri="{FF2B5EF4-FFF2-40B4-BE49-F238E27FC236}">
-                <a16:creationId xmlns:a16="http://schemas.microsoft.com/office/drawing/2014/main" id="{3D6B6787-F216-4965-8873-4D0B5E39ABE9}"/>
+                <a16:creationId xmlns:a16="http://schemas.microsoft.com/office/drawing/2014/main" id="{2A212621-A6C1-4A2A-9A6C-9673FA6E577E}"/>
               </a:ext>
             </a:extLst>
           </p:cNvPr>
@@ -8524,7 +8524,7 @@
           <p:cNvPr id="6" name="">
             <a:extLst xmlns:a="http://schemas.openxmlformats.org/drawingml/2006/main">
               <a:ext uri="{FF2B5EF4-FFF2-40B4-BE49-F238E27FC236}">
-                <a16:creationId xmlns:a16="http://schemas.microsoft.com/office/drawing/2014/main" id="{090C6E9C-FE3C-4B26-923F-AF13D12A6BC4}"/>
+                <a16:creationId xmlns:a16="http://schemas.microsoft.com/office/drawing/2014/main" id="{EC3B78A1-ED33-4775-A51F-CB321E85047C}"/>
               </a:ext>
             </a:extLst>
           </p:cNvPr>
@@ -8734,7 +8734,7 @@
     </p:spTree>
     <p:extLst>
       <p:ext uri="{BB962C8B-B14F-4D97-AF65-F5344CB8AC3E}">
-        <p14:creationId xmlns:p14="http://schemas.microsoft.com/office/powerpoint/2010/main" val="41912502"/>
+        <p14:creationId xmlns:p14="http://schemas.microsoft.com/office/powerpoint/2010/main" val="243137724"/>
       </p:ext>
     </p:extLst>
   </p:cSld>
@@ -8765,7 +8765,7 @@
           <p:cNvPr id="10" name="">
             <a:extLst xmlns:a="http://schemas.openxmlformats.org/drawingml/2006/main">
               <a:ext uri="{FF2B5EF4-FFF2-40B4-BE49-F238E27FC236}">
-                <a16:creationId xmlns:a16="http://schemas.microsoft.com/office/drawing/2014/main" id="{76D02123-59AB-442F-A771-F7A4D902D1F1}"/>
+                <a16:creationId xmlns:a16="http://schemas.microsoft.com/office/drawing/2014/main" id="{DE398EFD-8A17-4B19-B7B5-E3842FE56817}"/>
               </a:ext>
             </a:extLst>
           </p:cNvPr>
@@ -8921,7 +8921,7 @@
           <p:cNvPr id="2" name="">
             <a:extLst xmlns:a="http://schemas.openxmlformats.org/drawingml/2006/main">
               <a:ext uri="{FF2B5EF4-FFF2-40B4-BE49-F238E27FC236}">
-                <a16:creationId xmlns:a16="http://schemas.microsoft.com/office/drawing/2014/main" id="{7B6BC4B3-C284-49EA-BB6C-5E5C9EF66B83}"/>
+                <a16:creationId xmlns:a16="http://schemas.microsoft.com/office/drawing/2014/main" id="{016E4B6F-0205-4485-9B67-1567FD4A6189}"/>
               </a:ext>
             </a:extLst>
           </p:cNvPr>
@@ -9077,7 +9077,7 @@
           <p:cNvPr id="3" name="">
             <a:extLst xmlns:a="http://schemas.openxmlformats.org/drawingml/2006/main">
               <a:ext uri="{FF2B5EF4-FFF2-40B4-BE49-F238E27FC236}">
-                <a16:creationId xmlns:a16="http://schemas.microsoft.com/office/drawing/2014/main" id="{2389788F-5128-49E6-80F1-6977AB8CEA43}"/>
+                <a16:creationId xmlns:a16="http://schemas.microsoft.com/office/drawing/2014/main" id="{1CA49840-1BA5-46A8-9668-3E4407F07E8F}"/>
               </a:ext>
             </a:extLst>
           </p:cNvPr>
@@ -9233,7 +9233,7 @@
           <p:cNvPr id="4" name="">
             <a:extLst xmlns:a="http://schemas.openxmlformats.org/drawingml/2006/main">
               <a:ext uri="{FF2B5EF4-FFF2-40B4-BE49-F238E27FC236}">
-                <a16:creationId xmlns:a16="http://schemas.microsoft.com/office/drawing/2014/main" id="{ACBB5860-268D-44BC-B18F-222F727D71FB}"/>
+                <a16:creationId xmlns:a16="http://schemas.microsoft.com/office/drawing/2014/main" id="{44296E0F-057D-4C7F-A55F-EF0EC0F66439}"/>
               </a:ext>
             </a:extLst>
           </p:cNvPr>
@@ -9379,7 +9379,7 @@
                 <a:ea typeface="Arial"/>
                 <a:cs typeface="Arial"/>
               </a:rPr>
-              <a:t>Baseline backend tests</a:t>
+              <a:t>Candidate backend tests</a:t>
             </a:r>
           </a:p>
         </p:txBody>
@@ -9389,7 +9389,7 @@
           <p:cNvPr id="5" name="">
             <a:extLst xmlns:a="http://schemas.openxmlformats.org/drawingml/2006/main">
               <a:ext uri="{FF2B5EF4-FFF2-40B4-BE49-F238E27FC236}">
-                <a16:creationId xmlns:a16="http://schemas.microsoft.com/office/drawing/2014/main" id="{8B339FEB-BDF8-4194-B98E-8BE8F4406E4C}"/>
+                <a16:creationId xmlns:a16="http://schemas.microsoft.com/office/drawing/2014/main" id="{E42571AC-2125-4FFE-9366-3D5F0C053720}"/>
               </a:ext>
             </a:extLst>
           </p:cNvPr>
@@ -9535,7 +9535,7 @@
                 <a:ea typeface="Arial"/>
                 <a:cs typeface="Arial"/>
               </a:rPr>
-              <a:t>521 passed</a:t>
+              <a:t>553 passed</a:t>
             </a:r>
           </a:p>
         </p:txBody>
@@ -9545,7 +9545,7 @@
           <p:cNvPr id="6" name="">
             <a:extLst xmlns:a="http://schemas.openxmlformats.org/drawingml/2006/main">
               <a:ext uri="{FF2B5EF4-FFF2-40B4-BE49-F238E27FC236}">
-                <a16:creationId xmlns:a16="http://schemas.microsoft.com/office/drawing/2014/main" id="{252C9251-E0C9-42EC-AA64-5357B92F5C8F}"/>
+                <a16:creationId xmlns:a16="http://schemas.microsoft.com/office/drawing/2014/main" id="{2D759F43-4842-4DAF-9575-39E0C4822614}"/>
               </a:ext>
             </a:extLst>
           </p:cNvPr>
@@ -9701,7 +9701,7 @@
           <p:cNvPr id="7" name="">
             <a:extLst xmlns:a="http://schemas.openxmlformats.org/drawingml/2006/main">
               <a:ext uri="{FF2B5EF4-FFF2-40B4-BE49-F238E27FC236}">
-                <a16:creationId xmlns:a16="http://schemas.microsoft.com/office/drawing/2014/main" id="{36F1E517-6EC9-4010-A5BF-1CAAB66BB21F}"/>
+                <a16:creationId xmlns:a16="http://schemas.microsoft.com/office/drawing/2014/main" id="{23B857EB-0F78-481C-80CA-80A09C41527E}"/>
               </a:ext>
             </a:extLst>
           </p:cNvPr>
@@ -9857,7 +9857,7 @@
           <p:cNvPr id="8" name="">
             <a:extLst xmlns:a="http://schemas.openxmlformats.org/drawingml/2006/main">
               <a:ext uri="{FF2B5EF4-FFF2-40B4-BE49-F238E27FC236}">
-                <a16:creationId xmlns:a16="http://schemas.microsoft.com/office/drawing/2014/main" id="{88BD65B7-79A9-4141-9AE8-B6CC2B522AD8}"/>
+                <a16:creationId xmlns:a16="http://schemas.microsoft.com/office/drawing/2014/main" id="{7C33DA71-907E-4206-AC52-C1218EE39D47}"/>
               </a:ext>
             </a:extLst>
           </p:cNvPr>
@@ -10082,7 +10082,7 @@
           <p:cNvPr id="9" name="">
             <a:extLst xmlns:a="http://schemas.openxmlformats.org/drawingml/2006/main">
               <a:ext uri="{FF2B5EF4-FFF2-40B4-BE49-F238E27FC236}">
-                <a16:creationId xmlns:a16="http://schemas.microsoft.com/office/drawing/2014/main" id="{680814A2-D50C-4F90-B742-691C8431594B}"/>
+                <a16:creationId xmlns:a16="http://schemas.microsoft.com/office/drawing/2014/main" id="{7D804E1A-F67F-4D09-BCEA-2AB09DB04210}"/>
               </a:ext>
             </a:extLst>
           </p:cNvPr>
@@ -10228,7 +10228,7 @@
                 <a:ea typeface="Arial"/>
                 <a:cs typeface="Arial"/>
               </a:rPr>
-              <a:t>Historical local baseline, not candidate acceptance or user impact. No external provider benchmark or model accuracy claim.</a:t>
+              <a:t>Local candidate test run, 58 skips explicit. No live-model accuracy, external provider benchmark or customer-impact claim.</a:t>
             </a:r>
           </a:p>
         </p:txBody>
@@ -10236,7 +10236,7 @@
     </p:spTree>
     <p:extLst>
       <p:ext uri="{BB962C8B-B14F-4D97-AF65-F5344CB8AC3E}">
-        <p14:creationId xmlns:p14="http://schemas.microsoft.com/office/powerpoint/2010/main" val="20558428"/>
+        <p14:creationId xmlns:p14="http://schemas.microsoft.com/office/powerpoint/2010/main" val="562388160"/>
       </p:ext>
     </p:extLst>
   </p:cSld>
@@ -10267,7 +10267,7 @@
           <p:cNvPr id="7" name="">
             <a:extLst xmlns:a="http://schemas.openxmlformats.org/drawingml/2006/main">
               <a:ext uri="{FF2B5EF4-FFF2-40B4-BE49-F238E27FC236}">
-                <a16:creationId xmlns:a16="http://schemas.microsoft.com/office/drawing/2014/main" id="{DF02AC14-AF50-4E1C-A980-B1314ABC61A5}"/>
+                <a16:creationId xmlns:a16="http://schemas.microsoft.com/office/drawing/2014/main" id="{EA1C3697-1C6F-4230-A8E7-0980976D9B14}"/>
               </a:ext>
             </a:extLst>
           </p:cNvPr>
@@ -10423,7 +10423,7 @@
           <p:cNvPr id="2" name="">
             <a:extLst xmlns:a="http://schemas.openxmlformats.org/drawingml/2006/main">
               <a:ext uri="{FF2B5EF4-FFF2-40B4-BE49-F238E27FC236}">
-                <a16:creationId xmlns:a16="http://schemas.microsoft.com/office/drawing/2014/main" id="{F742940C-62A1-42F6-B72A-982B350ED59B}"/>
+                <a16:creationId xmlns:a16="http://schemas.microsoft.com/office/drawing/2014/main" id="{9DC38F94-6CB0-4B1F-AFE6-01775FCB98BC}"/>
               </a:ext>
             </a:extLst>
           </p:cNvPr>
@@ -10579,7 +10579,7 @@
           <p:cNvPr id="3" name="">
             <a:extLst xmlns:a="http://schemas.openxmlformats.org/drawingml/2006/main">
               <a:ext uri="{FF2B5EF4-FFF2-40B4-BE49-F238E27FC236}">
-                <a16:creationId xmlns:a16="http://schemas.microsoft.com/office/drawing/2014/main" id="{05203031-B8E9-4AFF-A05F-E21AC22023F9}"/>
+                <a16:creationId xmlns:a16="http://schemas.microsoft.com/office/drawing/2014/main" id="{5EC3C0EE-2A32-49D9-8729-186547DD1A69}"/>
               </a:ext>
             </a:extLst>
           </p:cNvPr>
@@ -10735,7 +10735,7 @@
           <p:cNvPr id="4" name="">
             <a:extLst xmlns:a="http://schemas.openxmlformats.org/drawingml/2006/main">
               <a:ext uri="{FF2B5EF4-FFF2-40B4-BE49-F238E27FC236}">
-                <a16:creationId xmlns:a16="http://schemas.microsoft.com/office/drawing/2014/main" id="{71D3DE99-F55B-4795-8110-30C4E1E3B0A1}"/>
+                <a16:creationId xmlns:a16="http://schemas.microsoft.com/office/drawing/2014/main" id="{5CF8B0D8-14F2-4D11-A242-D3318BEE89F8}"/>
               </a:ext>
             </a:extLst>
           </p:cNvPr>
@@ -10891,7 +10891,7 @@
           <p:cNvPr id="5" name="">
             <a:extLst xmlns:a="http://schemas.openxmlformats.org/drawingml/2006/main">
               <a:ext uri="{FF2B5EF4-FFF2-40B4-BE49-F238E27FC236}">
-                <a16:creationId xmlns:a16="http://schemas.microsoft.com/office/drawing/2014/main" id="{D235DAC8-535B-43A1-9D53-F53B09B5E5D4}"/>
+                <a16:creationId xmlns:a16="http://schemas.microsoft.com/office/drawing/2014/main" id="{89D9B778-DAC7-4E4F-99EA-34728DB6912A}"/>
               </a:ext>
             </a:extLst>
           </p:cNvPr>
@@ -11047,7 +11047,7 @@
           <p:cNvPr id="6" name="">
             <a:extLst xmlns:a="http://schemas.openxmlformats.org/drawingml/2006/main">
               <a:ext uri="{FF2B5EF4-FFF2-40B4-BE49-F238E27FC236}">
-                <a16:creationId xmlns:a16="http://schemas.microsoft.com/office/drawing/2014/main" id="{3457D40E-BDDF-48AC-8840-4721FAC9754F}"/>
+                <a16:creationId xmlns:a16="http://schemas.microsoft.com/office/drawing/2014/main" id="{2F0793CB-3227-4FF5-879D-9747B756FFF7}"/>
               </a:ext>
             </a:extLst>
           </p:cNvPr>
@@ -11201,7 +11201,7 @@
     </p:spTree>
     <p:extLst>
       <p:ext uri="{BB962C8B-B14F-4D97-AF65-F5344CB8AC3E}">
-        <p14:creationId xmlns:p14="http://schemas.microsoft.com/office/powerpoint/2010/main" val="1225335444"/>
+        <p14:creationId xmlns:p14="http://schemas.microsoft.com/office/powerpoint/2010/main" val="494189156"/>
       </p:ext>
     </p:extLst>
   </p:cSld>
@@ -11232,7 +11232,7 @@
           <p:cNvPr id="11" name="">
             <a:extLst xmlns:a="http://schemas.openxmlformats.org/drawingml/2006/main">
               <a:ext uri="{FF2B5EF4-FFF2-40B4-BE49-F238E27FC236}">
-                <a16:creationId xmlns:a16="http://schemas.microsoft.com/office/drawing/2014/main" id="{2852375D-06A5-402D-9C53-417CF34313A7}"/>
+                <a16:creationId xmlns:a16="http://schemas.microsoft.com/office/drawing/2014/main" id="{3EBBCB5D-2E1A-468D-B927-7F109B67896A}"/>
               </a:ext>
             </a:extLst>
           </p:cNvPr>
@@ -11388,7 +11388,7 @@
           <p:cNvPr id="2" name="">
             <a:extLst xmlns:a="http://schemas.openxmlformats.org/drawingml/2006/main">
               <a:ext uri="{FF2B5EF4-FFF2-40B4-BE49-F238E27FC236}">
-                <a16:creationId xmlns:a16="http://schemas.microsoft.com/office/drawing/2014/main" id="{DBDCE6BD-E030-48A4-911C-4867930A434C}"/>
+                <a16:creationId xmlns:a16="http://schemas.microsoft.com/office/drawing/2014/main" id="{F053AB7B-FEEE-400A-8A31-4C66F37D0036}"/>
               </a:ext>
             </a:extLst>
           </p:cNvPr>
@@ -11544,7 +11544,7 @@
           <p:cNvPr id="3" name="">
             <a:extLst xmlns:a="http://schemas.openxmlformats.org/drawingml/2006/main">
               <a:ext uri="{FF2B5EF4-FFF2-40B4-BE49-F238E27FC236}">
-                <a16:creationId xmlns:a16="http://schemas.microsoft.com/office/drawing/2014/main" id="{C96BA01E-2491-48CA-82F1-EA6DFBEF63E4}"/>
+                <a16:creationId xmlns:a16="http://schemas.microsoft.com/office/drawing/2014/main" id="{C8728977-20FF-441C-8D75-A276370164BB}"/>
               </a:ext>
             </a:extLst>
           </p:cNvPr>
@@ -11700,7 +11700,7 @@
           <p:cNvPr id="4" name="">
             <a:extLst xmlns:a="http://schemas.openxmlformats.org/drawingml/2006/main">
               <a:ext uri="{FF2B5EF4-FFF2-40B4-BE49-F238E27FC236}">
-                <a16:creationId xmlns:a16="http://schemas.microsoft.com/office/drawing/2014/main" id="{3F46D2B9-3E80-4878-BA55-8818A558F6BC}"/>
+                <a16:creationId xmlns:a16="http://schemas.microsoft.com/office/drawing/2014/main" id="{FDEED9C0-5B9C-4CB3-8385-D33FC1352D74}"/>
               </a:ext>
             </a:extLst>
           </p:cNvPr>
@@ -11856,7 +11856,7 @@
           <p:cNvPr id="5" name="">
             <a:extLst xmlns:a="http://schemas.openxmlformats.org/drawingml/2006/main">
               <a:ext uri="{FF2B5EF4-FFF2-40B4-BE49-F238E27FC236}">
-                <a16:creationId xmlns:a16="http://schemas.microsoft.com/office/drawing/2014/main" id="{DED889B7-4250-4F6A-8255-FD1224073883}"/>
+                <a16:creationId xmlns:a16="http://schemas.microsoft.com/office/drawing/2014/main" id="{DB21C38E-1B34-4BD2-98BF-D429A6661B95}"/>
               </a:ext>
             </a:extLst>
           </p:cNvPr>
@@ -12012,7 +12012,7 @@
           <p:cNvPr id="6" name="">
             <a:extLst xmlns:a="http://schemas.openxmlformats.org/drawingml/2006/main">
               <a:ext uri="{FF2B5EF4-FFF2-40B4-BE49-F238E27FC236}">
-                <a16:creationId xmlns:a16="http://schemas.microsoft.com/office/drawing/2014/main" id="{FCDCED1B-C522-438C-9349-40BA4BB0DBF2}"/>
+                <a16:creationId xmlns:a16="http://schemas.microsoft.com/office/drawing/2014/main" id="{1D92C613-6E7F-451C-966C-E65598CA6B41}"/>
               </a:ext>
             </a:extLst>
           </p:cNvPr>
@@ -12168,7 +12168,7 @@
           <p:cNvPr id="7" name="">
             <a:extLst xmlns:a="http://schemas.openxmlformats.org/drawingml/2006/main">
               <a:ext uri="{FF2B5EF4-FFF2-40B4-BE49-F238E27FC236}">
-                <a16:creationId xmlns:a16="http://schemas.microsoft.com/office/drawing/2014/main" id="{B8F61FE0-D67B-46C0-8E8A-4C7F9BD64876}"/>
+                <a16:creationId xmlns:a16="http://schemas.microsoft.com/office/drawing/2014/main" id="{091E3089-0924-4B92-ADA8-35DFCD70A62B}"/>
               </a:ext>
             </a:extLst>
           </p:cNvPr>
@@ -12324,7 +12324,7 @@
           <p:cNvPr id="8" name="">
             <a:extLst xmlns:a="http://schemas.openxmlformats.org/drawingml/2006/main">
               <a:ext uri="{FF2B5EF4-FFF2-40B4-BE49-F238E27FC236}">
-                <a16:creationId xmlns:a16="http://schemas.microsoft.com/office/drawing/2014/main" id="{8BAFAE15-5834-45FA-A7BA-1EECC55814A3}"/>
+                <a16:creationId xmlns:a16="http://schemas.microsoft.com/office/drawing/2014/main" id="{B57548B9-B47A-415B-AEE2-BCD2B5BDBA6E}"/>
               </a:ext>
             </a:extLst>
           </p:cNvPr>
@@ -12480,7 +12480,7 @@
           <p:cNvPr id="9" name="">
             <a:extLst xmlns:a="http://schemas.openxmlformats.org/drawingml/2006/main">
               <a:ext uri="{FF2B5EF4-FFF2-40B4-BE49-F238E27FC236}">
-                <a16:creationId xmlns:a16="http://schemas.microsoft.com/office/drawing/2014/main" id="{14842923-C2B4-4C84-BF05-E3FFEBB0D271}"/>
+                <a16:creationId xmlns:a16="http://schemas.microsoft.com/office/drawing/2014/main" id="{BCF5FA55-B1E1-4CDC-B21D-8E8676CF5987}"/>
               </a:ext>
             </a:extLst>
           </p:cNvPr>
@@ -12636,7 +12636,7 @@
           <p:cNvPr id="10" name="">
             <a:extLst xmlns:a="http://schemas.openxmlformats.org/drawingml/2006/main">
               <a:ext uri="{FF2B5EF4-FFF2-40B4-BE49-F238E27FC236}">
-                <a16:creationId xmlns:a16="http://schemas.microsoft.com/office/drawing/2014/main" id="{046F0571-66D6-4BFA-9B7C-57BC058307F2}"/>
+                <a16:creationId xmlns:a16="http://schemas.microsoft.com/office/drawing/2014/main" id="{58A28B22-C5B8-4012-8410-1BEA3F10AFF5}"/>
               </a:ext>
             </a:extLst>
           </p:cNvPr>
@@ -12790,7 +12790,7 @@
     </p:spTree>
     <p:extLst>
       <p:ext uri="{BB962C8B-B14F-4D97-AF65-F5344CB8AC3E}">
-        <p14:creationId xmlns:p14="http://schemas.microsoft.com/office/powerpoint/2010/main" val="254016398"/>
+        <p14:creationId xmlns:p14="http://schemas.microsoft.com/office/powerpoint/2010/main" val="525928519"/>
       </p:ext>
     </p:extLst>
   </p:cSld>
@@ -12821,7 +12821,7 @@
           <p:cNvPr id="7" name="">
             <a:extLst xmlns:a="http://schemas.openxmlformats.org/drawingml/2006/main">
               <a:ext uri="{FF2B5EF4-FFF2-40B4-BE49-F238E27FC236}">
-                <a16:creationId xmlns:a16="http://schemas.microsoft.com/office/drawing/2014/main" id="{E55264C7-2693-4378-BCE0-D1E5D0B55D3C}"/>
+                <a16:creationId xmlns:a16="http://schemas.microsoft.com/office/drawing/2014/main" id="{E16F758B-AD26-4B0B-A817-EC3E93BBC492}"/>
               </a:ext>
             </a:extLst>
           </p:cNvPr>
@@ -12977,7 +12977,7 @@
           <p:cNvPr id="2" name="">
             <a:extLst xmlns:a="http://schemas.openxmlformats.org/drawingml/2006/main">
               <a:ext uri="{FF2B5EF4-FFF2-40B4-BE49-F238E27FC236}">
-                <a16:creationId xmlns:a16="http://schemas.microsoft.com/office/drawing/2014/main" id="{32AF1F4B-D8B1-4DD1-81A1-6A91DE42C49B}"/>
+                <a16:creationId xmlns:a16="http://schemas.microsoft.com/office/drawing/2014/main" id="{C84F4592-327B-413D-8523-7F36B0B7677C}"/>
               </a:ext>
             </a:extLst>
           </p:cNvPr>
@@ -13133,7 +13133,7 @@
           <p:cNvPr id="3" name="">
             <a:extLst xmlns:a="http://schemas.openxmlformats.org/drawingml/2006/main">
               <a:ext uri="{FF2B5EF4-FFF2-40B4-BE49-F238E27FC236}">
-                <a16:creationId xmlns:a16="http://schemas.microsoft.com/office/drawing/2014/main" id="{786B6EFF-5E16-4275-9E03-1E5C62B8F1D5}"/>
+                <a16:creationId xmlns:a16="http://schemas.microsoft.com/office/drawing/2014/main" id="{DB0D2A3B-50AB-48F3-B79C-EB0F593C22E7}"/>
               </a:ext>
             </a:extLst>
           </p:cNvPr>
@@ -13289,7 +13289,7 @@
           <p:cNvPr id="4" name="">
             <a:extLst xmlns:a="http://schemas.openxmlformats.org/drawingml/2006/main">
               <a:ext uri="{FF2B5EF4-FFF2-40B4-BE49-F238E27FC236}">
-                <a16:creationId xmlns:a16="http://schemas.microsoft.com/office/drawing/2014/main" id="{C701DFB2-19DA-4230-BFED-0421B9F51FB6}"/>
+                <a16:creationId xmlns:a16="http://schemas.microsoft.com/office/drawing/2014/main" id="{FA8011EA-7989-44EC-99CB-2EF1F082B18B}"/>
               </a:ext>
             </a:extLst>
           </p:cNvPr>
@@ -13445,7 +13445,7 @@
           <p:cNvPr id="5" name="">
             <a:extLst xmlns:a="http://schemas.openxmlformats.org/drawingml/2006/main">
               <a:ext uri="{FF2B5EF4-FFF2-40B4-BE49-F238E27FC236}">
-                <a16:creationId xmlns:a16="http://schemas.microsoft.com/office/drawing/2014/main" id="{9DAFDFE5-DCBF-43C7-9D2A-F8A3D67FB9E1}"/>
+                <a16:creationId xmlns:a16="http://schemas.microsoft.com/office/drawing/2014/main" id="{90783EB6-6725-4AF7-B8D4-AF3192A8C305}"/>
               </a:ext>
             </a:extLst>
           </p:cNvPr>
@@ -13601,7 +13601,7 @@
           <p:cNvPr id="6" name="">
             <a:extLst xmlns:a="http://schemas.openxmlformats.org/drawingml/2006/main">
               <a:ext uri="{FF2B5EF4-FFF2-40B4-BE49-F238E27FC236}">
-                <a16:creationId xmlns:a16="http://schemas.microsoft.com/office/drawing/2014/main" id="{F8CBF0EB-4DF6-4E00-BF72-0779144BF304}"/>
+                <a16:creationId xmlns:a16="http://schemas.microsoft.com/office/drawing/2014/main" id="{ABD6679E-8D12-42D2-B6B2-A710D9E0FBB7}"/>
               </a:ext>
             </a:extLst>
           </p:cNvPr>
@@ -13755,7 +13755,7 @@
     </p:spTree>
     <p:extLst>
       <p:ext uri="{BB962C8B-B14F-4D97-AF65-F5344CB8AC3E}">
-        <p14:creationId xmlns:p14="http://schemas.microsoft.com/office/powerpoint/2010/main" val="1737528640"/>
+        <p14:creationId xmlns:p14="http://schemas.microsoft.com/office/powerpoint/2010/main" val="778488274"/>
       </p:ext>
     </p:extLst>
   </p:cSld>
@@ -13786,7 +13786,7 @@
           <p:cNvPr id="8" name="">
             <a:extLst xmlns:a="http://schemas.openxmlformats.org/drawingml/2006/main">
               <a:ext uri="{FF2B5EF4-FFF2-40B4-BE49-F238E27FC236}">
-                <a16:creationId xmlns:a16="http://schemas.microsoft.com/office/drawing/2014/main" id="{D7CEB23F-677F-4B3C-83CB-3A45D3A9AA59}"/>
+                <a16:creationId xmlns:a16="http://schemas.microsoft.com/office/drawing/2014/main" id="{3554640A-B872-4272-9A94-2B9B70ABDEF7}"/>
               </a:ext>
             </a:extLst>
           </p:cNvPr>
@@ -13942,7 +13942,7 @@
           <p:cNvPr id="2" name="">
             <a:extLst xmlns:a="http://schemas.openxmlformats.org/drawingml/2006/main">
               <a:ext uri="{FF2B5EF4-FFF2-40B4-BE49-F238E27FC236}">
-                <a16:creationId xmlns:a16="http://schemas.microsoft.com/office/drawing/2014/main" id="{9998893D-79D7-4500-B165-AA4D09E852D4}"/>
+                <a16:creationId xmlns:a16="http://schemas.microsoft.com/office/drawing/2014/main" id="{1B34B386-A180-4CFC-9263-3951801AEDDE}"/>
               </a:ext>
             </a:extLst>
           </p:cNvPr>
@@ -14098,7 +14098,7 @@
           <p:cNvPr id="3" name="">
             <a:extLst xmlns:a="http://schemas.openxmlformats.org/drawingml/2006/main">
               <a:ext uri="{FF2B5EF4-FFF2-40B4-BE49-F238E27FC236}">
-                <a16:creationId xmlns:a16="http://schemas.microsoft.com/office/drawing/2014/main" id="{7DFA4FB2-17F2-48DF-A821-605F0A9A3665}"/>
+                <a16:creationId xmlns:a16="http://schemas.microsoft.com/office/drawing/2014/main" id="{756086D3-598D-410C-AAD6-626B279709DA}"/>
               </a:ext>
             </a:extLst>
           </p:cNvPr>
@@ -14254,7 +14254,7 @@
           <p:cNvPr id="4" name="">
             <a:extLst xmlns:a="http://schemas.openxmlformats.org/drawingml/2006/main">
               <a:ext uri="{FF2B5EF4-FFF2-40B4-BE49-F238E27FC236}">
-                <a16:creationId xmlns:a16="http://schemas.microsoft.com/office/drawing/2014/main" id="{837FB034-8BB6-4C89-8BFE-9B96CC8E50BC}"/>
+                <a16:creationId xmlns:a16="http://schemas.microsoft.com/office/drawing/2014/main" id="{7D8CD7F4-F23F-4743-A3B2-C637BCB83F31}"/>
               </a:ext>
             </a:extLst>
           </p:cNvPr>
@@ -14410,7 +14410,7 @@
           <p:cNvPr id="5" name="">
             <a:extLst xmlns:a="http://schemas.openxmlformats.org/drawingml/2006/main">
               <a:ext uri="{FF2B5EF4-FFF2-40B4-BE49-F238E27FC236}">
-                <a16:creationId xmlns:a16="http://schemas.microsoft.com/office/drawing/2014/main" id="{06D4EEA7-D7AF-4197-B1F2-5055115DD49C}"/>
+                <a16:creationId xmlns:a16="http://schemas.microsoft.com/office/drawing/2014/main" id="{B427C008-7C1A-4BCA-BEF0-D190D6CAFCA9}"/>
               </a:ext>
             </a:extLst>
           </p:cNvPr>
@@ -14566,7 +14566,7 @@
           <p:cNvPr id="6" name="">
             <a:extLst xmlns:a="http://schemas.openxmlformats.org/drawingml/2006/main">
               <a:ext uri="{FF2B5EF4-FFF2-40B4-BE49-F238E27FC236}">
-                <a16:creationId xmlns:a16="http://schemas.microsoft.com/office/drawing/2014/main" id="{BAB2D799-288D-4EEB-9C54-58AD95311921}"/>
+                <a16:creationId xmlns:a16="http://schemas.microsoft.com/office/drawing/2014/main" id="{8954DDED-0111-41CF-952A-02643DB69522}"/>
               </a:ext>
             </a:extLst>
           </p:cNvPr>
@@ -14722,7 +14722,7 @@
           <p:cNvPr id="7" name="">
             <a:extLst xmlns:a="http://schemas.openxmlformats.org/drawingml/2006/main">
               <a:ext uri="{FF2B5EF4-FFF2-40B4-BE49-F238E27FC236}">
-                <a16:creationId xmlns:a16="http://schemas.microsoft.com/office/drawing/2014/main" id="{9EC171D7-8A62-4033-A4A4-410F1BA590A3}"/>
+                <a16:creationId xmlns:a16="http://schemas.microsoft.com/office/drawing/2014/main" id="{91542B25-006F-47DD-964B-E7B50313874B}"/>
               </a:ext>
             </a:extLst>
           </p:cNvPr>
@@ -14868,7 +14868,7 @@
                 <a:ea typeface="Arial"/>
                 <a:cs typeface="Arial"/>
               </a:rPr>
-              <a:t>BFSI fit: trustworthy financial migration and onboarding. Exact selected challenge statement pending.</a:t>
+              <a:t>BFSI: Intelligent Risk, Fraud &amp; Financial Experiences. Fit: migration risk, complex process automation and informed financial decisions.</a:t>
             </a:r>
           </a:p>
         </p:txBody>
@@ -14876,7 +14876,7 @@
     </p:spTree>
     <p:extLst>
       <p:ext uri="{BB962C8B-B14F-4D97-AF65-F5344CB8AC3E}">
-        <p14:creationId xmlns:p14="http://schemas.microsoft.com/office/powerpoint/2010/main" val="1600778726"/>
+        <p14:creationId xmlns:p14="http://schemas.microsoft.com/office/powerpoint/2010/main" val="1666032879"/>
       </p:ext>
     </p:extLst>
   </p:cSld>
@@ -14907,7 +14907,7 @@
           <p:cNvPr id="8" name="">
             <a:extLst xmlns:a="http://schemas.openxmlformats.org/drawingml/2006/main">
               <a:ext uri="{FF2B5EF4-FFF2-40B4-BE49-F238E27FC236}">
-                <a16:creationId xmlns:a16="http://schemas.microsoft.com/office/drawing/2014/main" id="{BC32B972-9C3D-443D-AD8F-634B2485A5F6}"/>
+                <a16:creationId xmlns:a16="http://schemas.microsoft.com/office/drawing/2014/main" id="{E92D7385-DD49-4B2A-9F8A-BCC6BC446736}"/>
               </a:ext>
             </a:extLst>
           </p:cNvPr>
@@ -15063,7 +15063,7 @@
           <p:cNvPr id="2" name="">
             <a:extLst xmlns:a="http://schemas.openxmlformats.org/drawingml/2006/main">
               <a:ext uri="{FF2B5EF4-FFF2-40B4-BE49-F238E27FC236}">
-                <a16:creationId xmlns:a16="http://schemas.microsoft.com/office/drawing/2014/main" id="{C68250F5-1F19-41F0-8D71-6E3B53E036CE}"/>
+                <a16:creationId xmlns:a16="http://schemas.microsoft.com/office/drawing/2014/main" id="{FAB4B7EA-0D49-4D36-ABA1-1F501B115E57}"/>
               </a:ext>
             </a:extLst>
           </p:cNvPr>
@@ -15219,7 +15219,7 @@
           <p:cNvPr id="3" name="">
             <a:extLst xmlns:a="http://schemas.openxmlformats.org/drawingml/2006/main">
               <a:ext uri="{FF2B5EF4-FFF2-40B4-BE49-F238E27FC236}">
-                <a16:creationId xmlns:a16="http://schemas.microsoft.com/office/drawing/2014/main" id="{F365AC4E-D23E-406D-A2C6-312418003D90}"/>
+                <a16:creationId xmlns:a16="http://schemas.microsoft.com/office/drawing/2014/main" id="{68C04414-1DA9-4F55-A577-8B9D6697784A}"/>
               </a:ext>
             </a:extLst>
           </p:cNvPr>
@@ -15375,7 +15375,7 @@
           <p:cNvPr id="4" name="">
             <a:extLst xmlns:a="http://schemas.openxmlformats.org/drawingml/2006/main">
               <a:ext uri="{FF2B5EF4-FFF2-40B4-BE49-F238E27FC236}">
-                <a16:creationId xmlns:a16="http://schemas.microsoft.com/office/drawing/2014/main" id="{F7A7E2E0-9FFB-43E2-B8E1-4CD7BF9B1940}"/>
+                <a16:creationId xmlns:a16="http://schemas.microsoft.com/office/drawing/2014/main" id="{948C3912-0CCA-4DAE-B571-4AA3F0A88505}"/>
               </a:ext>
             </a:extLst>
           </p:cNvPr>
@@ -15531,7 +15531,7 @@
           <p:cNvPr id="5" name="">
             <a:extLst xmlns:a="http://schemas.openxmlformats.org/drawingml/2006/main">
               <a:ext uri="{FF2B5EF4-FFF2-40B4-BE49-F238E27FC236}">
-                <a16:creationId xmlns:a16="http://schemas.microsoft.com/office/drawing/2014/main" id="{E4145D7E-6389-4029-8BC1-7EE4B33500C2}"/>
+                <a16:creationId xmlns:a16="http://schemas.microsoft.com/office/drawing/2014/main" id="{2ACB8814-5E79-46FD-8642-419B332E5F8D}"/>
               </a:ext>
             </a:extLst>
           </p:cNvPr>
@@ -15687,7 +15687,7 @@
           <p:cNvPr id="6" name="">
             <a:extLst xmlns:a="http://schemas.openxmlformats.org/drawingml/2006/main">
               <a:ext uri="{FF2B5EF4-FFF2-40B4-BE49-F238E27FC236}">
-                <a16:creationId xmlns:a16="http://schemas.microsoft.com/office/drawing/2014/main" id="{CF110DDF-4269-4A0A-A4D1-21DE2B504D35}"/>
+                <a16:creationId xmlns:a16="http://schemas.microsoft.com/office/drawing/2014/main" id="{B19081B4-4549-4C0B-9ADA-470C8710C540}"/>
               </a:ext>
             </a:extLst>
           </p:cNvPr>
@@ -15843,7 +15843,7 @@
           <p:cNvPr id="7" name="">
             <a:extLst xmlns:a="http://schemas.openxmlformats.org/drawingml/2006/main">
               <a:ext uri="{FF2B5EF4-FFF2-40B4-BE49-F238E27FC236}">
-                <a16:creationId xmlns:a16="http://schemas.microsoft.com/office/drawing/2014/main" id="{4C42B3F5-A7C2-4355-8CC8-7F08AF3A9E4C}"/>
+                <a16:creationId xmlns:a16="http://schemas.microsoft.com/office/drawing/2014/main" id="{6ED80A65-27AD-4682-9638-7E92832D0B5D}"/>
               </a:ext>
             </a:extLst>
           </p:cNvPr>
@@ -15997,7 +15997,7 @@
     </p:spTree>
     <p:extLst>
       <p:ext uri="{BB962C8B-B14F-4D97-AF65-F5344CB8AC3E}">
-        <p14:creationId xmlns:p14="http://schemas.microsoft.com/office/powerpoint/2010/main" val="862105366"/>
+        <p14:creationId xmlns:p14="http://schemas.microsoft.com/office/powerpoint/2010/main" val="947440618"/>
       </p:ext>
     </p:extLst>
   </p:cSld>
@@ -16028,7 +16028,7 @@
           <p:cNvPr id="7" name="">
             <a:extLst xmlns:a="http://schemas.openxmlformats.org/drawingml/2006/main">
               <a:ext uri="{FF2B5EF4-FFF2-40B4-BE49-F238E27FC236}">
-                <a16:creationId xmlns:a16="http://schemas.microsoft.com/office/drawing/2014/main" id="{6F59E8B4-4B69-43B5-AB8E-8492858089D7}"/>
+                <a16:creationId xmlns:a16="http://schemas.microsoft.com/office/drawing/2014/main" id="{24AF0700-9D6E-49D9-8CEC-371B4C624034}"/>
               </a:ext>
             </a:extLst>
           </p:cNvPr>
@@ -16184,7 +16184,7 @@
           <p:cNvPr id="2" name="">
             <a:extLst xmlns:a="http://schemas.openxmlformats.org/drawingml/2006/main">
               <a:ext uri="{FF2B5EF4-FFF2-40B4-BE49-F238E27FC236}">
-                <a16:creationId xmlns:a16="http://schemas.microsoft.com/office/drawing/2014/main" id="{049B1BB0-426D-4E03-A94E-68DFF4BA38F1}"/>
+                <a16:creationId xmlns:a16="http://schemas.microsoft.com/office/drawing/2014/main" id="{B0A90773-7020-43D9-A5BF-19918C2F05B0}"/>
               </a:ext>
             </a:extLst>
           </p:cNvPr>
@@ -16340,7 +16340,7 @@
           <p:cNvPr id="3" name="">
             <a:extLst xmlns:a="http://schemas.openxmlformats.org/drawingml/2006/main">
               <a:ext uri="{FF2B5EF4-FFF2-40B4-BE49-F238E27FC236}">
-                <a16:creationId xmlns:a16="http://schemas.microsoft.com/office/drawing/2014/main" id="{73D63323-4B88-4ADC-9140-5FD4AC5D3A1D}"/>
+                <a16:creationId xmlns:a16="http://schemas.microsoft.com/office/drawing/2014/main" id="{8A9D6D9D-5DEB-4888-9C46-9709E2AC1264}"/>
               </a:ext>
             </a:extLst>
           </p:cNvPr>
@@ -16496,7 +16496,7 @@
           <p:cNvPr id="4" name="">
             <a:extLst xmlns:a="http://schemas.openxmlformats.org/drawingml/2006/main">
               <a:ext uri="{FF2B5EF4-FFF2-40B4-BE49-F238E27FC236}">
-                <a16:creationId xmlns:a16="http://schemas.microsoft.com/office/drawing/2014/main" id="{22793679-EF8E-44EB-B12B-E3BAE2566F3B}"/>
+                <a16:creationId xmlns:a16="http://schemas.microsoft.com/office/drawing/2014/main" id="{4708E75E-88FC-47FA-8656-47E88785F965}"/>
               </a:ext>
             </a:extLst>
           </p:cNvPr>
@@ -16652,7 +16652,7 @@
           <p:cNvPr id="5" name="">
             <a:extLst xmlns:a="http://schemas.openxmlformats.org/drawingml/2006/main">
               <a:ext uri="{FF2B5EF4-FFF2-40B4-BE49-F238E27FC236}">
-                <a16:creationId xmlns:a16="http://schemas.microsoft.com/office/drawing/2014/main" id="{75C540E0-33C6-48B8-A165-EF80D0C86778}"/>
+                <a16:creationId xmlns:a16="http://schemas.microsoft.com/office/drawing/2014/main" id="{8C443A26-4734-46B4-8EB6-EF3360594BD8}"/>
               </a:ext>
             </a:extLst>
           </p:cNvPr>
@@ -16808,7 +16808,7 @@
           <p:cNvPr id="6" name="">
             <a:extLst xmlns:a="http://schemas.openxmlformats.org/drawingml/2006/main">
               <a:ext uri="{FF2B5EF4-FFF2-40B4-BE49-F238E27FC236}">
-                <a16:creationId xmlns:a16="http://schemas.microsoft.com/office/drawing/2014/main" id="{41483D07-F7EA-4197-8CF9-4640B4BE6055}"/>
+                <a16:creationId xmlns:a16="http://schemas.microsoft.com/office/drawing/2014/main" id="{26729C5F-71DD-4942-8A70-AD684F5B2E06}"/>
               </a:ext>
             </a:extLst>
           </p:cNvPr>
@@ -16962,7 +16962,7 @@
     </p:spTree>
     <p:extLst>
       <p:ext uri="{BB962C8B-B14F-4D97-AF65-F5344CB8AC3E}">
-        <p14:creationId xmlns:p14="http://schemas.microsoft.com/office/powerpoint/2010/main" val="1092067673"/>
+        <p14:creationId xmlns:p14="http://schemas.microsoft.com/office/powerpoint/2010/main" val="654671608"/>
       </p:ext>
     </p:extLst>
   </p:cSld>
@@ -16990,10 +16990,10 @@
       </p:grpSpPr>
       <p:sp>
         <p:nvSpPr>
-          <p:cNvPr id="11" name="">
+          <p:cNvPr id="12" name="">
             <a:extLst xmlns:a="http://schemas.openxmlformats.org/drawingml/2006/main">
               <a:ext uri="{FF2B5EF4-FFF2-40B4-BE49-F238E27FC236}">
-                <a16:creationId xmlns:a16="http://schemas.microsoft.com/office/drawing/2014/main" id="{74762CBC-6AA1-4A3A-A43C-1D7FC9522F91}"/>
+                <a16:creationId xmlns:a16="http://schemas.microsoft.com/office/drawing/2014/main" id="{6D4C5C99-093F-4E77-A26D-DCAC4F94FFEA}"/>
               </a:ext>
             </a:extLst>
           </p:cNvPr>
@@ -17149,7 +17149,7 @@
           <p:cNvPr id="2" name="">
             <a:extLst xmlns:a="http://schemas.openxmlformats.org/drawingml/2006/main">
               <a:ext uri="{FF2B5EF4-FFF2-40B4-BE49-F238E27FC236}">
-                <a16:creationId xmlns:a16="http://schemas.microsoft.com/office/drawing/2014/main" id="{FF4246FC-5437-4A61-9C92-5C3968105CB5}"/>
+                <a16:creationId xmlns:a16="http://schemas.microsoft.com/office/drawing/2014/main" id="{38B8CF1A-2070-4B8A-B038-CAB3FE5DC6A2}"/>
               </a:ext>
             </a:extLst>
           </p:cNvPr>
@@ -17305,7 +17305,7 @@
           <p:cNvPr id="3" name="">
             <a:extLst xmlns:a="http://schemas.openxmlformats.org/drawingml/2006/main">
               <a:ext uri="{FF2B5EF4-FFF2-40B4-BE49-F238E27FC236}">
-                <a16:creationId xmlns:a16="http://schemas.microsoft.com/office/drawing/2014/main" id="{1AD05EF2-A6C3-46CF-B3D1-4D357B1A4BEC}"/>
+                <a16:creationId xmlns:a16="http://schemas.microsoft.com/office/drawing/2014/main" id="{4EBF5616-E861-48EA-AF63-D67E052B1987}"/>
               </a:ext>
             </a:extLst>
           </p:cNvPr>
@@ -17456,12 +17456,40 @@
           </a:p>
         </p:txBody>
       </p:sp>
-      <p:sp>
-        <p:nvSpPr>
+      <p:pic>
+        <p:nvPicPr>
           <p:cNvPr id="4" name="">
             <a:extLst xmlns:a="http://schemas.openxmlformats.org/drawingml/2006/main">
               <a:ext uri="{FF2B5EF4-FFF2-40B4-BE49-F238E27FC236}">
-                <a16:creationId xmlns:a16="http://schemas.microsoft.com/office/drawing/2014/main" id="{6D5F2674-0CF1-4883-905B-F6D2AE84D1D0}"/>
+                <a16:creationId xmlns:a16="http://schemas.microsoft.com/office/drawing/2014/main" id="{DA4B2787-CEC2-4269-924D-2F88F525548A}"/>
+              </a:ext>
+            </a:extLst>
+          </p:cNvPr>
+          <p:cNvPicPr>
+            <a:picLocks xmlns:a="http://schemas.openxmlformats.org/drawingml/2006/main" noChangeAspect="1"/>
+          </p:cNvPicPr>
+          <p:nvPr/>
+        </p:nvPicPr>
+        <p:blipFill>
+          <a:blip xmlns:r="http://schemas.openxmlformats.org/officeDocument/2006/relationships" xmlns:a="http://schemas.openxmlformats.org/drawingml/2006/main" r:embed="R040ad2964a5b4b56"/>
+          <a:stretch xmlns:a="http://schemas.openxmlformats.org/drawingml/2006/main"/>
+        </p:blipFill>
+        <p:spPr>
+          <a:xfrm xmlns:a="http://schemas.openxmlformats.org/drawingml/2006/main">
+            <a:off x="798526" y="1571625"/>
+            <a:ext cx="7242149" cy="4381500"/>
+          </a:xfrm>
+          <a:prstGeom xmlns:a="http://schemas.openxmlformats.org/drawingml/2006/main" prst="rect">
+            <a:avLst/>
+          </a:prstGeom>
+        </p:spPr>
+      </p:pic>
+      <p:sp>
+        <p:nvSpPr>
+          <p:cNvPr id="5" name="">
+            <a:extLst xmlns:a="http://schemas.openxmlformats.org/drawingml/2006/main">
+              <a:ext uri="{FF2B5EF4-FFF2-40B4-BE49-F238E27FC236}">
+                <a16:creationId xmlns:a16="http://schemas.microsoft.com/office/drawing/2014/main" id="{E573C620-9F9D-482C-B876-2CD6C5A0F963}"/>
               </a:ext>
             </a:extLst>
           </p:cNvPr>
@@ -17472,8 +17500,8 @@
         </p:nvSpPr>
         <p:spPr>
           <a:xfrm xmlns:a="http://schemas.openxmlformats.org/drawingml/2006/main">
-            <a:off x="609600" y="1666875"/>
-            <a:ext cx="2571750" cy="571500"/>
+            <a:off x="8667750" y="1619250"/>
+            <a:ext cx="2952750" cy="428625"/>
           </a:xfrm>
           <a:prstGeom xmlns:a="http://schemas.openxmlformats.org/drawingml/2006/main" prst="rect">
             <a:avLst/>
@@ -17487,7 +17515,7 @@
           <a:bodyPr xmlns:a="http://schemas.openxmlformats.org/drawingml/2006/main"/>
           <a:lstStyle xmlns:a="http://schemas.openxmlformats.org/drawingml/2006/main">
             <a:defPPr>
-              <a:defRPr sz="2775" b="1">
+              <a:defRPr sz="2400" b="1">
                 <a:solidFill>
                   <a:srgbClr val="2563EB"/>
                 </a:solidFill>
@@ -17497,7 +17525,7 @@
               </a:defRPr>
             </a:defPPr>
             <a:lvl1pPr>
-              <a:defRPr sz="2775" b="1">
+              <a:defRPr sz="2400" b="1">
                 <a:solidFill>
                   <a:srgbClr val="2563EB"/>
                 </a:solidFill>
@@ -17507,7 +17535,7 @@
               </a:defRPr>
             </a:lvl1pPr>
             <a:lvl2pPr>
-              <a:defRPr sz="2775" b="1">
+              <a:defRPr sz="2400" b="1">
                 <a:solidFill>
                   <a:srgbClr val="2563EB"/>
                 </a:solidFill>
@@ -17517,7 +17545,7 @@
               </a:defRPr>
             </a:lvl2pPr>
             <a:lvl3pPr>
-              <a:defRPr sz="2775" b="1">
+              <a:defRPr sz="2400" b="1">
                 <a:solidFill>
                   <a:srgbClr val="2563EB"/>
                 </a:solidFill>
@@ -17527,7 +17555,7 @@
               </a:defRPr>
             </a:lvl3pPr>
             <a:lvl4pPr>
-              <a:defRPr sz="2775" b="1">
+              <a:defRPr sz="2400" b="1">
                 <a:solidFill>
                   <a:srgbClr val="2563EB"/>
                 </a:solidFill>
@@ -17537,7 +17565,7 @@
               </a:defRPr>
             </a:lvl4pPr>
             <a:lvl5pPr>
-              <a:defRPr sz="2775" b="1">
+              <a:defRPr sz="2400" b="1">
                 <a:solidFill>
                   <a:srgbClr val="2563EB"/>
                 </a:solidFill>
@@ -17547,7 +17575,7 @@
               </a:defRPr>
             </a:lvl5pPr>
             <a:lvl6pPr>
-              <a:defRPr sz="2775" b="1">
+              <a:defRPr sz="2400" b="1">
                 <a:solidFill>
                   <a:srgbClr val="2563EB"/>
                 </a:solidFill>
@@ -17557,7 +17585,7 @@
               </a:defRPr>
             </a:lvl6pPr>
             <a:lvl7pPr>
-              <a:defRPr sz="2775" b="1">
+              <a:defRPr sz="2400" b="1">
                 <a:solidFill>
                   <a:srgbClr val="2563EB"/>
                 </a:solidFill>
@@ -17567,7 +17595,7 @@
               </a:defRPr>
             </a:lvl7pPr>
             <a:lvl8pPr>
-              <a:defRPr sz="2775" b="1">
+              <a:defRPr sz="2400" b="1">
                 <a:solidFill>
                   <a:srgbClr val="2563EB"/>
                 </a:solidFill>
@@ -17577,7 +17605,7 @@
               </a:defRPr>
             </a:lvl8pPr>
             <a:lvl9pPr>
-              <a:defRPr sz="2775" b="1">
+              <a:defRPr sz="2400" b="1">
                 <a:solidFill>
                   <a:srgbClr val="2563EB"/>
                 </a:solidFill>
@@ -17589,7 +17617,7 @@
           </a:lstStyle>
           <a:p xmlns:a="http://schemas.openxmlformats.org/drawingml/2006/main">
             <a:pPr>
-              <a:defRPr sz="2775" b="1">
+              <a:defRPr sz="2400" b="1">
                 <a:solidFill>
                   <a:srgbClr val="2563EB"/>
                 </a:solidFill>
@@ -17599,7 +17627,7 @@
               </a:defRPr>
             </a:pPr>
             <a:r>
-              <a:rPr sz="2775" b="1">
+              <a:rPr sz="2400" b="1">
                 <a:solidFill>
                   <a:srgbClr val="2563EB"/>
                 </a:solidFill>
@@ -17614,10 +17642,10 @@
       </p:sp>
       <p:sp>
         <p:nvSpPr>
-          <p:cNvPr id="5" name="">
+          <p:cNvPr id="6" name="">
             <a:extLst xmlns:a="http://schemas.openxmlformats.org/drawingml/2006/main">
               <a:ext uri="{FF2B5EF4-FFF2-40B4-BE49-F238E27FC236}">
-                <a16:creationId xmlns:a16="http://schemas.microsoft.com/office/drawing/2014/main" id="{068EADA9-3438-4558-A90E-562E41431BF7}"/>
+                <a16:creationId xmlns:a16="http://schemas.microsoft.com/office/drawing/2014/main" id="{F98B4E45-E66D-4836-BF97-8C3315DEF5C8}"/>
               </a:ext>
             </a:extLst>
           </p:cNvPr>
@@ -17628,8 +17656,8 @@
         </p:nvSpPr>
         <p:spPr>
           <a:xfrm xmlns:a="http://schemas.openxmlformats.org/drawingml/2006/main">
-            <a:off x="609600" y="2381250"/>
-            <a:ext cx="3143250" cy="1809750"/>
+            <a:off x="8667750" y="2143125"/>
+            <a:ext cx="2857500" cy="809625"/>
           </a:xfrm>
           <a:prstGeom xmlns:a="http://schemas.openxmlformats.org/drawingml/2006/main" prst="rect">
             <a:avLst/>
@@ -17643,7 +17671,7 @@
           <a:bodyPr xmlns:a="http://schemas.openxmlformats.org/drawingml/2006/main"/>
           <a:lstStyle xmlns:a="http://schemas.openxmlformats.org/drawingml/2006/main">
             <a:defPPr>
-              <a:defRPr sz="2100" b="0">
+              <a:defRPr sz="1800" b="0">
                 <a:solidFill>
                   <a:srgbClr val="12233F"/>
                 </a:solidFill>
@@ -17653,7 +17681,7 @@
               </a:defRPr>
             </a:defPPr>
             <a:lvl1pPr>
-              <a:defRPr sz="2100" b="0">
+              <a:defRPr sz="1800" b="0">
                 <a:solidFill>
                   <a:srgbClr val="12233F"/>
                 </a:solidFill>
@@ -17663,7 +17691,7 @@
               </a:defRPr>
             </a:lvl1pPr>
             <a:lvl2pPr>
-              <a:defRPr sz="2100" b="0">
+              <a:defRPr sz="1800" b="0">
                 <a:solidFill>
                   <a:srgbClr val="12233F"/>
                 </a:solidFill>
@@ -17673,7 +17701,7 @@
               </a:defRPr>
             </a:lvl2pPr>
             <a:lvl3pPr>
-              <a:defRPr sz="2100" b="0">
+              <a:defRPr sz="1800" b="0">
                 <a:solidFill>
                   <a:srgbClr val="12233F"/>
                 </a:solidFill>
@@ -17683,7 +17711,7 @@
               </a:defRPr>
             </a:lvl3pPr>
             <a:lvl4pPr>
-              <a:defRPr sz="2100" b="0">
+              <a:defRPr sz="1800" b="0">
                 <a:solidFill>
                   <a:srgbClr val="12233F"/>
                 </a:solidFill>
@@ -17693,7 +17721,7 @@
               </a:defRPr>
             </a:lvl4pPr>
             <a:lvl5pPr>
-              <a:defRPr sz="2100" b="0">
+              <a:defRPr sz="1800" b="0">
                 <a:solidFill>
                   <a:srgbClr val="12233F"/>
                 </a:solidFill>
@@ -17703,7 +17731,7 @@
               </a:defRPr>
             </a:lvl5pPr>
             <a:lvl6pPr>
-              <a:defRPr sz="2100" b="0">
+              <a:defRPr sz="1800" b="0">
                 <a:solidFill>
                   <a:srgbClr val="12233F"/>
                 </a:solidFill>
@@ -17713,7 +17741,7 @@
               </a:defRPr>
             </a:lvl6pPr>
             <a:lvl7pPr>
-              <a:defRPr sz="2100" b="0">
+              <a:defRPr sz="1800" b="0">
                 <a:solidFill>
                   <a:srgbClr val="12233F"/>
                 </a:solidFill>
@@ -17723,7 +17751,7 @@
               </a:defRPr>
             </a:lvl7pPr>
             <a:lvl8pPr>
-              <a:defRPr sz="2100" b="0">
+              <a:defRPr sz="1800" b="0">
                 <a:solidFill>
                   <a:srgbClr val="12233F"/>
                 </a:solidFill>
@@ -17733,7 +17761,7 @@
               </a:defRPr>
             </a:lvl8pPr>
             <a:lvl9pPr>
-              <a:defRPr sz="2100" b="0">
+              <a:defRPr sz="1800" b="0">
                 <a:solidFill>
                   <a:srgbClr val="12233F"/>
                 </a:solidFill>
@@ -17745,7 +17773,7 @@
           </a:lstStyle>
           <a:p xmlns:a="http://schemas.openxmlformats.org/drawingml/2006/main">
             <a:pPr>
-              <a:defRPr sz="2100" b="0">
+              <a:defRPr sz="1800" b="0">
                 <a:solidFill>
                   <a:srgbClr val="12233F"/>
                 </a:solidFill>
@@ -17755,7 +17783,7 @@
               </a:defRPr>
             </a:pPr>
             <a:r>
-              <a:rPr sz="2100" b="0">
+              <a:rPr sz="1800" b="0">
                 <a:solidFill>
                   <a:srgbClr val="12233F"/>
                 </a:solidFill>
@@ -17763,17 +17791,17 @@
                 <a:ea typeface="Arial"/>
                 <a:cs typeface="Arial"/>
               </a:rPr>
-              <a:t>A playable office mission for learning migration concepts.</a:t>
+              <a:t>Explore an office and solve an evidence puzzle.</a:t>
             </a:r>
           </a:p>
         </p:txBody>
       </p:sp>
       <p:sp>
         <p:nvSpPr>
-          <p:cNvPr id="6" name="">
+          <p:cNvPr id="7" name="">
             <a:extLst xmlns:a="http://schemas.openxmlformats.org/drawingml/2006/main">
               <a:ext uri="{FF2B5EF4-FFF2-40B4-BE49-F238E27FC236}">
-                <a16:creationId xmlns:a16="http://schemas.microsoft.com/office/drawing/2014/main" id="{75514B5F-0462-4DA6-AB40-541E6CD96230}"/>
+                <a16:creationId xmlns:a16="http://schemas.microsoft.com/office/drawing/2014/main" id="{95F1782C-FF23-44E6-AA52-D3468B44D5E8}"/>
               </a:ext>
             </a:extLst>
           </p:cNvPr>
@@ -17784,8 +17812,8 @@
         </p:nvSpPr>
         <p:spPr>
           <a:xfrm xmlns:a="http://schemas.openxmlformats.org/drawingml/2006/main">
-            <a:off x="4429125" y="1666875"/>
-            <a:ext cx="3286125" cy="571500"/>
+            <a:off x="8667750" y="3143250"/>
+            <a:ext cx="2952750" cy="428625"/>
           </a:xfrm>
           <a:prstGeom xmlns:a="http://schemas.openxmlformats.org/drawingml/2006/main" prst="rect">
             <a:avLst/>
@@ -17799,7 +17827,7 @@
           <a:bodyPr xmlns:a="http://schemas.openxmlformats.org/drawingml/2006/main"/>
           <a:lstStyle xmlns:a="http://schemas.openxmlformats.org/drawingml/2006/main">
             <a:defPPr>
-              <a:defRPr sz="2775" b="1">
+              <a:defRPr sz="2400" b="1">
                 <a:solidFill>
                   <a:srgbClr val="2563EB"/>
                 </a:solidFill>
@@ -17809,7 +17837,7 @@
               </a:defRPr>
             </a:defPPr>
             <a:lvl1pPr>
-              <a:defRPr sz="2775" b="1">
+              <a:defRPr sz="2400" b="1">
                 <a:solidFill>
                   <a:srgbClr val="2563EB"/>
                 </a:solidFill>
@@ -17819,7 +17847,7 @@
               </a:defRPr>
             </a:lvl1pPr>
             <a:lvl2pPr>
-              <a:defRPr sz="2775" b="1">
+              <a:defRPr sz="2400" b="1">
                 <a:solidFill>
                   <a:srgbClr val="2563EB"/>
                 </a:solidFill>
@@ -17829,7 +17857,7 @@
               </a:defRPr>
             </a:lvl2pPr>
             <a:lvl3pPr>
-              <a:defRPr sz="2775" b="1">
+              <a:defRPr sz="2400" b="1">
                 <a:solidFill>
                   <a:srgbClr val="2563EB"/>
                 </a:solidFill>
@@ -17839,7 +17867,7 @@
               </a:defRPr>
             </a:lvl3pPr>
             <a:lvl4pPr>
-              <a:defRPr sz="2775" b="1">
+              <a:defRPr sz="2400" b="1">
                 <a:solidFill>
                   <a:srgbClr val="2563EB"/>
                 </a:solidFill>
@@ -17849,7 +17877,7 @@
               </a:defRPr>
             </a:lvl4pPr>
             <a:lvl5pPr>
-              <a:defRPr sz="2775" b="1">
+              <a:defRPr sz="2400" b="1">
                 <a:solidFill>
                   <a:srgbClr val="2563EB"/>
                 </a:solidFill>
@@ -17859,7 +17887,7 @@
               </a:defRPr>
             </a:lvl5pPr>
             <a:lvl6pPr>
-              <a:defRPr sz="2775" b="1">
+              <a:defRPr sz="2400" b="1">
                 <a:solidFill>
                   <a:srgbClr val="2563EB"/>
                 </a:solidFill>
@@ -17869,7 +17897,7 @@
               </a:defRPr>
             </a:lvl6pPr>
             <a:lvl7pPr>
-              <a:defRPr sz="2775" b="1">
+              <a:defRPr sz="2400" b="1">
                 <a:solidFill>
                   <a:srgbClr val="2563EB"/>
                 </a:solidFill>
@@ -17879,7 +17907,7 @@
               </a:defRPr>
             </a:lvl7pPr>
             <a:lvl8pPr>
-              <a:defRPr sz="2775" b="1">
+              <a:defRPr sz="2400" b="1">
                 <a:solidFill>
                   <a:srgbClr val="2563EB"/>
                 </a:solidFill>
@@ -17889,7 +17917,7 @@
               </a:defRPr>
             </a:lvl8pPr>
             <a:lvl9pPr>
-              <a:defRPr sz="2775" b="1">
+              <a:defRPr sz="2400" b="1">
                 <a:solidFill>
                   <a:srgbClr val="2563EB"/>
                 </a:solidFill>
@@ -17901,7 +17929,7 @@
           </a:lstStyle>
           <a:p xmlns:a="http://schemas.openxmlformats.org/drawingml/2006/main">
             <a:pPr>
-              <a:defRPr sz="2775" b="1">
+              <a:defRPr sz="2400" b="1">
                 <a:solidFill>
                   <a:srgbClr val="2563EB"/>
                 </a:solidFill>
@@ -17911,7 +17939,7 @@
               </a:defRPr>
             </a:pPr>
             <a:r>
-              <a:rPr sz="2775" b="1">
+              <a:rPr sz="2400" b="1">
                 <a:solidFill>
                   <a:srgbClr val="2563EB"/>
                 </a:solidFill>
@@ -17926,10 +17954,10 @@
       </p:sp>
       <p:sp>
         <p:nvSpPr>
-          <p:cNvPr id="7" name="">
+          <p:cNvPr id="8" name="">
             <a:extLst xmlns:a="http://schemas.openxmlformats.org/drawingml/2006/main">
               <a:ext uri="{FF2B5EF4-FFF2-40B4-BE49-F238E27FC236}">
-                <a16:creationId xmlns:a16="http://schemas.microsoft.com/office/drawing/2014/main" id="{824C6BCF-536E-4051-A3EC-3A3F4F2B6A8C}"/>
+                <a16:creationId xmlns:a16="http://schemas.microsoft.com/office/drawing/2014/main" id="{AD9DFADF-A017-47FF-8B3D-358C4A87F1EC}"/>
               </a:ext>
             </a:extLst>
           </p:cNvPr>
@@ -17940,8 +17968,8 @@
         </p:nvSpPr>
         <p:spPr>
           <a:xfrm xmlns:a="http://schemas.openxmlformats.org/drawingml/2006/main">
-            <a:off x="4429125" y="2381250"/>
-            <a:ext cx="3143250" cy="1809750"/>
+            <a:off x="8667750" y="3667125"/>
+            <a:ext cx="2857500" cy="809625"/>
           </a:xfrm>
           <a:prstGeom xmlns:a="http://schemas.openxmlformats.org/drawingml/2006/main" prst="rect">
             <a:avLst/>
@@ -17955,7 +17983,7 @@
           <a:bodyPr xmlns:a="http://schemas.openxmlformats.org/drawingml/2006/main"/>
           <a:lstStyle xmlns:a="http://schemas.openxmlformats.org/drawingml/2006/main">
             <a:defPPr>
-              <a:defRPr sz="2100" b="0">
+              <a:defRPr sz="1800" b="0">
                 <a:solidFill>
                   <a:srgbClr val="12233F"/>
                 </a:solidFill>
@@ -17965,7 +17993,7 @@
               </a:defRPr>
             </a:defPPr>
             <a:lvl1pPr>
-              <a:defRPr sz="2100" b="0">
+              <a:defRPr sz="1800" b="0">
                 <a:solidFill>
                   <a:srgbClr val="12233F"/>
                 </a:solidFill>
@@ -17975,7 +18003,7 @@
               </a:defRPr>
             </a:lvl1pPr>
             <a:lvl2pPr>
-              <a:defRPr sz="2100" b="0">
+              <a:defRPr sz="1800" b="0">
                 <a:solidFill>
                   <a:srgbClr val="12233F"/>
                 </a:solidFill>
@@ -17985,7 +18013,7 @@
               </a:defRPr>
             </a:lvl2pPr>
             <a:lvl3pPr>
-              <a:defRPr sz="2100" b="0">
+              <a:defRPr sz="1800" b="0">
                 <a:solidFill>
                   <a:srgbClr val="12233F"/>
                 </a:solidFill>
@@ -17995,7 +18023,7 @@
               </a:defRPr>
             </a:lvl3pPr>
             <a:lvl4pPr>
-              <a:defRPr sz="2100" b="0">
+              <a:defRPr sz="1800" b="0">
                 <a:solidFill>
                   <a:srgbClr val="12233F"/>
                 </a:solidFill>
@@ -18005,7 +18033,7 @@
               </a:defRPr>
             </a:lvl4pPr>
             <a:lvl5pPr>
-              <a:defRPr sz="2100" b="0">
+              <a:defRPr sz="1800" b="0">
                 <a:solidFill>
                   <a:srgbClr val="12233F"/>
                 </a:solidFill>
@@ -18015,7 +18043,7 @@
               </a:defRPr>
             </a:lvl5pPr>
             <a:lvl6pPr>
-              <a:defRPr sz="2100" b="0">
+              <a:defRPr sz="1800" b="0">
                 <a:solidFill>
                   <a:srgbClr val="12233F"/>
                 </a:solidFill>
@@ -18025,7 +18053,7 @@
               </a:defRPr>
             </a:lvl6pPr>
             <a:lvl7pPr>
-              <a:defRPr sz="2100" b="0">
+              <a:defRPr sz="1800" b="0">
                 <a:solidFill>
                   <a:srgbClr val="12233F"/>
                 </a:solidFill>
@@ -18035,7 +18063,7 @@
               </a:defRPr>
             </a:lvl7pPr>
             <a:lvl8pPr>
-              <a:defRPr sz="2100" b="0">
+              <a:defRPr sz="1800" b="0">
                 <a:solidFill>
                   <a:srgbClr val="12233F"/>
                 </a:solidFill>
@@ -18045,7 +18073,7 @@
               </a:defRPr>
             </a:lvl8pPr>
             <a:lvl9pPr>
-              <a:defRPr sz="2100" b="0">
+              <a:defRPr sz="1800" b="0">
                 <a:solidFill>
                   <a:srgbClr val="12233F"/>
                 </a:solidFill>
@@ -18057,7 +18085,7 @@
           </a:lstStyle>
           <a:p xmlns:a="http://schemas.openxmlformats.org/drawingml/2006/main">
             <a:pPr>
-              <a:defRPr sz="2100" b="0">
+              <a:defRPr sz="1800" b="0">
                 <a:solidFill>
                   <a:srgbClr val="12233F"/>
                 </a:solidFill>
@@ -18067,7 +18095,7 @@
               </a:defRPr>
             </a:pPr>
             <a:r>
-              <a:rPr sz="2100" b="0">
+              <a:rPr sz="1800" b="0">
                 <a:solidFill>
                   <a:srgbClr val="12233F"/>
                 </a:solidFill>
@@ -18075,17 +18103,17 @@
                 <a:ea typeface="Arial"/>
                 <a:cs typeface="Arial"/>
               </a:rPr>
-              <a:t>A complete Harbor Light Books synthetic migration rehearsal.</a:t>
+              <a:t>Rehearse Harbor Light Books through verified FPU.</a:t>
             </a:r>
           </a:p>
         </p:txBody>
       </p:sp>
       <p:sp>
         <p:nvSpPr>
-          <p:cNvPr id="8" name="">
+          <p:cNvPr id="9" name="">
             <a:extLst xmlns:a="http://schemas.openxmlformats.org/drawingml/2006/main">
               <a:ext uri="{FF2B5EF4-FFF2-40B4-BE49-F238E27FC236}">
-                <a16:creationId xmlns:a16="http://schemas.microsoft.com/office/drawing/2014/main" id="{BE7291EC-587C-4786-B0BD-C4ED579059DF}"/>
+                <a16:creationId xmlns:a16="http://schemas.microsoft.com/office/drawing/2014/main" id="{B01A6419-27F3-4BE0-8647-97042CA5E480}"/>
               </a:ext>
             </a:extLst>
           </p:cNvPr>
@@ -18096,8 +18124,8 @@
         </p:nvSpPr>
         <p:spPr>
           <a:xfrm xmlns:a="http://schemas.openxmlformats.org/drawingml/2006/main">
-            <a:off x="8248650" y="1666875"/>
-            <a:ext cx="3333750" cy="571500"/>
+            <a:off x="8667750" y="4667250"/>
+            <a:ext cx="2952750" cy="428625"/>
           </a:xfrm>
           <a:prstGeom xmlns:a="http://schemas.openxmlformats.org/drawingml/2006/main" prst="rect">
             <a:avLst/>
@@ -18111,7 +18139,7 @@
           <a:bodyPr xmlns:a="http://schemas.openxmlformats.org/drawingml/2006/main"/>
           <a:lstStyle xmlns:a="http://schemas.openxmlformats.org/drawingml/2006/main">
             <a:defPPr>
-              <a:defRPr sz="2775" b="1">
+              <a:defRPr sz="2400" b="1">
                 <a:solidFill>
                   <a:srgbClr val="2563EB"/>
                 </a:solidFill>
@@ -18121,7 +18149,7 @@
               </a:defRPr>
             </a:defPPr>
             <a:lvl1pPr>
-              <a:defRPr sz="2775" b="1">
+              <a:defRPr sz="2400" b="1">
                 <a:solidFill>
                   <a:srgbClr val="2563EB"/>
                 </a:solidFill>
@@ -18131,7 +18159,7 @@
               </a:defRPr>
             </a:lvl1pPr>
             <a:lvl2pPr>
-              <a:defRPr sz="2775" b="1">
+              <a:defRPr sz="2400" b="1">
                 <a:solidFill>
                   <a:srgbClr val="2563EB"/>
                 </a:solidFill>
@@ -18141,7 +18169,7 @@
               </a:defRPr>
             </a:lvl2pPr>
             <a:lvl3pPr>
-              <a:defRPr sz="2775" b="1">
+              <a:defRPr sz="2400" b="1">
                 <a:solidFill>
                   <a:srgbClr val="2563EB"/>
                 </a:solidFill>
@@ -18151,7 +18179,7 @@
               </a:defRPr>
             </a:lvl3pPr>
             <a:lvl4pPr>
-              <a:defRPr sz="2775" b="1">
+              <a:defRPr sz="2400" b="1">
                 <a:solidFill>
                   <a:srgbClr val="2563EB"/>
                 </a:solidFill>
@@ -18161,7 +18189,7 @@
               </a:defRPr>
             </a:lvl4pPr>
             <a:lvl5pPr>
-              <a:defRPr sz="2775" b="1">
+              <a:defRPr sz="2400" b="1">
                 <a:solidFill>
                   <a:srgbClr val="2563EB"/>
                 </a:solidFill>
@@ -18171,7 +18199,7 @@
               </a:defRPr>
             </a:lvl5pPr>
             <a:lvl6pPr>
-              <a:defRPr sz="2775" b="1">
+              <a:defRPr sz="2400" b="1">
                 <a:solidFill>
                   <a:srgbClr val="2563EB"/>
                 </a:solidFill>
@@ -18181,7 +18209,7 @@
               </a:defRPr>
             </a:lvl6pPr>
             <a:lvl7pPr>
-              <a:defRPr sz="2775" b="1">
+              <a:defRPr sz="2400" b="1">
                 <a:solidFill>
                   <a:srgbClr val="2563EB"/>
                 </a:solidFill>
@@ -18191,7 +18219,7 @@
               </a:defRPr>
             </a:lvl7pPr>
             <a:lvl8pPr>
-              <a:defRPr sz="2775" b="1">
+              <a:defRPr sz="2400" b="1">
                 <a:solidFill>
                   <a:srgbClr val="2563EB"/>
                 </a:solidFill>
@@ -18201,7 +18229,7 @@
               </a:defRPr>
             </a:lvl8pPr>
             <a:lvl9pPr>
-              <a:defRPr sz="2775" b="1">
+              <a:defRPr sz="2400" b="1">
                 <a:solidFill>
                   <a:srgbClr val="2563EB"/>
                 </a:solidFill>
@@ -18213,7 +18241,7 @@
           </a:lstStyle>
           <a:p xmlns:a="http://schemas.openxmlformats.org/drawingml/2006/main">
             <a:pPr>
-              <a:defRPr sz="2775" b="1">
+              <a:defRPr sz="2400" b="1">
                 <a:solidFill>
                   <a:srgbClr val="2563EB"/>
                 </a:solidFill>
@@ -18223,7 +18251,7 @@
               </a:defRPr>
             </a:pPr>
             <a:r>
-              <a:rPr sz="2775" b="1">
+              <a:rPr sz="2400" b="1">
                 <a:solidFill>
                   <a:srgbClr val="2563EB"/>
                 </a:solidFill>
@@ -18238,10 +18266,10 @@
       </p:sp>
       <p:sp>
         <p:nvSpPr>
-          <p:cNvPr id="9" name="">
+          <p:cNvPr id="10" name="">
             <a:extLst xmlns:a="http://schemas.openxmlformats.org/drawingml/2006/main">
               <a:ext uri="{FF2B5EF4-FFF2-40B4-BE49-F238E27FC236}">
-                <a16:creationId xmlns:a16="http://schemas.microsoft.com/office/drawing/2014/main" id="{13A80688-940F-4FB0-9342-C03540D352A5}"/>
+                <a16:creationId xmlns:a16="http://schemas.microsoft.com/office/drawing/2014/main" id="{60D4877A-49E3-4EA0-A865-F43F9D7AAB74}"/>
               </a:ext>
             </a:extLst>
           </p:cNvPr>
@@ -18252,8 +18280,8 @@
         </p:nvSpPr>
         <p:spPr>
           <a:xfrm xmlns:a="http://schemas.openxmlformats.org/drawingml/2006/main">
-            <a:off x="8248650" y="2381250"/>
-            <a:ext cx="3143250" cy="2000250"/>
+            <a:off x="8667750" y="5191125"/>
+            <a:ext cx="2857500" cy="904875"/>
           </a:xfrm>
           <a:prstGeom xmlns:a="http://schemas.openxmlformats.org/drawingml/2006/main" prst="rect">
             <a:avLst/>
@@ -18267,7 +18295,7 @@
           <a:bodyPr xmlns:a="http://schemas.openxmlformats.org/drawingml/2006/main"/>
           <a:lstStyle xmlns:a="http://schemas.openxmlformats.org/drawingml/2006/main">
             <a:defPPr>
-              <a:defRPr sz="2100" b="0">
+              <a:defRPr sz="1800" b="0">
                 <a:solidFill>
                   <a:srgbClr val="12233F"/>
                 </a:solidFill>
@@ -18277,7 +18305,7 @@
               </a:defRPr>
             </a:defPPr>
             <a:lvl1pPr>
-              <a:defRPr sz="2100" b="0">
+              <a:defRPr sz="1800" b="0">
                 <a:solidFill>
                   <a:srgbClr val="12233F"/>
                 </a:solidFill>
@@ -18287,7 +18315,7 @@
               </a:defRPr>
             </a:lvl1pPr>
             <a:lvl2pPr>
-              <a:defRPr sz="2100" b="0">
+              <a:defRPr sz="1800" b="0">
                 <a:solidFill>
                   <a:srgbClr val="12233F"/>
                 </a:solidFill>
@@ -18297,7 +18325,7 @@
               </a:defRPr>
             </a:lvl2pPr>
             <a:lvl3pPr>
-              <a:defRPr sz="2100" b="0">
+              <a:defRPr sz="1800" b="0">
                 <a:solidFill>
                   <a:srgbClr val="12233F"/>
                 </a:solidFill>
@@ -18307,7 +18335,7 @@
               </a:defRPr>
             </a:lvl3pPr>
             <a:lvl4pPr>
-              <a:defRPr sz="2100" b="0">
+              <a:defRPr sz="1800" b="0">
                 <a:solidFill>
                   <a:srgbClr val="12233F"/>
                 </a:solidFill>
@@ -18317,7 +18345,7 @@
               </a:defRPr>
             </a:lvl4pPr>
             <a:lvl5pPr>
-              <a:defRPr sz="2100" b="0">
+              <a:defRPr sz="1800" b="0">
                 <a:solidFill>
                   <a:srgbClr val="12233F"/>
                 </a:solidFill>
@@ -18327,7 +18355,7 @@
               </a:defRPr>
             </a:lvl5pPr>
             <a:lvl6pPr>
-              <a:defRPr sz="2100" b="0">
+              <a:defRPr sz="1800" b="0">
                 <a:solidFill>
                   <a:srgbClr val="12233F"/>
                 </a:solidFill>
@@ -18337,7 +18365,7 @@
               </a:defRPr>
             </a:lvl6pPr>
             <a:lvl7pPr>
-              <a:defRPr sz="2100" b="0">
+              <a:defRPr sz="1800" b="0">
                 <a:solidFill>
                   <a:srgbClr val="12233F"/>
                 </a:solidFill>
@@ -18347,7 +18375,7 @@
               </a:defRPr>
             </a:lvl7pPr>
             <a:lvl8pPr>
-              <a:defRPr sz="2100" b="0">
+              <a:defRPr sz="1800" b="0">
                 <a:solidFill>
                   <a:srgbClr val="12233F"/>
                 </a:solidFill>
@@ -18357,7 +18385,7 @@
               </a:defRPr>
             </a:lvl8pPr>
             <a:lvl9pPr>
-              <a:defRPr sz="2100" b="0">
+              <a:defRPr sz="1800" b="0">
                 <a:solidFill>
                   <a:srgbClr val="12233F"/>
                 </a:solidFill>
@@ -18369,7 +18397,7 @@
           </a:lstStyle>
           <a:p xmlns:a="http://schemas.openxmlformats.org/drawingml/2006/main">
             <a:pPr>
-              <a:defRPr sz="2100" b="0">
+              <a:defRPr sz="1800" b="0">
                 <a:solidFill>
                   <a:srgbClr val="12233F"/>
                 </a:solidFill>
@@ -18379,7 +18407,7 @@
               </a:defRPr>
             </a:pPr>
             <a:r>
-              <a:rPr sz="2100" b="0">
+              <a:rPr sz="1800" b="0">
                 <a:solidFill>
                   <a:srgbClr val="12233F"/>
                 </a:solidFill>
@@ -18387,17 +18415,17 @@
                 <a:ea typeface="Arial"/>
                 <a:cs typeface="Arial"/>
               </a:rPr>
-              <a:t>Validation of permitted test packages. Hosted uploads remain separately gated.</a:t>
+              <a:t>Validate permitted test packages locally. Hosted uploads stay gated.</a:t>
             </a:r>
           </a:p>
         </p:txBody>
       </p:sp>
       <p:sp>
         <p:nvSpPr>
-          <p:cNvPr id="10" name="">
+          <p:cNvPr id="11" name="">
             <a:extLst xmlns:a="http://schemas.openxmlformats.org/drawingml/2006/main">
               <a:ext uri="{FF2B5EF4-FFF2-40B4-BE49-F238E27FC236}">
-                <a16:creationId xmlns:a16="http://schemas.microsoft.com/office/drawing/2014/main" id="{A14E6375-843D-44B4-A107-964ECB9B435C}"/>
+                <a16:creationId xmlns:a16="http://schemas.microsoft.com/office/drawing/2014/main" id="{7B6B0F24-23ED-4303-B142-1D5067EC45A8}"/>
               </a:ext>
             </a:extLst>
           </p:cNvPr>
@@ -18408,8 +18436,8 @@
         </p:nvSpPr>
         <p:spPr>
           <a:xfrm xmlns:a="http://schemas.openxmlformats.org/drawingml/2006/main">
-            <a:off x="609600" y="5334000"/>
-            <a:ext cx="10477500" cy="476250"/>
+            <a:off x="609600" y="6000750"/>
+            <a:ext cx="7620000" cy="266700"/>
           </a:xfrm>
           <a:prstGeom xmlns:a="http://schemas.openxmlformats.org/drawingml/2006/main" prst="rect">
             <a:avLst/>
@@ -18423,7 +18451,7 @@
           <a:bodyPr xmlns:a="http://schemas.openxmlformats.org/drawingml/2006/main"/>
           <a:lstStyle xmlns:a="http://schemas.openxmlformats.org/drawingml/2006/main">
             <a:defPPr>
-              <a:defRPr sz="1950" b="0">
+              <a:defRPr sz="1350" b="0">
                 <a:solidFill>
                   <a:srgbClr val="50657F"/>
                 </a:solidFill>
@@ -18433,7 +18461,7 @@
               </a:defRPr>
             </a:defPPr>
             <a:lvl1pPr>
-              <a:defRPr sz="1950" b="0">
+              <a:defRPr sz="1350" b="0">
                 <a:solidFill>
                   <a:srgbClr val="50657F"/>
                 </a:solidFill>
@@ -18443,7 +18471,7 @@
               </a:defRPr>
             </a:lvl1pPr>
             <a:lvl2pPr>
-              <a:defRPr sz="1950" b="0">
+              <a:defRPr sz="1350" b="0">
                 <a:solidFill>
                   <a:srgbClr val="50657F"/>
                 </a:solidFill>
@@ -18453,7 +18481,7 @@
               </a:defRPr>
             </a:lvl2pPr>
             <a:lvl3pPr>
-              <a:defRPr sz="1950" b="0">
+              <a:defRPr sz="1350" b="0">
                 <a:solidFill>
                   <a:srgbClr val="50657F"/>
                 </a:solidFill>
@@ -18463,7 +18491,7 @@
               </a:defRPr>
             </a:lvl3pPr>
             <a:lvl4pPr>
-              <a:defRPr sz="1950" b="0">
+              <a:defRPr sz="1350" b="0">
                 <a:solidFill>
                   <a:srgbClr val="50657F"/>
                 </a:solidFill>
@@ -18473,7 +18501,7 @@
               </a:defRPr>
             </a:lvl4pPr>
             <a:lvl5pPr>
-              <a:defRPr sz="1950" b="0">
+              <a:defRPr sz="1350" b="0">
                 <a:solidFill>
                   <a:srgbClr val="50657F"/>
                 </a:solidFill>
@@ -18483,7 +18511,7 @@
               </a:defRPr>
             </a:lvl5pPr>
             <a:lvl6pPr>
-              <a:defRPr sz="1950" b="0">
+              <a:defRPr sz="1350" b="0">
                 <a:solidFill>
                   <a:srgbClr val="50657F"/>
                 </a:solidFill>
@@ -18493,7 +18521,7 @@
               </a:defRPr>
             </a:lvl6pPr>
             <a:lvl7pPr>
-              <a:defRPr sz="1950" b="0">
+              <a:defRPr sz="1350" b="0">
                 <a:solidFill>
                   <a:srgbClr val="50657F"/>
                 </a:solidFill>
@@ -18503,7 +18531,7 @@
               </a:defRPr>
             </a:lvl7pPr>
             <a:lvl8pPr>
-              <a:defRPr sz="1950" b="0">
+              <a:defRPr sz="1350" b="0">
                 <a:solidFill>
                   <a:srgbClr val="50657F"/>
                 </a:solidFill>
@@ -18513,7 +18541,7 @@
               </a:defRPr>
             </a:lvl8pPr>
             <a:lvl9pPr>
-              <a:defRPr sz="1950" b="0">
+              <a:defRPr sz="1350" b="0">
                 <a:solidFill>
                   <a:srgbClr val="50657F"/>
                 </a:solidFill>
@@ -18525,7 +18553,7 @@
           </a:lstStyle>
           <a:p xmlns:a="http://schemas.openxmlformats.org/drawingml/2006/main">
             <a:pPr>
-              <a:defRPr sz="1950" b="0">
+              <a:defRPr sz="1350" b="0">
                 <a:solidFill>
                   <a:srgbClr val="50657F"/>
                 </a:solidFill>
@@ -18535,7 +18563,7 @@
               </a:defRPr>
             </a:pPr>
             <a:r>
-              <a:rPr sz="1950" b="0">
+              <a:rPr sz="1350" b="0">
                 <a:solidFill>
                   <a:srgbClr val="50657F"/>
                 </a:solidFill>
@@ -18543,7 +18571,7 @@
                 <a:ea typeface="Arial"/>
                 <a:cs typeface="Arial"/>
               </a:rPr>
-              <a:t>All paths preserve the same financial and approval boundaries.</a:t>
+              <a:t>Authentic local candidate capture. Play acceptance: 14 browser checks passed.</a:t>
             </a:r>
           </a:p>
         </p:txBody>
@@ -18551,7 +18579,7 @@
     </p:spTree>
     <p:extLst>
       <p:ext uri="{BB962C8B-B14F-4D97-AF65-F5344CB8AC3E}">
-        <p14:creationId xmlns:p14="http://schemas.microsoft.com/office/powerpoint/2010/main" val="310920385"/>
+        <p14:creationId xmlns:p14="http://schemas.microsoft.com/office/powerpoint/2010/main" val="15654975"/>
       </p:ext>
     </p:extLst>
   </p:cSld>
@@ -18582,7 +18610,7 @@
           <p:cNvPr id="20" name="">
             <a:extLst xmlns:a="http://schemas.openxmlformats.org/drawingml/2006/main">
               <a:ext uri="{FF2B5EF4-FFF2-40B4-BE49-F238E27FC236}">
-                <a16:creationId xmlns:a16="http://schemas.microsoft.com/office/drawing/2014/main" id="{74393BE1-E20F-45D8-BC64-A3769D33B632}"/>
+                <a16:creationId xmlns:a16="http://schemas.microsoft.com/office/drawing/2014/main" id="{9A2708AD-6966-41CA-8DD5-C0D5E2D913DD}"/>
               </a:ext>
             </a:extLst>
           </p:cNvPr>
@@ -18738,7 +18766,7 @@
           <p:cNvPr id="2" name="">
             <a:extLst xmlns:a="http://schemas.openxmlformats.org/drawingml/2006/main">
               <a:ext uri="{FF2B5EF4-FFF2-40B4-BE49-F238E27FC236}">
-                <a16:creationId xmlns:a16="http://schemas.microsoft.com/office/drawing/2014/main" id="{13987F97-A7B5-4D0C-8F83-03EEEA70A4C1}"/>
+                <a16:creationId xmlns:a16="http://schemas.microsoft.com/office/drawing/2014/main" id="{5758A936-314E-4A96-A473-B103502CC78B}"/>
               </a:ext>
             </a:extLst>
           </p:cNvPr>
@@ -18894,7 +18922,7 @@
           <p:cNvPr id="3" name="">
             <a:extLst xmlns:a="http://schemas.openxmlformats.org/drawingml/2006/main">
               <a:ext uri="{FF2B5EF4-FFF2-40B4-BE49-F238E27FC236}">
-                <a16:creationId xmlns:a16="http://schemas.microsoft.com/office/drawing/2014/main" id="{3E0BC458-2723-42CD-80BD-7DBEEA368105}"/>
+                <a16:creationId xmlns:a16="http://schemas.microsoft.com/office/drawing/2014/main" id="{C6181259-3D5E-471E-B1B7-2ADC41E6EE50}"/>
               </a:ext>
             </a:extLst>
           </p:cNvPr>
@@ -19050,7 +19078,7 @@
           <p:cNvPr id="4" name="">
             <a:extLst xmlns:a="http://schemas.openxmlformats.org/drawingml/2006/main">
               <a:ext uri="{FF2B5EF4-FFF2-40B4-BE49-F238E27FC236}">
-                <a16:creationId xmlns:a16="http://schemas.microsoft.com/office/drawing/2014/main" id="{795A8483-D9CE-48BB-AFCE-2D9FCC506B53}"/>
+                <a16:creationId xmlns:a16="http://schemas.microsoft.com/office/drawing/2014/main" id="{2CF3E7F4-32A2-43FE-93C3-EED81DE41243}"/>
               </a:ext>
             </a:extLst>
           </p:cNvPr>
@@ -19206,7 +19234,7 @@
           <p:cNvPr id="5" name="">
             <a:extLst xmlns:a="http://schemas.openxmlformats.org/drawingml/2006/main">
               <a:ext uri="{FF2B5EF4-FFF2-40B4-BE49-F238E27FC236}">
-                <a16:creationId xmlns:a16="http://schemas.microsoft.com/office/drawing/2014/main" id="{7DE34C00-F41C-45A8-A23A-6E87754A91C7}"/>
+                <a16:creationId xmlns:a16="http://schemas.microsoft.com/office/drawing/2014/main" id="{18E511A6-E9D8-4645-A701-55A6D229FE5B}"/>
               </a:ext>
             </a:extLst>
           </p:cNvPr>
@@ -19362,7 +19390,7 @@
           <p:cNvPr id="6" name="">
             <a:extLst xmlns:a="http://schemas.openxmlformats.org/drawingml/2006/main">
               <a:ext uri="{FF2B5EF4-FFF2-40B4-BE49-F238E27FC236}">
-                <a16:creationId xmlns:a16="http://schemas.microsoft.com/office/drawing/2014/main" id="{FB3904BC-55E4-4812-A14F-9FAF4FB60793}"/>
+                <a16:creationId xmlns:a16="http://schemas.microsoft.com/office/drawing/2014/main" id="{752283BF-E67E-44A5-BD5A-BEF1BC78D0E0}"/>
               </a:ext>
             </a:extLst>
           </p:cNvPr>
@@ -19518,7 +19546,7 @@
           <p:cNvPr id="7" name="">
             <a:extLst xmlns:a="http://schemas.openxmlformats.org/drawingml/2006/main">
               <a:ext uri="{FF2B5EF4-FFF2-40B4-BE49-F238E27FC236}">
-                <a16:creationId xmlns:a16="http://schemas.microsoft.com/office/drawing/2014/main" id="{B891BCB6-A81D-45B2-8A57-966BF059E70A}"/>
+                <a16:creationId xmlns:a16="http://schemas.microsoft.com/office/drawing/2014/main" id="{B5F6F77F-766F-477F-8BE8-6C538889DF36}"/>
               </a:ext>
             </a:extLst>
           </p:cNvPr>
@@ -19674,7 +19702,7 @@
           <p:cNvPr id="8" name="">
             <a:extLst xmlns:a="http://schemas.openxmlformats.org/drawingml/2006/main">
               <a:ext uri="{FF2B5EF4-FFF2-40B4-BE49-F238E27FC236}">
-                <a16:creationId xmlns:a16="http://schemas.microsoft.com/office/drawing/2014/main" id="{AF0544F9-E6B8-452B-AE45-D36F7FBFC030}"/>
+                <a16:creationId xmlns:a16="http://schemas.microsoft.com/office/drawing/2014/main" id="{5A89CD3B-B138-49EB-8D9B-7181477D99A3}"/>
               </a:ext>
             </a:extLst>
           </p:cNvPr>
@@ -19830,7 +19858,7 @@
           <p:cNvPr id="9" name="">
             <a:extLst xmlns:a="http://schemas.openxmlformats.org/drawingml/2006/main">
               <a:ext uri="{FF2B5EF4-FFF2-40B4-BE49-F238E27FC236}">
-                <a16:creationId xmlns:a16="http://schemas.microsoft.com/office/drawing/2014/main" id="{922DB406-E2B7-40A2-9B23-8EE51CF42549}"/>
+                <a16:creationId xmlns:a16="http://schemas.microsoft.com/office/drawing/2014/main" id="{BCBF4556-1CD3-44B7-BD00-2371564C9CD4}"/>
               </a:ext>
             </a:extLst>
           </p:cNvPr>
@@ -19986,7 +20014,7 @@
           <p:cNvPr id="10" name="">
             <a:extLst xmlns:a="http://schemas.openxmlformats.org/drawingml/2006/main">
               <a:ext uri="{FF2B5EF4-FFF2-40B4-BE49-F238E27FC236}">
-                <a16:creationId xmlns:a16="http://schemas.microsoft.com/office/drawing/2014/main" id="{D22D826F-5E7C-4C3F-8E17-3E72562BD37C}"/>
+                <a16:creationId xmlns:a16="http://schemas.microsoft.com/office/drawing/2014/main" id="{1C8D95A5-41CE-404B-A4AB-D23A43F2D0BA}"/>
               </a:ext>
             </a:extLst>
           </p:cNvPr>
@@ -20142,7 +20170,7 @@
           <p:cNvPr id="11" name="">
             <a:extLst xmlns:a="http://schemas.openxmlformats.org/drawingml/2006/main">
               <a:ext uri="{FF2B5EF4-FFF2-40B4-BE49-F238E27FC236}">
-                <a16:creationId xmlns:a16="http://schemas.microsoft.com/office/drawing/2014/main" id="{2A5F806B-D75F-452D-847F-F33F123C41EE}"/>
+                <a16:creationId xmlns:a16="http://schemas.microsoft.com/office/drawing/2014/main" id="{C7AD182A-CF54-41A2-BBF3-4A9CD307227F}"/>
               </a:ext>
             </a:extLst>
           </p:cNvPr>
@@ -20298,7 +20326,7 @@
           <p:cNvPr id="12" name="">
             <a:extLst xmlns:a="http://schemas.openxmlformats.org/drawingml/2006/main">
               <a:ext uri="{FF2B5EF4-FFF2-40B4-BE49-F238E27FC236}">
-                <a16:creationId xmlns:a16="http://schemas.microsoft.com/office/drawing/2014/main" id="{856CBC42-71E8-4B50-B023-F94AEFF25712}"/>
+                <a16:creationId xmlns:a16="http://schemas.microsoft.com/office/drawing/2014/main" id="{EAB137A1-CBC4-4959-BD2B-1B782BABE33F}"/>
               </a:ext>
             </a:extLst>
           </p:cNvPr>
@@ -20454,7 +20482,7 @@
           <p:cNvPr id="13" name="">
             <a:extLst xmlns:a="http://schemas.openxmlformats.org/drawingml/2006/main">
               <a:ext uri="{FF2B5EF4-FFF2-40B4-BE49-F238E27FC236}">
-                <a16:creationId xmlns:a16="http://schemas.microsoft.com/office/drawing/2014/main" id="{43F9EE39-D284-491E-9E83-E4D40E0B357A}"/>
+                <a16:creationId xmlns:a16="http://schemas.microsoft.com/office/drawing/2014/main" id="{E3637051-3341-4ED5-B256-A3FF88C67DC3}"/>
               </a:ext>
             </a:extLst>
           </p:cNvPr>
@@ -20610,7 +20638,7 @@
           <p:cNvPr id="14" name="">
             <a:extLst xmlns:a="http://schemas.openxmlformats.org/drawingml/2006/main">
               <a:ext uri="{FF2B5EF4-FFF2-40B4-BE49-F238E27FC236}">
-                <a16:creationId xmlns:a16="http://schemas.microsoft.com/office/drawing/2014/main" id="{103EB8B4-41C6-452A-84F4-1B1582B02F87}"/>
+                <a16:creationId xmlns:a16="http://schemas.microsoft.com/office/drawing/2014/main" id="{1BC0A4E3-693D-42AF-A2CC-775D3F3BFA89}"/>
               </a:ext>
             </a:extLst>
           </p:cNvPr>
@@ -20766,7 +20794,7 @@
           <p:cNvPr id="15" name="">
             <a:extLst xmlns:a="http://schemas.openxmlformats.org/drawingml/2006/main">
               <a:ext uri="{FF2B5EF4-FFF2-40B4-BE49-F238E27FC236}">
-                <a16:creationId xmlns:a16="http://schemas.microsoft.com/office/drawing/2014/main" id="{BFC81A09-87DF-4B2D-942C-E09CF1A3E90B}"/>
+                <a16:creationId xmlns:a16="http://schemas.microsoft.com/office/drawing/2014/main" id="{72651BDD-52DA-4F2B-B8F8-B11C7CF811F8}"/>
               </a:ext>
             </a:extLst>
           </p:cNvPr>
@@ -20922,7 +20950,7 @@
           <p:cNvPr id="16" name="">
             <a:extLst xmlns:a="http://schemas.openxmlformats.org/drawingml/2006/main">
               <a:ext uri="{FF2B5EF4-FFF2-40B4-BE49-F238E27FC236}">
-                <a16:creationId xmlns:a16="http://schemas.microsoft.com/office/drawing/2014/main" id="{AD8FA490-2B73-4189-B33F-30DED7F1886D}"/>
+                <a16:creationId xmlns:a16="http://schemas.microsoft.com/office/drawing/2014/main" id="{3610C6FE-A1AC-4294-ADB4-3C650DC0518B}"/>
               </a:ext>
             </a:extLst>
           </p:cNvPr>
@@ -21078,7 +21106,7 @@
           <p:cNvPr id="17" name="">
             <a:extLst xmlns:a="http://schemas.openxmlformats.org/drawingml/2006/main">
               <a:ext uri="{FF2B5EF4-FFF2-40B4-BE49-F238E27FC236}">
-                <a16:creationId xmlns:a16="http://schemas.microsoft.com/office/drawing/2014/main" id="{A599F993-C702-4C4A-83E9-9C37AEAB852D}"/>
+                <a16:creationId xmlns:a16="http://schemas.microsoft.com/office/drawing/2014/main" id="{0D98819D-5D5F-42C3-8056-9049D51E1F49}"/>
               </a:ext>
             </a:extLst>
           </p:cNvPr>
@@ -21234,7 +21262,7 @@
           <p:cNvPr id="18" name="">
             <a:extLst xmlns:a="http://schemas.openxmlformats.org/drawingml/2006/main">
               <a:ext uri="{FF2B5EF4-FFF2-40B4-BE49-F238E27FC236}">
-                <a16:creationId xmlns:a16="http://schemas.microsoft.com/office/drawing/2014/main" id="{5C0EC726-5D4F-4EE9-A1A4-544B2674D3AB}"/>
+                <a16:creationId xmlns:a16="http://schemas.microsoft.com/office/drawing/2014/main" id="{DCA14930-7ED8-43AA-B843-441DAA356F4F}"/>
               </a:ext>
             </a:extLst>
           </p:cNvPr>
@@ -21390,7 +21418,7 @@
           <p:cNvPr id="19" name="">
             <a:extLst xmlns:a="http://schemas.openxmlformats.org/drawingml/2006/main">
               <a:ext uri="{FF2B5EF4-FFF2-40B4-BE49-F238E27FC236}">
-                <a16:creationId xmlns:a16="http://schemas.microsoft.com/office/drawing/2014/main" id="{47C2E11F-0606-4AA6-8B6A-54A780607B1C}"/>
+                <a16:creationId xmlns:a16="http://schemas.microsoft.com/office/drawing/2014/main" id="{BD255EA6-6005-4AEF-BFFC-F12468D1FE80}"/>
               </a:ext>
             </a:extLst>
           </p:cNvPr>
@@ -21544,7 +21572,7 @@
     </p:spTree>
     <p:extLst>
       <p:ext uri="{BB962C8B-B14F-4D97-AF65-F5344CB8AC3E}">
-        <p14:creationId xmlns:p14="http://schemas.microsoft.com/office/powerpoint/2010/main" val="631933676"/>
+        <p14:creationId xmlns:p14="http://schemas.microsoft.com/office/powerpoint/2010/main" val="475765623"/>
       </p:ext>
     </p:extLst>
   </p:cSld>
@@ -21575,7 +21603,7 @@
           <p:cNvPr id="8" name="">
             <a:extLst xmlns:a="http://schemas.openxmlformats.org/drawingml/2006/main">
               <a:ext uri="{FF2B5EF4-FFF2-40B4-BE49-F238E27FC236}">
-                <a16:creationId xmlns:a16="http://schemas.microsoft.com/office/drawing/2014/main" id="{3B35ADF6-3D90-4D2F-BFD3-8CD40AFBD9F4}"/>
+                <a16:creationId xmlns:a16="http://schemas.microsoft.com/office/drawing/2014/main" id="{5F4E630C-51C6-4A63-81DE-88F2F413B86A}"/>
               </a:ext>
             </a:extLst>
           </p:cNvPr>
@@ -21731,7 +21759,7 @@
           <p:cNvPr id="2" name="">
             <a:extLst xmlns:a="http://schemas.openxmlformats.org/drawingml/2006/main">
               <a:ext uri="{FF2B5EF4-FFF2-40B4-BE49-F238E27FC236}">
-                <a16:creationId xmlns:a16="http://schemas.microsoft.com/office/drawing/2014/main" id="{F2EA5E92-2A62-4689-BAA9-A1DFF81DE576}"/>
+                <a16:creationId xmlns:a16="http://schemas.microsoft.com/office/drawing/2014/main" id="{F3401E1C-65FB-405F-9A88-C2DE9DD1B82A}"/>
               </a:ext>
             </a:extLst>
           </p:cNvPr>
@@ -21887,7 +21915,7 @@
           <p:cNvPr id="3" name="">
             <a:extLst xmlns:a="http://schemas.openxmlformats.org/drawingml/2006/main">
               <a:ext uri="{FF2B5EF4-FFF2-40B4-BE49-F238E27FC236}">
-                <a16:creationId xmlns:a16="http://schemas.microsoft.com/office/drawing/2014/main" id="{BFC83371-9217-4AE7-87DA-5B558EEF0289}"/>
+                <a16:creationId xmlns:a16="http://schemas.microsoft.com/office/drawing/2014/main" id="{F84A3038-8DD8-4EF5-BA57-F97BAC4D33DA}"/>
               </a:ext>
             </a:extLst>
           </p:cNvPr>
@@ -22043,7 +22071,7 @@
           <p:cNvPr id="4" name="">
             <a:extLst xmlns:a="http://schemas.openxmlformats.org/drawingml/2006/main">
               <a:ext uri="{FF2B5EF4-FFF2-40B4-BE49-F238E27FC236}">
-                <a16:creationId xmlns:a16="http://schemas.microsoft.com/office/drawing/2014/main" id="{78ED0C13-2BBE-4493-9D17-3B8B81E22DA8}"/>
+                <a16:creationId xmlns:a16="http://schemas.microsoft.com/office/drawing/2014/main" id="{351560A1-BA56-4C19-8434-344DA6CCCEA4}"/>
               </a:ext>
             </a:extLst>
           </p:cNvPr>
@@ -22053,7 +22081,7 @@
           <p:nvPr/>
         </p:nvPicPr>
         <p:blipFill>
-          <a:blip xmlns:r="http://schemas.openxmlformats.org/officeDocument/2006/relationships" xmlns:a="http://schemas.openxmlformats.org/drawingml/2006/main" r:embed="R73008b081d564270"/>
+          <a:blip xmlns:r="http://schemas.openxmlformats.org/officeDocument/2006/relationships" xmlns:a="http://schemas.openxmlformats.org/drawingml/2006/main" r:embed="R7a20a47932a44b55"/>
           <a:stretch xmlns:a="http://schemas.openxmlformats.org/drawingml/2006/main"/>
         </p:blipFill>
         <p:spPr>
@@ -22071,7 +22099,7 @@
           <p:cNvPr id="5" name="">
             <a:extLst xmlns:a="http://schemas.openxmlformats.org/drawingml/2006/main">
               <a:ext uri="{FF2B5EF4-FFF2-40B4-BE49-F238E27FC236}">
-                <a16:creationId xmlns:a16="http://schemas.microsoft.com/office/drawing/2014/main" id="{0A5863BC-949E-44D7-9F4B-8E2527DF9BC2}"/>
+                <a16:creationId xmlns:a16="http://schemas.microsoft.com/office/drawing/2014/main" id="{9231A037-8086-4AFC-890E-AE999014EDD6}"/>
               </a:ext>
             </a:extLst>
           </p:cNvPr>
@@ -22227,7 +22255,7 @@
           <p:cNvPr id="6" name="">
             <a:extLst xmlns:a="http://schemas.openxmlformats.org/drawingml/2006/main">
               <a:ext uri="{FF2B5EF4-FFF2-40B4-BE49-F238E27FC236}">
-                <a16:creationId xmlns:a16="http://schemas.microsoft.com/office/drawing/2014/main" id="{CB4E32A1-99AE-45E4-8B3E-031DE54AC759}"/>
+                <a16:creationId xmlns:a16="http://schemas.microsoft.com/office/drawing/2014/main" id="{CD66D86F-49F6-42FC-A21D-71F6E3C7299E}"/>
               </a:ext>
             </a:extLst>
           </p:cNvPr>
@@ -22429,7 +22457,7 @@
           <p:cNvPr id="7" name="">
             <a:extLst xmlns:a="http://schemas.openxmlformats.org/drawingml/2006/main">
               <a:ext uri="{FF2B5EF4-FFF2-40B4-BE49-F238E27FC236}">
-                <a16:creationId xmlns:a16="http://schemas.microsoft.com/office/drawing/2014/main" id="{70E84CBC-0A52-46FD-9C00-614DBB8B39A5}"/>
+                <a16:creationId xmlns:a16="http://schemas.microsoft.com/office/drawing/2014/main" id="{89281D89-AC38-4CD2-AD91-8FEBC90C2A14}"/>
               </a:ext>
             </a:extLst>
           </p:cNvPr>
@@ -22583,7 +22611,7 @@
     </p:spTree>
     <p:extLst>
       <p:ext uri="{BB962C8B-B14F-4D97-AF65-F5344CB8AC3E}">
-        <p14:creationId xmlns:p14="http://schemas.microsoft.com/office/powerpoint/2010/main" val="2085461141"/>
+        <p14:creationId xmlns:p14="http://schemas.microsoft.com/office/powerpoint/2010/main" val="1945874397"/>
       </p:ext>
     </p:extLst>
   </p:cSld>
@@ -22609,12 +22637,167 @@
       <p:grpSpPr>
         <a:xfrm xmlns:a="http://schemas.openxmlformats.org/drawingml/2006/main"/>
       </p:grpSpPr>
-      <p:sp>
-        <p:nvSpPr>
+      <p:cxnSp>
+        <p:nvCxnSpPr>
+          <p:cNvPr id="20" name="">
+            <a:extLst xmlns:a="http://schemas.openxmlformats.org/drawingml/2006/main">
+              <a:ext uri="{FF2B5EF4-FFF2-40B4-BE49-F238E27FC236}">
+                <a16:creationId xmlns:a16="http://schemas.microsoft.com/office/drawing/2014/main" id="{37F7226D-33E1-4AFD-98EE-8FDDB2BBC498}"/>
+              </a:ext>
+            </a:extLst>
+          </p:cNvPr>
+          <p:cNvCxnSpPr>
+            <a:stCxn xmlns:a="http://schemas.openxmlformats.org/drawingml/2006/main" id="8" idx="2"/>
+            <a:endCxn xmlns:a="http://schemas.openxmlformats.org/drawingml/2006/main" id="14" idx="0"/>
+          </p:cNvCxnSpPr>
+          <p:nvPr/>
+        </p:nvCxnSpPr>
+        <p:spPr>
+          <a:xfrm xmlns:a="http://schemas.openxmlformats.org/drawingml/2006/main">
+            <a:off x="9953625" y="2571750"/>
+            <a:ext cx="0" cy="1143000"/>
+          </a:xfrm>
+          <a:prstGeom xmlns:a="http://schemas.openxmlformats.org/drawingml/2006/main" prst="straightConnector1">
+            <a:avLst/>
+          </a:prstGeom>
+          <a:ln xmlns:a="http://schemas.openxmlformats.org/drawingml/2006/main" w="19050">
+            <a:solidFill>
+              <a:srgbClr val="2563EB"/>
+            </a:solidFill>
+            <a:tailEnd type="arrow" w="med" len="med"/>
+          </a:ln>
+        </p:spPr>
+      </p:cxnSp>
+      <p:cxnSp>
+        <p:nvCxnSpPr>
+          <p:cNvPr id="19" name="">
+            <a:extLst xmlns:a="http://schemas.openxmlformats.org/drawingml/2006/main">
+              <a:ext uri="{FF2B5EF4-FFF2-40B4-BE49-F238E27FC236}">
+                <a16:creationId xmlns:a16="http://schemas.microsoft.com/office/drawing/2014/main" id="{E3D52050-A547-4D13-A3B7-52917F69BB86}"/>
+              </a:ext>
+            </a:extLst>
+          </p:cNvPr>
+          <p:cNvCxnSpPr>
+            <a:stCxn xmlns:a="http://schemas.openxmlformats.org/drawingml/2006/main" id="6" idx="2"/>
+            <a:endCxn xmlns:a="http://schemas.openxmlformats.org/drawingml/2006/main" id="12" idx="0"/>
+          </p:cNvCxnSpPr>
+          <p:nvPr/>
+        </p:nvCxnSpPr>
+        <p:spPr>
+          <a:xfrm xmlns:a="http://schemas.openxmlformats.org/drawingml/2006/main">
+            <a:off x="5953125" y="2571750"/>
+            <a:ext cx="0" cy="1143000"/>
+          </a:xfrm>
+          <a:prstGeom xmlns:a="http://schemas.openxmlformats.org/drawingml/2006/main" prst="straightConnector1">
+            <a:avLst/>
+          </a:prstGeom>
+          <a:ln xmlns:a="http://schemas.openxmlformats.org/drawingml/2006/main" w="19050">
+            <a:solidFill>
+              <a:srgbClr val="2563EB"/>
+            </a:solidFill>
+            <a:tailEnd type="arrow" w="med" len="med"/>
+          </a:ln>
+        </p:spPr>
+      </p:cxnSp>
+      <p:cxnSp>
+        <p:nvCxnSpPr>
+          <p:cNvPr id="18" name="">
+            <a:extLst xmlns:a="http://schemas.openxmlformats.org/drawingml/2006/main">
+              <a:ext uri="{FF2B5EF4-FFF2-40B4-BE49-F238E27FC236}">
+                <a16:creationId xmlns:a16="http://schemas.microsoft.com/office/drawing/2014/main" id="{CDEDE91C-9805-4574-AC32-3CAB454620D0}"/>
+              </a:ext>
+            </a:extLst>
+          </p:cNvPr>
+          <p:cNvCxnSpPr>
+            <a:stCxn xmlns:a="http://schemas.openxmlformats.org/drawingml/2006/main" id="10" idx="0"/>
+            <a:endCxn xmlns:a="http://schemas.openxmlformats.org/drawingml/2006/main" id="4" idx="2"/>
+          </p:cNvCxnSpPr>
+          <p:nvPr/>
+        </p:nvCxnSpPr>
+        <p:spPr>
+          <a:xfrm xmlns:a="http://schemas.openxmlformats.org/drawingml/2006/main" flipV="1">
+            <a:off x="2085975" y="2571750"/>
+            <a:ext cx="0" cy="1143000"/>
+          </a:xfrm>
+          <a:prstGeom xmlns:a="http://schemas.openxmlformats.org/drawingml/2006/main" prst="straightConnector1">
+            <a:avLst/>
+          </a:prstGeom>
+          <a:ln xmlns:a="http://schemas.openxmlformats.org/drawingml/2006/main" w="19050">
+            <a:solidFill>
+              <a:srgbClr val="2563EB"/>
+            </a:solidFill>
+            <a:tailEnd type="arrow" w="med" len="med"/>
+          </a:ln>
+        </p:spPr>
+      </p:cxnSp>
+      <p:cxnSp>
+        <p:nvCxnSpPr>
           <p:cNvPr id="17" name="">
             <a:extLst xmlns:a="http://schemas.openxmlformats.org/drawingml/2006/main">
               <a:ext uri="{FF2B5EF4-FFF2-40B4-BE49-F238E27FC236}">
-                <a16:creationId xmlns:a16="http://schemas.microsoft.com/office/drawing/2014/main" id="{87D26862-9491-457C-8DB0-FBFB65B82A95}"/>
+                <a16:creationId xmlns:a16="http://schemas.microsoft.com/office/drawing/2014/main" id="{FA31A0A0-42D0-4BDE-9319-8B6D2F1E4196}"/>
+              </a:ext>
+            </a:extLst>
+          </p:cNvPr>
+          <p:cNvCxnSpPr>
+            <a:stCxn xmlns:a="http://schemas.openxmlformats.org/drawingml/2006/main" id="6" idx="3"/>
+            <a:endCxn xmlns:a="http://schemas.openxmlformats.org/drawingml/2006/main" id="8" idx="1"/>
+          </p:cNvCxnSpPr>
+          <p:nvPr/>
+        </p:nvCxnSpPr>
+        <p:spPr>
+          <a:xfrm xmlns:a="http://schemas.openxmlformats.org/drawingml/2006/main">
+            <a:off x="7572375" y="2143125"/>
+            <a:ext cx="762000" cy="0"/>
+          </a:xfrm>
+          <a:prstGeom xmlns:a="http://schemas.openxmlformats.org/drawingml/2006/main" prst="straightConnector1">
+            <a:avLst/>
+          </a:prstGeom>
+          <a:ln xmlns:a="http://schemas.openxmlformats.org/drawingml/2006/main" w="19050">
+            <a:solidFill>
+              <a:srgbClr val="2563EB"/>
+            </a:solidFill>
+            <a:tailEnd type="arrow" w="med" len="med"/>
+          </a:ln>
+        </p:spPr>
+      </p:cxnSp>
+      <p:cxnSp>
+        <p:nvCxnSpPr>
+          <p:cNvPr id="16" name="">
+            <a:extLst xmlns:a="http://schemas.openxmlformats.org/drawingml/2006/main">
+              <a:ext uri="{FF2B5EF4-FFF2-40B4-BE49-F238E27FC236}">
+                <a16:creationId xmlns:a16="http://schemas.microsoft.com/office/drawing/2014/main" id="{A68F3F35-C3C5-4B4E-A1F1-C4CDF575DEE7}"/>
+              </a:ext>
+            </a:extLst>
+          </p:cNvPr>
+          <p:cNvCxnSpPr>
+            <a:stCxn xmlns:a="http://schemas.openxmlformats.org/drawingml/2006/main" id="4" idx="3"/>
+            <a:endCxn xmlns:a="http://schemas.openxmlformats.org/drawingml/2006/main" id="6" idx="1"/>
+          </p:cNvCxnSpPr>
+          <p:nvPr/>
+        </p:nvCxnSpPr>
+        <p:spPr>
+          <a:xfrm xmlns:a="http://schemas.openxmlformats.org/drawingml/2006/main">
+            <a:off x="3562350" y="2143125"/>
+            <a:ext cx="771525" cy="0"/>
+          </a:xfrm>
+          <a:prstGeom xmlns:a="http://schemas.openxmlformats.org/drawingml/2006/main" prst="straightConnector1">
+            <a:avLst/>
+          </a:prstGeom>
+          <a:ln xmlns:a="http://schemas.openxmlformats.org/drawingml/2006/main" w="19050">
+            <a:solidFill>
+              <a:srgbClr val="2563EB"/>
+            </a:solidFill>
+            <a:tailEnd type="arrow" w="med" len="med"/>
+          </a:ln>
+        </p:spPr>
+      </p:cxnSp>
+      <p:sp>
+        <p:nvSpPr>
+          <p:cNvPr id="22" name="">
+            <a:extLst xmlns:a="http://schemas.openxmlformats.org/drawingml/2006/main">
+              <a:ext uri="{FF2B5EF4-FFF2-40B4-BE49-F238E27FC236}">
+                <a16:creationId xmlns:a16="http://schemas.microsoft.com/office/drawing/2014/main" id="{5B6F1523-9BF6-458E-B165-905E54A443AB}"/>
               </a:ext>
             </a:extLst>
           </p:cNvPr>
@@ -22770,7 +22953,7 @@
           <p:cNvPr id="2" name="">
             <a:extLst xmlns:a="http://schemas.openxmlformats.org/drawingml/2006/main">
               <a:ext uri="{FF2B5EF4-FFF2-40B4-BE49-F238E27FC236}">
-                <a16:creationId xmlns:a16="http://schemas.microsoft.com/office/drawing/2014/main" id="{730CBC5A-0ECD-4A64-A35A-433B6BB9C9C4}"/>
+                <a16:creationId xmlns:a16="http://schemas.microsoft.com/office/drawing/2014/main" id="{2D16ABA1-608B-416F-A235-D95C878EDC07}"/>
               </a:ext>
             </a:extLst>
           </p:cNvPr>
@@ -22926,7 +23109,7 @@
           <p:cNvPr id="3" name="">
             <a:extLst xmlns:a="http://schemas.openxmlformats.org/drawingml/2006/main">
               <a:ext uri="{FF2B5EF4-FFF2-40B4-BE49-F238E27FC236}">
-                <a16:creationId xmlns:a16="http://schemas.microsoft.com/office/drawing/2014/main" id="{905957AE-0BB9-4D20-8CA1-7799D34A8178}"/>
+                <a16:creationId xmlns:a16="http://schemas.microsoft.com/office/drawing/2014/main" id="{3E2BA4EF-5522-4F10-8C56-F8A070F1B8A2}"/>
               </a:ext>
             </a:extLst>
           </p:cNvPr>
@@ -23082,7 +23265,7 @@
           <p:cNvPr id="4" name="">
             <a:extLst xmlns:a="http://schemas.openxmlformats.org/drawingml/2006/main">
               <a:ext uri="{FF2B5EF4-FFF2-40B4-BE49-F238E27FC236}">
-                <a16:creationId xmlns:a16="http://schemas.microsoft.com/office/drawing/2014/main" id="{1A47C735-A013-4D65-8653-D05C6841AB82}"/>
+                <a16:creationId xmlns:a16="http://schemas.microsoft.com/office/drawing/2014/main" id="{BDFB9B5B-8A06-4D9E-9EED-0CB2CED40257}"/>
               </a:ext>
             </a:extLst>
           </p:cNvPr>
@@ -23114,7 +23297,7 @@
           <p:cNvPr id="5" name="">
             <a:extLst xmlns:a="http://schemas.openxmlformats.org/drawingml/2006/main">
               <a:ext uri="{FF2B5EF4-FFF2-40B4-BE49-F238E27FC236}">
-                <a16:creationId xmlns:a16="http://schemas.microsoft.com/office/drawing/2014/main" id="{2EBCE61A-F5D3-4069-978A-766252C750A0}"/>
+                <a16:creationId xmlns:a16="http://schemas.microsoft.com/office/drawing/2014/main" id="{3151A65C-32D1-4C1D-BE55-56931EB3415A}"/>
               </a:ext>
             </a:extLst>
           </p:cNvPr>
@@ -23270,7 +23453,7 @@
           <p:cNvPr id="6" name="">
             <a:extLst xmlns:a="http://schemas.openxmlformats.org/drawingml/2006/main">
               <a:ext uri="{FF2B5EF4-FFF2-40B4-BE49-F238E27FC236}">
-                <a16:creationId xmlns:a16="http://schemas.microsoft.com/office/drawing/2014/main" id="{4237113F-6CC5-4778-95CE-32911169191A}"/>
+                <a16:creationId xmlns:a16="http://schemas.microsoft.com/office/drawing/2014/main" id="{18D231D1-42A5-4DA7-8FD2-CEE89491FBB6}"/>
               </a:ext>
             </a:extLst>
           </p:cNvPr>
@@ -23302,7 +23485,7 @@
           <p:cNvPr id="7" name="">
             <a:extLst xmlns:a="http://schemas.openxmlformats.org/drawingml/2006/main">
               <a:ext uri="{FF2B5EF4-FFF2-40B4-BE49-F238E27FC236}">
-                <a16:creationId xmlns:a16="http://schemas.microsoft.com/office/drawing/2014/main" id="{40BA837E-8704-4571-BF65-5A2547E504E0}"/>
+                <a16:creationId xmlns:a16="http://schemas.microsoft.com/office/drawing/2014/main" id="{6F2A57AB-4C4C-45C2-B1AD-0AE8FE92FC04}"/>
               </a:ext>
             </a:extLst>
           </p:cNvPr>
@@ -23458,7 +23641,7 @@
           <p:cNvPr id="8" name="">
             <a:extLst xmlns:a="http://schemas.openxmlformats.org/drawingml/2006/main">
               <a:ext uri="{FF2B5EF4-FFF2-40B4-BE49-F238E27FC236}">
-                <a16:creationId xmlns:a16="http://schemas.microsoft.com/office/drawing/2014/main" id="{4289DEF1-1902-41CE-80B0-A78AF50E3DF9}"/>
+                <a16:creationId xmlns:a16="http://schemas.microsoft.com/office/drawing/2014/main" id="{E110255E-0632-4664-A07E-EF99848B902D}"/>
               </a:ext>
             </a:extLst>
           </p:cNvPr>
@@ -23490,7 +23673,7 @@
           <p:cNvPr id="9" name="">
             <a:extLst xmlns:a="http://schemas.openxmlformats.org/drawingml/2006/main">
               <a:ext uri="{FF2B5EF4-FFF2-40B4-BE49-F238E27FC236}">
-                <a16:creationId xmlns:a16="http://schemas.microsoft.com/office/drawing/2014/main" id="{64543437-1F67-4791-B65B-32A50D84A58E}"/>
+                <a16:creationId xmlns:a16="http://schemas.microsoft.com/office/drawing/2014/main" id="{D2C8A353-F59E-4AE2-B93C-F340CA18437C}"/>
               </a:ext>
             </a:extLst>
           </p:cNvPr>
@@ -23646,7 +23829,7 @@
           <p:cNvPr id="10" name="">
             <a:extLst xmlns:a="http://schemas.openxmlformats.org/drawingml/2006/main">
               <a:ext uri="{FF2B5EF4-FFF2-40B4-BE49-F238E27FC236}">
-                <a16:creationId xmlns:a16="http://schemas.microsoft.com/office/drawing/2014/main" id="{E1F95B3C-1A87-449B-BFB4-5CB9EEAA3947}"/>
+                <a16:creationId xmlns:a16="http://schemas.microsoft.com/office/drawing/2014/main" id="{8DFC29D5-6232-4263-991D-29A4C04609BB}"/>
               </a:ext>
             </a:extLst>
           </p:cNvPr>
@@ -23678,7 +23861,7 @@
           <p:cNvPr id="11" name="">
             <a:extLst xmlns:a="http://schemas.openxmlformats.org/drawingml/2006/main">
               <a:ext uri="{FF2B5EF4-FFF2-40B4-BE49-F238E27FC236}">
-                <a16:creationId xmlns:a16="http://schemas.microsoft.com/office/drawing/2014/main" id="{D445E4F1-D325-45E5-B970-9D0C9A601F4E}"/>
+                <a16:creationId xmlns:a16="http://schemas.microsoft.com/office/drawing/2014/main" id="{1CCBFEBE-BDFB-46A9-B802-2EC71BEF7B76}"/>
               </a:ext>
             </a:extLst>
           </p:cNvPr>
@@ -23834,7 +24017,7 @@
           <p:cNvPr id="12" name="">
             <a:extLst xmlns:a="http://schemas.openxmlformats.org/drawingml/2006/main">
               <a:ext uri="{FF2B5EF4-FFF2-40B4-BE49-F238E27FC236}">
-                <a16:creationId xmlns:a16="http://schemas.microsoft.com/office/drawing/2014/main" id="{126B54C8-488B-4B40-9EB1-506668D6633A}"/>
+                <a16:creationId xmlns:a16="http://schemas.microsoft.com/office/drawing/2014/main" id="{817A6F44-138B-4310-BBF8-9F6501458839}"/>
               </a:ext>
             </a:extLst>
           </p:cNvPr>
@@ -23866,7 +24049,7 @@
           <p:cNvPr id="13" name="">
             <a:extLst xmlns:a="http://schemas.openxmlformats.org/drawingml/2006/main">
               <a:ext uri="{FF2B5EF4-FFF2-40B4-BE49-F238E27FC236}">
-                <a16:creationId xmlns:a16="http://schemas.microsoft.com/office/drawing/2014/main" id="{D3693A22-2CEA-4F81-9130-A81E73B9B7AF}"/>
+                <a16:creationId xmlns:a16="http://schemas.microsoft.com/office/drawing/2014/main" id="{0228CB96-1D3A-416E-89A7-2A6AFB654579}"/>
               </a:ext>
             </a:extLst>
           </p:cNvPr>
@@ -24022,7 +24205,7 @@
           <p:cNvPr id="14" name="">
             <a:extLst xmlns:a="http://schemas.openxmlformats.org/drawingml/2006/main">
               <a:ext uri="{FF2B5EF4-FFF2-40B4-BE49-F238E27FC236}">
-                <a16:creationId xmlns:a16="http://schemas.microsoft.com/office/drawing/2014/main" id="{E1EEEBE5-A732-4C13-8299-A873B08A0300}"/>
+                <a16:creationId xmlns:a16="http://schemas.microsoft.com/office/drawing/2014/main" id="{729DE916-A70F-4F43-9FEA-5B951D431197}"/>
               </a:ext>
             </a:extLst>
           </p:cNvPr>
@@ -24054,7 +24237,7 @@
           <p:cNvPr id="15" name="">
             <a:extLst xmlns:a="http://schemas.openxmlformats.org/drawingml/2006/main">
               <a:ext uri="{FF2B5EF4-FFF2-40B4-BE49-F238E27FC236}">
-                <a16:creationId xmlns:a16="http://schemas.microsoft.com/office/drawing/2014/main" id="{4E35E526-4C9F-4B4D-B8E0-59D208DC6D51}"/>
+                <a16:creationId xmlns:a16="http://schemas.microsoft.com/office/drawing/2014/main" id="{6236EE93-AE34-44B7-873C-081FC0A5F7D7}"/>
               </a:ext>
             </a:extLst>
           </p:cNvPr>
@@ -24207,10 +24390,10 @@
       </p:sp>
       <p:sp>
         <p:nvSpPr>
-          <p:cNvPr id="16" name="">
+          <p:cNvPr id="21" name="">
             <a:extLst xmlns:a="http://schemas.openxmlformats.org/drawingml/2006/main">
               <a:ext uri="{FF2B5EF4-FFF2-40B4-BE49-F238E27FC236}">
-                <a16:creationId xmlns:a16="http://schemas.microsoft.com/office/drawing/2014/main" id="{71B2BC3D-481E-483A-AE2F-4085D47FD65B}"/>
+                <a16:creationId xmlns:a16="http://schemas.microsoft.com/office/drawing/2014/main" id="{1AC413AC-080A-4F91-A254-7022A4E681CF}"/>
               </a:ext>
             </a:extLst>
           </p:cNvPr>
@@ -24364,7 +24547,7 @@
     </p:spTree>
     <p:extLst>
       <p:ext uri="{BB962C8B-B14F-4D97-AF65-F5344CB8AC3E}">
-        <p14:creationId xmlns:p14="http://schemas.microsoft.com/office/powerpoint/2010/main" val="1392509717"/>
+        <p14:creationId xmlns:p14="http://schemas.microsoft.com/office/powerpoint/2010/main" val="1204216656"/>
       </p:ext>
     </p:extLst>
   </p:cSld>

</xml_diff>

<commit_message>
docs: record closed control findings and final candidate test totals
</commit_message>
<xml_diff>
--- a/docs/submission/assets/movebooks-submission-draft.pptx
+++ b/docs/submission/assets/movebooks-submission-draft.pptx
@@ -2,27 +2,27 @@
 <file path=ppt/presentation.xml><?xml version="1.0" encoding="utf-8"?>
 <p:presentation xmlns:p="http://schemas.openxmlformats.org/presentationml/2006/main">
   <p:sldMasterIdLst>
-    <p:sldMasterId xmlns:r="http://schemas.openxmlformats.org/officeDocument/2006/relationships" id="2147483648" r:id="Rcb1183d9bd9d47c4"/>
+    <p:sldMasterId xmlns:r="http://schemas.openxmlformats.org/officeDocument/2006/relationships" id="2147483648" r:id="R3226f739db324d7e"/>
   </p:sldMasterIdLst>
   <p:notesMasterIdLst>
-    <p:notesMasterId xmlns:r="http://schemas.openxmlformats.org/officeDocument/2006/relationships" r:id="R6efde62b410f4434"/>
+    <p:notesMasterId xmlns:r="http://schemas.openxmlformats.org/officeDocument/2006/relationships" r:id="Re0dd5cd8f6734bc6"/>
   </p:notesMasterIdLst>
   <p:sldIdLst>
-    <p:sldId xmlns:r="http://schemas.openxmlformats.org/officeDocument/2006/relationships" id="256" r:id="R7de357b247ec4de1"/>
-    <p:sldId xmlns:r="http://schemas.openxmlformats.org/officeDocument/2006/relationships" id="257" r:id="R70da24bae9ae44c0"/>
-    <p:sldId xmlns:r="http://schemas.openxmlformats.org/officeDocument/2006/relationships" id="258" r:id="R455e4d4f22924660"/>
-    <p:sldId xmlns:r="http://schemas.openxmlformats.org/officeDocument/2006/relationships" id="259" r:id="R40c4979afd2f48a2"/>
-    <p:sldId xmlns:r="http://schemas.openxmlformats.org/officeDocument/2006/relationships" id="260" r:id="R622a13962d0642f2"/>
-    <p:sldId xmlns:r="http://schemas.openxmlformats.org/officeDocument/2006/relationships" id="261" r:id="R304b28327341439b"/>
-    <p:sldId xmlns:r="http://schemas.openxmlformats.org/officeDocument/2006/relationships" id="262" r:id="R71c06b126a844ad1"/>
-    <p:sldId xmlns:r="http://schemas.openxmlformats.org/officeDocument/2006/relationships" id="263" r:id="R5cd17f329836489d"/>
-    <p:sldId xmlns:r="http://schemas.openxmlformats.org/officeDocument/2006/relationships" id="264" r:id="R90ce74ebf96f411e"/>
-    <p:sldId xmlns:r="http://schemas.openxmlformats.org/officeDocument/2006/relationships" id="265" r:id="R222ce543f56d4cdc"/>
-    <p:sldId xmlns:r="http://schemas.openxmlformats.org/officeDocument/2006/relationships" id="266" r:id="Ref6884faa1f54864"/>
-    <p:sldId xmlns:r="http://schemas.openxmlformats.org/officeDocument/2006/relationships" id="267" r:id="Raf40e6060f6d423d"/>
-    <p:sldId xmlns:r="http://schemas.openxmlformats.org/officeDocument/2006/relationships" id="268" r:id="R52290c55c1c9413f"/>
-    <p:sldId xmlns:r="http://schemas.openxmlformats.org/officeDocument/2006/relationships" id="269" r:id="R79187c5a9bec4eb9"/>
-    <p:sldId xmlns:r="http://schemas.openxmlformats.org/officeDocument/2006/relationships" id="270" r:id="R9d0f61dca8c944a2"/>
+    <p:sldId xmlns:r="http://schemas.openxmlformats.org/officeDocument/2006/relationships" id="256" r:id="Ra94e4893fde04579"/>
+    <p:sldId xmlns:r="http://schemas.openxmlformats.org/officeDocument/2006/relationships" id="257" r:id="R89c92a7144af4d46"/>
+    <p:sldId xmlns:r="http://schemas.openxmlformats.org/officeDocument/2006/relationships" id="258" r:id="R5b5108b2437c41e9"/>
+    <p:sldId xmlns:r="http://schemas.openxmlformats.org/officeDocument/2006/relationships" id="259" r:id="R1c86798c13e2460a"/>
+    <p:sldId xmlns:r="http://schemas.openxmlformats.org/officeDocument/2006/relationships" id="260" r:id="R7572a16a96e14fbd"/>
+    <p:sldId xmlns:r="http://schemas.openxmlformats.org/officeDocument/2006/relationships" id="261" r:id="Rdead22ee230749ea"/>
+    <p:sldId xmlns:r="http://schemas.openxmlformats.org/officeDocument/2006/relationships" id="262" r:id="R51ba50ce40744bcd"/>
+    <p:sldId xmlns:r="http://schemas.openxmlformats.org/officeDocument/2006/relationships" id="263" r:id="Rd4cec5cfd7b64431"/>
+    <p:sldId xmlns:r="http://schemas.openxmlformats.org/officeDocument/2006/relationships" id="264" r:id="Rcf24104f13004ae0"/>
+    <p:sldId xmlns:r="http://schemas.openxmlformats.org/officeDocument/2006/relationships" id="265" r:id="R09ec2c9574284c6f"/>
+    <p:sldId xmlns:r="http://schemas.openxmlformats.org/officeDocument/2006/relationships" id="266" r:id="Re4c5d0f60f724355"/>
+    <p:sldId xmlns:r="http://schemas.openxmlformats.org/officeDocument/2006/relationships" id="267" r:id="R624adac2a26d490e"/>
+    <p:sldId xmlns:r="http://schemas.openxmlformats.org/officeDocument/2006/relationships" id="268" r:id="R996f017cf0714a37"/>
+    <p:sldId xmlns:r="http://schemas.openxmlformats.org/officeDocument/2006/relationships" id="269" r:id="Rc134b689ee9c4541"/>
+    <p:sldId xmlns:r="http://schemas.openxmlformats.org/officeDocument/2006/relationships" id="270" r:id="Rc82340bb60754eaf"/>
   </p:sldIdLst>
   <p:sldSz cx="12192000" cy="6858000"/>
   <p:notesSz cx="6858000" cy="9144000"/>
@@ -736,7 +736,7 @@
           <a:lstStyle xmlns:a="http://schemas.openxmlformats.org/drawingml/2006/main"/>
           <a:p xmlns:a="http://schemas.openxmlformats.org/drawingml/2006/main">
             <a:r>
-              <a:t>Source: root integration-owner report candidate local backend553 passed58 skipped,17 October2026; named tests. Candidate run and external benchmarking pending.</a:t>
+              <a:t>Source: integration owner final combined candidate report, 17 October 2026: backend 559 passed / 58 skipped in 26.65 seconds; frontend 658 passed across 50 files; lint, typecheck and build passed. Focused independent model-control/Reviewer rerun: 36 passed in 1.49 seconds. These are local implementation tests, not live-cloud evidence or a model-quality benchmark.</a:t>
             </a:r>
           </a:p>
         </p:txBody>
@@ -1483,7 +1483,7 @@
           <p:cNvPr id="3" name="Title">
             <a:extLst xmlns:a="http://schemas.openxmlformats.org/drawingml/2006/main">
               <a:ext uri="{FF2B5EF4-FFF2-40B4-BE49-F238E27FC236}">
-                <a16:creationId xmlns:a16="http://schemas.microsoft.com/office/drawing/2014/main" id="{E0B8169A-DD39-45A2-9B1D-E858487E03AE}"/>
+                <a16:creationId xmlns:a16="http://schemas.microsoft.com/office/drawing/2014/main" id="{DBB25011-B854-4BF3-A0E7-72937A1A955F}"/>
               </a:ext>
             </a:extLst>
           </p:cNvPr>
@@ -1712,7 +1712,7 @@
           <p:cNvPr id="2" name="Subtitle">
             <a:extLst xmlns:a="http://schemas.openxmlformats.org/drawingml/2006/main">
               <a:ext uri="{FF2B5EF4-FFF2-40B4-BE49-F238E27FC236}">
-                <a16:creationId xmlns:a16="http://schemas.microsoft.com/office/drawing/2014/main" id="{B78F3264-7CA1-4019-81F4-F6755E3E883C}"/>
+                <a16:creationId xmlns:a16="http://schemas.microsoft.com/office/drawing/2014/main" id="{3C4C2743-4FD6-4BC7-99AF-7900FED94947}"/>
               </a:ext>
             </a:extLst>
           </p:cNvPr>
@@ -1958,7 +1958,7 @@
           <p:cNvPr id="2" name="Section title">
             <a:extLst xmlns:a="http://schemas.openxmlformats.org/drawingml/2006/main">
               <a:ext uri="{FF2B5EF4-FFF2-40B4-BE49-F238E27FC236}">
-                <a16:creationId xmlns:a16="http://schemas.microsoft.com/office/drawing/2014/main" id="{53039007-0934-4E96-9DBE-1550033F2218}"/>
+                <a16:creationId xmlns:a16="http://schemas.microsoft.com/office/drawing/2014/main" id="{F58748CF-B156-4F00-9454-6498C0ACD01A}"/>
               </a:ext>
             </a:extLst>
           </p:cNvPr>
@@ -2204,7 +2204,7 @@
           <p:cNvPr id="3" name="Title">
             <a:extLst xmlns:a="http://schemas.openxmlformats.org/drawingml/2006/main">
               <a:ext uri="{FF2B5EF4-FFF2-40B4-BE49-F238E27FC236}">
-                <a16:creationId xmlns:a16="http://schemas.microsoft.com/office/drawing/2014/main" id="{4B255BF4-0E28-4113-85B6-AD626A3DBA94}"/>
+                <a16:creationId xmlns:a16="http://schemas.microsoft.com/office/drawing/2014/main" id="{552BACE8-BC41-4995-A7BE-F3D6F30D80C7}"/>
               </a:ext>
             </a:extLst>
           </p:cNvPr>
@@ -2433,7 +2433,7 @@
           <p:cNvPr id="2" name="Body">
             <a:extLst xmlns:a="http://schemas.openxmlformats.org/drawingml/2006/main">
               <a:ext uri="{FF2B5EF4-FFF2-40B4-BE49-F238E27FC236}">
-                <a16:creationId xmlns:a16="http://schemas.microsoft.com/office/drawing/2014/main" id="{FAFD87E8-4694-4B7D-B2C1-37B3E0BBA32D}"/>
+                <a16:creationId xmlns:a16="http://schemas.microsoft.com/office/drawing/2014/main" id="{A3780A7E-BE1A-4ED0-B3A6-95F86013A780}"/>
               </a:ext>
             </a:extLst>
           </p:cNvPr>
@@ -2679,7 +2679,7 @@
           <p:cNvPr id="4" name="Title">
             <a:extLst xmlns:a="http://schemas.openxmlformats.org/drawingml/2006/main">
               <a:ext uri="{FF2B5EF4-FFF2-40B4-BE49-F238E27FC236}">
-                <a16:creationId xmlns:a16="http://schemas.microsoft.com/office/drawing/2014/main" id="{99A4B40B-E176-4E59-A79A-09FCADF58D56}"/>
+                <a16:creationId xmlns:a16="http://schemas.microsoft.com/office/drawing/2014/main" id="{FD8F73D8-C9E7-4663-97DB-26CA865D2DD2}"/>
               </a:ext>
             </a:extLst>
           </p:cNvPr>
@@ -2908,7 +2908,7 @@
           <p:cNvPr id="2" name="Left column">
             <a:extLst xmlns:a="http://schemas.openxmlformats.org/drawingml/2006/main">
               <a:ext uri="{FF2B5EF4-FFF2-40B4-BE49-F238E27FC236}">
-                <a16:creationId xmlns:a16="http://schemas.microsoft.com/office/drawing/2014/main" id="{E73189C2-95BE-4C50-BA42-9F1FDA512B40}"/>
+                <a16:creationId xmlns:a16="http://schemas.microsoft.com/office/drawing/2014/main" id="{F3BD0F10-35A2-46E0-AE8A-22C8787FE481}"/>
               </a:ext>
             </a:extLst>
           </p:cNvPr>
@@ -3137,7 +3137,7 @@
           <p:cNvPr id="3" name="Right column">
             <a:extLst xmlns:a="http://schemas.openxmlformats.org/drawingml/2006/main">
               <a:ext uri="{FF2B5EF4-FFF2-40B4-BE49-F238E27FC236}">
-                <a16:creationId xmlns:a16="http://schemas.microsoft.com/office/drawing/2014/main" id="{5FDF95C6-F4CD-433C-8CC1-6D6D04F349F0}"/>
+                <a16:creationId xmlns:a16="http://schemas.microsoft.com/office/drawing/2014/main" id="{5E178E5B-CDE9-4FB1-8A89-4CD58D5F6E11}"/>
               </a:ext>
             </a:extLst>
           </p:cNvPr>
@@ -3383,7 +3383,7 @@
           <p:cNvPr id="3" name="Title">
             <a:extLst xmlns:a="http://schemas.openxmlformats.org/drawingml/2006/main">
               <a:ext uri="{FF2B5EF4-FFF2-40B4-BE49-F238E27FC236}">
-                <a16:creationId xmlns:a16="http://schemas.microsoft.com/office/drawing/2014/main" id="{36BCE56E-F7AE-49C0-8F4C-CC90C356F009}"/>
+                <a16:creationId xmlns:a16="http://schemas.microsoft.com/office/drawing/2014/main" id="{D1FB4F01-61AB-4AC4-8FC5-6267A9EE56DB}"/>
               </a:ext>
             </a:extLst>
           </p:cNvPr>
@@ -3612,7 +3612,7 @@
           <p:cNvPr id="2" name="Left column">
             <a:extLst xmlns:a="http://schemas.openxmlformats.org/drawingml/2006/main">
               <a:ext uri="{FF2B5EF4-FFF2-40B4-BE49-F238E27FC236}">
-                <a16:creationId xmlns:a16="http://schemas.microsoft.com/office/drawing/2014/main" id="{7CEAE731-EFB6-4FF8-99E7-200D30B7A94B}"/>
+                <a16:creationId xmlns:a16="http://schemas.microsoft.com/office/drawing/2014/main" id="{B26ABF13-64B0-43A6-953E-035B21A3F1C9}"/>
               </a:ext>
             </a:extLst>
           </p:cNvPr>
@@ -3879,12 +3879,12 @@
   </p:cSld>
   <p:clrMap bg1="lt1" tx1="dk1" bg2="lt2" tx2="dk2" accent1="accent1" accent2="accent2" accent3="accent3" accent4="accent4" accent5="accent5" accent6="accent6" hlink="hlink" folHlink="folHlink"/>
   <p:sldLayoutIdLst>
-    <p:sldLayoutId xmlns:r="http://schemas.openxmlformats.org/officeDocument/2006/relationships" id="2147483649" r:id="R55ce00d2912a42db"/>
-    <p:sldLayoutId xmlns:r="http://schemas.openxmlformats.org/officeDocument/2006/relationships" id="2147483650" r:id="Recf6a2b8388a45eb"/>
-    <p:sldLayoutId xmlns:r="http://schemas.openxmlformats.org/officeDocument/2006/relationships" id="2147483651" r:id="R3a3e53c1bb604b07"/>
-    <p:sldLayoutId xmlns:r="http://schemas.openxmlformats.org/officeDocument/2006/relationships" id="2147483652" r:id="R16ce3956bf5f4384"/>
-    <p:sldLayoutId xmlns:r="http://schemas.openxmlformats.org/officeDocument/2006/relationships" id="2147483653" r:id="Rfdf9508ff59244a6"/>
-    <p:sldLayoutId xmlns:r="http://schemas.openxmlformats.org/officeDocument/2006/relationships" id="2147483654" r:id="R719d4b9966e94a5f"/>
+    <p:sldLayoutId xmlns:r="http://schemas.openxmlformats.org/officeDocument/2006/relationships" id="2147483649" r:id="R39147f4597334244"/>
+    <p:sldLayoutId xmlns:r="http://schemas.openxmlformats.org/officeDocument/2006/relationships" id="2147483650" r:id="R7797a96106c14f0b"/>
+    <p:sldLayoutId xmlns:r="http://schemas.openxmlformats.org/officeDocument/2006/relationships" id="2147483651" r:id="Rb69afea43e4d4d5a"/>
+    <p:sldLayoutId xmlns:r="http://schemas.openxmlformats.org/officeDocument/2006/relationships" id="2147483652" r:id="R8284d819e7ad4a06"/>
+    <p:sldLayoutId xmlns:r="http://schemas.openxmlformats.org/officeDocument/2006/relationships" id="2147483653" r:id="R7bfe153074a84535"/>
+    <p:sldLayoutId xmlns:r="http://schemas.openxmlformats.org/officeDocument/2006/relationships" id="2147483654" r:id="R652ceed78ee94caf"/>
   </p:sldLayoutIdLst>
   <p:txStyles>
     <p:titleStyle>
@@ -4435,7 +4435,7 @@
           <p:cNvPr id="8" name="">
             <a:extLst xmlns:a="http://schemas.openxmlformats.org/drawingml/2006/main">
               <a:ext uri="{FF2B5EF4-FFF2-40B4-BE49-F238E27FC236}">
-                <a16:creationId xmlns:a16="http://schemas.microsoft.com/office/drawing/2014/main" id="{F4290E5B-0651-43DD-89A5-C8FF1C989311}"/>
+                <a16:creationId xmlns:a16="http://schemas.microsoft.com/office/drawing/2014/main" id="{EF25B1FF-305F-4041-814B-3A12EFE7E704}"/>
               </a:ext>
             </a:extLst>
           </p:cNvPr>
@@ -4591,7 +4591,7 @@
           <p:cNvPr id="2" name="">
             <a:extLst xmlns:a="http://schemas.openxmlformats.org/drawingml/2006/main">
               <a:ext uri="{FF2B5EF4-FFF2-40B4-BE49-F238E27FC236}">
-                <a16:creationId xmlns:a16="http://schemas.microsoft.com/office/drawing/2014/main" id="{C57AFB26-F14B-4EB3-9AFB-37D4123AC9B8}"/>
+                <a16:creationId xmlns:a16="http://schemas.microsoft.com/office/drawing/2014/main" id="{3FCD7E12-5763-4C51-A094-51C9B9FB64A4}"/>
               </a:ext>
             </a:extLst>
           </p:cNvPr>
@@ -4747,7 +4747,7 @@
           <p:cNvPr id="3" name="">
             <a:extLst xmlns:a="http://schemas.openxmlformats.org/drawingml/2006/main">
               <a:ext uri="{FF2B5EF4-FFF2-40B4-BE49-F238E27FC236}">
-                <a16:creationId xmlns:a16="http://schemas.microsoft.com/office/drawing/2014/main" id="{A3F31763-7684-47AA-B56A-A4E93D22D2B9}"/>
+                <a16:creationId xmlns:a16="http://schemas.microsoft.com/office/drawing/2014/main" id="{4E91DA48-4FC5-48C7-884D-52D88E290F61}"/>
               </a:ext>
             </a:extLst>
           </p:cNvPr>
@@ -4903,7 +4903,7 @@
           <p:cNvPr id="4" name="">
             <a:extLst xmlns:a="http://schemas.openxmlformats.org/drawingml/2006/main">
               <a:ext uri="{FF2B5EF4-FFF2-40B4-BE49-F238E27FC236}">
-                <a16:creationId xmlns:a16="http://schemas.microsoft.com/office/drawing/2014/main" id="{1BA7FE4F-4F72-47FB-816E-79E1BF7CE9DD}"/>
+                <a16:creationId xmlns:a16="http://schemas.microsoft.com/office/drawing/2014/main" id="{5E160776-26F6-4392-95F1-4882E5FCA22B}"/>
               </a:ext>
             </a:extLst>
           </p:cNvPr>
@@ -5082,7 +5082,7 @@
           <p:cNvPr id="5" name="">
             <a:extLst xmlns:a="http://schemas.openxmlformats.org/drawingml/2006/main">
               <a:ext uri="{FF2B5EF4-FFF2-40B4-BE49-F238E27FC236}">
-                <a16:creationId xmlns:a16="http://schemas.microsoft.com/office/drawing/2014/main" id="{DC93B400-D69B-421D-A5FF-5200DC200C19}"/>
+                <a16:creationId xmlns:a16="http://schemas.microsoft.com/office/drawing/2014/main" id="{52885DDD-2301-41BB-925F-F9C357AFBF23}"/>
               </a:ext>
             </a:extLst>
           </p:cNvPr>
@@ -5238,7 +5238,7 @@
           <p:cNvPr id="6" name="">
             <a:extLst xmlns:a="http://schemas.openxmlformats.org/drawingml/2006/main">
               <a:ext uri="{FF2B5EF4-FFF2-40B4-BE49-F238E27FC236}">
-                <a16:creationId xmlns:a16="http://schemas.microsoft.com/office/drawing/2014/main" id="{8CE54ACC-C4F4-4B86-93BA-ECB42A2D24EA}"/>
+                <a16:creationId xmlns:a16="http://schemas.microsoft.com/office/drawing/2014/main" id="{05AFC871-3568-41EF-BD6D-62A56BD2ADF2}"/>
               </a:ext>
             </a:extLst>
           </p:cNvPr>
@@ -5417,7 +5417,7 @@
           <p:cNvPr id="7" name="">
             <a:extLst xmlns:a="http://schemas.openxmlformats.org/drawingml/2006/main">
               <a:ext uri="{FF2B5EF4-FFF2-40B4-BE49-F238E27FC236}">
-                <a16:creationId xmlns:a16="http://schemas.microsoft.com/office/drawing/2014/main" id="{C8E9DF62-2F32-4965-8705-656D989973F1}"/>
+                <a16:creationId xmlns:a16="http://schemas.microsoft.com/office/drawing/2014/main" id="{5B68AF62-F1DF-42D9-9A43-E62CA690EE7F}"/>
               </a:ext>
             </a:extLst>
           </p:cNvPr>
@@ -5427,7 +5427,7 @@
           <p:nvPr/>
         </p:nvPicPr>
         <p:blipFill>
-          <a:blip xmlns:r="http://schemas.openxmlformats.org/officeDocument/2006/relationships" xmlns:a="http://schemas.openxmlformats.org/drawingml/2006/main" r:embed="Rbbd80fc731d64507"/>
+          <a:blip xmlns:r="http://schemas.openxmlformats.org/officeDocument/2006/relationships" xmlns:a="http://schemas.openxmlformats.org/drawingml/2006/main" r:embed="Rbcb92a7008774ba5"/>
           <a:stretch xmlns:a="http://schemas.openxmlformats.org/drawingml/2006/main"/>
         </p:blipFill>
         <p:spPr>
@@ -5443,7 +5443,7 @@
     </p:spTree>
     <p:extLst>
       <p:ext uri="{BB962C8B-B14F-4D97-AF65-F5344CB8AC3E}">
-        <p14:creationId xmlns:p14="http://schemas.microsoft.com/office/powerpoint/2010/main" val="889947719"/>
+        <p14:creationId xmlns:p14="http://schemas.microsoft.com/office/powerpoint/2010/main" val="1777484122"/>
       </p:ext>
     </p:extLst>
   </p:cSld>
@@ -5474,7 +5474,7 @@
           <p:cNvPr id="8" name="">
             <a:extLst xmlns:a="http://schemas.openxmlformats.org/drawingml/2006/main">
               <a:ext uri="{FF2B5EF4-FFF2-40B4-BE49-F238E27FC236}">
-                <a16:creationId xmlns:a16="http://schemas.microsoft.com/office/drawing/2014/main" id="{226FD625-4CF1-402D-9CC1-B4329FDD5B14}"/>
+                <a16:creationId xmlns:a16="http://schemas.microsoft.com/office/drawing/2014/main" id="{B08C22A1-647A-429C-8B27-B2ADB7C1F8BA}"/>
               </a:ext>
             </a:extLst>
           </p:cNvPr>
@@ -5630,7 +5630,7 @@
           <p:cNvPr id="2" name="">
             <a:extLst xmlns:a="http://schemas.openxmlformats.org/drawingml/2006/main">
               <a:ext uri="{FF2B5EF4-FFF2-40B4-BE49-F238E27FC236}">
-                <a16:creationId xmlns:a16="http://schemas.microsoft.com/office/drawing/2014/main" id="{718A0181-74A4-421B-8689-3A9CB0CAE52C}"/>
+                <a16:creationId xmlns:a16="http://schemas.microsoft.com/office/drawing/2014/main" id="{17DA0F5F-0597-4894-AE9D-564605974F72}"/>
               </a:ext>
             </a:extLst>
           </p:cNvPr>
@@ -5786,7 +5786,7 @@
           <p:cNvPr id="3" name="">
             <a:extLst xmlns:a="http://schemas.openxmlformats.org/drawingml/2006/main">
               <a:ext uri="{FF2B5EF4-FFF2-40B4-BE49-F238E27FC236}">
-                <a16:creationId xmlns:a16="http://schemas.microsoft.com/office/drawing/2014/main" id="{8080D5AB-E866-43ED-B2B2-2305F9438F05}"/>
+                <a16:creationId xmlns:a16="http://schemas.microsoft.com/office/drawing/2014/main" id="{443C7C1C-5C3E-4259-908F-218C682D9CFD}"/>
               </a:ext>
             </a:extLst>
           </p:cNvPr>
@@ -5942,7 +5942,7 @@
           <p:cNvPr id="4" name="">
             <a:extLst xmlns:a="http://schemas.openxmlformats.org/drawingml/2006/main">
               <a:ext uri="{FF2B5EF4-FFF2-40B4-BE49-F238E27FC236}">
-                <a16:creationId xmlns:a16="http://schemas.microsoft.com/office/drawing/2014/main" id="{30DC7EA7-A8EB-44D1-B396-3F1C6C585816}"/>
+                <a16:creationId xmlns:a16="http://schemas.microsoft.com/office/drawing/2014/main" id="{F0183384-880B-4F2A-84FF-0EC92E031089}"/>
               </a:ext>
             </a:extLst>
           </p:cNvPr>
@@ -6098,7 +6098,7 @@
           <p:cNvPr id="5" name="">
             <a:extLst xmlns:a="http://schemas.openxmlformats.org/drawingml/2006/main">
               <a:ext uri="{FF2B5EF4-FFF2-40B4-BE49-F238E27FC236}">
-                <a16:creationId xmlns:a16="http://schemas.microsoft.com/office/drawing/2014/main" id="{6981E04A-081D-4979-BB27-0218114E9A6C}"/>
+                <a16:creationId xmlns:a16="http://schemas.microsoft.com/office/drawing/2014/main" id="{716DD497-166A-4578-AED6-BB99D0616EAF}"/>
               </a:ext>
             </a:extLst>
           </p:cNvPr>
@@ -6254,7 +6254,7 @@
           <p:cNvPr id="6" name="">
             <a:extLst xmlns:a="http://schemas.openxmlformats.org/drawingml/2006/main">
               <a:ext uri="{FF2B5EF4-FFF2-40B4-BE49-F238E27FC236}">
-                <a16:creationId xmlns:a16="http://schemas.microsoft.com/office/drawing/2014/main" id="{CB2A478C-BB92-42B5-B677-73ABE65D28D8}"/>
+                <a16:creationId xmlns:a16="http://schemas.microsoft.com/office/drawing/2014/main" id="{550CD179-06A0-4495-9DFA-B314DCD6F522}"/>
               </a:ext>
             </a:extLst>
           </p:cNvPr>
@@ -6410,7 +6410,7 @@
           <p:cNvPr id="7" name="">
             <a:extLst xmlns:a="http://schemas.openxmlformats.org/drawingml/2006/main">
               <a:ext uri="{FF2B5EF4-FFF2-40B4-BE49-F238E27FC236}">
-                <a16:creationId xmlns:a16="http://schemas.microsoft.com/office/drawing/2014/main" id="{8E31CBFE-36BB-4B7A-A0AF-ED3F26A90708}"/>
+                <a16:creationId xmlns:a16="http://schemas.microsoft.com/office/drawing/2014/main" id="{7A47DE8D-D96C-4BEE-ADE0-B55923DD6E0C}"/>
               </a:ext>
             </a:extLst>
           </p:cNvPr>
@@ -6564,7 +6564,7 @@
     </p:spTree>
     <p:extLst>
       <p:ext uri="{BB962C8B-B14F-4D97-AF65-F5344CB8AC3E}">
-        <p14:creationId xmlns:p14="http://schemas.microsoft.com/office/powerpoint/2010/main" val="532238422"/>
+        <p14:creationId xmlns:p14="http://schemas.microsoft.com/office/powerpoint/2010/main" val="537027289"/>
       </p:ext>
     </p:extLst>
   </p:cSld>
@@ -6595,7 +6595,7 @@
           <p:cNvPr id="9" name="">
             <a:extLst xmlns:a="http://schemas.openxmlformats.org/drawingml/2006/main">
               <a:ext uri="{FF2B5EF4-FFF2-40B4-BE49-F238E27FC236}">
-                <a16:creationId xmlns:a16="http://schemas.microsoft.com/office/drawing/2014/main" id="{5EFE77E5-FD09-4882-884D-50F63857D6C3}"/>
+                <a16:creationId xmlns:a16="http://schemas.microsoft.com/office/drawing/2014/main" id="{DDA1A99A-7473-4B3A-90C4-FB4BCD9B20E2}"/>
               </a:ext>
             </a:extLst>
           </p:cNvPr>
@@ -6751,7 +6751,7 @@
           <p:cNvPr id="2" name="">
             <a:extLst xmlns:a="http://schemas.openxmlformats.org/drawingml/2006/main">
               <a:ext uri="{FF2B5EF4-FFF2-40B4-BE49-F238E27FC236}">
-                <a16:creationId xmlns:a16="http://schemas.microsoft.com/office/drawing/2014/main" id="{CD50C78B-B4C9-45D7-A1F6-F76FFCD4E4BB}"/>
+                <a16:creationId xmlns:a16="http://schemas.microsoft.com/office/drawing/2014/main" id="{D83FB493-A1D3-4952-AE19-34BA2780ACC0}"/>
               </a:ext>
             </a:extLst>
           </p:cNvPr>
@@ -6907,7 +6907,7 @@
           <p:cNvPr id="3" name="">
             <a:extLst xmlns:a="http://schemas.openxmlformats.org/drawingml/2006/main">
               <a:ext uri="{FF2B5EF4-FFF2-40B4-BE49-F238E27FC236}">
-                <a16:creationId xmlns:a16="http://schemas.microsoft.com/office/drawing/2014/main" id="{FE0FDF8E-EDA6-4E7B-A32A-CB16AA726D92}"/>
+                <a16:creationId xmlns:a16="http://schemas.microsoft.com/office/drawing/2014/main" id="{9507FFB5-2B72-4C0E-9815-D7D052FCEC9B}"/>
               </a:ext>
             </a:extLst>
           </p:cNvPr>
@@ -7063,7 +7063,7 @@
           <p:cNvPr id="4" name="">
             <a:extLst xmlns:a="http://schemas.openxmlformats.org/drawingml/2006/main">
               <a:ext uri="{FF2B5EF4-FFF2-40B4-BE49-F238E27FC236}">
-                <a16:creationId xmlns:a16="http://schemas.microsoft.com/office/drawing/2014/main" id="{DCC3DAEF-9333-4755-B66B-8AE69DD7F27D}"/>
+                <a16:creationId xmlns:a16="http://schemas.microsoft.com/office/drawing/2014/main" id="{57E3E640-DB3F-488E-A9F5-93001431A15E}"/>
               </a:ext>
             </a:extLst>
           </p:cNvPr>
@@ -7219,7 +7219,7 @@
           <p:cNvPr id="5" name="">
             <a:extLst xmlns:a="http://schemas.openxmlformats.org/drawingml/2006/main">
               <a:ext uri="{FF2B5EF4-FFF2-40B4-BE49-F238E27FC236}">
-                <a16:creationId xmlns:a16="http://schemas.microsoft.com/office/drawing/2014/main" id="{0FA90CC5-3B52-474F-9ECF-EC48B57D5223}"/>
+                <a16:creationId xmlns:a16="http://schemas.microsoft.com/office/drawing/2014/main" id="{F5B410FD-54AD-4AF6-AFC6-00D379D26CFB}"/>
               </a:ext>
             </a:extLst>
           </p:cNvPr>
@@ -7375,7 +7375,7 @@
           <p:cNvPr id="6" name="">
             <a:extLst xmlns:a="http://schemas.openxmlformats.org/drawingml/2006/main">
               <a:ext uri="{FF2B5EF4-FFF2-40B4-BE49-F238E27FC236}">
-                <a16:creationId xmlns:a16="http://schemas.microsoft.com/office/drawing/2014/main" id="{0A13E2DC-1866-4B4A-A90D-ECA6C7E356A2}"/>
+                <a16:creationId xmlns:a16="http://schemas.microsoft.com/office/drawing/2014/main" id="{16A13C67-3C09-48A9-8B96-1F4EDD9BE09E}"/>
               </a:ext>
             </a:extLst>
           </p:cNvPr>
@@ -7531,7 +7531,7 @@
           <p:cNvPr id="7" name="">
             <a:extLst xmlns:a="http://schemas.openxmlformats.org/drawingml/2006/main">
               <a:ext uri="{FF2B5EF4-FFF2-40B4-BE49-F238E27FC236}">
-                <a16:creationId xmlns:a16="http://schemas.microsoft.com/office/drawing/2014/main" id="{F15A5C71-61AD-4215-AE39-010C263A907A}"/>
+                <a16:creationId xmlns:a16="http://schemas.microsoft.com/office/drawing/2014/main" id="{C2612EE9-1DF7-4AD2-ADA1-F78381A9A9F2}"/>
               </a:ext>
             </a:extLst>
           </p:cNvPr>
@@ -7687,7 +7687,7 @@
           <p:cNvPr id="8" name="">
             <a:extLst xmlns:a="http://schemas.openxmlformats.org/drawingml/2006/main">
               <a:ext uri="{FF2B5EF4-FFF2-40B4-BE49-F238E27FC236}">
-                <a16:creationId xmlns:a16="http://schemas.microsoft.com/office/drawing/2014/main" id="{EB7F9234-B1BE-437C-A23D-D2F305AA3947}"/>
+                <a16:creationId xmlns:a16="http://schemas.microsoft.com/office/drawing/2014/main" id="{7F4AB5EE-5245-42B7-9459-2C5361B4ECE9}"/>
               </a:ext>
             </a:extLst>
           </p:cNvPr>
@@ -7841,7 +7841,7 @@
     </p:spTree>
     <p:extLst>
       <p:ext uri="{BB962C8B-B14F-4D97-AF65-F5344CB8AC3E}">
-        <p14:creationId xmlns:p14="http://schemas.microsoft.com/office/powerpoint/2010/main" val="1335565359"/>
+        <p14:creationId xmlns:p14="http://schemas.microsoft.com/office/powerpoint/2010/main" val="674286225"/>
       </p:ext>
     </p:extLst>
   </p:cSld>
@@ -7872,7 +7872,7 @@
           <p:cNvPr id="7" name="">
             <a:extLst xmlns:a="http://schemas.openxmlformats.org/drawingml/2006/main">
               <a:ext uri="{FF2B5EF4-FFF2-40B4-BE49-F238E27FC236}">
-                <a16:creationId xmlns:a16="http://schemas.microsoft.com/office/drawing/2014/main" id="{998BD62E-0607-45A4-A65F-8325DA9F100C}"/>
+                <a16:creationId xmlns:a16="http://schemas.microsoft.com/office/drawing/2014/main" id="{39E1CEE7-AB32-4777-8CD9-36C1E0DE7439}"/>
               </a:ext>
             </a:extLst>
           </p:cNvPr>
@@ -8028,7 +8028,7 @@
           <p:cNvPr id="2" name="">
             <a:extLst xmlns:a="http://schemas.openxmlformats.org/drawingml/2006/main">
               <a:ext uri="{FF2B5EF4-FFF2-40B4-BE49-F238E27FC236}">
-                <a16:creationId xmlns:a16="http://schemas.microsoft.com/office/drawing/2014/main" id="{CA3B5DE5-F2AF-4F83-BCA9-D8CA570E7FB9}"/>
+                <a16:creationId xmlns:a16="http://schemas.microsoft.com/office/drawing/2014/main" id="{C7450DBC-657B-48FE-93D5-AE92EE0E42D2}"/>
               </a:ext>
             </a:extLst>
           </p:cNvPr>
@@ -8184,7 +8184,7 @@
           <p:cNvPr id="3" name="">
             <a:extLst xmlns:a="http://schemas.openxmlformats.org/drawingml/2006/main">
               <a:ext uri="{FF2B5EF4-FFF2-40B4-BE49-F238E27FC236}">
-                <a16:creationId xmlns:a16="http://schemas.microsoft.com/office/drawing/2014/main" id="{7CCCAA73-D603-4CB3-9E0B-4364A329B37E}"/>
+                <a16:creationId xmlns:a16="http://schemas.microsoft.com/office/drawing/2014/main" id="{D01EA6BA-9C59-4BF4-93C3-604836CC3662}"/>
               </a:ext>
             </a:extLst>
           </p:cNvPr>
@@ -8340,7 +8340,7 @@
           <p:cNvPr id="4" name="">
             <a:extLst xmlns:a="http://schemas.openxmlformats.org/drawingml/2006/main">
               <a:ext uri="{FF2B5EF4-FFF2-40B4-BE49-F238E27FC236}">
-                <a16:creationId xmlns:a16="http://schemas.microsoft.com/office/drawing/2014/main" id="{5E737FEA-9C6E-41BF-8A5A-A8F867FA795F}"/>
+                <a16:creationId xmlns:a16="http://schemas.microsoft.com/office/drawing/2014/main" id="{5C6993F8-0FB5-4A54-A0B6-E57FC4C3F60B}"/>
               </a:ext>
             </a:extLst>
           </p:cNvPr>
@@ -8350,7 +8350,7 @@
           <p:nvPr/>
         </p:nvPicPr>
         <p:blipFill>
-          <a:blip xmlns:r="http://schemas.openxmlformats.org/officeDocument/2006/relationships" xmlns:a="http://schemas.openxmlformats.org/drawingml/2006/main" r:embed="Rec924c103df74625"/>
+          <a:blip xmlns:r="http://schemas.openxmlformats.org/officeDocument/2006/relationships" xmlns:a="http://schemas.openxmlformats.org/drawingml/2006/main" r:embed="R444c47c69fb24ff1"/>
           <a:stretch xmlns:a="http://schemas.openxmlformats.org/drawingml/2006/main"/>
         </p:blipFill>
         <p:spPr>
@@ -8368,7 +8368,7 @@
           <p:cNvPr id="5" name="">
             <a:extLst xmlns:a="http://schemas.openxmlformats.org/drawingml/2006/main">
               <a:ext uri="{FF2B5EF4-FFF2-40B4-BE49-F238E27FC236}">
-                <a16:creationId xmlns:a16="http://schemas.microsoft.com/office/drawing/2014/main" id="{2A212621-A6C1-4A2A-9A6C-9673FA6E577E}"/>
+                <a16:creationId xmlns:a16="http://schemas.microsoft.com/office/drawing/2014/main" id="{EE178F04-F3BB-44FC-B237-CD5BD30E1F81}"/>
               </a:ext>
             </a:extLst>
           </p:cNvPr>
@@ -8524,7 +8524,7 @@
           <p:cNvPr id="6" name="">
             <a:extLst xmlns:a="http://schemas.openxmlformats.org/drawingml/2006/main">
               <a:ext uri="{FF2B5EF4-FFF2-40B4-BE49-F238E27FC236}">
-                <a16:creationId xmlns:a16="http://schemas.microsoft.com/office/drawing/2014/main" id="{EC3B78A1-ED33-4775-A51F-CB321E85047C}"/>
+                <a16:creationId xmlns:a16="http://schemas.microsoft.com/office/drawing/2014/main" id="{D58C062B-13C9-4E82-9AD5-72905B877F5D}"/>
               </a:ext>
             </a:extLst>
           </p:cNvPr>
@@ -8734,7 +8734,7 @@
     </p:spTree>
     <p:extLst>
       <p:ext uri="{BB962C8B-B14F-4D97-AF65-F5344CB8AC3E}">
-        <p14:creationId xmlns:p14="http://schemas.microsoft.com/office/powerpoint/2010/main" val="243137724"/>
+        <p14:creationId xmlns:p14="http://schemas.microsoft.com/office/powerpoint/2010/main" val="1049339756"/>
       </p:ext>
     </p:extLst>
   </p:cSld>
@@ -8762,10 +8762,10 @@
       </p:grpSpPr>
       <p:sp>
         <p:nvSpPr>
-          <p:cNvPr id="10" name="">
+          <p:cNvPr id="12" name="">
             <a:extLst xmlns:a="http://schemas.openxmlformats.org/drawingml/2006/main">
               <a:ext uri="{FF2B5EF4-FFF2-40B4-BE49-F238E27FC236}">
-                <a16:creationId xmlns:a16="http://schemas.microsoft.com/office/drawing/2014/main" id="{DE398EFD-8A17-4B19-B7B5-E3842FE56817}"/>
+                <a16:creationId xmlns:a16="http://schemas.microsoft.com/office/drawing/2014/main" id="{69CD1A39-353A-4ED3-8D0A-9D59E1940B42}"/>
               </a:ext>
             </a:extLst>
           </p:cNvPr>
@@ -8921,7 +8921,7 @@
           <p:cNvPr id="2" name="">
             <a:extLst xmlns:a="http://schemas.openxmlformats.org/drawingml/2006/main">
               <a:ext uri="{FF2B5EF4-FFF2-40B4-BE49-F238E27FC236}">
-                <a16:creationId xmlns:a16="http://schemas.microsoft.com/office/drawing/2014/main" id="{016E4B6F-0205-4485-9B67-1567FD4A6189}"/>
+                <a16:creationId xmlns:a16="http://schemas.microsoft.com/office/drawing/2014/main" id="{920147B3-1688-4F83-81BB-242CB13703D5}"/>
               </a:ext>
             </a:extLst>
           </p:cNvPr>
@@ -9077,7 +9077,7 @@
           <p:cNvPr id="3" name="">
             <a:extLst xmlns:a="http://schemas.openxmlformats.org/drawingml/2006/main">
               <a:ext uri="{FF2B5EF4-FFF2-40B4-BE49-F238E27FC236}">
-                <a16:creationId xmlns:a16="http://schemas.microsoft.com/office/drawing/2014/main" id="{1CA49840-1BA5-46A8-9668-3E4407F07E8F}"/>
+                <a16:creationId xmlns:a16="http://schemas.microsoft.com/office/drawing/2014/main" id="{58D27430-27D4-43E0-B8F3-752A9BC09EEE}"/>
               </a:ext>
             </a:extLst>
           </p:cNvPr>
@@ -9233,7 +9233,7 @@
           <p:cNvPr id="4" name="">
             <a:extLst xmlns:a="http://schemas.openxmlformats.org/drawingml/2006/main">
               <a:ext uri="{FF2B5EF4-FFF2-40B4-BE49-F238E27FC236}">
-                <a16:creationId xmlns:a16="http://schemas.microsoft.com/office/drawing/2014/main" id="{44296E0F-057D-4C7F-A55F-EF0EC0F66439}"/>
+                <a16:creationId xmlns:a16="http://schemas.microsoft.com/office/drawing/2014/main" id="{17F6D4A8-8961-4E8E-8CB9-3CC39BAC66B5}"/>
               </a:ext>
             </a:extLst>
           </p:cNvPr>
@@ -9245,7 +9245,7 @@
         <p:spPr>
           <a:xfrm xmlns:a="http://schemas.openxmlformats.org/drawingml/2006/main">
             <a:off x="609600" y="1666875"/>
-            <a:ext cx="6477000" cy="571500"/>
+            <a:ext cx="4762500" cy="523875"/>
           </a:xfrm>
           <a:prstGeom xmlns:a="http://schemas.openxmlformats.org/drawingml/2006/main" prst="rect">
             <a:avLst/>
@@ -9259,7 +9259,7 @@
           <a:bodyPr xmlns:a="http://schemas.openxmlformats.org/drawingml/2006/main"/>
           <a:lstStyle xmlns:a="http://schemas.openxmlformats.org/drawingml/2006/main">
             <a:defPPr>
-              <a:defRPr sz="2700" b="1">
+              <a:defRPr sz="2550" b="1">
                 <a:solidFill>
                   <a:srgbClr val="12233F"/>
                 </a:solidFill>
@@ -9269,7 +9269,7 @@
               </a:defRPr>
             </a:defPPr>
             <a:lvl1pPr>
-              <a:defRPr sz="2700" b="1">
+              <a:defRPr sz="2550" b="1">
                 <a:solidFill>
                   <a:srgbClr val="12233F"/>
                 </a:solidFill>
@@ -9279,7 +9279,7 @@
               </a:defRPr>
             </a:lvl1pPr>
             <a:lvl2pPr>
-              <a:defRPr sz="2700" b="1">
+              <a:defRPr sz="2550" b="1">
                 <a:solidFill>
                   <a:srgbClr val="12233F"/>
                 </a:solidFill>
@@ -9289,7 +9289,7 @@
               </a:defRPr>
             </a:lvl2pPr>
             <a:lvl3pPr>
-              <a:defRPr sz="2700" b="1">
+              <a:defRPr sz="2550" b="1">
                 <a:solidFill>
                   <a:srgbClr val="12233F"/>
                 </a:solidFill>
@@ -9299,7 +9299,7 @@
               </a:defRPr>
             </a:lvl3pPr>
             <a:lvl4pPr>
-              <a:defRPr sz="2700" b="1">
+              <a:defRPr sz="2550" b="1">
                 <a:solidFill>
                   <a:srgbClr val="12233F"/>
                 </a:solidFill>
@@ -9309,7 +9309,7 @@
               </a:defRPr>
             </a:lvl4pPr>
             <a:lvl5pPr>
-              <a:defRPr sz="2700" b="1">
+              <a:defRPr sz="2550" b="1">
                 <a:solidFill>
                   <a:srgbClr val="12233F"/>
                 </a:solidFill>
@@ -9319,7 +9319,7 @@
               </a:defRPr>
             </a:lvl5pPr>
             <a:lvl6pPr>
-              <a:defRPr sz="2700" b="1">
+              <a:defRPr sz="2550" b="1">
                 <a:solidFill>
                   <a:srgbClr val="12233F"/>
                 </a:solidFill>
@@ -9329,7 +9329,7 @@
               </a:defRPr>
             </a:lvl6pPr>
             <a:lvl7pPr>
-              <a:defRPr sz="2700" b="1">
+              <a:defRPr sz="2550" b="1">
                 <a:solidFill>
                   <a:srgbClr val="12233F"/>
                 </a:solidFill>
@@ -9339,7 +9339,7 @@
               </a:defRPr>
             </a:lvl7pPr>
             <a:lvl8pPr>
-              <a:defRPr sz="2700" b="1">
+              <a:defRPr sz="2550" b="1">
                 <a:solidFill>
                   <a:srgbClr val="12233F"/>
                 </a:solidFill>
@@ -9349,7 +9349,7 @@
               </a:defRPr>
             </a:lvl8pPr>
             <a:lvl9pPr>
-              <a:defRPr sz="2700" b="1">
+              <a:defRPr sz="2550" b="1">
                 <a:solidFill>
                   <a:srgbClr val="12233F"/>
                 </a:solidFill>
@@ -9361,7 +9361,7 @@
           </a:lstStyle>
           <a:p xmlns:a="http://schemas.openxmlformats.org/drawingml/2006/main">
             <a:pPr>
-              <a:defRPr sz="2700" b="1">
+              <a:defRPr sz="2550" b="1">
                 <a:solidFill>
                   <a:srgbClr val="12233F"/>
                 </a:solidFill>
@@ -9371,7 +9371,7 @@
               </a:defRPr>
             </a:pPr>
             <a:r>
-              <a:rPr sz="2700" b="1">
+              <a:rPr sz="2550" b="1">
                 <a:solidFill>
                   <a:srgbClr val="12233F"/>
                 </a:solidFill>
@@ -9379,7 +9379,7 @@
                 <a:ea typeface="Arial"/>
                 <a:cs typeface="Arial"/>
               </a:rPr>
-              <a:t>Candidate backend tests</a:t>
+              <a:t>Backend tests</a:t>
             </a:r>
           </a:p>
         </p:txBody>
@@ -9389,7 +9389,7 @@
           <p:cNvPr id="5" name="">
             <a:extLst xmlns:a="http://schemas.openxmlformats.org/drawingml/2006/main">
               <a:ext uri="{FF2B5EF4-FFF2-40B4-BE49-F238E27FC236}">
-                <a16:creationId xmlns:a16="http://schemas.microsoft.com/office/drawing/2014/main" id="{E42571AC-2125-4FFE-9366-3D5F0C053720}"/>
+                <a16:creationId xmlns:a16="http://schemas.microsoft.com/office/drawing/2014/main" id="{3AF7D9E8-CED6-415B-B334-35C872F305A6}"/>
               </a:ext>
             </a:extLst>
           </p:cNvPr>
@@ -9400,8 +9400,8 @@
         </p:nvSpPr>
         <p:spPr>
           <a:xfrm xmlns:a="http://schemas.openxmlformats.org/drawingml/2006/main">
-            <a:off x="609600" y="2476500"/>
-            <a:ext cx="6477000" cy="952500"/>
+            <a:off x="609600" y="2381250"/>
+            <a:ext cx="4762500" cy="952500"/>
           </a:xfrm>
           <a:prstGeom xmlns:a="http://schemas.openxmlformats.org/drawingml/2006/main" prst="rect">
             <a:avLst/>
@@ -9535,7 +9535,7 @@
                 <a:ea typeface="Arial"/>
                 <a:cs typeface="Arial"/>
               </a:rPr>
-              <a:t>553 passed</a:t>
+              <a:t>559 passed</a:t>
             </a:r>
           </a:p>
         </p:txBody>
@@ -9545,7 +9545,7 @@
           <p:cNvPr id="6" name="">
             <a:extLst xmlns:a="http://schemas.openxmlformats.org/drawingml/2006/main">
               <a:ext uri="{FF2B5EF4-FFF2-40B4-BE49-F238E27FC236}">
-                <a16:creationId xmlns:a16="http://schemas.microsoft.com/office/drawing/2014/main" id="{2D759F43-4842-4DAF-9575-39E0C4822614}"/>
+                <a16:creationId xmlns:a16="http://schemas.microsoft.com/office/drawing/2014/main" id="{2217D6AE-2EC3-4946-A529-69A29BD8EE3C}"/>
               </a:ext>
             </a:extLst>
           </p:cNvPr>
@@ -9556,8 +9556,8 @@
         </p:nvSpPr>
         <p:spPr>
           <a:xfrm xmlns:a="http://schemas.openxmlformats.org/drawingml/2006/main">
-            <a:off x="609600" y="3524250"/>
-            <a:ext cx="6477000" cy="571500"/>
+            <a:off x="609600" y="3476625"/>
+            <a:ext cx="4762500" cy="523875"/>
           </a:xfrm>
           <a:prstGeom xmlns:a="http://schemas.openxmlformats.org/drawingml/2006/main" prst="rect">
             <a:avLst/>
@@ -9571,7 +9571,7 @@
           <a:bodyPr xmlns:a="http://schemas.openxmlformats.org/drawingml/2006/main"/>
           <a:lstStyle xmlns:a="http://schemas.openxmlformats.org/drawingml/2006/main">
             <a:defPPr>
-              <a:defRPr sz="2550" b="0">
+              <a:defRPr sz="2400" b="0">
                 <a:solidFill>
                   <a:srgbClr val="50657F"/>
                 </a:solidFill>
@@ -9581,7 +9581,7 @@
               </a:defRPr>
             </a:defPPr>
             <a:lvl1pPr>
-              <a:defRPr sz="2550" b="0">
+              <a:defRPr sz="2400" b="0">
                 <a:solidFill>
                   <a:srgbClr val="50657F"/>
                 </a:solidFill>
@@ -9591,7 +9591,7 @@
               </a:defRPr>
             </a:lvl1pPr>
             <a:lvl2pPr>
-              <a:defRPr sz="2550" b="0">
+              <a:defRPr sz="2400" b="0">
                 <a:solidFill>
                   <a:srgbClr val="50657F"/>
                 </a:solidFill>
@@ -9601,7 +9601,7 @@
               </a:defRPr>
             </a:lvl2pPr>
             <a:lvl3pPr>
-              <a:defRPr sz="2550" b="0">
+              <a:defRPr sz="2400" b="0">
                 <a:solidFill>
                   <a:srgbClr val="50657F"/>
                 </a:solidFill>
@@ -9611,7 +9611,7 @@
               </a:defRPr>
             </a:lvl3pPr>
             <a:lvl4pPr>
-              <a:defRPr sz="2550" b="0">
+              <a:defRPr sz="2400" b="0">
                 <a:solidFill>
                   <a:srgbClr val="50657F"/>
                 </a:solidFill>
@@ -9621,7 +9621,7 @@
               </a:defRPr>
             </a:lvl4pPr>
             <a:lvl5pPr>
-              <a:defRPr sz="2550" b="0">
+              <a:defRPr sz="2400" b="0">
                 <a:solidFill>
                   <a:srgbClr val="50657F"/>
                 </a:solidFill>
@@ -9631,7 +9631,7 @@
               </a:defRPr>
             </a:lvl5pPr>
             <a:lvl6pPr>
-              <a:defRPr sz="2550" b="0">
+              <a:defRPr sz="2400" b="0">
                 <a:solidFill>
                   <a:srgbClr val="50657F"/>
                 </a:solidFill>
@@ -9641,7 +9641,7 @@
               </a:defRPr>
             </a:lvl6pPr>
             <a:lvl7pPr>
-              <a:defRPr sz="2550" b="0">
+              <a:defRPr sz="2400" b="0">
                 <a:solidFill>
                   <a:srgbClr val="50657F"/>
                 </a:solidFill>
@@ -9651,7 +9651,7 @@
               </a:defRPr>
             </a:lvl7pPr>
             <a:lvl8pPr>
-              <a:defRPr sz="2550" b="0">
+              <a:defRPr sz="2400" b="0">
                 <a:solidFill>
                   <a:srgbClr val="50657F"/>
                 </a:solidFill>
@@ -9661,7 +9661,7 @@
               </a:defRPr>
             </a:lvl8pPr>
             <a:lvl9pPr>
-              <a:defRPr sz="2550" b="0">
+              <a:defRPr sz="2400" b="0">
                 <a:solidFill>
                   <a:srgbClr val="50657F"/>
                 </a:solidFill>
@@ -9673,7 +9673,7 @@
           </a:lstStyle>
           <a:p xmlns:a="http://schemas.openxmlformats.org/drawingml/2006/main">
             <a:pPr>
-              <a:defRPr sz="2550" b="0">
+              <a:defRPr sz="2400" b="0">
                 <a:solidFill>
                   <a:srgbClr val="50657F"/>
                 </a:solidFill>
@@ -9683,7 +9683,7 @@
               </a:defRPr>
             </a:pPr>
             <a:r>
-              <a:rPr sz="2550" b="0">
+              <a:rPr sz="2400" b="0">
                 <a:solidFill>
                   <a:srgbClr val="50657F"/>
                 </a:solidFill>
@@ -9701,7 +9701,7 @@
           <p:cNvPr id="7" name="">
             <a:extLst xmlns:a="http://schemas.openxmlformats.org/drawingml/2006/main">
               <a:ext uri="{FF2B5EF4-FFF2-40B4-BE49-F238E27FC236}">
-                <a16:creationId xmlns:a16="http://schemas.microsoft.com/office/drawing/2014/main" id="{23B857EB-0F78-481C-80CA-80A09C41527E}"/>
+                <a16:creationId xmlns:a16="http://schemas.microsoft.com/office/drawing/2014/main" id="{B3B6E014-BAAE-4884-8A9E-FF7CAA9494CB}"/>
               </a:ext>
             </a:extLst>
           </p:cNvPr>
@@ -9712,8 +9712,8 @@
         </p:nvSpPr>
         <p:spPr>
           <a:xfrm xmlns:a="http://schemas.openxmlformats.org/drawingml/2006/main">
-            <a:off x="7429500" y="1666875"/>
-            <a:ext cx="4000500" cy="666750"/>
+            <a:off x="6477000" y="1666875"/>
+            <a:ext cx="4762500" cy="523875"/>
           </a:xfrm>
           <a:prstGeom xmlns:a="http://schemas.openxmlformats.org/drawingml/2006/main" prst="rect">
             <a:avLst/>
@@ -9727,7 +9727,7 @@
           <a:bodyPr xmlns:a="http://schemas.openxmlformats.org/drawingml/2006/main"/>
           <a:lstStyle xmlns:a="http://schemas.openxmlformats.org/drawingml/2006/main">
             <a:defPPr>
-              <a:defRPr sz="2325" b="1">
+              <a:defRPr sz="2550" b="1">
                 <a:solidFill>
                   <a:srgbClr val="12233F"/>
                 </a:solidFill>
@@ -9737,7 +9737,7 @@
               </a:defRPr>
             </a:defPPr>
             <a:lvl1pPr>
-              <a:defRPr sz="2325" b="1">
+              <a:defRPr sz="2550" b="1">
                 <a:solidFill>
                   <a:srgbClr val="12233F"/>
                 </a:solidFill>
@@ -9747,7 +9747,7 @@
               </a:defRPr>
             </a:lvl1pPr>
             <a:lvl2pPr>
-              <a:defRPr sz="2325" b="1">
+              <a:defRPr sz="2550" b="1">
                 <a:solidFill>
                   <a:srgbClr val="12233F"/>
                 </a:solidFill>
@@ -9757,7 +9757,7 @@
               </a:defRPr>
             </a:lvl2pPr>
             <a:lvl3pPr>
-              <a:defRPr sz="2325" b="1">
+              <a:defRPr sz="2550" b="1">
                 <a:solidFill>
                   <a:srgbClr val="12233F"/>
                 </a:solidFill>
@@ -9767,7 +9767,7 @@
               </a:defRPr>
             </a:lvl3pPr>
             <a:lvl4pPr>
-              <a:defRPr sz="2325" b="1">
+              <a:defRPr sz="2550" b="1">
                 <a:solidFill>
                   <a:srgbClr val="12233F"/>
                 </a:solidFill>
@@ -9777,7 +9777,7 @@
               </a:defRPr>
             </a:lvl4pPr>
             <a:lvl5pPr>
-              <a:defRPr sz="2325" b="1">
+              <a:defRPr sz="2550" b="1">
                 <a:solidFill>
                   <a:srgbClr val="12233F"/>
                 </a:solidFill>
@@ -9787,7 +9787,7 @@
               </a:defRPr>
             </a:lvl5pPr>
             <a:lvl6pPr>
-              <a:defRPr sz="2325" b="1">
+              <a:defRPr sz="2550" b="1">
                 <a:solidFill>
                   <a:srgbClr val="12233F"/>
                 </a:solidFill>
@@ -9797,7 +9797,7 @@
               </a:defRPr>
             </a:lvl6pPr>
             <a:lvl7pPr>
-              <a:defRPr sz="2325" b="1">
+              <a:defRPr sz="2550" b="1">
                 <a:solidFill>
                   <a:srgbClr val="12233F"/>
                 </a:solidFill>
@@ -9807,7 +9807,7 @@
               </a:defRPr>
             </a:lvl7pPr>
             <a:lvl8pPr>
-              <a:defRPr sz="2325" b="1">
+              <a:defRPr sz="2550" b="1">
                 <a:solidFill>
                   <a:srgbClr val="12233F"/>
                 </a:solidFill>
@@ -9817,7 +9817,7 @@
               </a:defRPr>
             </a:lvl8pPr>
             <a:lvl9pPr>
-              <a:defRPr sz="2325" b="1">
+              <a:defRPr sz="2550" b="1">
                 <a:solidFill>
                   <a:srgbClr val="12233F"/>
                 </a:solidFill>
@@ -9829,7 +9829,7 @@
           </a:lstStyle>
           <a:p xmlns:a="http://schemas.openxmlformats.org/drawingml/2006/main">
             <a:pPr>
-              <a:defRPr sz="2325" b="1">
+              <a:defRPr sz="2550" b="1">
                 <a:solidFill>
                   <a:srgbClr val="12233F"/>
                 </a:solidFill>
@@ -9839,7 +9839,7 @@
               </a:defRPr>
             </a:pPr>
             <a:r>
-              <a:rPr sz="2325" b="1">
+              <a:rPr sz="2550" b="1">
                 <a:solidFill>
                   <a:srgbClr val="12233F"/>
                 </a:solidFill>
@@ -9847,7 +9847,7 @@
                 <a:ea typeface="Arial"/>
                 <a:cs typeface="Arial"/>
               </a:rPr>
-              <a:t>What the evidence covers</a:t>
+              <a:t>Frontend tests</a:t>
             </a:r>
           </a:p>
         </p:txBody>
@@ -9857,7 +9857,7 @@
           <p:cNvPr id="8" name="">
             <a:extLst xmlns:a="http://schemas.openxmlformats.org/drawingml/2006/main">
               <a:ext uri="{FF2B5EF4-FFF2-40B4-BE49-F238E27FC236}">
-                <a16:creationId xmlns:a16="http://schemas.microsoft.com/office/drawing/2014/main" id="{7C33DA71-907E-4206-AC52-C1218EE39D47}"/>
+                <a16:creationId xmlns:a16="http://schemas.microsoft.com/office/drawing/2014/main" id="{BAFDF6D8-6E2B-4F21-9B23-D378EE61E388}"/>
               </a:ext>
             </a:extLst>
           </p:cNvPr>
@@ -9868,8 +9868,320 @@
         </p:nvSpPr>
         <p:spPr>
           <a:xfrm xmlns:a="http://schemas.openxmlformats.org/drawingml/2006/main">
-            <a:off x="7429500" y="2571750"/>
-            <a:ext cx="4000500" cy="2095500"/>
+            <a:off x="6477000" y="2381250"/>
+            <a:ext cx="4762500" cy="952500"/>
+          </a:xfrm>
+          <a:prstGeom xmlns:a="http://schemas.openxmlformats.org/drawingml/2006/main" prst="rect">
+            <a:avLst/>
+          </a:prstGeom>
+          <a:noFill xmlns:a="http://schemas.openxmlformats.org/drawingml/2006/main"/>
+          <a:ln xmlns:a="http://schemas.openxmlformats.org/drawingml/2006/main" w="0">
+            <a:noFill/>
+          </a:ln>
+        </p:spPr>
+        <p:txBody>
+          <a:bodyPr xmlns:a="http://schemas.openxmlformats.org/drawingml/2006/main"/>
+          <a:lstStyle xmlns:a="http://schemas.openxmlformats.org/drawingml/2006/main">
+            <a:defPPr>
+              <a:defRPr sz="4950" b="1">
+                <a:solidFill>
+                  <a:srgbClr val="2563EB"/>
+                </a:solidFill>
+                <a:latin typeface="Arial"/>
+                <a:ea typeface="Arial"/>
+                <a:cs typeface="Arial"/>
+              </a:defRPr>
+            </a:defPPr>
+            <a:lvl1pPr>
+              <a:defRPr sz="4950" b="1">
+                <a:solidFill>
+                  <a:srgbClr val="2563EB"/>
+                </a:solidFill>
+                <a:latin typeface="Arial"/>
+                <a:ea typeface="Arial"/>
+                <a:cs typeface="Arial"/>
+              </a:defRPr>
+            </a:lvl1pPr>
+            <a:lvl2pPr>
+              <a:defRPr sz="4950" b="1">
+                <a:solidFill>
+                  <a:srgbClr val="2563EB"/>
+                </a:solidFill>
+                <a:latin typeface="Arial"/>
+                <a:ea typeface="Arial"/>
+                <a:cs typeface="Arial"/>
+              </a:defRPr>
+            </a:lvl2pPr>
+            <a:lvl3pPr>
+              <a:defRPr sz="4950" b="1">
+                <a:solidFill>
+                  <a:srgbClr val="2563EB"/>
+                </a:solidFill>
+                <a:latin typeface="Arial"/>
+                <a:ea typeface="Arial"/>
+                <a:cs typeface="Arial"/>
+              </a:defRPr>
+            </a:lvl3pPr>
+            <a:lvl4pPr>
+              <a:defRPr sz="4950" b="1">
+                <a:solidFill>
+                  <a:srgbClr val="2563EB"/>
+                </a:solidFill>
+                <a:latin typeface="Arial"/>
+                <a:ea typeface="Arial"/>
+                <a:cs typeface="Arial"/>
+              </a:defRPr>
+            </a:lvl4pPr>
+            <a:lvl5pPr>
+              <a:defRPr sz="4950" b="1">
+                <a:solidFill>
+                  <a:srgbClr val="2563EB"/>
+                </a:solidFill>
+                <a:latin typeface="Arial"/>
+                <a:ea typeface="Arial"/>
+                <a:cs typeface="Arial"/>
+              </a:defRPr>
+            </a:lvl5pPr>
+            <a:lvl6pPr>
+              <a:defRPr sz="4950" b="1">
+                <a:solidFill>
+                  <a:srgbClr val="2563EB"/>
+                </a:solidFill>
+                <a:latin typeface="Arial"/>
+                <a:ea typeface="Arial"/>
+                <a:cs typeface="Arial"/>
+              </a:defRPr>
+            </a:lvl6pPr>
+            <a:lvl7pPr>
+              <a:defRPr sz="4950" b="1">
+                <a:solidFill>
+                  <a:srgbClr val="2563EB"/>
+                </a:solidFill>
+                <a:latin typeface="Arial"/>
+                <a:ea typeface="Arial"/>
+                <a:cs typeface="Arial"/>
+              </a:defRPr>
+            </a:lvl7pPr>
+            <a:lvl8pPr>
+              <a:defRPr sz="4950" b="1">
+                <a:solidFill>
+                  <a:srgbClr val="2563EB"/>
+                </a:solidFill>
+                <a:latin typeface="Arial"/>
+                <a:ea typeface="Arial"/>
+                <a:cs typeface="Arial"/>
+              </a:defRPr>
+            </a:lvl8pPr>
+            <a:lvl9pPr>
+              <a:defRPr sz="4950" b="1">
+                <a:solidFill>
+                  <a:srgbClr val="2563EB"/>
+                </a:solidFill>
+                <a:latin typeface="Arial"/>
+                <a:ea typeface="Arial"/>
+                <a:cs typeface="Arial"/>
+              </a:defRPr>
+            </a:lvl9pPr>
+          </a:lstStyle>
+          <a:p xmlns:a="http://schemas.openxmlformats.org/drawingml/2006/main">
+            <a:pPr>
+              <a:defRPr sz="4950" b="1">
+                <a:solidFill>
+                  <a:srgbClr val="2563EB"/>
+                </a:solidFill>
+                <a:latin typeface="Arial"/>
+                <a:ea typeface="Arial"/>
+                <a:cs typeface="Arial"/>
+              </a:defRPr>
+            </a:pPr>
+            <a:r>
+              <a:rPr sz="4950" b="1">
+                <a:solidFill>
+                  <a:srgbClr val="2563EB"/>
+                </a:solidFill>
+                <a:latin typeface="Arial"/>
+                <a:ea typeface="Arial"/>
+                <a:cs typeface="Arial"/>
+              </a:rPr>
+              <a:t>658 passed</a:t>
+            </a:r>
+          </a:p>
+        </p:txBody>
+      </p:sp>
+      <p:sp>
+        <p:nvSpPr>
+          <p:cNvPr id="9" name="">
+            <a:extLst xmlns:a="http://schemas.openxmlformats.org/drawingml/2006/main">
+              <a:ext uri="{FF2B5EF4-FFF2-40B4-BE49-F238E27FC236}">
+                <a16:creationId xmlns:a16="http://schemas.microsoft.com/office/drawing/2014/main" id="{B7088D81-3442-49A0-8A91-76C6111AA94C}"/>
+              </a:ext>
+            </a:extLst>
+          </p:cNvPr>
+          <p:cNvSpPr>
+            <a:spLocks xmlns:a="http://schemas.openxmlformats.org/drawingml/2006/main" noGrp="1"/>
+          </p:cNvSpPr>
+          <p:nvPr/>
+        </p:nvSpPr>
+        <p:spPr>
+          <a:xfrm xmlns:a="http://schemas.openxmlformats.org/drawingml/2006/main">
+            <a:off x="6477000" y="3476625"/>
+            <a:ext cx="4762500" cy="523875"/>
+          </a:xfrm>
+          <a:prstGeom xmlns:a="http://schemas.openxmlformats.org/drawingml/2006/main" prst="rect">
+            <a:avLst/>
+          </a:prstGeom>
+          <a:noFill xmlns:a="http://schemas.openxmlformats.org/drawingml/2006/main"/>
+          <a:ln xmlns:a="http://schemas.openxmlformats.org/drawingml/2006/main" w="0">
+            <a:noFill/>
+          </a:ln>
+        </p:spPr>
+        <p:txBody>
+          <a:bodyPr xmlns:a="http://schemas.openxmlformats.org/drawingml/2006/main"/>
+          <a:lstStyle xmlns:a="http://schemas.openxmlformats.org/drawingml/2006/main">
+            <a:defPPr>
+              <a:defRPr sz="2400" b="0">
+                <a:solidFill>
+                  <a:srgbClr val="50657F"/>
+                </a:solidFill>
+                <a:latin typeface="Arial"/>
+                <a:ea typeface="Arial"/>
+                <a:cs typeface="Arial"/>
+              </a:defRPr>
+            </a:defPPr>
+            <a:lvl1pPr>
+              <a:defRPr sz="2400" b="0">
+                <a:solidFill>
+                  <a:srgbClr val="50657F"/>
+                </a:solidFill>
+                <a:latin typeface="Arial"/>
+                <a:ea typeface="Arial"/>
+                <a:cs typeface="Arial"/>
+              </a:defRPr>
+            </a:lvl1pPr>
+            <a:lvl2pPr>
+              <a:defRPr sz="2400" b="0">
+                <a:solidFill>
+                  <a:srgbClr val="50657F"/>
+                </a:solidFill>
+                <a:latin typeface="Arial"/>
+                <a:ea typeface="Arial"/>
+                <a:cs typeface="Arial"/>
+              </a:defRPr>
+            </a:lvl2pPr>
+            <a:lvl3pPr>
+              <a:defRPr sz="2400" b="0">
+                <a:solidFill>
+                  <a:srgbClr val="50657F"/>
+                </a:solidFill>
+                <a:latin typeface="Arial"/>
+                <a:ea typeface="Arial"/>
+                <a:cs typeface="Arial"/>
+              </a:defRPr>
+            </a:lvl3pPr>
+            <a:lvl4pPr>
+              <a:defRPr sz="2400" b="0">
+                <a:solidFill>
+                  <a:srgbClr val="50657F"/>
+                </a:solidFill>
+                <a:latin typeface="Arial"/>
+                <a:ea typeface="Arial"/>
+                <a:cs typeface="Arial"/>
+              </a:defRPr>
+            </a:lvl4pPr>
+            <a:lvl5pPr>
+              <a:defRPr sz="2400" b="0">
+                <a:solidFill>
+                  <a:srgbClr val="50657F"/>
+                </a:solidFill>
+                <a:latin typeface="Arial"/>
+                <a:ea typeface="Arial"/>
+                <a:cs typeface="Arial"/>
+              </a:defRPr>
+            </a:lvl5pPr>
+            <a:lvl6pPr>
+              <a:defRPr sz="2400" b="0">
+                <a:solidFill>
+                  <a:srgbClr val="50657F"/>
+                </a:solidFill>
+                <a:latin typeface="Arial"/>
+                <a:ea typeface="Arial"/>
+                <a:cs typeface="Arial"/>
+              </a:defRPr>
+            </a:lvl6pPr>
+            <a:lvl7pPr>
+              <a:defRPr sz="2400" b="0">
+                <a:solidFill>
+                  <a:srgbClr val="50657F"/>
+                </a:solidFill>
+                <a:latin typeface="Arial"/>
+                <a:ea typeface="Arial"/>
+                <a:cs typeface="Arial"/>
+              </a:defRPr>
+            </a:lvl7pPr>
+            <a:lvl8pPr>
+              <a:defRPr sz="2400" b="0">
+                <a:solidFill>
+                  <a:srgbClr val="50657F"/>
+                </a:solidFill>
+                <a:latin typeface="Arial"/>
+                <a:ea typeface="Arial"/>
+                <a:cs typeface="Arial"/>
+              </a:defRPr>
+            </a:lvl8pPr>
+            <a:lvl9pPr>
+              <a:defRPr sz="2400" b="0">
+                <a:solidFill>
+                  <a:srgbClr val="50657F"/>
+                </a:solidFill>
+                <a:latin typeface="Arial"/>
+                <a:ea typeface="Arial"/>
+                <a:cs typeface="Arial"/>
+              </a:defRPr>
+            </a:lvl9pPr>
+          </a:lstStyle>
+          <a:p xmlns:a="http://schemas.openxmlformats.org/drawingml/2006/main">
+            <a:pPr>
+              <a:defRPr sz="2400" b="0">
+                <a:solidFill>
+                  <a:srgbClr val="50657F"/>
+                </a:solidFill>
+                <a:latin typeface="Arial"/>
+                <a:ea typeface="Arial"/>
+                <a:cs typeface="Arial"/>
+              </a:defRPr>
+            </a:pPr>
+            <a:r>
+              <a:rPr sz="2400" b="0">
+                <a:solidFill>
+                  <a:srgbClr val="50657F"/>
+                </a:solidFill>
+                <a:latin typeface="Arial"/>
+                <a:ea typeface="Arial"/>
+                <a:cs typeface="Arial"/>
+              </a:rPr>
+              <a:t>50 test files</a:t>
+            </a:r>
+          </a:p>
+        </p:txBody>
+      </p:sp>
+      <p:sp>
+        <p:nvSpPr>
+          <p:cNvPr id="10" name="">
+            <a:extLst xmlns:a="http://schemas.openxmlformats.org/drawingml/2006/main">
+              <a:ext uri="{FF2B5EF4-FFF2-40B4-BE49-F238E27FC236}">
+                <a16:creationId xmlns:a16="http://schemas.microsoft.com/office/drawing/2014/main" id="{3374F8E1-5730-4F6E-901D-F034EA993843}"/>
+              </a:ext>
+            </a:extLst>
+          </p:cNvPr>
+          <p:cNvSpPr>
+            <a:spLocks xmlns:a="http://schemas.openxmlformats.org/drawingml/2006/main" noGrp="1"/>
+          </p:cNvSpPr>
+          <p:nvPr/>
+        </p:nvSpPr>
+        <p:spPr>
+          <a:xfrm xmlns:a="http://schemas.openxmlformats.org/drawingml/2006/main">
+            <a:off x="609600" y="4476750"/>
+            <a:ext cx="10668000" cy="857250"/>
           </a:xfrm>
           <a:prstGeom xmlns:a="http://schemas.openxmlformats.org/drawingml/2006/main" prst="rect">
             <a:avLst/>
@@ -10003,86 +10315,17 @@
                 <a:ea typeface="Arial"/>
                 <a:cs typeface="Arial"/>
               </a:rPr>
-              <a:t>Owner/approval boundaries</a:t>
-            </a:r>
-          </a:p>
-          <a:p xmlns:a="http://schemas.openxmlformats.org/drawingml/2006/main">
-            <a:pPr>
-              <a:defRPr sz="2100" b="0">
-                <a:solidFill>
-                  <a:srgbClr val="12233F"/>
-                </a:solidFill>
-                <a:latin typeface="Arial"/>
-                <a:ea typeface="Arial"/>
-                <a:cs typeface="Arial"/>
-              </a:defRPr>
-            </a:pPr>
-            <a:r>
-              <a:rPr sz="2100" b="0">
-                <a:solidFill>
-                  <a:srgbClr val="12233F"/>
-                </a:solidFill>
-                <a:latin typeface="Arial"/>
-                <a:ea typeface="Arial"/>
-                <a:cs typeface="Arial"/>
-              </a:rPr>
-              <a:t>State transitions and replay</a:t>
-            </a:r>
-          </a:p>
-          <a:p xmlns:a="http://schemas.openxmlformats.org/drawingml/2006/main">
-            <a:pPr>
-              <a:defRPr sz="2100" b="0">
-                <a:solidFill>
-                  <a:srgbClr val="12233F"/>
-                </a:solidFill>
-                <a:latin typeface="Arial"/>
-                <a:ea typeface="Arial"/>
-                <a:cs typeface="Arial"/>
-              </a:defRPr>
-            </a:pPr>
-            <a:r>
-              <a:rPr sz="2100" b="0">
-                <a:solidFill>
-                  <a:srgbClr val="12233F"/>
-                </a:solidFill>
-                <a:latin typeface="Arial"/>
-                <a:ea typeface="Arial"/>
-                <a:cs typeface="Arial"/>
-              </a:rPr>
-              <a:t>Recovery and reconciliation</a:t>
-            </a:r>
-          </a:p>
-          <a:p xmlns:a="http://schemas.openxmlformats.org/drawingml/2006/main">
-            <a:pPr>
-              <a:defRPr sz="2100" b="0">
-                <a:solidFill>
-                  <a:srgbClr val="12233F"/>
-                </a:solidFill>
-                <a:latin typeface="Arial"/>
-                <a:ea typeface="Arial"/>
-                <a:cs typeface="Arial"/>
-              </a:defRPr>
-            </a:pPr>
-            <a:r>
-              <a:rPr sz="2100" b="0">
-                <a:solidFill>
-                  <a:srgbClr val="12233F"/>
-                </a:solidFill>
-                <a:latin typeface="Arial"/>
-                <a:ea typeface="Arial"/>
-                <a:cs typeface="Arial"/>
-              </a:rPr>
-              <a:t>Synthetic FPU</a:t>
+              <a:t>Checks cover owner and approval boundaries, state transitions, recovery, reconciliation, UI behavior and synthetic FPU.</a:t>
             </a:r>
           </a:p>
         </p:txBody>
       </p:sp>
       <p:sp>
         <p:nvSpPr>
-          <p:cNvPr id="9" name="">
+          <p:cNvPr id="11" name="">
             <a:extLst xmlns:a="http://schemas.openxmlformats.org/drawingml/2006/main">
               <a:ext uri="{FF2B5EF4-FFF2-40B4-BE49-F238E27FC236}">
-                <a16:creationId xmlns:a16="http://schemas.microsoft.com/office/drawing/2014/main" id="{7D804E1A-F67F-4D09-BCEA-2AB09DB04210}"/>
+                <a16:creationId xmlns:a16="http://schemas.microsoft.com/office/drawing/2014/main" id="{DB8265F3-C125-4F8B-A6A3-951AC91B6260}"/>
               </a:ext>
             </a:extLst>
           </p:cNvPr>
@@ -10093,7 +10336,7 @@
         </p:nvSpPr>
         <p:spPr>
           <a:xfrm xmlns:a="http://schemas.openxmlformats.org/drawingml/2006/main">
-            <a:off x="609600" y="5429250"/>
+            <a:off x="609600" y="5524500"/>
             <a:ext cx="10668000" cy="619125"/>
           </a:xfrm>
           <a:prstGeom xmlns:a="http://schemas.openxmlformats.org/drawingml/2006/main" prst="rect">
@@ -10108,7 +10351,7 @@
           <a:bodyPr xmlns:a="http://schemas.openxmlformats.org/drawingml/2006/main"/>
           <a:lstStyle xmlns:a="http://schemas.openxmlformats.org/drawingml/2006/main">
             <a:defPPr>
-              <a:defRPr sz="1800" b="0">
+              <a:defRPr sz="1725" b="0">
                 <a:solidFill>
                   <a:srgbClr val="50657F"/>
                 </a:solidFill>
@@ -10118,7 +10361,7 @@
               </a:defRPr>
             </a:defPPr>
             <a:lvl1pPr>
-              <a:defRPr sz="1800" b="0">
+              <a:defRPr sz="1725" b="0">
                 <a:solidFill>
                   <a:srgbClr val="50657F"/>
                 </a:solidFill>
@@ -10128,7 +10371,7 @@
               </a:defRPr>
             </a:lvl1pPr>
             <a:lvl2pPr>
-              <a:defRPr sz="1800" b="0">
+              <a:defRPr sz="1725" b="0">
                 <a:solidFill>
                   <a:srgbClr val="50657F"/>
                 </a:solidFill>
@@ -10138,7 +10381,7 @@
               </a:defRPr>
             </a:lvl2pPr>
             <a:lvl3pPr>
-              <a:defRPr sz="1800" b="0">
+              <a:defRPr sz="1725" b="0">
                 <a:solidFill>
                   <a:srgbClr val="50657F"/>
                 </a:solidFill>
@@ -10148,7 +10391,7 @@
               </a:defRPr>
             </a:lvl3pPr>
             <a:lvl4pPr>
-              <a:defRPr sz="1800" b="0">
+              <a:defRPr sz="1725" b="0">
                 <a:solidFill>
                   <a:srgbClr val="50657F"/>
                 </a:solidFill>
@@ -10158,7 +10401,7 @@
               </a:defRPr>
             </a:lvl4pPr>
             <a:lvl5pPr>
-              <a:defRPr sz="1800" b="0">
+              <a:defRPr sz="1725" b="0">
                 <a:solidFill>
                   <a:srgbClr val="50657F"/>
                 </a:solidFill>
@@ -10168,7 +10411,7 @@
               </a:defRPr>
             </a:lvl5pPr>
             <a:lvl6pPr>
-              <a:defRPr sz="1800" b="0">
+              <a:defRPr sz="1725" b="0">
                 <a:solidFill>
                   <a:srgbClr val="50657F"/>
                 </a:solidFill>
@@ -10178,7 +10421,7 @@
               </a:defRPr>
             </a:lvl6pPr>
             <a:lvl7pPr>
-              <a:defRPr sz="1800" b="0">
+              <a:defRPr sz="1725" b="0">
                 <a:solidFill>
                   <a:srgbClr val="50657F"/>
                 </a:solidFill>
@@ -10188,7 +10431,7 @@
               </a:defRPr>
             </a:lvl7pPr>
             <a:lvl8pPr>
-              <a:defRPr sz="1800" b="0">
+              <a:defRPr sz="1725" b="0">
                 <a:solidFill>
                   <a:srgbClr val="50657F"/>
                 </a:solidFill>
@@ -10198,7 +10441,7 @@
               </a:defRPr>
             </a:lvl8pPr>
             <a:lvl9pPr>
-              <a:defRPr sz="1800" b="0">
+              <a:defRPr sz="1725" b="0">
                 <a:solidFill>
                   <a:srgbClr val="50657F"/>
                 </a:solidFill>
@@ -10210,7 +10453,7 @@
           </a:lstStyle>
           <a:p xmlns:a="http://schemas.openxmlformats.org/drawingml/2006/main">
             <a:pPr>
-              <a:defRPr sz="1800" b="0">
+              <a:defRPr sz="1725" b="0">
                 <a:solidFill>
                   <a:srgbClr val="50657F"/>
                 </a:solidFill>
@@ -10220,7 +10463,7 @@
               </a:defRPr>
             </a:pPr>
             <a:r>
-              <a:rPr sz="1800" b="0">
+              <a:rPr sz="1725" b="0">
                 <a:solidFill>
                   <a:srgbClr val="50657F"/>
                 </a:solidFill>
@@ -10228,7 +10471,7 @@
                 <a:ea typeface="Arial"/>
                 <a:cs typeface="Arial"/>
               </a:rPr>
-              <a:t>Local candidate test run, 58 skips explicit. No live-model accuracy, external provider benchmark or customer-impact claim.</a:t>
+              <a:t>Local candidate evidence. Lint, typecheck and build passed. No live-model accuracy, external provider benchmark or customer-impact claim.</a:t>
             </a:r>
           </a:p>
         </p:txBody>
@@ -10236,7 +10479,7 @@
     </p:spTree>
     <p:extLst>
       <p:ext uri="{BB962C8B-B14F-4D97-AF65-F5344CB8AC3E}">
-        <p14:creationId xmlns:p14="http://schemas.microsoft.com/office/powerpoint/2010/main" val="562388160"/>
+        <p14:creationId xmlns:p14="http://schemas.microsoft.com/office/powerpoint/2010/main" val="722293371"/>
       </p:ext>
     </p:extLst>
   </p:cSld>
@@ -10267,7 +10510,7 @@
           <p:cNvPr id="7" name="">
             <a:extLst xmlns:a="http://schemas.openxmlformats.org/drawingml/2006/main">
               <a:ext uri="{FF2B5EF4-FFF2-40B4-BE49-F238E27FC236}">
-                <a16:creationId xmlns:a16="http://schemas.microsoft.com/office/drawing/2014/main" id="{EA1C3697-1C6F-4230-A8E7-0980976D9B14}"/>
+                <a16:creationId xmlns:a16="http://schemas.microsoft.com/office/drawing/2014/main" id="{3BB5C22B-D56F-4044-9472-BEEFE0B18EAC}"/>
               </a:ext>
             </a:extLst>
           </p:cNvPr>
@@ -10423,7 +10666,7 @@
           <p:cNvPr id="2" name="">
             <a:extLst xmlns:a="http://schemas.openxmlformats.org/drawingml/2006/main">
               <a:ext uri="{FF2B5EF4-FFF2-40B4-BE49-F238E27FC236}">
-                <a16:creationId xmlns:a16="http://schemas.microsoft.com/office/drawing/2014/main" id="{9DC38F94-6CB0-4B1F-AFE6-01775FCB98BC}"/>
+                <a16:creationId xmlns:a16="http://schemas.microsoft.com/office/drawing/2014/main" id="{2FE37A0D-13B9-449A-9433-39DDC6C1009E}"/>
               </a:ext>
             </a:extLst>
           </p:cNvPr>
@@ -10579,7 +10822,7 @@
           <p:cNvPr id="3" name="">
             <a:extLst xmlns:a="http://schemas.openxmlformats.org/drawingml/2006/main">
               <a:ext uri="{FF2B5EF4-FFF2-40B4-BE49-F238E27FC236}">
-                <a16:creationId xmlns:a16="http://schemas.microsoft.com/office/drawing/2014/main" id="{5EC3C0EE-2A32-49D9-8729-186547DD1A69}"/>
+                <a16:creationId xmlns:a16="http://schemas.microsoft.com/office/drawing/2014/main" id="{4475FC63-F5B5-4F07-9A2D-268573656C05}"/>
               </a:ext>
             </a:extLst>
           </p:cNvPr>
@@ -10735,7 +10978,7 @@
           <p:cNvPr id="4" name="">
             <a:extLst xmlns:a="http://schemas.openxmlformats.org/drawingml/2006/main">
               <a:ext uri="{FF2B5EF4-FFF2-40B4-BE49-F238E27FC236}">
-                <a16:creationId xmlns:a16="http://schemas.microsoft.com/office/drawing/2014/main" id="{5CF8B0D8-14F2-4D11-A242-D3318BEE89F8}"/>
+                <a16:creationId xmlns:a16="http://schemas.microsoft.com/office/drawing/2014/main" id="{FE3F7A01-69E3-41CD-9DCD-2F422A6B5B71}"/>
               </a:ext>
             </a:extLst>
           </p:cNvPr>
@@ -10891,7 +11134,7 @@
           <p:cNvPr id="5" name="">
             <a:extLst xmlns:a="http://schemas.openxmlformats.org/drawingml/2006/main">
               <a:ext uri="{FF2B5EF4-FFF2-40B4-BE49-F238E27FC236}">
-                <a16:creationId xmlns:a16="http://schemas.microsoft.com/office/drawing/2014/main" id="{89D9B778-DAC7-4E4F-99EA-34728DB6912A}"/>
+                <a16:creationId xmlns:a16="http://schemas.microsoft.com/office/drawing/2014/main" id="{B2CC80CC-6DBB-4AFD-A6DA-C52B3D91349B}"/>
               </a:ext>
             </a:extLst>
           </p:cNvPr>
@@ -11047,7 +11290,7 @@
           <p:cNvPr id="6" name="">
             <a:extLst xmlns:a="http://schemas.openxmlformats.org/drawingml/2006/main">
               <a:ext uri="{FF2B5EF4-FFF2-40B4-BE49-F238E27FC236}">
-                <a16:creationId xmlns:a16="http://schemas.microsoft.com/office/drawing/2014/main" id="{2F0793CB-3227-4FF5-879D-9747B756FFF7}"/>
+                <a16:creationId xmlns:a16="http://schemas.microsoft.com/office/drawing/2014/main" id="{4092D56B-5AB9-4697-890C-CB04C41EBC9B}"/>
               </a:ext>
             </a:extLst>
           </p:cNvPr>
@@ -11201,7 +11444,7 @@
     </p:spTree>
     <p:extLst>
       <p:ext uri="{BB962C8B-B14F-4D97-AF65-F5344CB8AC3E}">
-        <p14:creationId xmlns:p14="http://schemas.microsoft.com/office/powerpoint/2010/main" val="494189156"/>
+        <p14:creationId xmlns:p14="http://schemas.microsoft.com/office/powerpoint/2010/main" val="1482145178"/>
       </p:ext>
     </p:extLst>
   </p:cSld>
@@ -11232,7 +11475,7 @@
           <p:cNvPr id="11" name="">
             <a:extLst xmlns:a="http://schemas.openxmlformats.org/drawingml/2006/main">
               <a:ext uri="{FF2B5EF4-FFF2-40B4-BE49-F238E27FC236}">
-                <a16:creationId xmlns:a16="http://schemas.microsoft.com/office/drawing/2014/main" id="{3EBBCB5D-2E1A-468D-B927-7F109B67896A}"/>
+                <a16:creationId xmlns:a16="http://schemas.microsoft.com/office/drawing/2014/main" id="{D28A0BE3-56AB-43BF-B4D4-1E83B69C0489}"/>
               </a:ext>
             </a:extLst>
           </p:cNvPr>
@@ -11388,7 +11631,7 @@
           <p:cNvPr id="2" name="">
             <a:extLst xmlns:a="http://schemas.openxmlformats.org/drawingml/2006/main">
               <a:ext uri="{FF2B5EF4-FFF2-40B4-BE49-F238E27FC236}">
-                <a16:creationId xmlns:a16="http://schemas.microsoft.com/office/drawing/2014/main" id="{F053AB7B-FEEE-400A-8A31-4C66F37D0036}"/>
+                <a16:creationId xmlns:a16="http://schemas.microsoft.com/office/drawing/2014/main" id="{086C06F9-6011-48D5-B060-BC8E9E862EAF}"/>
               </a:ext>
             </a:extLst>
           </p:cNvPr>
@@ -11544,7 +11787,7 @@
           <p:cNvPr id="3" name="">
             <a:extLst xmlns:a="http://schemas.openxmlformats.org/drawingml/2006/main">
               <a:ext uri="{FF2B5EF4-FFF2-40B4-BE49-F238E27FC236}">
-                <a16:creationId xmlns:a16="http://schemas.microsoft.com/office/drawing/2014/main" id="{C8728977-20FF-441C-8D75-A276370164BB}"/>
+                <a16:creationId xmlns:a16="http://schemas.microsoft.com/office/drawing/2014/main" id="{0A8B4936-8967-4579-A46E-4FDAA1BAFA73}"/>
               </a:ext>
             </a:extLst>
           </p:cNvPr>
@@ -11700,7 +11943,7 @@
           <p:cNvPr id="4" name="">
             <a:extLst xmlns:a="http://schemas.openxmlformats.org/drawingml/2006/main">
               <a:ext uri="{FF2B5EF4-FFF2-40B4-BE49-F238E27FC236}">
-                <a16:creationId xmlns:a16="http://schemas.microsoft.com/office/drawing/2014/main" id="{FDEED9C0-5B9C-4CB3-8385-D33FC1352D74}"/>
+                <a16:creationId xmlns:a16="http://schemas.microsoft.com/office/drawing/2014/main" id="{EBAB979F-62A0-47C7-AD26-46EF88B31906}"/>
               </a:ext>
             </a:extLst>
           </p:cNvPr>
@@ -11856,7 +12099,7 @@
           <p:cNvPr id="5" name="">
             <a:extLst xmlns:a="http://schemas.openxmlformats.org/drawingml/2006/main">
               <a:ext uri="{FF2B5EF4-FFF2-40B4-BE49-F238E27FC236}">
-                <a16:creationId xmlns:a16="http://schemas.microsoft.com/office/drawing/2014/main" id="{DB21C38E-1B34-4BD2-98BF-D429A6661B95}"/>
+                <a16:creationId xmlns:a16="http://schemas.microsoft.com/office/drawing/2014/main" id="{05F47234-5A63-4B2C-8890-85823D2B7063}"/>
               </a:ext>
             </a:extLst>
           </p:cNvPr>
@@ -12012,7 +12255,7 @@
           <p:cNvPr id="6" name="">
             <a:extLst xmlns:a="http://schemas.openxmlformats.org/drawingml/2006/main">
               <a:ext uri="{FF2B5EF4-FFF2-40B4-BE49-F238E27FC236}">
-                <a16:creationId xmlns:a16="http://schemas.microsoft.com/office/drawing/2014/main" id="{1D92C613-6E7F-451C-966C-E65598CA6B41}"/>
+                <a16:creationId xmlns:a16="http://schemas.microsoft.com/office/drawing/2014/main" id="{466359F1-B7C9-42BC-9E73-63B9268CC810}"/>
               </a:ext>
             </a:extLst>
           </p:cNvPr>
@@ -12168,7 +12411,7 @@
           <p:cNvPr id="7" name="">
             <a:extLst xmlns:a="http://schemas.openxmlformats.org/drawingml/2006/main">
               <a:ext uri="{FF2B5EF4-FFF2-40B4-BE49-F238E27FC236}">
-                <a16:creationId xmlns:a16="http://schemas.microsoft.com/office/drawing/2014/main" id="{091E3089-0924-4B92-ADA8-35DFCD70A62B}"/>
+                <a16:creationId xmlns:a16="http://schemas.microsoft.com/office/drawing/2014/main" id="{791B9ECC-65AB-4F15-A3EA-207F08CD2EF8}"/>
               </a:ext>
             </a:extLst>
           </p:cNvPr>
@@ -12324,7 +12567,7 @@
           <p:cNvPr id="8" name="">
             <a:extLst xmlns:a="http://schemas.openxmlformats.org/drawingml/2006/main">
               <a:ext uri="{FF2B5EF4-FFF2-40B4-BE49-F238E27FC236}">
-                <a16:creationId xmlns:a16="http://schemas.microsoft.com/office/drawing/2014/main" id="{B57548B9-B47A-415B-AEE2-BCD2B5BDBA6E}"/>
+                <a16:creationId xmlns:a16="http://schemas.microsoft.com/office/drawing/2014/main" id="{C87F4B43-56C9-4EBE-ADF1-5BBA48E2F7DF}"/>
               </a:ext>
             </a:extLst>
           </p:cNvPr>
@@ -12480,7 +12723,7 @@
           <p:cNvPr id="9" name="">
             <a:extLst xmlns:a="http://schemas.openxmlformats.org/drawingml/2006/main">
               <a:ext uri="{FF2B5EF4-FFF2-40B4-BE49-F238E27FC236}">
-                <a16:creationId xmlns:a16="http://schemas.microsoft.com/office/drawing/2014/main" id="{BCF5FA55-B1E1-4CDC-B21D-8E8676CF5987}"/>
+                <a16:creationId xmlns:a16="http://schemas.microsoft.com/office/drawing/2014/main" id="{0D52F3B5-7E6C-4F9D-BFD0-AFBAEC3583D2}"/>
               </a:ext>
             </a:extLst>
           </p:cNvPr>
@@ -12636,7 +12879,7 @@
           <p:cNvPr id="10" name="">
             <a:extLst xmlns:a="http://schemas.openxmlformats.org/drawingml/2006/main">
               <a:ext uri="{FF2B5EF4-FFF2-40B4-BE49-F238E27FC236}">
-                <a16:creationId xmlns:a16="http://schemas.microsoft.com/office/drawing/2014/main" id="{58A28B22-C5B8-4012-8410-1BEA3F10AFF5}"/>
+                <a16:creationId xmlns:a16="http://schemas.microsoft.com/office/drawing/2014/main" id="{03E1D115-66FC-4954-94B4-F2BB3405053C}"/>
               </a:ext>
             </a:extLst>
           </p:cNvPr>
@@ -12790,7 +13033,7 @@
     </p:spTree>
     <p:extLst>
       <p:ext uri="{BB962C8B-B14F-4D97-AF65-F5344CB8AC3E}">
-        <p14:creationId xmlns:p14="http://schemas.microsoft.com/office/powerpoint/2010/main" val="525928519"/>
+        <p14:creationId xmlns:p14="http://schemas.microsoft.com/office/powerpoint/2010/main" val="972751252"/>
       </p:ext>
     </p:extLst>
   </p:cSld>
@@ -12821,7 +13064,7 @@
           <p:cNvPr id="7" name="">
             <a:extLst xmlns:a="http://schemas.openxmlformats.org/drawingml/2006/main">
               <a:ext uri="{FF2B5EF4-FFF2-40B4-BE49-F238E27FC236}">
-                <a16:creationId xmlns:a16="http://schemas.microsoft.com/office/drawing/2014/main" id="{E16F758B-AD26-4B0B-A817-EC3E93BBC492}"/>
+                <a16:creationId xmlns:a16="http://schemas.microsoft.com/office/drawing/2014/main" id="{A52375D3-562E-47C0-8B3A-588E71B19D54}"/>
               </a:ext>
             </a:extLst>
           </p:cNvPr>
@@ -12977,7 +13220,7 @@
           <p:cNvPr id="2" name="">
             <a:extLst xmlns:a="http://schemas.openxmlformats.org/drawingml/2006/main">
               <a:ext uri="{FF2B5EF4-FFF2-40B4-BE49-F238E27FC236}">
-                <a16:creationId xmlns:a16="http://schemas.microsoft.com/office/drawing/2014/main" id="{C84F4592-327B-413D-8523-7F36B0B7677C}"/>
+                <a16:creationId xmlns:a16="http://schemas.microsoft.com/office/drawing/2014/main" id="{29BFB2DD-D6B2-4CC0-B1C5-D52037AA149A}"/>
               </a:ext>
             </a:extLst>
           </p:cNvPr>
@@ -13133,7 +13376,7 @@
           <p:cNvPr id="3" name="">
             <a:extLst xmlns:a="http://schemas.openxmlformats.org/drawingml/2006/main">
               <a:ext uri="{FF2B5EF4-FFF2-40B4-BE49-F238E27FC236}">
-                <a16:creationId xmlns:a16="http://schemas.microsoft.com/office/drawing/2014/main" id="{DB0D2A3B-50AB-48F3-B79C-EB0F593C22E7}"/>
+                <a16:creationId xmlns:a16="http://schemas.microsoft.com/office/drawing/2014/main" id="{72C0A16C-7363-46EF-807D-53A4B2D078D5}"/>
               </a:ext>
             </a:extLst>
           </p:cNvPr>
@@ -13289,7 +13532,7 @@
           <p:cNvPr id="4" name="">
             <a:extLst xmlns:a="http://schemas.openxmlformats.org/drawingml/2006/main">
               <a:ext uri="{FF2B5EF4-FFF2-40B4-BE49-F238E27FC236}">
-                <a16:creationId xmlns:a16="http://schemas.microsoft.com/office/drawing/2014/main" id="{FA8011EA-7989-44EC-99CB-2EF1F082B18B}"/>
+                <a16:creationId xmlns:a16="http://schemas.microsoft.com/office/drawing/2014/main" id="{ECD04D5D-0F9F-4A2A-9F75-D1C6F43C726F}"/>
               </a:ext>
             </a:extLst>
           </p:cNvPr>
@@ -13445,7 +13688,7 @@
           <p:cNvPr id="5" name="">
             <a:extLst xmlns:a="http://schemas.openxmlformats.org/drawingml/2006/main">
               <a:ext uri="{FF2B5EF4-FFF2-40B4-BE49-F238E27FC236}">
-                <a16:creationId xmlns:a16="http://schemas.microsoft.com/office/drawing/2014/main" id="{90783EB6-6725-4AF7-B8D4-AF3192A8C305}"/>
+                <a16:creationId xmlns:a16="http://schemas.microsoft.com/office/drawing/2014/main" id="{BABC086D-8562-4D40-973D-CDF094FB0161}"/>
               </a:ext>
             </a:extLst>
           </p:cNvPr>
@@ -13601,7 +13844,7 @@
           <p:cNvPr id="6" name="">
             <a:extLst xmlns:a="http://schemas.openxmlformats.org/drawingml/2006/main">
               <a:ext uri="{FF2B5EF4-FFF2-40B4-BE49-F238E27FC236}">
-                <a16:creationId xmlns:a16="http://schemas.microsoft.com/office/drawing/2014/main" id="{ABD6679E-8D12-42D2-B6B2-A710D9E0FBB7}"/>
+                <a16:creationId xmlns:a16="http://schemas.microsoft.com/office/drawing/2014/main" id="{3DD5C2D6-6BBA-45AE-9ED3-05C8A7D834A3}"/>
               </a:ext>
             </a:extLst>
           </p:cNvPr>
@@ -13755,7 +13998,7 @@
     </p:spTree>
     <p:extLst>
       <p:ext uri="{BB962C8B-B14F-4D97-AF65-F5344CB8AC3E}">
-        <p14:creationId xmlns:p14="http://schemas.microsoft.com/office/powerpoint/2010/main" val="778488274"/>
+        <p14:creationId xmlns:p14="http://schemas.microsoft.com/office/powerpoint/2010/main" val="1731411501"/>
       </p:ext>
     </p:extLst>
   </p:cSld>
@@ -13786,7 +14029,7 @@
           <p:cNvPr id="8" name="">
             <a:extLst xmlns:a="http://schemas.openxmlformats.org/drawingml/2006/main">
               <a:ext uri="{FF2B5EF4-FFF2-40B4-BE49-F238E27FC236}">
-                <a16:creationId xmlns:a16="http://schemas.microsoft.com/office/drawing/2014/main" id="{3554640A-B872-4272-9A94-2B9B70ABDEF7}"/>
+                <a16:creationId xmlns:a16="http://schemas.microsoft.com/office/drawing/2014/main" id="{928D1EA9-9110-45D3-8F5D-32B095955180}"/>
               </a:ext>
             </a:extLst>
           </p:cNvPr>
@@ -13942,7 +14185,7 @@
           <p:cNvPr id="2" name="">
             <a:extLst xmlns:a="http://schemas.openxmlformats.org/drawingml/2006/main">
               <a:ext uri="{FF2B5EF4-FFF2-40B4-BE49-F238E27FC236}">
-                <a16:creationId xmlns:a16="http://schemas.microsoft.com/office/drawing/2014/main" id="{1B34B386-A180-4CFC-9263-3951801AEDDE}"/>
+                <a16:creationId xmlns:a16="http://schemas.microsoft.com/office/drawing/2014/main" id="{2A834C48-779D-4985-AF3A-7484582EB8EB}"/>
               </a:ext>
             </a:extLst>
           </p:cNvPr>
@@ -14098,7 +14341,7 @@
           <p:cNvPr id="3" name="">
             <a:extLst xmlns:a="http://schemas.openxmlformats.org/drawingml/2006/main">
               <a:ext uri="{FF2B5EF4-FFF2-40B4-BE49-F238E27FC236}">
-                <a16:creationId xmlns:a16="http://schemas.microsoft.com/office/drawing/2014/main" id="{756086D3-598D-410C-AAD6-626B279709DA}"/>
+                <a16:creationId xmlns:a16="http://schemas.microsoft.com/office/drawing/2014/main" id="{4F8B406A-F03E-435E-8DBB-2381BDE9B388}"/>
               </a:ext>
             </a:extLst>
           </p:cNvPr>
@@ -14254,7 +14497,7 @@
           <p:cNvPr id="4" name="">
             <a:extLst xmlns:a="http://schemas.openxmlformats.org/drawingml/2006/main">
               <a:ext uri="{FF2B5EF4-FFF2-40B4-BE49-F238E27FC236}">
-                <a16:creationId xmlns:a16="http://schemas.microsoft.com/office/drawing/2014/main" id="{7D8CD7F4-F23F-4743-A3B2-C637BCB83F31}"/>
+                <a16:creationId xmlns:a16="http://schemas.microsoft.com/office/drawing/2014/main" id="{4EC67CE8-8AFC-47ED-8F37-05FD5CF226E0}"/>
               </a:ext>
             </a:extLst>
           </p:cNvPr>
@@ -14410,7 +14653,7 @@
           <p:cNvPr id="5" name="">
             <a:extLst xmlns:a="http://schemas.openxmlformats.org/drawingml/2006/main">
               <a:ext uri="{FF2B5EF4-FFF2-40B4-BE49-F238E27FC236}">
-                <a16:creationId xmlns:a16="http://schemas.microsoft.com/office/drawing/2014/main" id="{B427C008-7C1A-4BCA-BEF0-D190D6CAFCA9}"/>
+                <a16:creationId xmlns:a16="http://schemas.microsoft.com/office/drawing/2014/main" id="{A995F738-1755-4DB3-B6E6-07CDF728BE97}"/>
               </a:ext>
             </a:extLst>
           </p:cNvPr>
@@ -14566,7 +14809,7 @@
           <p:cNvPr id="6" name="">
             <a:extLst xmlns:a="http://schemas.openxmlformats.org/drawingml/2006/main">
               <a:ext uri="{FF2B5EF4-FFF2-40B4-BE49-F238E27FC236}">
-                <a16:creationId xmlns:a16="http://schemas.microsoft.com/office/drawing/2014/main" id="{8954DDED-0111-41CF-952A-02643DB69522}"/>
+                <a16:creationId xmlns:a16="http://schemas.microsoft.com/office/drawing/2014/main" id="{EB94547E-4526-4F54-944B-BB07EE8D8599}"/>
               </a:ext>
             </a:extLst>
           </p:cNvPr>
@@ -14722,7 +14965,7 @@
           <p:cNvPr id="7" name="">
             <a:extLst xmlns:a="http://schemas.openxmlformats.org/drawingml/2006/main">
               <a:ext uri="{FF2B5EF4-FFF2-40B4-BE49-F238E27FC236}">
-                <a16:creationId xmlns:a16="http://schemas.microsoft.com/office/drawing/2014/main" id="{91542B25-006F-47DD-964B-E7B50313874B}"/>
+                <a16:creationId xmlns:a16="http://schemas.microsoft.com/office/drawing/2014/main" id="{BA4E78AA-B74E-4C60-8692-50D4026944E1}"/>
               </a:ext>
             </a:extLst>
           </p:cNvPr>
@@ -14876,7 +15119,7 @@
     </p:spTree>
     <p:extLst>
       <p:ext uri="{BB962C8B-B14F-4D97-AF65-F5344CB8AC3E}">
-        <p14:creationId xmlns:p14="http://schemas.microsoft.com/office/powerpoint/2010/main" val="1666032879"/>
+        <p14:creationId xmlns:p14="http://schemas.microsoft.com/office/powerpoint/2010/main" val="288601407"/>
       </p:ext>
     </p:extLst>
   </p:cSld>
@@ -14907,7 +15150,7 @@
           <p:cNvPr id="8" name="">
             <a:extLst xmlns:a="http://schemas.openxmlformats.org/drawingml/2006/main">
               <a:ext uri="{FF2B5EF4-FFF2-40B4-BE49-F238E27FC236}">
-                <a16:creationId xmlns:a16="http://schemas.microsoft.com/office/drawing/2014/main" id="{E92D7385-DD49-4B2A-9F8A-BCC6BC446736}"/>
+                <a16:creationId xmlns:a16="http://schemas.microsoft.com/office/drawing/2014/main" id="{1FC6005D-57A3-4B15-86E3-541EB7A83A7D}"/>
               </a:ext>
             </a:extLst>
           </p:cNvPr>
@@ -15063,7 +15306,7 @@
           <p:cNvPr id="2" name="">
             <a:extLst xmlns:a="http://schemas.openxmlformats.org/drawingml/2006/main">
               <a:ext uri="{FF2B5EF4-FFF2-40B4-BE49-F238E27FC236}">
-                <a16:creationId xmlns:a16="http://schemas.microsoft.com/office/drawing/2014/main" id="{FAB4B7EA-0D49-4D36-ABA1-1F501B115E57}"/>
+                <a16:creationId xmlns:a16="http://schemas.microsoft.com/office/drawing/2014/main" id="{4935D9C7-3D08-4534-98CF-FAA83F8AF983}"/>
               </a:ext>
             </a:extLst>
           </p:cNvPr>
@@ -15219,7 +15462,7 @@
           <p:cNvPr id="3" name="">
             <a:extLst xmlns:a="http://schemas.openxmlformats.org/drawingml/2006/main">
               <a:ext uri="{FF2B5EF4-FFF2-40B4-BE49-F238E27FC236}">
-                <a16:creationId xmlns:a16="http://schemas.microsoft.com/office/drawing/2014/main" id="{68C04414-1DA9-4F55-A577-8B9D6697784A}"/>
+                <a16:creationId xmlns:a16="http://schemas.microsoft.com/office/drawing/2014/main" id="{562D9DDC-E455-4F7C-82FB-4A48B93D7593}"/>
               </a:ext>
             </a:extLst>
           </p:cNvPr>
@@ -15375,7 +15618,7 @@
           <p:cNvPr id="4" name="">
             <a:extLst xmlns:a="http://schemas.openxmlformats.org/drawingml/2006/main">
               <a:ext uri="{FF2B5EF4-FFF2-40B4-BE49-F238E27FC236}">
-                <a16:creationId xmlns:a16="http://schemas.microsoft.com/office/drawing/2014/main" id="{948C3912-0CCA-4DAE-B571-4AA3F0A88505}"/>
+                <a16:creationId xmlns:a16="http://schemas.microsoft.com/office/drawing/2014/main" id="{71A772DB-2E2C-4323-BC06-B4E5A86F8CC1}"/>
               </a:ext>
             </a:extLst>
           </p:cNvPr>
@@ -15531,7 +15774,7 @@
           <p:cNvPr id="5" name="">
             <a:extLst xmlns:a="http://schemas.openxmlformats.org/drawingml/2006/main">
               <a:ext uri="{FF2B5EF4-FFF2-40B4-BE49-F238E27FC236}">
-                <a16:creationId xmlns:a16="http://schemas.microsoft.com/office/drawing/2014/main" id="{2ACB8814-5E79-46FD-8642-419B332E5F8D}"/>
+                <a16:creationId xmlns:a16="http://schemas.microsoft.com/office/drawing/2014/main" id="{14B6E0C6-0AFA-400D-8743-F87A932BBFA8}"/>
               </a:ext>
             </a:extLst>
           </p:cNvPr>
@@ -15687,7 +15930,7 @@
           <p:cNvPr id="6" name="">
             <a:extLst xmlns:a="http://schemas.openxmlformats.org/drawingml/2006/main">
               <a:ext uri="{FF2B5EF4-FFF2-40B4-BE49-F238E27FC236}">
-                <a16:creationId xmlns:a16="http://schemas.microsoft.com/office/drawing/2014/main" id="{B19081B4-4549-4C0B-9ADA-470C8710C540}"/>
+                <a16:creationId xmlns:a16="http://schemas.microsoft.com/office/drawing/2014/main" id="{2BD5BD48-0840-4731-84F7-A47A990BF143}"/>
               </a:ext>
             </a:extLst>
           </p:cNvPr>
@@ -15843,7 +16086,7 @@
           <p:cNvPr id="7" name="">
             <a:extLst xmlns:a="http://schemas.openxmlformats.org/drawingml/2006/main">
               <a:ext uri="{FF2B5EF4-FFF2-40B4-BE49-F238E27FC236}">
-                <a16:creationId xmlns:a16="http://schemas.microsoft.com/office/drawing/2014/main" id="{6ED80A65-27AD-4682-9638-7E92832D0B5D}"/>
+                <a16:creationId xmlns:a16="http://schemas.microsoft.com/office/drawing/2014/main" id="{A96FCC6F-848B-4E47-A98F-4205B9C48272}"/>
               </a:ext>
             </a:extLst>
           </p:cNvPr>
@@ -15997,7 +16240,7 @@
     </p:spTree>
     <p:extLst>
       <p:ext uri="{BB962C8B-B14F-4D97-AF65-F5344CB8AC3E}">
-        <p14:creationId xmlns:p14="http://schemas.microsoft.com/office/powerpoint/2010/main" val="947440618"/>
+        <p14:creationId xmlns:p14="http://schemas.microsoft.com/office/powerpoint/2010/main" val="814217100"/>
       </p:ext>
     </p:extLst>
   </p:cSld>
@@ -16028,7 +16271,7 @@
           <p:cNvPr id="7" name="">
             <a:extLst xmlns:a="http://schemas.openxmlformats.org/drawingml/2006/main">
               <a:ext uri="{FF2B5EF4-FFF2-40B4-BE49-F238E27FC236}">
-                <a16:creationId xmlns:a16="http://schemas.microsoft.com/office/drawing/2014/main" id="{24AF0700-9D6E-49D9-8CEC-371B4C624034}"/>
+                <a16:creationId xmlns:a16="http://schemas.microsoft.com/office/drawing/2014/main" id="{9AC7EDE0-08B3-45D9-B4D9-917DF3FF3F05}"/>
               </a:ext>
             </a:extLst>
           </p:cNvPr>
@@ -16184,7 +16427,7 @@
           <p:cNvPr id="2" name="">
             <a:extLst xmlns:a="http://schemas.openxmlformats.org/drawingml/2006/main">
               <a:ext uri="{FF2B5EF4-FFF2-40B4-BE49-F238E27FC236}">
-                <a16:creationId xmlns:a16="http://schemas.microsoft.com/office/drawing/2014/main" id="{B0A90773-7020-43D9-A5BF-19918C2F05B0}"/>
+                <a16:creationId xmlns:a16="http://schemas.microsoft.com/office/drawing/2014/main" id="{B665C49E-35B1-4634-A89C-A931347B42AA}"/>
               </a:ext>
             </a:extLst>
           </p:cNvPr>
@@ -16340,7 +16583,7 @@
           <p:cNvPr id="3" name="">
             <a:extLst xmlns:a="http://schemas.openxmlformats.org/drawingml/2006/main">
               <a:ext uri="{FF2B5EF4-FFF2-40B4-BE49-F238E27FC236}">
-                <a16:creationId xmlns:a16="http://schemas.microsoft.com/office/drawing/2014/main" id="{8A9D6D9D-5DEB-4888-9C46-9709E2AC1264}"/>
+                <a16:creationId xmlns:a16="http://schemas.microsoft.com/office/drawing/2014/main" id="{621B62DC-4C2E-4E24-B1CA-3D3A44598DE6}"/>
               </a:ext>
             </a:extLst>
           </p:cNvPr>
@@ -16496,7 +16739,7 @@
           <p:cNvPr id="4" name="">
             <a:extLst xmlns:a="http://schemas.openxmlformats.org/drawingml/2006/main">
               <a:ext uri="{FF2B5EF4-FFF2-40B4-BE49-F238E27FC236}">
-                <a16:creationId xmlns:a16="http://schemas.microsoft.com/office/drawing/2014/main" id="{4708E75E-88FC-47FA-8656-47E88785F965}"/>
+                <a16:creationId xmlns:a16="http://schemas.microsoft.com/office/drawing/2014/main" id="{53BC6630-E7D8-4F38-A525-AAF75BD7751E}"/>
               </a:ext>
             </a:extLst>
           </p:cNvPr>
@@ -16652,7 +16895,7 @@
           <p:cNvPr id="5" name="">
             <a:extLst xmlns:a="http://schemas.openxmlformats.org/drawingml/2006/main">
               <a:ext uri="{FF2B5EF4-FFF2-40B4-BE49-F238E27FC236}">
-                <a16:creationId xmlns:a16="http://schemas.microsoft.com/office/drawing/2014/main" id="{8C443A26-4734-46B4-8EB6-EF3360594BD8}"/>
+                <a16:creationId xmlns:a16="http://schemas.microsoft.com/office/drawing/2014/main" id="{C3D768D2-8B18-4A92-A557-85EE3CB078E0}"/>
               </a:ext>
             </a:extLst>
           </p:cNvPr>
@@ -16808,7 +17051,7 @@
           <p:cNvPr id="6" name="">
             <a:extLst xmlns:a="http://schemas.openxmlformats.org/drawingml/2006/main">
               <a:ext uri="{FF2B5EF4-FFF2-40B4-BE49-F238E27FC236}">
-                <a16:creationId xmlns:a16="http://schemas.microsoft.com/office/drawing/2014/main" id="{26729C5F-71DD-4942-8A70-AD684F5B2E06}"/>
+                <a16:creationId xmlns:a16="http://schemas.microsoft.com/office/drawing/2014/main" id="{73DA91FC-AAA7-43AE-A469-46C4AB04C0EB}"/>
               </a:ext>
             </a:extLst>
           </p:cNvPr>
@@ -16962,7 +17205,7 @@
     </p:spTree>
     <p:extLst>
       <p:ext uri="{BB962C8B-B14F-4D97-AF65-F5344CB8AC3E}">
-        <p14:creationId xmlns:p14="http://schemas.microsoft.com/office/powerpoint/2010/main" val="654671608"/>
+        <p14:creationId xmlns:p14="http://schemas.microsoft.com/office/powerpoint/2010/main" val="573882118"/>
       </p:ext>
     </p:extLst>
   </p:cSld>
@@ -16993,7 +17236,7 @@
           <p:cNvPr id="12" name="">
             <a:extLst xmlns:a="http://schemas.openxmlformats.org/drawingml/2006/main">
               <a:ext uri="{FF2B5EF4-FFF2-40B4-BE49-F238E27FC236}">
-                <a16:creationId xmlns:a16="http://schemas.microsoft.com/office/drawing/2014/main" id="{6D4C5C99-093F-4E77-A26D-DCAC4F94FFEA}"/>
+                <a16:creationId xmlns:a16="http://schemas.microsoft.com/office/drawing/2014/main" id="{D5ED5641-C685-4C22-962D-7DF05CEC50A9}"/>
               </a:ext>
             </a:extLst>
           </p:cNvPr>
@@ -17149,7 +17392,7 @@
           <p:cNvPr id="2" name="">
             <a:extLst xmlns:a="http://schemas.openxmlformats.org/drawingml/2006/main">
               <a:ext uri="{FF2B5EF4-FFF2-40B4-BE49-F238E27FC236}">
-                <a16:creationId xmlns:a16="http://schemas.microsoft.com/office/drawing/2014/main" id="{38B8CF1A-2070-4B8A-B038-CAB3FE5DC6A2}"/>
+                <a16:creationId xmlns:a16="http://schemas.microsoft.com/office/drawing/2014/main" id="{933208BB-CC2A-444D-A764-AEF47840397D}"/>
               </a:ext>
             </a:extLst>
           </p:cNvPr>
@@ -17305,7 +17548,7 @@
           <p:cNvPr id="3" name="">
             <a:extLst xmlns:a="http://schemas.openxmlformats.org/drawingml/2006/main">
               <a:ext uri="{FF2B5EF4-FFF2-40B4-BE49-F238E27FC236}">
-                <a16:creationId xmlns:a16="http://schemas.microsoft.com/office/drawing/2014/main" id="{4EBF5616-E861-48EA-AF63-D67E052B1987}"/>
+                <a16:creationId xmlns:a16="http://schemas.microsoft.com/office/drawing/2014/main" id="{D5E9FE54-7FDF-477C-B926-5F0287B24D3F}"/>
               </a:ext>
             </a:extLst>
           </p:cNvPr>
@@ -17461,7 +17704,7 @@
           <p:cNvPr id="4" name="">
             <a:extLst xmlns:a="http://schemas.openxmlformats.org/drawingml/2006/main">
               <a:ext uri="{FF2B5EF4-FFF2-40B4-BE49-F238E27FC236}">
-                <a16:creationId xmlns:a16="http://schemas.microsoft.com/office/drawing/2014/main" id="{DA4B2787-CEC2-4269-924D-2F88F525548A}"/>
+                <a16:creationId xmlns:a16="http://schemas.microsoft.com/office/drawing/2014/main" id="{6824C1A5-43EE-46F2-96FF-F7165F535D30}"/>
               </a:ext>
             </a:extLst>
           </p:cNvPr>
@@ -17471,7 +17714,7 @@
           <p:nvPr/>
         </p:nvPicPr>
         <p:blipFill>
-          <a:blip xmlns:r="http://schemas.openxmlformats.org/officeDocument/2006/relationships" xmlns:a="http://schemas.openxmlformats.org/drawingml/2006/main" r:embed="R040ad2964a5b4b56"/>
+          <a:blip xmlns:r="http://schemas.openxmlformats.org/officeDocument/2006/relationships" xmlns:a="http://schemas.openxmlformats.org/drawingml/2006/main" r:embed="R525717e770d54d68"/>
           <a:stretch xmlns:a="http://schemas.openxmlformats.org/drawingml/2006/main"/>
         </p:blipFill>
         <p:spPr>
@@ -17489,7 +17732,7 @@
           <p:cNvPr id="5" name="">
             <a:extLst xmlns:a="http://schemas.openxmlformats.org/drawingml/2006/main">
               <a:ext uri="{FF2B5EF4-FFF2-40B4-BE49-F238E27FC236}">
-                <a16:creationId xmlns:a16="http://schemas.microsoft.com/office/drawing/2014/main" id="{E573C620-9F9D-482C-B876-2CD6C5A0F963}"/>
+                <a16:creationId xmlns:a16="http://schemas.microsoft.com/office/drawing/2014/main" id="{2547DEE6-6B9F-420B-BF17-1C1593BA2354}"/>
               </a:ext>
             </a:extLst>
           </p:cNvPr>
@@ -17645,7 +17888,7 @@
           <p:cNvPr id="6" name="">
             <a:extLst xmlns:a="http://schemas.openxmlformats.org/drawingml/2006/main">
               <a:ext uri="{FF2B5EF4-FFF2-40B4-BE49-F238E27FC236}">
-                <a16:creationId xmlns:a16="http://schemas.microsoft.com/office/drawing/2014/main" id="{F98B4E45-E66D-4836-BF97-8C3315DEF5C8}"/>
+                <a16:creationId xmlns:a16="http://schemas.microsoft.com/office/drawing/2014/main" id="{C6EF63D5-0CAA-4070-9D82-878CD604D253}"/>
               </a:ext>
             </a:extLst>
           </p:cNvPr>
@@ -17801,7 +18044,7 @@
           <p:cNvPr id="7" name="">
             <a:extLst xmlns:a="http://schemas.openxmlformats.org/drawingml/2006/main">
               <a:ext uri="{FF2B5EF4-FFF2-40B4-BE49-F238E27FC236}">
-                <a16:creationId xmlns:a16="http://schemas.microsoft.com/office/drawing/2014/main" id="{95F1782C-FF23-44E6-AA52-D3468B44D5E8}"/>
+                <a16:creationId xmlns:a16="http://schemas.microsoft.com/office/drawing/2014/main" id="{CD655C96-8388-4C28-A76F-C59487BA43A0}"/>
               </a:ext>
             </a:extLst>
           </p:cNvPr>
@@ -17957,7 +18200,7 @@
           <p:cNvPr id="8" name="">
             <a:extLst xmlns:a="http://schemas.openxmlformats.org/drawingml/2006/main">
               <a:ext uri="{FF2B5EF4-FFF2-40B4-BE49-F238E27FC236}">
-                <a16:creationId xmlns:a16="http://schemas.microsoft.com/office/drawing/2014/main" id="{AD9DFADF-A017-47FF-8B3D-358C4A87F1EC}"/>
+                <a16:creationId xmlns:a16="http://schemas.microsoft.com/office/drawing/2014/main" id="{9E401DA1-BEF6-4FD1-A347-0A213CB15389}"/>
               </a:ext>
             </a:extLst>
           </p:cNvPr>
@@ -18113,7 +18356,7 @@
           <p:cNvPr id="9" name="">
             <a:extLst xmlns:a="http://schemas.openxmlformats.org/drawingml/2006/main">
               <a:ext uri="{FF2B5EF4-FFF2-40B4-BE49-F238E27FC236}">
-                <a16:creationId xmlns:a16="http://schemas.microsoft.com/office/drawing/2014/main" id="{B01A6419-27F3-4BE0-8647-97042CA5E480}"/>
+                <a16:creationId xmlns:a16="http://schemas.microsoft.com/office/drawing/2014/main" id="{537D20C5-A3F3-4AF6-A2A6-799C848F04BD}"/>
               </a:ext>
             </a:extLst>
           </p:cNvPr>
@@ -18269,7 +18512,7 @@
           <p:cNvPr id="10" name="">
             <a:extLst xmlns:a="http://schemas.openxmlformats.org/drawingml/2006/main">
               <a:ext uri="{FF2B5EF4-FFF2-40B4-BE49-F238E27FC236}">
-                <a16:creationId xmlns:a16="http://schemas.microsoft.com/office/drawing/2014/main" id="{60D4877A-49E3-4EA0-A865-F43F9D7AAB74}"/>
+                <a16:creationId xmlns:a16="http://schemas.microsoft.com/office/drawing/2014/main" id="{4F9D809E-28F9-4C1D-8E7A-FDECBAEC89BD}"/>
               </a:ext>
             </a:extLst>
           </p:cNvPr>
@@ -18425,7 +18668,7 @@
           <p:cNvPr id="11" name="">
             <a:extLst xmlns:a="http://schemas.openxmlformats.org/drawingml/2006/main">
               <a:ext uri="{FF2B5EF4-FFF2-40B4-BE49-F238E27FC236}">
-                <a16:creationId xmlns:a16="http://schemas.microsoft.com/office/drawing/2014/main" id="{7B6B0F24-23ED-4303-B142-1D5067EC45A8}"/>
+                <a16:creationId xmlns:a16="http://schemas.microsoft.com/office/drawing/2014/main" id="{9B082893-FBC9-4921-8248-D48FBD18574F}"/>
               </a:ext>
             </a:extLst>
           </p:cNvPr>
@@ -18579,7 +18822,7 @@
     </p:spTree>
     <p:extLst>
       <p:ext uri="{BB962C8B-B14F-4D97-AF65-F5344CB8AC3E}">
-        <p14:creationId xmlns:p14="http://schemas.microsoft.com/office/powerpoint/2010/main" val="15654975"/>
+        <p14:creationId xmlns:p14="http://schemas.microsoft.com/office/powerpoint/2010/main" val="381143559"/>
       </p:ext>
     </p:extLst>
   </p:cSld>
@@ -18610,7 +18853,7 @@
           <p:cNvPr id="20" name="">
             <a:extLst xmlns:a="http://schemas.openxmlformats.org/drawingml/2006/main">
               <a:ext uri="{FF2B5EF4-FFF2-40B4-BE49-F238E27FC236}">
-                <a16:creationId xmlns:a16="http://schemas.microsoft.com/office/drawing/2014/main" id="{9A2708AD-6966-41CA-8DD5-C0D5E2D913DD}"/>
+                <a16:creationId xmlns:a16="http://schemas.microsoft.com/office/drawing/2014/main" id="{4345BA3C-01E7-427E-942F-149C3BE3F385}"/>
               </a:ext>
             </a:extLst>
           </p:cNvPr>
@@ -18766,7 +19009,7 @@
           <p:cNvPr id="2" name="">
             <a:extLst xmlns:a="http://schemas.openxmlformats.org/drawingml/2006/main">
               <a:ext uri="{FF2B5EF4-FFF2-40B4-BE49-F238E27FC236}">
-                <a16:creationId xmlns:a16="http://schemas.microsoft.com/office/drawing/2014/main" id="{5758A936-314E-4A96-A473-B103502CC78B}"/>
+                <a16:creationId xmlns:a16="http://schemas.microsoft.com/office/drawing/2014/main" id="{7F07A249-AF09-4889-AA9F-D89918945AA3}"/>
               </a:ext>
             </a:extLst>
           </p:cNvPr>
@@ -18922,7 +19165,7 @@
           <p:cNvPr id="3" name="">
             <a:extLst xmlns:a="http://schemas.openxmlformats.org/drawingml/2006/main">
               <a:ext uri="{FF2B5EF4-FFF2-40B4-BE49-F238E27FC236}">
-                <a16:creationId xmlns:a16="http://schemas.microsoft.com/office/drawing/2014/main" id="{C6181259-3D5E-471E-B1B7-2ADC41E6EE50}"/>
+                <a16:creationId xmlns:a16="http://schemas.microsoft.com/office/drawing/2014/main" id="{C8BF3CF5-0C19-4751-9B27-7049826D91EA}"/>
               </a:ext>
             </a:extLst>
           </p:cNvPr>
@@ -19078,7 +19321,7 @@
           <p:cNvPr id="4" name="">
             <a:extLst xmlns:a="http://schemas.openxmlformats.org/drawingml/2006/main">
               <a:ext uri="{FF2B5EF4-FFF2-40B4-BE49-F238E27FC236}">
-                <a16:creationId xmlns:a16="http://schemas.microsoft.com/office/drawing/2014/main" id="{2CF3E7F4-32A2-43FE-93C3-EED81DE41243}"/>
+                <a16:creationId xmlns:a16="http://schemas.microsoft.com/office/drawing/2014/main" id="{AD1506E4-8C4E-4840-9663-3704C90EAB74}"/>
               </a:ext>
             </a:extLst>
           </p:cNvPr>
@@ -19234,7 +19477,7 @@
           <p:cNvPr id="5" name="">
             <a:extLst xmlns:a="http://schemas.openxmlformats.org/drawingml/2006/main">
               <a:ext uri="{FF2B5EF4-FFF2-40B4-BE49-F238E27FC236}">
-                <a16:creationId xmlns:a16="http://schemas.microsoft.com/office/drawing/2014/main" id="{18E511A6-E9D8-4645-A701-55A6D229FE5B}"/>
+                <a16:creationId xmlns:a16="http://schemas.microsoft.com/office/drawing/2014/main" id="{F1495106-0CDB-4738-B9F9-9A0488BC87EE}"/>
               </a:ext>
             </a:extLst>
           </p:cNvPr>
@@ -19390,7 +19633,7 @@
           <p:cNvPr id="6" name="">
             <a:extLst xmlns:a="http://schemas.openxmlformats.org/drawingml/2006/main">
               <a:ext uri="{FF2B5EF4-FFF2-40B4-BE49-F238E27FC236}">
-                <a16:creationId xmlns:a16="http://schemas.microsoft.com/office/drawing/2014/main" id="{752283BF-E67E-44A5-BD5A-BEF1BC78D0E0}"/>
+                <a16:creationId xmlns:a16="http://schemas.microsoft.com/office/drawing/2014/main" id="{05E6FC85-3C13-4966-8541-718DE308C917}"/>
               </a:ext>
             </a:extLst>
           </p:cNvPr>
@@ -19546,7 +19789,7 @@
           <p:cNvPr id="7" name="">
             <a:extLst xmlns:a="http://schemas.openxmlformats.org/drawingml/2006/main">
               <a:ext uri="{FF2B5EF4-FFF2-40B4-BE49-F238E27FC236}">
-                <a16:creationId xmlns:a16="http://schemas.microsoft.com/office/drawing/2014/main" id="{B5F6F77F-766F-477F-8BE8-6C538889DF36}"/>
+                <a16:creationId xmlns:a16="http://schemas.microsoft.com/office/drawing/2014/main" id="{51B06BCE-0F38-4677-BF53-EACC1C79441A}"/>
               </a:ext>
             </a:extLst>
           </p:cNvPr>
@@ -19702,7 +19945,7 @@
           <p:cNvPr id="8" name="">
             <a:extLst xmlns:a="http://schemas.openxmlformats.org/drawingml/2006/main">
               <a:ext uri="{FF2B5EF4-FFF2-40B4-BE49-F238E27FC236}">
-                <a16:creationId xmlns:a16="http://schemas.microsoft.com/office/drawing/2014/main" id="{5A89CD3B-B138-49EB-8D9B-7181477D99A3}"/>
+                <a16:creationId xmlns:a16="http://schemas.microsoft.com/office/drawing/2014/main" id="{7379C94A-C659-4C4F-98DF-447E56E98252}"/>
               </a:ext>
             </a:extLst>
           </p:cNvPr>
@@ -19858,7 +20101,7 @@
           <p:cNvPr id="9" name="">
             <a:extLst xmlns:a="http://schemas.openxmlformats.org/drawingml/2006/main">
               <a:ext uri="{FF2B5EF4-FFF2-40B4-BE49-F238E27FC236}">
-                <a16:creationId xmlns:a16="http://schemas.microsoft.com/office/drawing/2014/main" id="{BCBF4556-1CD3-44B7-BD00-2371564C9CD4}"/>
+                <a16:creationId xmlns:a16="http://schemas.microsoft.com/office/drawing/2014/main" id="{605D5543-FE2A-4D7B-9092-59614FC8C811}"/>
               </a:ext>
             </a:extLst>
           </p:cNvPr>
@@ -20014,7 +20257,7 @@
           <p:cNvPr id="10" name="">
             <a:extLst xmlns:a="http://schemas.openxmlformats.org/drawingml/2006/main">
               <a:ext uri="{FF2B5EF4-FFF2-40B4-BE49-F238E27FC236}">
-                <a16:creationId xmlns:a16="http://schemas.microsoft.com/office/drawing/2014/main" id="{1C8D95A5-41CE-404B-A4AB-D23A43F2D0BA}"/>
+                <a16:creationId xmlns:a16="http://schemas.microsoft.com/office/drawing/2014/main" id="{CCD15751-777D-443C-AAEC-6E5FA5EA061E}"/>
               </a:ext>
             </a:extLst>
           </p:cNvPr>
@@ -20170,7 +20413,7 @@
           <p:cNvPr id="11" name="">
             <a:extLst xmlns:a="http://schemas.openxmlformats.org/drawingml/2006/main">
               <a:ext uri="{FF2B5EF4-FFF2-40B4-BE49-F238E27FC236}">
-                <a16:creationId xmlns:a16="http://schemas.microsoft.com/office/drawing/2014/main" id="{C7AD182A-CF54-41A2-BBF3-4A9CD307227F}"/>
+                <a16:creationId xmlns:a16="http://schemas.microsoft.com/office/drawing/2014/main" id="{CE64FF27-BC94-45D0-8305-EC0FF0D70490}"/>
               </a:ext>
             </a:extLst>
           </p:cNvPr>
@@ -20326,7 +20569,7 @@
           <p:cNvPr id="12" name="">
             <a:extLst xmlns:a="http://schemas.openxmlformats.org/drawingml/2006/main">
               <a:ext uri="{FF2B5EF4-FFF2-40B4-BE49-F238E27FC236}">
-                <a16:creationId xmlns:a16="http://schemas.microsoft.com/office/drawing/2014/main" id="{EAB137A1-CBC4-4959-BD2B-1B782BABE33F}"/>
+                <a16:creationId xmlns:a16="http://schemas.microsoft.com/office/drawing/2014/main" id="{E2E07B00-700A-44F5-B18F-2578F93836AD}"/>
               </a:ext>
             </a:extLst>
           </p:cNvPr>
@@ -20482,7 +20725,7 @@
           <p:cNvPr id="13" name="">
             <a:extLst xmlns:a="http://schemas.openxmlformats.org/drawingml/2006/main">
               <a:ext uri="{FF2B5EF4-FFF2-40B4-BE49-F238E27FC236}">
-                <a16:creationId xmlns:a16="http://schemas.microsoft.com/office/drawing/2014/main" id="{E3637051-3341-4ED5-B256-A3FF88C67DC3}"/>
+                <a16:creationId xmlns:a16="http://schemas.microsoft.com/office/drawing/2014/main" id="{75ED2389-0E89-430C-BFAB-8C1939318267}"/>
               </a:ext>
             </a:extLst>
           </p:cNvPr>
@@ -20638,7 +20881,7 @@
           <p:cNvPr id="14" name="">
             <a:extLst xmlns:a="http://schemas.openxmlformats.org/drawingml/2006/main">
               <a:ext uri="{FF2B5EF4-FFF2-40B4-BE49-F238E27FC236}">
-                <a16:creationId xmlns:a16="http://schemas.microsoft.com/office/drawing/2014/main" id="{1BC0A4E3-693D-42AF-A2CC-775D3F3BFA89}"/>
+                <a16:creationId xmlns:a16="http://schemas.microsoft.com/office/drawing/2014/main" id="{86A446CD-D363-4EE6-AC4F-7A26D4ADE448}"/>
               </a:ext>
             </a:extLst>
           </p:cNvPr>
@@ -20794,7 +21037,7 @@
           <p:cNvPr id="15" name="">
             <a:extLst xmlns:a="http://schemas.openxmlformats.org/drawingml/2006/main">
               <a:ext uri="{FF2B5EF4-FFF2-40B4-BE49-F238E27FC236}">
-                <a16:creationId xmlns:a16="http://schemas.microsoft.com/office/drawing/2014/main" id="{72651BDD-52DA-4F2B-B8F8-B11C7CF811F8}"/>
+                <a16:creationId xmlns:a16="http://schemas.microsoft.com/office/drawing/2014/main" id="{4ACA0DCB-33F8-46A0-9466-58AAE40AF8BB}"/>
               </a:ext>
             </a:extLst>
           </p:cNvPr>
@@ -20950,7 +21193,7 @@
           <p:cNvPr id="16" name="">
             <a:extLst xmlns:a="http://schemas.openxmlformats.org/drawingml/2006/main">
               <a:ext uri="{FF2B5EF4-FFF2-40B4-BE49-F238E27FC236}">
-                <a16:creationId xmlns:a16="http://schemas.microsoft.com/office/drawing/2014/main" id="{3610C6FE-A1AC-4294-ADB4-3C650DC0518B}"/>
+                <a16:creationId xmlns:a16="http://schemas.microsoft.com/office/drawing/2014/main" id="{F9440CF4-9BB4-4801-B7FC-A2004B07D7DA}"/>
               </a:ext>
             </a:extLst>
           </p:cNvPr>
@@ -21106,7 +21349,7 @@
           <p:cNvPr id="17" name="">
             <a:extLst xmlns:a="http://schemas.openxmlformats.org/drawingml/2006/main">
               <a:ext uri="{FF2B5EF4-FFF2-40B4-BE49-F238E27FC236}">
-                <a16:creationId xmlns:a16="http://schemas.microsoft.com/office/drawing/2014/main" id="{0D98819D-5D5F-42C3-8056-9049D51E1F49}"/>
+                <a16:creationId xmlns:a16="http://schemas.microsoft.com/office/drawing/2014/main" id="{E54851C6-74CC-4FFD-8DB6-EE82FF7FFA75}"/>
               </a:ext>
             </a:extLst>
           </p:cNvPr>
@@ -21262,7 +21505,7 @@
           <p:cNvPr id="18" name="">
             <a:extLst xmlns:a="http://schemas.openxmlformats.org/drawingml/2006/main">
               <a:ext uri="{FF2B5EF4-FFF2-40B4-BE49-F238E27FC236}">
-                <a16:creationId xmlns:a16="http://schemas.microsoft.com/office/drawing/2014/main" id="{DCA14930-7ED8-43AA-B843-441DAA356F4F}"/>
+                <a16:creationId xmlns:a16="http://schemas.microsoft.com/office/drawing/2014/main" id="{6B2B8EB9-EF04-4391-AC79-9793D86D0B2F}"/>
               </a:ext>
             </a:extLst>
           </p:cNvPr>
@@ -21418,7 +21661,7 @@
           <p:cNvPr id="19" name="">
             <a:extLst xmlns:a="http://schemas.openxmlformats.org/drawingml/2006/main">
               <a:ext uri="{FF2B5EF4-FFF2-40B4-BE49-F238E27FC236}">
-                <a16:creationId xmlns:a16="http://schemas.microsoft.com/office/drawing/2014/main" id="{BD255EA6-6005-4AEF-BFFC-F12468D1FE80}"/>
+                <a16:creationId xmlns:a16="http://schemas.microsoft.com/office/drawing/2014/main" id="{EEB17040-2153-4473-8334-BA862F5F7EEA}"/>
               </a:ext>
             </a:extLst>
           </p:cNvPr>
@@ -21572,7 +21815,7 @@
     </p:spTree>
     <p:extLst>
       <p:ext uri="{BB962C8B-B14F-4D97-AF65-F5344CB8AC3E}">
-        <p14:creationId xmlns:p14="http://schemas.microsoft.com/office/powerpoint/2010/main" val="475765623"/>
+        <p14:creationId xmlns:p14="http://schemas.microsoft.com/office/powerpoint/2010/main" val="196944510"/>
       </p:ext>
     </p:extLst>
   </p:cSld>
@@ -21603,7 +21846,7 @@
           <p:cNvPr id="8" name="">
             <a:extLst xmlns:a="http://schemas.openxmlformats.org/drawingml/2006/main">
               <a:ext uri="{FF2B5EF4-FFF2-40B4-BE49-F238E27FC236}">
-                <a16:creationId xmlns:a16="http://schemas.microsoft.com/office/drawing/2014/main" id="{5F4E630C-51C6-4A63-81DE-88F2F413B86A}"/>
+                <a16:creationId xmlns:a16="http://schemas.microsoft.com/office/drawing/2014/main" id="{30AEDCB0-6002-40DA-A817-C9ABCCACE473}"/>
               </a:ext>
             </a:extLst>
           </p:cNvPr>
@@ -21759,7 +22002,7 @@
           <p:cNvPr id="2" name="">
             <a:extLst xmlns:a="http://schemas.openxmlformats.org/drawingml/2006/main">
               <a:ext uri="{FF2B5EF4-FFF2-40B4-BE49-F238E27FC236}">
-                <a16:creationId xmlns:a16="http://schemas.microsoft.com/office/drawing/2014/main" id="{F3401E1C-65FB-405F-9A88-C2DE9DD1B82A}"/>
+                <a16:creationId xmlns:a16="http://schemas.microsoft.com/office/drawing/2014/main" id="{F1A6F1C8-90A1-4E9F-A99F-335BAA799EBF}"/>
               </a:ext>
             </a:extLst>
           </p:cNvPr>
@@ -21915,7 +22158,7 @@
           <p:cNvPr id="3" name="">
             <a:extLst xmlns:a="http://schemas.openxmlformats.org/drawingml/2006/main">
               <a:ext uri="{FF2B5EF4-FFF2-40B4-BE49-F238E27FC236}">
-                <a16:creationId xmlns:a16="http://schemas.microsoft.com/office/drawing/2014/main" id="{F84A3038-8DD8-4EF5-BA57-F97BAC4D33DA}"/>
+                <a16:creationId xmlns:a16="http://schemas.microsoft.com/office/drawing/2014/main" id="{A1EB6841-505F-4021-8CF2-97EC731FD3CF}"/>
               </a:ext>
             </a:extLst>
           </p:cNvPr>
@@ -22071,7 +22314,7 @@
           <p:cNvPr id="4" name="">
             <a:extLst xmlns:a="http://schemas.openxmlformats.org/drawingml/2006/main">
               <a:ext uri="{FF2B5EF4-FFF2-40B4-BE49-F238E27FC236}">
-                <a16:creationId xmlns:a16="http://schemas.microsoft.com/office/drawing/2014/main" id="{351560A1-BA56-4C19-8434-344DA6CCCEA4}"/>
+                <a16:creationId xmlns:a16="http://schemas.microsoft.com/office/drawing/2014/main" id="{C56A1882-92B9-4E0E-81DC-47E515F64E1C}"/>
               </a:ext>
             </a:extLst>
           </p:cNvPr>
@@ -22081,7 +22324,7 @@
           <p:nvPr/>
         </p:nvPicPr>
         <p:blipFill>
-          <a:blip xmlns:r="http://schemas.openxmlformats.org/officeDocument/2006/relationships" xmlns:a="http://schemas.openxmlformats.org/drawingml/2006/main" r:embed="R7a20a47932a44b55"/>
+          <a:blip xmlns:r="http://schemas.openxmlformats.org/officeDocument/2006/relationships" xmlns:a="http://schemas.openxmlformats.org/drawingml/2006/main" r:embed="R6239ba764a834c4c"/>
           <a:stretch xmlns:a="http://schemas.openxmlformats.org/drawingml/2006/main"/>
         </p:blipFill>
         <p:spPr>
@@ -22099,7 +22342,7 @@
           <p:cNvPr id="5" name="">
             <a:extLst xmlns:a="http://schemas.openxmlformats.org/drawingml/2006/main">
               <a:ext uri="{FF2B5EF4-FFF2-40B4-BE49-F238E27FC236}">
-                <a16:creationId xmlns:a16="http://schemas.microsoft.com/office/drawing/2014/main" id="{9231A037-8086-4AFC-890E-AE999014EDD6}"/>
+                <a16:creationId xmlns:a16="http://schemas.microsoft.com/office/drawing/2014/main" id="{94918BFC-4B7A-4C4A-BCCC-A93A74B13247}"/>
               </a:ext>
             </a:extLst>
           </p:cNvPr>
@@ -22255,7 +22498,7 @@
           <p:cNvPr id="6" name="">
             <a:extLst xmlns:a="http://schemas.openxmlformats.org/drawingml/2006/main">
               <a:ext uri="{FF2B5EF4-FFF2-40B4-BE49-F238E27FC236}">
-                <a16:creationId xmlns:a16="http://schemas.microsoft.com/office/drawing/2014/main" id="{CD66D86F-49F6-42FC-A21D-71F6E3C7299E}"/>
+                <a16:creationId xmlns:a16="http://schemas.microsoft.com/office/drawing/2014/main" id="{D26DF794-787F-45DC-925B-E9D5083D0D8A}"/>
               </a:ext>
             </a:extLst>
           </p:cNvPr>
@@ -22457,7 +22700,7 @@
           <p:cNvPr id="7" name="">
             <a:extLst xmlns:a="http://schemas.openxmlformats.org/drawingml/2006/main">
               <a:ext uri="{FF2B5EF4-FFF2-40B4-BE49-F238E27FC236}">
-                <a16:creationId xmlns:a16="http://schemas.microsoft.com/office/drawing/2014/main" id="{89281D89-AC38-4CD2-AD91-8FEBC90C2A14}"/>
+                <a16:creationId xmlns:a16="http://schemas.microsoft.com/office/drawing/2014/main" id="{CFE3FD04-847E-4324-9994-87F8FFB1911B}"/>
               </a:ext>
             </a:extLst>
           </p:cNvPr>
@@ -22611,7 +22854,7 @@
     </p:spTree>
     <p:extLst>
       <p:ext uri="{BB962C8B-B14F-4D97-AF65-F5344CB8AC3E}">
-        <p14:creationId xmlns:p14="http://schemas.microsoft.com/office/powerpoint/2010/main" val="1945874397"/>
+        <p14:creationId xmlns:p14="http://schemas.microsoft.com/office/powerpoint/2010/main" val="202151969"/>
       </p:ext>
     </p:extLst>
   </p:cSld>
@@ -22642,7 +22885,7 @@
           <p:cNvPr id="20" name="">
             <a:extLst xmlns:a="http://schemas.openxmlformats.org/drawingml/2006/main">
               <a:ext uri="{FF2B5EF4-FFF2-40B4-BE49-F238E27FC236}">
-                <a16:creationId xmlns:a16="http://schemas.microsoft.com/office/drawing/2014/main" id="{37F7226D-33E1-4AFD-98EE-8FDDB2BBC498}"/>
+                <a16:creationId xmlns:a16="http://schemas.microsoft.com/office/drawing/2014/main" id="{3B7776EE-9CE9-4836-ADBA-81C1E648A7EF}"/>
               </a:ext>
             </a:extLst>
           </p:cNvPr>
@@ -22673,7 +22916,7 @@
           <p:cNvPr id="19" name="">
             <a:extLst xmlns:a="http://schemas.openxmlformats.org/drawingml/2006/main">
               <a:ext uri="{FF2B5EF4-FFF2-40B4-BE49-F238E27FC236}">
-                <a16:creationId xmlns:a16="http://schemas.microsoft.com/office/drawing/2014/main" id="{E3D52050-A547-4D13-A3B7-52917F69BB86}"/>
+                <a16:creationId xmlns:a16="http://schemas.microsoft.com/office/drawing/2014/main" id="{9039F15E-BD87-4849-857C-C46149208BF0}"/>
               </a:ext>
             </a:extLst>
           </p:cNvPr>
@@ -22704,7 +22947,7 @@
           <p:cNvPr id="18" name="">
             <a:extLst xmlns:a="http://schemas.openxmlformats.org/drawingml/2006/main">
               <a:ext uri="{FF2B5EF4-FFF2-40B4-BE49-F238E27FC236}">
-                <a16:creationId xmlns:a16="http://schemas.microsoft.com/office/drawing/2014/main" id="{CDEDE91C-9805-4574-AC32-3CAB454620D0}"/>
+                <a16:creationId xmlns:a16="http://schemas.microsoft.com/office/drawing/2014/main" id="{BD9DA31F-EFE4-42CE-A4DD-E4A695F83072}"/>
               </a:ext>
             </a:extLst>
           </p:cNvPr>
@@ -22735,7 +22978,7 @@
           <p:cNvPr id="17" name="">
             <a:extLst xmlns:a="http://schemas.openxmlformats.org/drawingml/2006/main">
               <a:ext uri="{FF2B5EF4-FFF2-40B4-BE49-F238E27FC236}">
-                <a16:creationId xmlns:a16="http://schemas.microsoft.com/office/drawing/2014/main" id="{FA31A0A0-42D0-4BDE-9319-8B6D2F1E4196}"/>
+                <a16:creationId xmlns:a16="http://schemas.microsoft.com/office/drawing/2014/main" id="{CF5716E4-182A-4FA8-9586-FF46ED5C87A5}"/>
               </a:ext>
             </a:extLst>
           </p:cNvPr>
@@ -22766,7 +23009,7 @@
           <p:cNvPr id="16" name="">
             <a:extLst xmlns:a="http://schemas.openxmlformats.org/drawingml/2006/main">
               <a:ext uri="{FF2B5EF4-FFF2-40B4-BE49-F238E27FC236}">
-                <a16:creationId xmlns:a16="http://schemas.microsoft.com/office/drawing/2014/main" id="{A68F3F35-C3C5-4B4E-A1F1-C4CDF575DEE7}"/>
+                <a16:creationId xmlns:a16="http://schemas.microsoft.com/office/drawing/2014/main" id="{F4840974-80DF-4863-A536-1102354E7EB3}"/>
               </a:ext>
             </a:extLst>
           </p:cNvPr>
@@ -22797,7 +23040,7 @@
           <p:cNvPr id="22" name="">
             <a:extLst xmlns:a="http://schemas.openxmlformats.org/drawingml/2006/main">
               <a:ext uri="{FF2B5EF4-FFF2-40B4-BE49-F238E27FC236}">
-                <a16:creationId xmlns:a16="http://schemas.microsoft.com/office/drawing/2014/main" id="{5B6F1523-9BF6-458E-B165-905E54A443AB}"/>
+                <a16:creationId xmlns:a16="http://schemas.microsoft.com/office/drawing/2014/main" id="{C7EF24C3-7425-408F-BD68-1244CE3D8AFB}"/>
               </a:ext>
             </a:extLst>
           </p:cNvPr>
@@ -22953,7 +23196,7 @@
           <p:cNvPr id="2" name="">
             <a:extLst xmlns:a="http://schemas.openxmlformats.org/drawingml/2006/main">
               <a:ext uri="{FF2B5EF4-FFF2-40B4-BE49-F238E27FC236}">
-                <a16:creationId xmlns:a16="http://schemas.microsoft.com/office/drawing/2014/main" id="{2D16ABA1-608B-416F-A235-D95C878EDC07}"/>
+                <a16:creationId xmlns:a16="http://schemas.microsoft.com/office/drawing/2014/main" id="{90962052-C036-48B1-97FE-6AAB7AC09614}"/>
               </a:ext>
             </a:extLst>
           </p:cNvPr>
@@ -23109,7 +23352,7 @@
           <p:cNvPr id="3" name="">
             <a:extLst xmlns:a="http://schemas.openxmlformats.org/drawingml/2006/main">
               <a:ext uri="{FF2B5EF4-FFF2-40B4-BE49-F238E27FC236}">
-                <a16:creationId xmlns:a16="http://schemas.microsoft.com/office/drawing/2014/main" id="{3E2BA4EF-5522-4F10-8C56-F8A070F1B8A2}"/>
+                <a16:creationId xmlns:a16="http://schemas.microsoft.com/office/drawing/2014/main" id="{51915157-EA45-4CE2-91E4-2AA62BC53EB7}"/>
               </a:ext>
             </a:extLst>
           </p:cNvPr>
@@ -23265,7 +23508,7 @@
           <p:cNvPr id="4" name="">
             <a:extLst xmlns:a="http://schemas.openxmlformats.org/drawingml/2006/main">
               <a:ext uri="{FF2B5EF4-FFF2-40B4-BE49-F238E27FC236}">
-                <a16:creationId xmlns:a16="http://schemas.microsoft.com/office/drawing/2014/main" id="{BDFB9B5B-8A06-4D9E-9EED-0CB2CED40257}"/>
+                <a16:creationId xmlns:a16="http://schemas.microsoft.com/office/drawing/2014/main" id="{70D81072-88D6-47C7-A83C-F5BD7434766B}"/>
               </a:ext>
             </a:extLst>
           </p:cNvPr>
@@ -23297,7 +23540,7 @@
           <p:cNvPr id="5" name="">
             <a:extLst xmlns:a="http://schemas.openxmlformats.org/drawingml/2006/main">
               <a:ext uri="{FF2B5EF4-FFF2-40B4-BE49-F238E27FC236}">
-                <a16:creationId xmlns:a16="http://schemas.microsoft.com/office/drawing/2014/main" id="{3151A65C-32D1-4C1D-BE55-56931EB3415A}"/>
+                <a16:creationId xmlns:a16="http://schemas.microsoft.com/office/drawing/2014/main" id="{45F324B4-3C4B-4060-B66D-8FFAF8B65BBA}"/>
               </a:ext>
             </a:extLst>
           </p:cNvPr>
@@ -23453,7 +23696,7 @@
           <p:cNvPr id="6" name="">
             <a:extLst xmlns:a="http://schemas.openxmlformats.org/drawingml/2006/main">
               <a:ext uri="{FF2B5EF4-FFF2-40B4-BE49-F238E27FC236}">
-                <a16:creationId xmlns:a16="http://schemas.microsoft.com/office/drawing/2014/main" id="{18D231D1-42A5-4DA7-8FD2-CEE89491FBB6}"/>
+                <a16:creationId xmlns:a16="http://schemas.microsoft.com/office/drawing/2014/main" id="{D4BB757E-1A99-4261-AE76-23D5DA5F8151}"/>
               </a:ext>
             </a:extLst>
           </p:cNvPr>
@@ -23485,7 +23728,7 @@
           <p:cNvPr id="7" name="">
             <a:extLst xmlns:a="http://schemas.openxmlformats.org/drawingml/2006/main">
               <a:ext uri="{FF2B5EF4-FFF2-40B4-BE49-F238E27FC236}">
-                <a16:creationId xmlns:a16="http://schemas.microsoft.com/office/drawing/2014/main" id="{6F2A57AB-4C4C-45C2-B1AD-0AE8FE92FC04}"/>
+                <a16:creationId xmlns:a16="http://schemas.microsoft.com/office/drawing/2014/main" id="{9B07EE06-F389-46A6-A9A1-71F5EA717AE2}"/>
               </a:ext>
             </a:extLst>
           </p:cNvPr>
@@ -23641,7 +23884,7 @@
           <p:cNvPr id="8" name="">
             <a:extLst xmlns:a="http://schemas.openxmlformats.org/drawingml/2006/main">
               <a:ext uri="{FF2B5EF4-FFF2-40B4-BE49-F238E27FC236}">
-                <a16:creationId xmlns:a16="http://schemas.microsoft.com/office/drawing/2014/main" id="{E110255E-0632-4664-A07E-EF99848B902D}"/>
+                <a16:creationId xmlns:a16="http://schemas.microsoft.com/office/drawing/2014/main" id="{97B4B63B-19A9-4673-8BD6-AFD7E9F86B41}"/>
               </a:ext>
             </a:extLst>
           </p:cNvPr>
@@ -23673,7 +23916,7 @@
           <p:cNvPr id="9" name="">
             <a:extLst xmlns:a="http://schemas.openxmlformats.org/drawingml/2006/main">
               <a:ext uri="{FF2B5EF4-FFF2-40B4-BE49-F238E27FC236}">
-                <a16:creationId xmlns:a16="http://schemas.microsoft.com/office/drawing/2014/main" id="{D2C8A353-F59E-4AE2-B93C-F340CA18437C}"/>
+                <a16:creationId xmlns:a16="http://schemas.microsoft.com/office/drawing/2014/main" id="{CC8CCDC1-1722-4FF7-976D-802994F70957}"/>
               </a:ext>
             </a:extLst>
           </p:cNvPr>
@@ -23829,7 +24072,7 @@
           <p:cNvPr id="10" name="">
             <a:extLst xmlns:a="http://schemas.openxmlformats.org/drawingml/2006/main">
               <a:ext uri="{FF2B5EF4-FFF2-40B4-BE49-F238E27FC236}">
-                <a16:creationId xmlns:a16="http://schemas.microsoft.com/office/drawing/2014/main" id="{8DFC29D5-6232-4263-991D-29A4C04609BB}"/>
+                <a16:creationId xmlns:a16="http://schemas.microsoft.com/office/drawing/2014/main" id="{B26ED066-1367-4FF6-98D0-CDFACA578C3A}"/>
               </a:ext>
             </a:extLst>
           </p:cNvPr>
@@ -23861,7 +24104,7 @@
           <p:cNvPr id="11" name="">
             <a:extLst xmlns:a="http://schemas.openxmlformats.org/drawingml/2006/main">
               <a:ext uri="{FF2B5EF4-FFF2-40B4-BE49-F238E27FC236}">
-                <a16:creationId xmlns:a16="http://schemas.microsoft.com/office/drawing/2014/main" id="{1CCBFEBE-BDFB-46A9-B802-2EC71BEF7B76}"/>
+                <a16:creationId xmlns:a16="http://schemas.microsoft.com/office/drawing/2014/main" id="{9B21276E-C06F-4064-88EB-30D0E13EC194}"/>
               </a:ext>
             </a:extLst>
           </p:cNvPr>
@@ -24017,7 +24260,7 @@
           <p:cNvPr id="12" name="">
             <a:extLst xmlns:a="http://schemas.openxmlformats.org/drawingml/2006/main">
               <a:ext uri="{FF2B5EF4-FFF2-40B4-BE49-F238E27FC236}">
-                <a16:creationId xmlns:a16="http://schemas.microsoft.com/office/drawing/2014/main" id="{817A6F44-138B-4310-BBF8-9F6501458839}"/>
+                <a16:creationId xmlns:a16="http://schemas.microsoft.com/office/drawing/2014/main" id="{02A73700-60A1-4EAE-A227-F6461269B2ED}"/>
               </a:ext>
             </a:extLst>
           </p:cNvPr>
@@ -24049,7 +24292,7 @@
           <p:cNvPr id="13" name="">
             <a:extLst xmlns:a="http://schemas.openxmlformats.org/drawingml/2006/main">
               <a:ext uri="{FF2B5EF4-FFF2-40B4-BE49-F238E27FC236}">
-                <a16:creationId xmlns:a16="http://schemas.microsoft.com/office/drawing/2014/main" id="{0228CB96-1D3A-416E-89A7-2A6AFB654579}"/>
+                <a16:creationId xmlns:a16="http://schemas.microsoft.com/office/drawing/2014/main" id="{BBEC7264-4F23-4FA4-B4F1-D3F74451C706}"/>
               </a:ext>
             </a:extLst>
           </p:cNvPr>
@@ -24205,7 +24448,7 @@
           <p:cNvPr id="14" name="">
             <a:extLst xmlns:a="http://schemas.openxmlformats.org/drawingml/2006/main">
               <a:ext uri="{FF2B5EF4-FFF2-40B4-BE49-F238E27FC236}">
-                <a16:creationId xmlns:a16="http://schemas.microsoft.com/office/drawing/2014/main" id="{729DE916-A70F-4F43-9FEA-5B951D431197}"/>
+                <a16:creationId xmlns:a16="http://schemas.microsoft.com/office/drawing/2014/main" id="{1682AC18-C548-4A53-AB81-1D8430E77C46}"/>
               </a:ext>
             </a:extLst>
           </p:cNvPr>
@@ -24237,7 +24480,7 @@
           <p:cNvPr id="15" name="">
             <a:extLst xmlns:a="http://schemas.openxmlformats.org/drawingml/2006/main">
               <a:ext uri="{FF2B5EF4-FFF2-40B4-BE49-F238E27FC236}">
-                <a16:creationId xmlns:a16="http://schemas.microsoft.com/office/drawing/2014/main" id="{6236EE93-AE34-44B7-873C-081FC0A5F7D7}"/>
+                <a16:creationId xmlns:a16="http://schemas.microsoft.com/office/drawing/2014/main" id="{5E4C5AC3-1193-421F-BD97-6CCEC95F90FD}"/>
               </a:ext>
             </a:extLst>
           </p:cNvPr>
@@ -24393,7 +24636,7 @@
           <p:cNvPr id="21" name="">
             <a:extLst xmlns:a="http://schemas.openxmlformats.org/drawingml/2006/main">
               <a:ext uri="{FF2B5EF4-FFF2-40B4-BE49-F238E27FC236}">
-                <a16:creationId xmlns:a16="http://schemas.microsoft.com/office/drawing/2014/main" id="{1AC413AC-080A-4F91-A254-7022A4E681CF}"/>
+                <a16:creationId xmlns:a16="http://schemas.microsoft.com/office/drawing/2014/main" id="{65DAFB60-C8C7-4B84-A5DC-7DDDB4F809BB}"/>
               </a:ext>
             </a:extLst>
           </p:cNvPr>
@@ -24547,7 +24790,7 @@
     </p:spTree>
     <p:extLst>
       <p:ext uri="{BB962C8B-B14F-4D97-AF65-F5344CB8AC3E}">
-        <p14:creationId xmlns:p14="http://schemas.microsoft.com/office/powerpoint/2010/main" val="1204216656"/>
+        <p14:creationId xmlns:p14="http://schemas.microsoft.com/office/powerpoint/2010/main" val="1089689742"/>
       </p:ext>
     </p:extLst>
   </p:cSld>

</xml_diff>

<commit_message>
docs: finalize authentic submission candidate evidence and assets
</commit_message>
<xml_diff>
--- a/docs/submission/assets/movebooks-submission-draft.pptx
+++ b/docs/submission/assets/movebooks-submission-draft.pptx
@@ -2,27 +2,27 @@
 <file path=ppt/presentation.xml><?xml version="1.0" encoding="utf-8"?>
 <p:presentation xmlns:p="http://schemas.openxmlformats.org/presentationml/2006/main">
   <p:sldMasterIdLst>
-    <p:sldMasterId xmlns:r="http://schemas.openxmlformats.org/officeDocument/2006/relationships" id="2147483648" r:id="R3226f739db324d7e"/>
+    <p:sldMasterId xmlns:r="http://schemas.openxmlformats.org/officeDocument/2006/relationships" id="2147483648" r:id="Rac96313233a74ca0"/>
   </p:sldMasterIdLst>
   <p:notesMasterIdLst>
-    <p:notesMasterId xmlns:r="http://schemas.openxmlformats.org/officeDocument/2006/relationships" r:id="Re0dd5cd8f6734bc6"/>
+    <p:notesMasterId xmlns:r="http://schemas.openxmlformats.org/officeDocument/2006/relationships" r:id="R2b945b03eec943ec"/>
   </p:notesMasterIdLst>
   <p:sldIdLst>
-    <p:sldId xmlns:r="http://schemas.openxmlformats.org/officeDocument/2006/relationships" id="256" r:id="Ra94e4893fde04579"/>
-    <p:sldId xmlns:r="http://schemas.openxmlformats.org/officeDocument/2006/relationships" id="257" r:id="R89c92a7144af4d46"/>
-    <p:sldId xmlns:r="http://schemas.openxmlformats.org/officeDocument/2006/relationships" id="258" r:id="R5b5108b2437c41e9"/>
-    <p:sldId xmlns:r="http://schemas.openxmlformats.org/officeDocument/2006/relationships" id="259" r:id="R1c86798c13e2460a"/>
-    <p:sldId xmlns:r="http://schemas.openxmlformats.org/officeDocument/2006/relationships" id="260" r:id="R7572a16a96e14fbd"/>
-    <p:sldId xmlns:r="http://schemas.openxmlformats.org/officeDocument/2006/relationships" id="261" r:id="Rdead22ee230749ea"/>
-    <p:sldId xmlns:r="http://schemas.openxmlformats.org/officeDocument/2006/relationships" id="262" r:id="R51ba50ce40744bcd"/>
-    <p:sldId xmlns:r="http://schemas.openxmlformats.org/officeDocument/2006/relationships" id="263" r:id="Rd4cec5cfd7b64431"/>
-    <p:sldId xmlns:r="http://schemas.openxmlformats.org/officeDocument/2006/relationships" id="264" r:id="Rcf24104f13004ae0"/>
-    <p:sldId xmlns:r="http://schemas.openxmlformats.org/officeDocument/2006/relationships" id="265" r:id="R09ec2c9574284c6f"/>
-    <p:sldId xmlns:r="http://schemas.openxmlformats.org/officeDocument/2006/relationships" id="266" r:id="Re4c5d0f60f724355"/>
-    <p:sldId xmlns:r="http://schemas.openxmlformats.org/officeDocument/2006/relationships" id="267" r:id="R624adac2a26d490e"/>
-    <p:sldId xmlns:r="http://schemas.openxmlformats.org/officeDocument/2006/relationships" id="268" r:id="R996f017cf0714a37"/>
-    <p:sldId xmlns:r="http://schemas.openxmlformats.org/officeDocument/2006/relationships" id="269" r:id="Rc134b689ee9c4541"/>
-    <p:sldId xmlns:r="http://schemas.openxmlformats.org/officeDocument/2006/relationships" id="270" r:id="Rc82340bb60754eaf"/>
+    <p:sldId xmlns:r="http://schemas.openxmlformats.org/officeDocument/2006/relationships" id="256" r:id="R00fd38b057be43ba"/>
+    <p:sldId xmlns:r="http://schemas.openxmlformats.org/officeDocument/2006/relationships" id="257" r:id="Rad4b3bddde8e4758"/>
+    <p:sldId xmlns:r="http://schemas.openxmlformats.org/officeDocument/2006/relationships" id="258" r:id="Rcbed0b24f4104e19"/>
+    <p:sldId xmlns:r="http://schemas.openxmlformats.org/officeDocument/2006/relationships" id="259" r:id="R6e73f31b475d46b8"/>
+    <p:sldId xmlns:r="http://schemas.openxmlformats.org/officeDocument/2006/relationships" id="260" r:id="R35c72dfe530947a4"/>
+    <p:sldId xmlns:r="http://schemas.openxmlformats.org/officeDocument/2006/relationships" id="261" r:id="R0615a767b7be46fc"/>
+    <p:sldId xmlns:r="http://schemas.openxmlformats.org/officeDocument/2006/relationships" id="262" r:id="R1d7ac33f493146e6"/>
+    <p:sldId xmlns:r="http://schemas.openxmlformats.org/officeDocument/2006/relationships" id="263" r:id="R0cd9f0f0806e4d11"/>
+    <p:sldId xmlns:r="http://schemas.openxmlformats.org/officeDocument/2006/relationships" id="264" r:id="R520f78ae62264ef5"/>
+    <p:sldId xmlns:r="http://schemas.openxmlformats.org/officeDocument/2006/relationships" id="265" r:id="R0d3fe947845d4c01"/>
+    <p:sldId xmlns:r="http://schemas.openxmlformats.org/officeDocument/2006/relationships" id="266" r:id="R26d184189c6e4755"/>
+    <p:sldId xmlns:r="http://schemas.openxmlformats.org/officeDocument/2006/relationships" id="267" r:id="R82913347673c4235"/>
+    <p:sldId xmlns:r="http://schemas.openxmlformats.org/officeDocument/2006/relationships" id="268" r:id="Re8d9867033034b49"/>
+    <p:sldId xmlns:r="http://schemas.openxmlformats.org/officeDocument/2006/relationships" id="269" r:id="R1bccd971586447c1"/>
+    <p:sldId xmlns:r="http://schemas.openxmlformats.org/officeDocument/2006/relationships" id="270" r:id="Rc0a2077f1b214983"/>
   </p:sldIdLst>
   <p:sldSz cx="12192000" cy="6858000"/>
   <p:notesSz cx="6858000" cy="9144000"/>
@@ -666,7 +666,7 @@
           <a:lstStyle xmlns:a="http://schemas.openxmlformats.org/drawingml/2006/main"/>
           <a:p xmlns:a="http://schemas.openxmlformats.org/drawingml/2006/main">
             <a:r>
-              <a:t>Source: docs/ux-v2/pr04/after-verified-1440.jpg; agents/orchestrator/onboard_fpu.py; tests/test_onboard_fpu.py. Historical authentic screenshot.</a:t>
+              <a:t>Source: docs/submission/assets/fpu-local-candidate.png; agents/orchestrator/onboard_fpu.py; tests/test_onboard_fpu.py. Authentic recorded local UI, API fffd14c. Approved synthetic invoice USD107.25; not a production provider claim.</a:t>
             </a:r>
           </a:p>
         </p:txBody>
@@ -736,7 +736,7 @@
           <a:lstStyle xmlns:a="http://schemas.openxmlformats.org/drawingml/2006/main"/>
           <a:p xmlns:a="http://schemas.openxmlformats.org/drawingml/2006/main">
             <a:r>
-              <a:t>Source: integration owner final combined candidate report, 17 October 2026: backend 559 passed / 58 skipped in 26.65 seconds; frontend 658 passed across 50 files; lint, typecheck and build passed. Focused independent model-control/Reviewer rerun: 36 passed in 1.49 seconds. These are local implementation tests, not live-cloud evidence or a model-quality benchmark.</a:t>
+              <a:t>Source: integration owner final combined candidate report, 17 October 2026: backend 584 passed / 58 skipped in23.73seconds; frontend674 passed across51files; lint, typecheck and build passed. Focused independent model-control/Reviewer rerun: 36 passed in 1.49 seconds. These are local implementation tests, not live-cloud evidence or a model-quality benchmark.</a:t>
             </a:r>
           </a:p>
         </p:txBody>
@@ -876,7 +876,7 @@
           <a:lstStyle xmlns:a="http://schemas.openxmlformats.org/drawingml/2006/main"/>
           <a:p xmlns:a="http://schemas.openxmlformats.org/drawingml/2006/main">
             <a:r>
-              <a:t>Source URLs: README.md and docs/deployment/public-beta.md. Current permissions/version to be verified by release owner. Exact official template and final working-video link still missing.</a:t>
+              <a:t>Source URLs: README.md and docs/deployment/public-beta.md. Current permissions/version to be verified by release owner. Official template/team missing. Local authentic video231.88seconds; accessible public video URL still pending release approval.</a:t>
             </a:r>
           </a:p>
         </p:txBody>
@@ -1366,7 +1366,7 @@
           <a:lstStyle xmlns:a="http://schemas.openxmlformats.org/drawingml/2006/main"/>
           <a:p xmlns:a="http://schemas.openxmlformats.org/drawingml/2006/main">
             <a:r>
-              <a:t>Source: docs/ux-v2/pr05/after-prepare-1440.jpg. Authentic historical candidate screenshot, not a wireframe or proof of this sprint deployment.</a:t>
+              <a:t>Source: docs/submission/assets/plan-local-candidate.png. Authentic recorded local UI, API fffd14c; independent deterministic review of 1200. Separate latest-source acceptance1a24a2c passed17checks. No live model or deployment claim.</a:t>
             </a:r>
           </a:p>
         </p:txBody>
@@ -1483,7 +1483,7 @@
           <p:cNvPr id="3" name="Title">
             <a:extLst xmlns:a="http://schemas.openxmlformats.org/drawingml/2006/main">
               <a:ext uri="{FF2B5EF4-FFF2-40B4-BE49-F238E27FC236}">
-                <a16:creationId xmlns:a16="http://schemas.microsoft.com/office/drawing/2014/main" id="{DBB25011-B854-4BF3-A0E7-72937A1A955F}"/>
+                <a16:creationId xmlns:a16="http://schemas.microsoft.com/office/drawing/2014/main" id="{6AFA874C-A9E2-4FB3-BC80-273F83A9A295}"/>
               </a:ext>
             </a:extLst>
           </p:cNvPr>
@@ -1712,7 +1712,7 @@
           <p:cNvPr id="2" name="Subtitle">
             <a:extLst xmlns:a="http://schemas.openxmlformats.org/drawingml/2006/main">
               <a:ext uri="{FF2B5EF4-FFF2-40B4-BE49-F238E27FC236}">
-                <a16:creationId xmlns:a16="http://schemas.microsoft.com/office/drawing/2014/main" id="{3C4C2743-4FD6-4BC7-99AF-7900FED94947}"/>
+                <a16:creationId xmlns:a16="http://schemas.microsoft.com/office/drawing/2014/main" id="{8CE74C9D-B9EA-414B-B807-3E4E726A2D86}"/>
               </a:ext>
             </a:extLst>
           </p:cNvPr>
@@ -1958,7 +1958,7 @@
           <p:cNvPr id="2" name="Section title">
             <a:extLst xmlns:a="http://schemas.openxmlformats.org/drawingml/2006/main">
               <a:ext uri="{FF2B5EF4-FFF2-40B4-BE49-F238E27FC236}">
-                <a16:creationId xmlns:a16="http://schemas.microsoft.com/office/drawing/2014/main" id="{F58748CF-B156-4F00-9454-6498C0ACD01A}"/>
+                <a16:creationId xmlns:a16="http://schemas.microsoft.com/office/drawing/2014/main" id="{DA9C9E1D-B380-498A-981F-3A7453A1CB6B}"/>
               </a:ext>
             </a:extLst>
           </p:cNvPr>
@@ -2204,7 +2204,7 @@
           <p:cNvPr id="3" name="Title">
             <a:extLst xmlns:a="http://schemas.openxmlformats.org/drawingml/2006/main">
               <a:ext uri="{FF2B5EF4-FFF2-40B4-BE49-F238E27FC236}">
-                <a16:creationId xmlns:a16="http://schemas.microsoft.com/office/drawing/2014/main" id="{552BACE8-BC41-4995-A7BE-F3D6F30D80C7}"/>
+                <a16:creationId xmlns:a16="http://schemas.microsoft.com/office/drawing/2014/main" id="{B029B0E5-5976-405B-BC21-1341D311B070}"/>
               </a:ext>
             </a:extLst>
           </p:cNvPr>
@@ -2433,7 +2433,7 @@
           <p:cNvPr id="2" name="Body">
             <a:extLst xmlns:a="http://schemas.openxmlformats.org/drawingml/2006/main">
               <a:ext uri="{FF2B5EF4-FFF2-40B4-BE49-F238E27FC236}">
-                <a16:creationId xmlns:a16="http://schemas.microsoft.com/office/drawing/2014/main" id="{A3780A7E-BE1A-4ED0-B3A6-95F86013A780}"/>
+                <a16:creationId xmlns:a16="http://schemas.microsoft.com/office/drawing/2014/main" id="{EA91A7E4-D644-4AF6-A0F1-5AE65D856790}"/>
               </a:ext>
             </a:extLst>
           </p:cNvPr>
@@ -2679,7 +2679,7 @@
           <p:cNvPr id="4" name="Title">
             <a:extLst xmlns:a="http://schemas.openxmlformats.org/drawingml/2006/main">
               <a:ext uri="{FF2B5EF4-FFF2-40B4-BE49-F238E27FC236}">
-                <a16:creationId xmlns:a16="http://schemas.microsoft.com/office/drawing/2014/main" id="{FD8F73D8-C9E7-4663-97DB-26CA865D2DD2}"/>
+                <a16:creationId xmlns:a16="http://schemas.microsoft.com/office/drawing/2014/main" id="{4FCBC349-7921-4D22-BF01-8274F9EAEE3A}"/>
               </a:ext>
             </a:extLst>
           </p:cNvPr>
@@ -2908,7 +2908,7 @@
           <p:cNvPr id="2" name="Left column">
             <a:extLst xmlns:a="http://schemas.openxmlformats.org/drawingml/2006/main">
               <a:ext uri="{FF2B5EF4-FFF2-40B4-BE49-F238E27FC236}">
-                <a16:creationId xmlns:a16="http://schemas.microsoft.com/office/drawing/2014/main" id="{F3BD0F10-35A2-46E0-AE8A-22C8787FE481}"/>
+                <a16:creationId xmlns:a16="http://schemas.microsoft.com/office/drawing/2014/main" id="{504131D6-2F9C-45CA-A547-0C1FF7801080}"/>
               </a:ext>
             </a:extLst>
           </p:cNvPr>
@@ -3137,7 +3137,7 @@
           <p:cNvPr id="3" name="Right column">
             <a:extLst xmlns:a="http://schemas.openxmlformats.org/drawingml/2006/main">
               <a:ext uri="{FF2B5EF4-FFF2-40B4-BE49-F238E27FC236}">
-                <a16:creationId xmlns:a16="http://schemas.microsoft.com/office/drawing/2014/main" id="{5E178E5B-CDE9-4FB1-8A89-4CD58D5F6E11}"/>
+                <a16:creationId xmlns:a16="http://schemas.microsoft.com/office/drawing/2014/main" id="{8EF94817-7199-4BE4-A076-72678DCE48AA}"/>
               </a:ext>
             </a:extLst>
           </p:cNvPr>
@@ -3383,7 +3383,7 @@
           <p:cNvPr id="3" name="Title">
             <a:extLst xmlns:a="http://schemas.openxmlformats.org/drawingml/2006/main">
               <a:ext uri="{FF2B5EF4-FFF2-40B4-BE49-F238E27FC236}">
-                <a16:creationId xmlns:a16="http://schemas.microsoft.com/office/drawing/2014/main" id="{D1FB4F01-61AB-4AC4-8FC5-6267A9EE56DB}"/>
+                <a16:creationId xmlns:a16="http://schemas.microsoft.com/office/drawing/2014/main" id="{8CDA1FD4-07E4-404A-977D-1363361EF356}"/>
               </a:ext>
             </a:extLst>
           </p:cNvPr>
@@ -3612,7 +3612,7 @@
           <p:cNvPr id="2" name="Left column">
             <a:extLst xmlns:a="http://schemas.openxmlformats.org/drawingml/2006/main">
               <a:ext uri="{FF2B5EF4-FFF2-40B4-BE49-F238E27FC236}">
-                <a16:creationId xmlns:a16="http://schemas.microsoft.com/office/drawing/2014/main" id="{B26ABF13-64B0-43A6-953E-035B21A3F1C9}"/>
+                <a16:creationId xmlns:a16="http://schemas.microsoft.com/office/drawing/2014/main" id="{084ECCFC-B974-4011-BECB-24C884421E7D}"/>
               </a:ext>
             </a:extLst>
           </p:cNvPr>
@@ -3879,12 +3879,12 @@
   </p:cSld>
   <p:clrMap bg1="lt1" tx1="dk1" bg2="lt2" tx2="dk2" accent1="accent1" accent2="accent2" accent3="accent3" accent4="accent4" accent5="accent5" accent6="accent6" hlink="hlink" folHlink="folHlink"/>
   <p:sldLayoutIdLst>
-    <p:sldLayoutId xmlns:r="http://schemas.openxmlformats.org/officeDocument/2006/relationships" id="2147483649" r:id="R39147f4597334244"/>
-    <p:sldLayoutId xmlns:r="http://schemas.openxmlformats.org/officeDocument/2006/relationships" id="2147483650" r:id="R7797a96106c14f0b"/>
-    <p:sldLayoutId xmlns:r="http://schemas.openxmlformats.org/officeDocument/2006/relationships" id="2147483651" r:id="Rb69afea43e4d4d5a"/>
-    <p:sldLayoutId xmlns:r="http://schemas.openxmlformats.org/officeDocument/2006/relationships" id="2147483652" r:id="R8284d819e7ad4a06"/>
-    <p:sldLayoutId xmlns:r="http://schemas.openxmlformats.org/officeDocument/2006/relationships" id="2147483653" r:id="R7bfe153074a84535"/>
-    <p:sldLayoutId xmlns:r="http://schemas.openxmlformats.org/officeDocument/2006/relationships" id="2147483654" r:id="R652ceed78ee94caf"/>
+    <p:sldLayoutId xmlns:r="http://schemas.openxmlformats.org/officeDocument/2006/relationships" id="2147483649" r:id="Re26f6144a21f4dcb"/>
+    <p:sldLayoutId xmlns:r="http://schemas.openxmlformats.org/officeDocument/2006/relationships" id="2147483650" r:id="R95d233cedf6d46e5"/>
+    <p:sldLayoutId xmlns:r="http://schemas.openxmlformats.org/officeDocument/2006/relationships" id="2147483651" r:id="R53fd99721c6144b2"/>
+    <p:sldLayoutId xmlns:r="http://schemas.openxmlformats.org/officeDocument/2006/relationships" id="2147483652" r:id="R056fbe9e4b2a4204"/>
+    <p:sldLayoutId xmlns:r="http://schemas.openxmlformats.org/officeDocument/2006/relationships" id="2147483653" r:id="R55b7ced7ad994c70"/>
+    <p:sldLayoutId xmlns:r="http://schemas.openxmlformats.org/officeDocument/2006/relationships" id="2147483654" r:id="R4da3304a92fd406c"/>
   </p:sldLayoutIdLst>
   <p:txStyles>
     <p:titleStyle>
@@ -4435,7 +4435,7 @@
           <p:cNvPr id="8" name="">
             <a:extLst xmlns:a="http://schemas.openxmlformats.org/drawingml/2006/main">
               <a:ext uri="{FF2B5EF4-FFF2-40B4-BE49-F238E27FC236}">
-                <a16:creationId xmlns:a16="http://schemas.microsoft.com/office/drawing/2014/main" id="{EF25B1FF-305F-4041-814B-3A12EFE7E704}"/>
+                <a16:creationId xmlns:a16="http://schemas.microsoft.com/office/drawing/2014/main" id="{56549D73-7F5F-4543-9B23-1572B9EBA8C3}"/>
               </a:ext>
             </a:extLst>
           </p:cNvPr>
@@ -4591,7 +4591,7 @@
           <p:cNvPr id="2" name="">
             <a:extLst xmlns:a="http://schemas.openxmlformats.org/drawingml/2006/main">
               <a:ext uri="{FF2B5EF4-FFF2-40B4-BE49-F238E27FC236}">
-                <a16:creationId xmlns:a16="http://schemas.microsoft.com/office/drawing/2014/main" id="{3FCD7E12-5763-4C51-A094-51C9B9FB64A4}"/>
+                <a16:creationId xmlns:a16="http://schemas.microsoft.com/office/drawing/2014/main" id="{E6AFF5D6-425E-4D7D-A669-3B94A435A813}"/>
               </a:ext>
             </a:extLst>
           </p:cNvPr>
@@ -4747,7 +4747,7 @@
           <p:cNvPr id="3" name="">
             <a:extLst xmlns:a="http://schemas.openxmlformats.org/drawingml/2006/main">
               <a:ext uri="{FF2B5EF4-FFF2-40B4-BE49-F238E27FC236}">
-                <a16:creationId xmlns:a16="http://schemas.microsoft.com/office/drawing/2014/main" id="{4E91DA48-4FC5-48C7-884D-52D88E290F61}"/>
+                <a16:creationId xmlns:a16="http://schemas.microsoft.com/office/drawing/2014/main" id="{EB901C6F-BC5D-45FA-8EDB-86A67C74AAF3}"/>
               </a:ext>
             </a:extLst>
           </p:cNvPr>
@@ -4903,7 +4903,7 @@
           <p:cNvPr id="4" name="">
             <a:extLst xmlns:a="http://schemas.openxmlformats.org/drawingml/2006/main">
               <a:ext uri="{FF2B5EF4-FFF2-40B4-BE49-F238E27FC236}">
-                <a16:creationId xmlns:a16="http://schemas.microsoft.com/office/drawing/2014/main" id="{5E160776-26F6-4392-95F1-4882E5FCA22B}"/>
+                <a16:creationId xmlns:a16="http://schemas.microsoft.com/office/drawing/2014/main" id="{C8D7C0CE-EB6C-4499-A11A-042C3A64868B}"/>
               </a:ext>
             </a:extLst>
           </p:cNvPr>
@@ -5082,7 +5082,7 @@
           <p:cNvPr id="5" name="">
             <a:extLst xmlns:a="http://schemas.openxmlformats.org/drawingml/2006/main">
               <a:ext uri="{FF2B5EF4-FFF2-40B4-BE49-F238E27FC236}">
-                <a16:creationId xmlns:a16="http://schemas.microsoft.com/office/drawing/2014/main" id="{52885DDD-2301-41BB-925F-F9C357AFBF23}"/>
+                <a16:creationId xmlns:a16="http://schemas.microsoft.com/office/drawing/2014/main" id="{677ED55F-5508-4F16-B736-41F41659C032}"/>
               </a:ext>
             </a:extLst>
           </p:cNvPr>
@@ -5238,7 +5238,7 @@
           <p:cNvPr id="6" name="">
             <a:extLst xmlns:a="http://schemas.openxmlformats.org/drawingml/2006/main">
               <a:ext uri="{FF2B5EF4-FFF2-40B4-BE49-F238E27FC236}">
-                <a16:creationId xmlns:a16="http://schemas.microsoft.com/office/drawing/2014/main" id="{05AFC871-3568-41EF-BD6D-62A56BD2ADF2}"/>
+                <a16:creationId xmlns:a16="http://schemas.microsoft.com/office/drawing/2014/main" id="{2637531F-49AC-40B6-89B0-6B7896272290}"/>
               </a:ext>
             </a:extLst>
           </p:cNvPr>
@@ -5417,7 +5417,7 @@
           <p:cNvPr id="7" name="">
             <a:extLst xmlns:a="http://schemas.openxmlformats.org/drawingml/2006/main">
               <a:ext uri="{FF2B5EF4-FFF2-40B4-BE49-F238E27FC236}">
-                <a16:creationId xmlns:a16="http://schemas.microsoft.com/office/drawing/2014/main" id="{5B68AF62-F1DF-42D9-9A43-E62CA690EE7F}"/>
+                <a16:creationId xmlns:a16="http://schemas.microsoft.com/office/drawing/2014/main" id="{99E069EA-95ED-42AD-BA1F-3F9678265B0A}"/>
               </a:ext>
             </a:extLst>
           </p:cNvPr>
@@ -5427,7 +5427,7 @@
           <p:nvPr/>
         </p:nvPicPr>
         <p:blipFill>
-          <a:blip xmlns:r="http://schemas.openxmlformats.org/officeDocument/2006/relationships" xmlns:a="http://schemas.openxmlformats.org/drawingml/2006/main" r:embed="Rbcb92a7008774ba5"/>
+          <a:blip xmlns:r="http://schemas.openxmlformats.org/officeDocument/2006/relationships" xmlns:a="http://schemas.openxmlformats.org/drawingml/2006/main" r:embed="R49273c620d66444f"/>
           <a:stretch xmlns:a="http://schemas.openxmlformats.org/drawingml/2006/main"/>
         </p:blipFill>
         <p:spPr>
@@ -5443,7 +5443,7 @@
     </p:spTree>
     <p:extLst>
       <p:ext uri="{BB962C8B-B14F-4D97-AF65-F5344CB8AC3E}">
-        <p14:creationId xmlns:p14="http://schemas.microsoft.com/office/powerpoint/2010/main" val="1777484122"/>
+        <p14:creationId xmlns:p14="http://schemas.microsoft.com/office/powerpoint/2010/main" val="929289667"/>
       </p:ext>
     </p:extLst>
   </p:cSld>
@@ -5474,7 +5474,7 @@
           <p:cNvPr id="8" name="">
             <a:extLst xmlns:a="http://schemas.openxmlformats.org/drawingml/2006/main">
               <a:ext uri="{FF2B5EF4-FFF2-40B4-BE49-F238E27FC236}">
-                <a16:creationId xmlns:a16="http://schemas.microsoft.com/office/drawing/2014/main" id="{B08C22A1-647A-429C-8B27-B2ADB7C1F8BA}"/>
+                <a16:creationId xmlns:a16="http://schemas.microsoft.com/office/drawing/2014/main" id="{BD527CCE-6BEA-4B23-B9AC-E934C28B8592}"/>
               </a:ext>
             </a:extLst>
           </p:cNvPr>
@@ -5630,7 +5630,7 @@
           <p:cNvPr id="2" name="">
             <a:extLst xmlns:a="http://schemas.openxmlformats.org/drawingml/2006/main">
               <a:ext uri="{FF2B5EF4-FFF2-40B4-BE49-F238E27FC236}">
-                <a16:creationId xmlns:a16="http://schemas.microsoft.com/office/drawing/2014/main" id="{17DA0F5F-0597-4894-AE9D-564605974F72}"/>
+                <a16:creationId xmlns:a16="http://schemas.microsoft.com/office/drawing/2014/main" id="{73979842-F7C9-4D3C-9B1B-8BBDA13F672E}"/>
               </a:ext>
             </a:extLst>
           </p:cNvPr>
@@ -5786,7 +5786,7 @@
           <p:cNvPr id="3" name="">
             <a:extLst xmlns:a="http://schemas.openxmlformats.org/drawingml/2006/main">
               <a:ext uri="{FF2B5EF4-FFF2-40B4-BE49-F238E27FC236}">
-                <a16:creationId xmlns:a16="http://schemas.microsoft.com/office/drawing/2014/main" id="{443C7C1C-5C3E-4259-908F-218C682D9CFD}"/>
+                <a16:creationId xmlns:a16="http://schemas.microsoft.com/office/drawing/2014/main" id="{22CFA26B-5C71-40B6-881A-6FF044048F9C}"/>
               </a:ext>
             </a:extLst>
           </p:cNvPr>
@@ -5942,7 +5942,7 @@
           <p:cNvPr id="4" name="">
             <a:extLst xmlns:a="http://schemas.openxmlformats.org/drawingml/2006/main">
               <a:ext uri="{FF2B5EF4-FFF2-40B4-BE49-F238E27FC236}">
-                <a16:creationId xmlns:a16="http://schemas.microsoft.com/office/drawing/2014/main" id="{F0183384-880B-4F2A-84FF-0EC92E031089}"/>
+                <a16:creationId xmlns:a16="http://schemas.microsoft.com/office/drawing/2014/main" id="{293B608E-6E0E-4846-9EB7-B2ADA636C84D}"/>
               </a:ext>
             </a:extLst>
           </p:cNvPr>
@@ -6098,7 +6098,7 @@
           <p:cNvPr id="5" name="">
             <a:extLst xmlns:a="http://schemas.openxmlformats.org/drawingml/2006/main">
               <a:ext uri="{FF2B5EF4-FFF2-40B4-BE49-F238E27FC236}">
-                <a16:creationId xmlns:a16="http://schemas.microsoft.com/office/drawing/2014/main" id="{716DD497-166A-4578-AED6-BB99D0616EAF}"/>
+                <a16:creationId xmlns:a16="http://schemas.microsoft.com/office/drawing/2014/main" id="{24B32E41-12EB-4B37-B2AB-4DC0117FE15F}"/>
               </a:ext>
             </a:extLst>
           </p:cNvPr>
@@ -6254,7 +6254,7 @@
           <p:cNvPr id="6" name="">
             <a:extLst xmlns:a="http://schemas.openxmlformats.org/drawingml/2006/main">
               <a:ext uri="{FF2B5EF4-FFF2-40B4-BE49-F238E27FC236}">
-                <a16:creationId xmlns:a16="http://schemas.microsoft.com/office/drawing/2014/main" id="{550CD179-06A0-4495-9DFA-B314DCD6F522}"/>
+                <a16:creationId xmlns:a16="http://schemas.microsoft.com/office/drawing/2014/main" id="{35561A79-0265-4CC9-A833-E4417C051353}"/>
               </a:ext>
             </a:extLst>
           </p:cNvPr>
@@ -6400,7 +6400,7 @@
                 <a:ea typeface="Arial"/>
                 <a:cs typeface="Arial"/>
               </a:rPr>
-              <a:t>Vertex AI / Gemini and Google ADK supply bounded advisory integration. Firestore operational controls remain separately activation-gated.</a:t>
+              <a:t>Vertex AI / Gemini and Google ADK supply bounded advisory integration. Firestore reservations, outcomes and owner-scoped activity readback are implemented; live activation remains gated.</a:t>
             </a:r>
           </a:p>
         </p:txBody>
@@ -6410,7 +6410,7 @@
           <p:cNvPr id="7" name="">
             <a:extLst xmlns:a="http://schemas.openxmlformats.org/drawingml/2006/main">
               <a:ext uri="{FF2B5EF4-FFF2-40B4-BE49-F238E27FC236}">
-                <a16:creationId xmlns:a16="http://schemas.microsoft.com/office/drawing/2014/main" id="{7A47DE8D-D96C-4BEE-ADE0-B55923DD6E0C}"/>
+                <a16:creationId xmlns:a16="http://schemas.microsoft.com/office/drawing/2014/main" id="{6628B326-BC33-433C-B217-4A67070179A7}"/>
               </a:ext>
             </a:extLst>
           </p:cNvPr>
@@ -6564,7 +6564,7 @@
     </p:spTree>
     <p:extLst>
       <p:ext uri="{BB962C8B-B14F-4D97-AF65-F5344CB8AC3E}">
-        <p14:creationId xmlns:p14="http://schemas.microsoft.com/office/powerpoint/2010/main" val="537027289"/>
+        <p14:creationId xmlns:p14="http://schemas.microsoft.com/office/powerpoint/2010/main" val="975340078"/>
       </p:ext>
     </p:extLst>
   </p:cSld>
@@ -6595,7 +6595,7 @@
           <p:cNvPr id="9" name="">
             <a:extLst xmlns:a="http://schemas.openxmlformats.org/drawingml/2006/main">
               <a:ext uri="{FF2B5EF4-FFF2-40B4-BE49-F238E27FC236}">
-                <a16:creationId xmlns:a16="http://schemas.microsoft.com/office/drawing/2014/main" id="{DDA1A99A-7473-4B3A-90C4-FB4BCD9B20E2}"/>
+                <a16:creationId xmlns:a16="http://schemas.microsoft.com/office/drawing/2014/main" id="{150392E2-E40C-48EA-9D89-EB290A637584}"/>
               </a:ext>
             </a:extLst>
           </p:cNvPr>
@@ -6751,7 +6751,7 @@
           <p:cNvPr id="2" name="">
             <a:extLst xmlns:a="http://schemas.openxmlformats.org/drawingml/2006/main">
               <a:ext uri="{FF2B5EF4-FFF2-40B4-BE49-F238E27FC236}">
-                <a16:creationId xmlns:a16="http://schemas.microsoft.com/office/drawing/2014/main" id="{D83FB493-A1D3-4952-AE19-34BA2780ACC0}"/>
+                <a16:creationId xmlns:a16="http://schemas.microsoft.com/office/drawing/2014/main" id="{A6BCDB9A-AE50-4FC0-86CB-5A64FDD98A67}"/>
               </a:ext>
             </a:extLst>
           </p:cNvPr>
@@ -6907,7 +6907,7 @@
           <p:cNvPr id="3" name="">
             <a:extLst xmlns:a="http://schemas.openxmlformats.org/drawingml/2006/main">
               <a:ext uri="{FF2B5EF4-FFF2-40B4-BE49-F238E27FC236}">
-                <a16:creationId xmlns:a16="http://schemas.microsoft.com/office/drawing/2014/main" id="{9507FFB5-2B72-4C0E-9815-D7D052FCEC9B}"/>
+                <a16:creationId xmlns:a16="http://schemas.microsoft.com/office/drawing/2014/main" id="{AFBFCB5B-B5F9-48CF-BC46-DA2EF1791C8E}"/>
               </a:ext>
             </a:extLst>
           </p:cNvPr>
@@ -7063,7 +7063,7 @@
           <p:cNvPr id="4" name="">
             <a:extLst xmlns:a="http://schemas.openxmlformats.org/drawingml/2006/main">
               <a:ext uri="{FF2B5EF4-FFF2-40B4-BE49-F238E27FC236}">
-                <a16:creationId xmlns:a16="http://schemas.microsoft.com/office/drawing/2014/main" id="{57E3E640-DB3F-488E-A9F5-93001431A15E}"/>
+                <a16:creationId xmlns:a16="http://schemas.microsoft.com/office/drawing/2014/main" id="{F0C27BAB-D731-4B41-875F-46A329595CE2}"/>
               </a:ext>
             </a:extLst>
           </p:cNvPr>
@@ -7219,7 +7219,7 @@
           <p:cNvPr id="5" name="">
             <a:extLst xmlns:a="http://schemas.openxmlformats.org/drawingml/2006/main">
               <a:ext uri="{FF2B5EF4-FFF2-40B4-BE49-F238E27FC236}">
-                <a16:creationId xmlns:a16="http://schemas.microsoft.com/office/drawing/2014/main" id="{F5B410FD-54AD-4AF6-AFC6-00D379D26CFB}"/>
+                <a16:creationId xmlns:a16="http://schemas.microsoft.com/office/drawing/2014/main" id="{C2E3CA19-B2F0-486F-BEF0-C7911295D351}"/>
               </a:ext>
             </a:extLst>
           </p:cNvPr>
@@ -7375,7 +7375,7 @@
           <p:cNvPr id="6" name="">
             <a:extLst xmlns:a="http://schemas.openxmlformats.org/drawingml/2006/main">
               <a:ext uri="{FF2B5EF4-FFF2-40B4-BE49-F238E27FC236}">
-                <a16:creationId xmlns:a16="http://schemas.microsoft.com/office/drawing/2014/main" id="{16A13C67-3C09-48A9-8B96-1F4EDD9BE09E}"/>
+                <a16:creationId xmlns:a16="http://schemas.microsoft.com/office/drawing/2014/main" id="{4571E77A-7B65-4E9B-A7E7-BB3DD276387E}"/>
               </a:ext>
             </a:extLst>
           </p:cNvPr>
@@ -7531,7 +7531,7 @@
           <p:cNvPr id="7" name="">
             <a:extLst xmlns:a="http://schemas.openxmlformats.org/drawingml/2006/main">
               <a:ext uri="{FF2B5EF4-FFF2-40B4-BE49-F238E27FC236}">
-                <a16:creationId xmlns:a16="http://schemas.microsoft.com/office/drawing/2014/main" id="{C2612EE9-1DF7-4AD2-ADA1-F78381A9A9F2}"/>
+                <a16:creationId xmlns:a16="http://schemas.microsoft.com/office/drawing/2014/main" id="{682F5DE4-E505-4D70-A783-5B966740B8ED}"/>
               </a:ext>
             </a:extLst>
           </p:cNvPr>
@@ -7687,7 +7687,7 @@
           <p:cNvPr id="8" name="">
             <a:extLst xmlns:a="http://schemas.openxmlformats.org/drawingml/2006/main">
               <a:ext uri="{FF2B5EF4-FFF2-40B4-BE49-F238E27FC236}">
-                <a16:creationId xmlns:a16="http://schemas.microsoft.com/office/drawing/2014/main" id="{7F4AB5EE-5245-42B7-9459-2C5361B4ECE9}"/>
+                <a16:creationId xmlns:a16="http://schemas.microsoft.com/office/drawing/2014/main" id="{E8280DEE-1777-4614-9CB4-B29BE2AE4523}"/>
               </a:ext>
             </a:extLst>
           </p:cNvPr>
@@ -7841,7 +7841,7 @@
     </p:spTree>
     <p:extLst>
       <p:ext uri="{BB962C8B-B14F-4D97-AF65-F5344CB8AC3E}">
-        <p14:creationId xmlns:p14="http://schemas.microsoft.com/office/powerpoint/2010/main" val="674286225"/>
+        <p14:creationId xmlns:p14="http://schemas.microsoft.com/office/powerpoint/2010/main" val="108631747"/>
       </p:ext>
     </p:extLst>
   </p:cSld>
@@ -7872,7 +7872,7 @@
           <p:cNvPr id="7" name="">
             <a:extLst xmlns:a="http://schemas.openxmlformats.org/drawingml/2006/main">
               <a:ext uri="{FF2B5EF4-FFF2-40B4-BE49-F238E27FC236}">
-                <a16:creationId xmlns:a16="http://schemas.microsoft.com/office/drawing/2014/main" id="{39E1CEE7-AB32-4777-8CD9-36C1E0DE7439}"/>
+                <a16:creationId xmlns:a16="http://schemas.microsoft.com/office/drawing/2014/main" id="{359AEF07-675F-4A06-94F4-67EA243F1459}"/>
               </a:ext>
             </a:extLst>
           </p:cNvPr>
@@ -8028,7 +8028,7 @@
           <p:cNvPr id="2" name="">
             <a:extLst xmlns:a="http://schemas.openxmlformats.org/drawingml/2006/main">
               <a:ext uri="{FF2B5EF4-FFF2-40B4-BE49-F238E27FC236}">
-                <a16:creationId xmlns:a16="http://schemas.microsoft.com/office/drawing/2014/main" id="{C7450DBC-657B-48FE-93D5-AE92EE0E42D2}"/>
+                <a16:creationId xmlns:a16="http://schemas.microsoft.com/office/drawing/2014/main" id="{5638416B-BD73-4F18-981C-3F267241C60A}"/>
               </a:ext>
             </a:extLst>
           </p:cNvPr>
@@ -8184,7 +8184,7 @@
           <p:cNvPr id="3" name="">
             <a:extLst xmlns:a="http://schemas.openxmlformats.org/drawingml/2006/main">
               <a:ext uri="{FF2B5EF4-FFF2-40B4-BE49-F238E27FC236}">
-                <a16:creationId xmlns:a16="http://schemas.microsoft.com/office/drawing/2014/main" id="{D01EA6BA-9C59-4BF4-93C3-604836CC3662}"/>
+                <a16:creationId xmlns:a16="http://schemas.microsoft.com/office/drawing/2014/main" id="{1F921071-8FE9-460B-8597-08F2F7CD7A73}"/>
               </a:ext>
             </a:extLst>
           </p:cNvPr>
@@ -8340,7 +8340,7 @@
           <p:cNvPr id="4" name="">
             <a:extLst xmlns:a="http://schemas.openxmlformats.org/drawingml/2006/main">
               <a:ext uri="{FF2B5EF4-FFF2-40B4-BE49-F238E27FC236}">
-                <a16:creationId xmlns:a16="http://schemas.microsoft.com/office/drawing/2014/main" id="{5C6993F8-0FB5-4A54-A0B6-E57FC4C3F60B}"/>
+                <a16:creationId xmlns:a16="http://schemas.microsoft.com/office/drawing/2014/main" id="{43FF4391-DD58-4E79-9CBC-73156C96F7F9}"/>
               </a:ext>
             </a:extLst>
           </p:cNvPr>
@@ -8350,13 +8350,13 @@
           <p:nvPr/>
         </p:nvPicPr>
         <p:blipFill>
-          <a:blip xmlns:r="http://schemas.openxmlformats.org/officeDocument/2006/relationships" xmlns:a="http://schemas.openxmlformats.org/drawingml/2006/main" r:embed="R444c47c69fb24ff1"/>
+          <a:blip xmlns:r="http://schemas.openxmlformats.org/officeDocument/2006/relationships" xmlns:a="http://schemas.openxmlformats.org/drawingml/2006/main" r:embed="R2141f2b900d74d35"/>
           <a:stretch xmlns:a="http://schemas.openxmlformats.org/drawingml/2006/main"/>
         </p:blipFill>
         <p:spPr>
           <a:xfrm xmlns:a="http://schemas.openxmlformats.org/drawingml/2006/main">
-            <a:off x="962025" y="1428750"/>
-            <a:ext cx="7010400" cy="4381500"/>
+            <a:off x="1312545" y="1428750"/>
+            <a:ext cx="6309360" cy="4381500"/>
           </a:xfrm>
           <a:prstGeom xmlns:a="http://schemas.openxmlformats.org/drawingml/2006/main" prst="rect">
             <a:avLst/>
@@ -8368,7 +8368,7 @@
           <p:cNvPr id="5" name="">
             <a:extLst xmlns:a="http://schemas.openxmlformats.org/drawingml/2006/main">
               <a:ext uri="{FF2B5EF4-FFF2-40B4-BE49-F238E27FC236}">
-                <a16:creationId xmlns:a16="http://schemas.microsoft.com/office/drawing/2014/main" id="{EE178F04-F3BB-44FC-B237-CD5BD30E1F81}"/>
+                <a16:creationId xmlns:a16="http://schemas.microsoft.com/office/drawing/2014/main" id="{5D1021CA-0507-493F-B1B8-5154EDCABCFA}"/>
               </a:ext>
             </a:extLst>
           </p:cNvPr>
@@ -8524,7 +8524,7 @@
           <p:cNvPr id="6" name="">
             <a:extLst xmlns:a="http://schemas.openxmlformats.org/drawingml/2006/main">
               <a:ext uri="{FF2B5EF4-FFF2-40B4-BE49-F238E27FC236}">
-                <a16:creationId xmlns:a16="http://schemas.microsoft.com/office/drawing/2014/main" id="{D58C062B-13C9-4E82-9AD5-72905B877F5D}"/>
+                <a16:creationId xmlns:a16="http://schemas.microsoft.com/office/drawing/2014/main" id="{DA5CADAA-2EF1-44C1-A10B-CBD892AE3E99}"/>
               </a:ext>
             </a:extLst>
           </p:cNvPr>
@@ -8734,7 +8734,7 @@
     </p:spTree>
     <p:extLst>
       <p:ext uri="{BB962C8B-B14F-4D97-AF65-F5344CB8AC3E}">
-        <p14:creationId xmlns:p14="http://schemas.microsoft.com/office/powerpoint/2010/main" val="1049339756"/>
+        <p14:creationId xmlns:p14="http://schemas.microsoft.com/office/powerpoint/2010/main" val="477061184"/>
       </p:ext>
     </p:extLst>
   </p:cSld>
@@ -8765,7 +8765,7 @@
           <p:cNvPr id="12" name="">
             <a:extLst xmlns:a="http://schemas.openxmlformats.org/drawingml/2006/main">
               <a:ext uri="{FF2B5EF4-FFF2-40B4-BE49-F238E27FC236}">
-                <a16:creationId xmlns:a16="http://schemas.microsoft.com/office/drawing/2014/main" id="{69CD1A39-353A-4ED3-8D0A-9D59E1940B42}"/>
+                <a16:creationId xmlns:a16="http://schemas.microsoft.com/office/drawing/2014/main" id="{471B21B7-6821-4A0B-AF38-AFB4A063CBD7}"/>
               </a:ext>
             </a:extLst>
           </p:cNvPr>
@@ -8921,7 +8921,7 @@
           <p:cNvPr id="2" name="">
             <a:extLst xmlns:a="http://schemas.openxmlformats.org/drawingml/2006/main">
               <a:ext uri="{FF2B5EF4-FFF2-40B4-BE49-F238E27FC236}">
-                <a16:creationId xmlns:a16="http://schemas.microsoft.com/office/drawing/2014/main" id="{920147B3-1688-4F83-81BB-242CB13703D5}"/>
+                <a16:creationId xmlns:a16="http://schemas.microsoft.com/office/drawing/2014/main" id="{30A0BDC2-C6EF-41CE-B55E-5F96378EFA38}"/>
               </a:ext>
             </a:extLst>
           </p:cNvPr>
@@ -9077,7 +9077,7 @@
           <p:cNvPr id="3" name="">
             <a:extLst xmlns:a="http://schemas.openxmlformats.org/drawingml/2006/main">
               <a:ext uri="{FF2B5EF4-FFF2-40B4-BE49-F238E27FC236}">
-                <a16:creationId xmlns:a16="http://schemas.microsoft.com/office/drawing/2014/main" id="{58D27430-27D4-43E0-B8F3-752A9BC09EEE}"/>
+                <a16:creationId xmlns:a16="http://schemas.microsoft.com/office/drawing/2014/main" id="{F63086BD-13B8-491C-88C8-D1AF244C4D25}"/>
               </a:ext>
             </a:extLst>
           </p:cNvPr>
@@ -9233,7 +9233,7 @@
           <p:cNvPr id="4" name="">
             <a:extLst xmlns:a="http://schemas.openxmlformats.org/drawingml/2006/main">
               <a:ext uri="{FF2B5EF4-FFF2-40B4-BE49-F238E27FC236}">
-                <a16:creationId xmlns:a16="http://schemas.microsoft.com/office/drawing/2014/main" id="{17F6D4A8-8961-4E8E-8CB9-3CC39BAC66B5}"/>
+                <a16:creationId xmlns:a16="http://schemas.microsoft.com/office/drawing/2014/main" id="{BB0BEE67-61ED-4D62-8599-A31F31CB092E}"/>
               </a:ext>
             </a:extLst>
           </p:cNvPr>
@@ -9389,7 +9389,7 @@
           <p:cNvPr id="5" name="">
             <a:extLst xmlns:a="http://schemas.openxmlformats.org/drawingml/2006/main">
               <a:ext uri="{FF2B5EF4-FFF2-40B4-BE49-F238E27FC236}">
-                <a16:creationId xmlns:a16="http://schemas.microsoft.com/office/drawing/2014/main" id="{3AF7D9E8-CED6-415B-B334-35C872F305A6}"/>
+                <a16:creationId xmlns:a16="http://schemas.microsoft.com/office/drawing/2014/main" id="{AF14F572-7E31-473F-9FA4-4E5D129E98D3}"/>
               </a:ext>
             </a:extLst>
           </p:cNvPr>
@@ -9535,7 +9535,7 @@
                 <a:ea typeface="Arial"/>
                 <a:cs typeface="Arial"/>
               </a:rPr>
-              <a:t>559 passed</a:t>
+              <a:t>584 passed</a:t>
             </a:r>
           </a:p>
         </p:txBody>
@@ -9545,7 +9545,7 @@
           <p:cNvPr id="6" name="">
             <a:extLst xmlns:a="http://schemas.openxmlformats.org/drawingml/2006/main">
               <a:ext uri="{FF2B5EF4-FFF2-40B4-BE49-F238E27FC236}">
-                <a16:creationId xmlns:a16="http://schemas.microsoft.com/office/drawing/2014/main" id="{2217D6AE-2EC3-4946-A529-69A29BD8EE3C}"/>
+                <a16:creationId xmlns:a16="http://schemas.microsoft.com/office/drawing/2014/main" id="{2D823B59-52C8-4020-A57E-205A265A4F6F}"/>
               </a:ext>
             </a:extLst>
           </p:cNvPr>
@@ -9701,7 +9701,7 @@
           <p:cNvPr id="7" name="">
             <a:extLst xmlns:a="http://schemas.openxmlformats.org/drawingml/2006/main">
               <a:ext uri="{FF2B5EF4-FFF2-40B4-BE49-F238E27FC236}">
-                <a16:creationId xmlns:a16="http://schemas.microsoft.com/office/drawing/2014/main" id="{B3B6E014-BAAE-4884-8A9E-FF7CAA9494CB}"/>
+                <a16:creationId xmlns:a16="http://schemas.microsoft.com/office/drawing/2014/main" id="{CDE20DAD-9A09-49CC-A553-F14B39F2BF7F}"/>
               </a:ext>
             </a:extLst>
           </p:cNvPr>
@@ -9857,7 +9857,7 @@
           <p:cNvPr id="8" name="">
             <a:extLst xmlns:a="http://schemas.openxmlformats.org/drawingml/2006/main">
               <a:ext uri="{FF2B5EF4-FFF2-40B4-BE49-F238E27FC236}">
-                <a16:creationId xmlns:a16="http://schemas.microsoft.com/office/drawing/2014/main" id="{BAFDF6D8-6E2B-4F21-9B23-D378EE61E388}"/>
+                <a16:creationId xmlns:a16="http://schemas.microsoft.com/office/drawing/2014/main" id="{707066C6-C2D1-462C-99D9-CF03277630CE}"/>
               </a:ext>
             </a:extLst>
           </p:cNvPr>
@@ -10003,7 +10003,7 @@
                 <a:ea typeface="Arial"/>
                 <a:cs typeface="Arial"/>
               </a:rPr>
-              <a:t>658 passed</a:t>
+              <a:t>674 passed</a:t>
             </a:r>
           </a:p>
         </p:txBody>
@@ -10013,7 +10013,7 @@
           <p:cNvPr id="9" name="">
             <a:extLst xmlns:a="http://schemas.openxmlformats.org/drawingml/2006/main">
               <a:ext uri="{FF2B5EF4-FFF2-40B4-BE49-F238E27FC236}">
-                <a16:creationId xmlns:a16="http://schemas.microsoft.com/office/drawing/2014/main" id="{B7088D81-3442-49A0-8A91-76C6111AA94C}"/>
+                <a16:creationId xmlns:a16="http://schemas.microsoft.com/office/drawing/2014/main" id="{1310EA7B-86C0-41A8-888A-D8F8355C8D87}"/>
               </a:ext>
             </a:extLst>
           </p:cNvPr>
@@ -10159,7 +10159,7 @@
                 <a:ea typeface="Arial"/>
                 <a:cs typeface="Arial"/>
               </a:rPr>
-              <a:t>50 test files</a:t>
+              <a:t>51 test files</a:t>
             </a:r>
           </a:p>
         </p:txBody>
@@ -10169,7 +10169,7 @@
           <p:cNvPr id="10" name="">
             <a:extLst xmlns:a="http://schemas.openxmlformats.org/drawingml/2006/main">
               <a:ext uri="{FF2B5EF4-FFF2-40B4-BE49-F238E27FC236}">
-                <a16:creationId xmlns:a16="http://schemas.microsoft.com/office/drawing/2014/main" id="{3374F8E1-5730-4F6E-901D-F034EA993843}"/>
+                <a16:creationId xmlns:a16="http://schemas.microsoft.com/office/drawing/2014/main" id="{56793F09-5B4D-48E2-9A62-6F72B47D1421}"/>
               </a:ext>
             </a:extLst>
           </p:cNvPr>
@@ -10325,7 +10325,7 @@
           <p:cNvPr id="11" name="">
             <a:extLst xmlns:a="http://schemas.openxmlformats.org/drawingml/2006/main">
               <a:ext uri="{FF2B5EF4-FFF2-40B4-BE49-F238E27FC236}">
-                <a16:creationId xmlns:a16="http://schemas.microsoft.com/office/drawing/2014/main" id="{DB8265F3-C125-4F8B-A6A3-951AC91B6260}"/>
+                <a16:creationId xmlns:a16="http://schemas.microsoft.com/office/drawing/2014/main" id="{827F6BF5-88A4-4C7C-AE6F-3256C99A8CED}"/>
               </a:ext>
             </a:extLst>
           </p:cNvPr>
@@ -10471,7 +10471,7 @@
                 <a:ea typeface="Arial"/>
                 <a:cs typeface="Arial"/>
               </a:rPr>
-              <a:t>Local candidate evidence. Lint, typecheck and build passed. No live-model accuracy, external provider benchmark or customer-impact claim.</a:t>
+              <a:t>Local candidate: 17/17 full-journey browser checks; 14/14 Play checks. Lint, types and build passed. Live-model quality and customer impact unmeasured.</a:t>
             </a:r>
           </a:p>
         </p:txBody>
@@ -10479,7 +10479,7 @@
     </p:spTree>
     <p:extLst>
       <p:ext uri="{BB962C8B-B14F-4D97-AF65-F5344CB8AC3E}">
-        <p14:creationId xmlns:p14="http://schemas.microsoft.com/office/powerpoint/2010/main" val="722293371"/>
+        <p14:creationId xmlns:p14="http://schemas.microsoft.com/office/powerpoint/2010/main" val="1065166922"/>
       </p:ext>
     </p:extLst>
   </p:cSld>
@@ -10510,7 +10510,7 @@
           <p:cNvPr id="7" name="">
             <a:extLst xmlns:a="http://schemas.openxmlformats.org/drawingml/2006/main">
               <a:ext uri="{FF2B5EF4-FFF2-40B4-BE49-F238E27FC236}">
-                <a16:creationId xmlns:a16="http://schemas.microsoft.com/office/drawing/2014/main" id="{3BB5C22B-D56F-4044-9472-BEEFE0B18EAC}"/>
+                <a16:creationId xmlns:a16="http://schemas.microsoft.com/office/drawing/2014/main" id="{9843AE95-F4D2-4083-A983-34623CF86F09}"/>
               </a:ext>
             </a:extLst>
           </p:cNvPr>
@@ -10666,7 +10666,7 @@
           <p:cNvPr id="2" name="">
             <a:extLst xmlns:a="http://schemas.openxmlformats.org/drawingml/2006/main">
               <a:ext uri="{FF2B5EF4-FFF2-40B4-BE49-F238E27FC236}">
-                <a16:creationId xmlns:a16="http://schemas.microsoft.com/office/drawing/2014/main" id="{2FE37A0D-13B9-449A-9433-39DDC6C1009E}"/>
+                <a16:creationId xmlns:a16="http://schemas.microsoft.com/office/drawing/2014/main" id="{035FDB83-8797-415F-9F64-D2FFD6D06FA5}"/>
               </a:ext>
             </a:extLst>
           </p:cNvPr>
@@ -10822,7 +10822,7 @@
           <p:cNvPr id="3" name="">
             <a:extLst xmlns:a="http://schemas.openxmlformats.org/drawingml/2006/main">
               <a:ext uri="{FF2B5EF4-FFF2-40B4-BE49-F238E27FC236}">
-                <a16:creationId xmlns:a16="http://schemas.microsoft.com/office/drawing/2014/main" id="{4475FC63-F5B5-4F07-9A2D-268573656C05}"/>
+                <a16:creationId xmlns:a16="http://schemas.microsoft.com/office/drawing/2014/main" id="{76D49A4C-7D5E-4565-8E81-CD7B5FE017BE}"/>
               </a:ext>
             </a:extLst>
           </p:cNvPr>
@@ -10978,7 +10978,7 @@
           <p:cNvPr id="4" name="">
             <a:extLst xmlns:a="http://schemas.openxmlformats.org/drawingml/2006/main">
               <a:ext uri="{FF2B5EF4-FFF2-40B4-BE49-F238E27FC236}">
-                <a16:creationId xmlns:a16="http://schemas.microsoft.com/office/drawing/2014/main" id="{FE3F7A01-69E3-41CD-9DCD-2F422A6B5B71}"/>
+                <a16:creationId xmlns:a16="http://schemas.microsoft.com/office/drawing/2014/main" id="{95603CBE-06AD-4799-9B80-DE5F0CF959D9}"/>
               </a:ext>
             </a:extLst>
           </p:cNvPr>
@@ -11134,7 +11134,7 @@
           <p:cNvPr id="5" name="">
             <a:extLst xmlns:a="http://schemas.openxmlformats.org/drawingml/2006/main">
               <a:ext uri="{FF2B5EF4-FFF2-40B4-BE49-F238E27FC236}">
-                <a16:creationId xmlns:a16="http://schemas.microsoft.com/office/drawing/2014/main" id="{B2CC80CC-6DBB-4AFD-A6DA-C52B3D91349B}"/>
+                <a16:creationId xmlns:a16="http://schemas.microsoft.com/office/drawing/2014/main" id="{160C6934-2553-4E65-BEC8-18BC46029CF3}"/>
               </a:ext>
             </a:extLst>
           </p:cNvPr>
@@ -11290,7 +11290,7 @@
           <p:cNvPr id="6" name="">
             <a:extLst xmlns:a="http://schemas.openxmlformats.org/drawingml/2006/main">
               <a:ext uri="{FF2B5EF4-FFF2-40B4-BE49-F238E27FC236}">
-                <a16:creationId xmlns:a16="http://schemas.microsoft.com/office/drawing/2014/main" id="{4092D56B-5AB9-4697-890C-CB04C41EBC9B}"/>
+                <a16:creationId xmlns:a16="http://schemas.microsoft.com/office/drawing/2014/main" id="{83572750-738C-4229-8CB2-3FF6465967C8}"/>
               </a:ext>
             </a:extLst>
           </p:cNvPr>
@@ -11444,7 +11444,7 @@
     </p:spTree>
     <p:extLst>
       <p:ext uri="{BB962C8B-B14F-4D97-AF65-F5344CB8AC3E}">
-        <p14:creationId xmlns:p14="http://schemas.microsoft.com/office/powerpoint/2010/main" val="1482145178"/>
+        <p14:creationId xmlns:p14="http://schemas.microsoft.com/office/powerpoint/2010/main" val="1243432657"/>
       </p:ext>
     </p:extLst>
   </p:cSld>
@@ -11475,7 +11475,7 @@
           <p:cNvPr id="11" name="">
             <a:extLst xmlns:a="http://schemas.openxmlformats.org/drawingml/2006/main">
               <a:ext uri="{FF2B5EF4-FFF2-40B4-BE49-F238E27FC236}">
-                <a16:creationId xmlns:a16="http://schemas.microsoft.com/office/drawing/2014/main" id="{D28A0BE3-56AB-43BF-B4D4-1E83B69C0489}"/>
+                <a16:creationId xmlns:a16="http://schemas.microsoft.com/office/drawing/2014/main" id="{AD19BDC3-0BB4-43F5-8782-798C4A87B5E4}"/>
               </a:ext>
             </a:extLst>
           </p:cNvPr>
@@ -11631,7 +11631,7 @@
           <p:cNvPr id="2" name="">
             <a:extLst xmlns:a="http://schemas.openxmlformats.org/drawingml/2006/main">
               <a:ext uri="{FF2B5EF4-FFF2-40B4-BE49-F238E27FC236}">
-                <a16:creationId xmlns:a16="http://schemas.microsoft.com/office/drawing/2014/main" id="{086C06F9-6011-48D5-B060-BC8E9E862EAF}"/>
+                <a16:creationId xmlns:a16="http://schemas.microsoft.com/office/drawing/2014/main" id="{69A8C22B-A5D3-4A77-99C7-5B12BC41EC9F}"/>
               </a:ext>
             </a:extLst>
           </p:cNvPr>
@@ -11787,7 +11787,7 @@
           <p:cNvPr id="3" name="">
             <a:extLst xmlns:a="http://schemas.openxmlformats.org/drawingml/2006/main">
               <a:ext uri="{FF2B5EF4-FFF2-40B4-BE49-F238E27FC236}">
-                <a16:creationId xmlns:a16="http://schemas.microsoft.com/office/drawing/2014/main" id="{0A8B4936-8967-4579-A46E-4FDAA1BAFA73}"/>
+                <a16:creationId xmlns:a16="http://schemas.microsoft.com/office/drawing/2014/main" id="{3734AAD5-4663-404B-A667-FAEFE54A67F2}"/>
               </a:ext>
             </a:extLst>
           </p:cNvPr>
@@ -11943,7 +11943,7 @@
           <p:cNvPr id="4" name="">
             <a:extLst xmlns:a="http://schemas.openxmlformats.org/drawingml/2006/main">
               <a:ext uri="{FF2B5EF4-FFF2-40B4-BE49-F238E27FC236}">
-                <a16:creationId xmlns:a16="http://schemas.microsoft.com/office/drawing/2014/main" id="{EBAB979F-62A0-47C7-AD26-46EF88B31906}"/>
+                <a16:creationId xmlns:a16="http://schemas.microsoft.com/office/drawing/2014/main" id="{B7D0EBAE-2D4C-460B-B812-F0B7B0A1F7BD}"/>
               </a:ext>
             </a:extLst>
           </p:cNvPr>
@@ -12099,7 +12099,7 @@
           <p:cNvPr id="5" name="">
             <a:extLst xmlns:a="http://schemas.openxmlformats.org/drawingml/2006/main">
               <a:ext uri="{FF2B5EF4-FFF2-40B4-BE49-F238E27FC236}">
-                <a16:creationId xmlns:a16="http://schemas.microsoft.com/office/drawing/2014/main" id="{05F47234-5A63-4B2C-8890-85823D2B7063}"/>
+                <a16:creationId xmlns:a16="http://schemas.microsoft.com/office/drawing/2014/main" id="{CFD01BC7-0374-44D5-AEDE-7159189C6A4A}"/>
               </a:ext>
             </a:extLst>
           </p:cNvPr>
@@ -12255,7 +12255,7 @@
           <p:cNvPr id="6" name="">
             <a:extLst xmlns:a="http://schemas.openxmlformats.org/drawingml/2006/main">
               <a:ext uri="{FF2B5EF4-FFF2-40B4-BE49-F238E27FC236}">
-                <a16:creationId xmlns:a16="http://schemas.microsoft.com/office/drawing/2014/main" id="{466359F1-B7C9-42BC-9E73-63B9268CC810}"/>
+                <a16:creationId xmlns:a16="http://schemas.microsoft.com/office/drawing/2014/main" id="{99673D63-5555-4E80-8AE1-26E2FE63E9EE}"/>
               </a:ext>
             </a:extLst>
           </p:cNvPr>
@@ -12411,7 +12411,7 @@
           <p:cNvPr id="7" name="">
             <a:extLst xmlns:a="http://schemas.openxmlformats.org/drawingml/2006/main">
               <a:ext uri="{FF2B5EF4-FFF2-40B4-BE49-F238E27FC236}">
-                <a16:creationId xmlns:a16="http://schemas.microsoft.com/office/drawing/2014/main" id="{791B9ECC-65AB-4F15-A3EA-207F08CD2EF8}"/>
+                <a16:creationId xmlns:a16="http://schemas.microsoft.com/office/drawing/2014/main" id="{1A347FE4-3279-48F6-8D61-4EB430639D8B}"/>
               </a:ext>
             </a:extLst>
           </p:cNvPr>
@@ -12567,7 +12567,7 @@
           <p:cNvPr id="8" name="">
             <a:extLst xmlns:a="http://schemas.openxmlformats.org/drawingml/2006/main">
               <a:ext uri="{FF2B5EF4-FFF2-40B4-BE49-F238E27FC236}">
-                <a16:creationId xmlns:a16="http://schemas.microsoft.com/office/drawing/2014/main" id="{C87F4B43-56C9-4EBE-ADF1-5BBA48E2F7DF}"/>
+                <a16:creationId xmlns:a16="http://schemas.microsoft.com/office/drawing/2014/main" id="{8E6E5555-1BD4-4BB3-8913-AE27BADEB039}"/>
               </a:ext>
             </a:extLst>
           </p:cNvPr>
@@ -12723,7 +12723,7 @@
           <p:cNvPr id="9" name="">
             <a:extLst xmlns:a="http://schemas.openxmlformats.org/drawingml/2006/main">
               <a:ext uri="{FF2B5EF4-FFF2-40B4-BE49-F238E27FC236}">
-                <a16:creationId xmlns:a16="http://schemas.microsoft.com/office/drawing/2014/main" id="{0D52F3B5-7E6C-4F9D-BFD0-AFBAEC3583D2}"/>
+                <a16:creationId xmlns:a16="http://schemas.microsoft.com/office/drawing/2014/main" id="{833812D8-541F-4F9C-AF59-60883B8AD297}"/>
               </a:ext>
             </a:extLst>
           </p:cNvPr>
@@ -12879,7 +12879,7 @@
           <p:cNvPr id="10" name="">
             <a:extLst xmlns:a="http://schemas.openxmlformats.org/drawingml/2006/main">
               <a:ext uri="{FF2B5EF4-FFF2-40B4-BE49-F238E27FC236}">
-                <a16:creationId xmlns:a16="http://schemas.microsoft.com/office/drawing/2014/main" id="{03E1D115-66FC-4954-94B4-F2BB3405053C}"/>
+                <a16:creationId xmlns:a16="http://schemas.microsoft.com/office/drawing/2014/main" id="{27C1F26E-E90A-458C-ADDD-450FE1C187E1}"/>
               </a:ext>
             </a:extLst>
           </p:cNvPr>
@@ -13025,7 +13025,7 @@
                 <a:ea typeface="Arial"/>
                 <a:cs typeface="Arial"/>
               </a:rPr>
-              <a:t>Release completion requires the official template, portal checks, accepted candidate evidence and an authentic 3–4 minute video.</a:t>
+              <a:t>Captioned working video: 3:51.88, local synthetic UI. Official template, team details, public video link and approved cloud release remain pending.</a:t>
             </a:r>
           </a:p>
         </p:txBody>
@@ -13033,7 +13033,7 @@
     </p:spTree>
     <p:extLst>
       <p:ext uri="{BB962C8B-B14F-4D97-AF65-F5344CB8AC3E}">
-        <p14:creationId xmlns:p14="http://schemas.microsoft.com/office/powerpoint/2010/main" val="972751252"/>
+        <p14:creationId xmlns:p14="http://schemas.microsoft.com/office/powerpoint/2010/main" val="71130850"/>
       </p:ext>
     </p:extLst>
   </p:cSld>
@@ -13064,7 +13064,7 @@
           <p:cNvPr id="7" name="">
             <a:extLst xmlns:a="http://schemas.openxmlformats.org/drawingml/2006/main">
               <a:ext uri="{FF2B5EF4-FFF2-40B4-BE49-F238E27FC236}">
-                <a16:creationId xmlns:a16="http://schemas.microsoft.com/office/drawing/2014/main" id="{A52375D3-562E-47C0-8B3A-588E71B19D54}"/>
+                <a16:creationId xmlns:a16="http://schemas.microsoft.com/office/drawing/2014/main" id="{FF8C1FE6-EC9C-432C-957E-C563800A76E3}"/>
               </a:ext>
             </a:extLst>
           </p:cNvPr>
@@ -13220,7 +13220,7 @@
           <p:cNvPr id="2" name="">
             <a:extLst xmlns:a="http://schemas.openxmlformats.org/drawingml/2006/main">
               <a:ext uri="{FF2B5EF4-FFF2-40B4-BE49-F238E27FC236}">
-                <a16:creationId xmlns:a16="http://schemas.microsoft.com/office/drawing/2014/main" id="{29BFB2DD-D6B2-4CC0-B1C5-D52037AA149A}"/>
+                <a16:creationId xmlns:a16="http://schemas.microsoft.com/office/drawing/2014/main" id="{97628E26-2FF8-4B06-8393-A437D836A4B4}"/>
               </a:ext>
             </a:extLst>
           </p:cNvPr>
@@ -13376,7 +13376,7 @@
           <p:cNvPr id="3" name="">
             <a:extLst xmlns:a="http://schemas.openxmlformats.org/drawingml/2006/main">
               <a:ext uri="{FF2B5EF4-FFF2-40B4-BE49-F238E27FC236}">
-                <a16:creationId xmlns:a16="http://schemas.microsoft.com/office/drawing/2014/main" id="{72C0A16C-7363-46EF-807D-53A4B2D078D5}"/>
+                <a16:creationId xmlns:a16="http://schemas.microsoft.com/office/drawing/2014/main" id="{6817C5F5-89E4-460C-B01D-084C3DB6871B}"/>
               </a:ext>
             </a:extLst>
           </p:cNvPr>
@@ -13532,7 +13532,7 @@
           <p:cNvPr id="4" name="">
             <a:extLst xmlns:a="http://schemas.openxmlformats.org/drawingml/2006/main">
               <a:ext uri="{FF2B5EF4-FFF2-40B4-BE49-F238E27FC236}">
-                <a16:creationId xmlns:a16="http://schemas.microsoft.com/office/drawing/2014/main" id="{ECD04D5D-0F9F-4A2A-9F75-D1C6F43C726F}"/>
+                <a16:creationId xmlns:a16="http://schemas.microsoft.com/office/drawing/2014/main" id="{50F1855D-FC51-4155-A5CF-DCDA93789594}"/>
               </a:ext>
             </a:extLst>
           </p:cNvPr>
@@ -13688,7 +13688,7 @@
           <p:cNvPr id="5" name="">
             <a:extLst xmlns:a="http://schemas.openxmlformats.org/drawingml/2006/main">
               <a:ext uri="{FF2B5EF4-FFF2-40B4-BE49-F238E27FC236}">
-                <a16:creationId xmlns:a16="http://schemas.microsoft.com/office/drawing/2014/main" id="{BABC086D-8562-4D40-973D-CDF094FB0161}"/>
+                <a16:creationId xmlns:a16="http://schemas.microsoft.com/office/drawing/2014/main" id="{DF87C884-B53C-4AC1-8EC6-FCEFF3DFE246}"/>
               </a:ext>
             </a:extLst>
           </p:cNvPr>
@@ -13844,7 +13844,7 @@
           <p:cNvPr id="6" name="">
             <a:extLst xmlns:a="http://schemas.openxmlformats.org/drawingml/2006/main">
               <a:ext uri="{FF2B5EF4-FFF2-40B4-BE49-F238E27FC236}">
-                <a16:creationId xmlns:a16="http://schemas.microsoft.com/office/drawing/2014/main" id="{3DD5C2D6-6BBA-45AE-9ED3-05C8A7D834A3}"/>
+                <a16:creationId xmlns:a16="http://schemas.microsoft.com/office/drawing/2014/main" id="{DDFFCA64-7181-40AD-9906-2951913F5744}"/>
               </a:ext>
             </a:extLst>
           </p:cNvPr>
@@ -13998,7 +13998,7 @@
     </p:spTree>
     <p:extLst>
       <p:ext uri="{BB962C8B-B14F-4D97-AF65-F5344CB8AC3E}">
-        <p14:creationId xmlns:p14="http://schemas.microsoft.com/office/powerpoint/2010/main" val="1731411501"/>
+        <p14:creationId xmlns:p14="http://schemas.microsoft.com/office/powerpoint/2010/main" val="2136867792"/>
       </p:ext>
     </p:extLst>
   </p:cSld>
@@ -14029,7 +14029,7 @@
           <p:cNvPr id="8" name="">
             <a:extLst xmlns:a="http://schemas.openxmlformats.org/drawingml/2006/main">
               <a:ext uri="{FF2B5EF4-FFF2-40B4-BE49-F238E27FC236}">
-                <a16:creationId xmlns:a16="http://schemas.microsoft.com/office/drawing/2014/main" id="{928D1EA9-9110-45D3-8F5D-32B095955180}"/>
+                <a16:creationId xmlns:a16="http://schemas.microsoft.com/office/drawing/2014/main" id="{79BC92C2-F4F4-4707-A9A4-C1B7B009FB0B}"/>
               </a:ext>
             </a:extLst>
           </p:cNvPr>
@@ -14185,7 +14185,7 @@
           <p:cNvPr id="2" name="">
             <a:extLst xmlns:a="http://schemas.openxmlformats.org/drawingml/2006/main">
               <a:ext uri="{FF2B5EF4-FFF2-40B4-BE49-F238E27FC236}">
-                <a16:creationId xmlns:a16="http://schemas.microsoft.com/office/drawing/2014/main" id="{2A834C48-779D-4985-AF3A-7484582EB8EB}"/>
+                <a16:creationId xmlns:a16="http://schemas.microsoft.com/office/drawing/2014/main" id="{D2F30AB0-A646-4E1A-B3C6-CC968D98F37F}"/>
               </a:ext>
             </a:extLst>
           </p:cNvPr>
@@ -14341,7 +14341,7 @@
           <p:cNvPr id="3" name="">
             <a:extLst xmlns:a="http://schemas.openxmlformats.org/drawingml/2006/main">
               <a:ext uri="{FF2B5EF4-FFF2-40B4-BE49-F238E27FC236}">
-                <a16:creationId xmlns:a16="http://schemas.microsoft.com/office/drawing/2014/main" id="{4F8B406A-F03E-435E-8DBB-2381BDE9B388}"/>
+                <a16:creationId xmlns:a16="http://schemas.microsoft.com/office/drawing/2014/main" id="{3B749F81-E1EB-4986-A282-CBA6532EC3A4}"/>
               </a:ext>
             </a:extLst>
           </p:cNvPr>
@@ -14497,7 +14497,7 @@
           <p:cNvPr id="4" name="">
             <a:extLst xmlns:a="http://schemas.openxmlformats.org/drawingml/2006/main">
               <a:ext uri="{FF2B5EF4-FFF2-40B4-BE49-F238E27FC236}">
-                <a16:creationId xmlns:a16="http://schemas.microsoft.com/office/drawing/2014/main" id="{4EC67CE8-8AFC-47ED-8F37-05FD5CF226E0}"/>
+                <a16:creationId xmlns:a16="http://schemas.microsoft.com/office/drawing/2014/main" id="{219EFC81-A88C-4989-900A-664EAF983B9E}"/>
               </a:ext>
             </a:extLst>
           </p:cNvPr>
@@ -14653,7 +14653,7 @@
           <p:cNvPr id="5" name="">
             <a:extLst xmlns:a="http://schemas.openxmlformats.org/drawingml/2006/main">
               <a:ext uri="{FF2B5EF4-FFF2-40B4-BE49-F238E27FC236}">
-                <a16:creationId xmlns:a16="http://schemas.microsoft.com/office/drawing/2014/main" id="{A995F738-1755-4DB3-B6E6-07CDF728BE97}"/>
+                <a16:creationId xmlns:a16="http://schemas.microsoft.com/office/drawing/2014/main" id="{7B528C01-2980-46C8-9E93-0710FAABFB7B}"/>
               </a:ext>
             </a:extLst>
           </p:cNvPr>
@@ -14809,7 +14809,7 @@
           <p:cNvPr id="6" name="">
             <a:extLst xmlns:a="http://schemas.openxmlformats.org/drawingml/2006/main">
               <a:ext uri="{FF2B5EF4-FFF2-40B4-BE49-F238E27FC236}">
-                <a16:creationId xmlns:a16="http://schemas.microsoft.com/office/drawing/2014/main" id="{EB94547E-4526-4F54-944B-BB07EE8D8599}"/>
+                <a16:creationId xmlns:a16="http://schemas.microsoft.com/office/drawing/2014/main" id="{90752C72-0CE2-463B-A863-30FA0518E358}"/>
               </a:ext>
             </a:extLst>
           </p:cNvPr>
@@ -14965,7 +14965,7 @@
           <p:cNvPr id="7" name="">
             <a:extLst xmlns:a="http://schemas.openxmlformats.org/drawingml/2006/main">
               <a:ext uri="{FF2B5EF4-FFF2-40B4-BE49-F238E27FC236}">
-                <a16:creationId xmlns:a16="http://schemas.microsoft.com/office/drawing/2014/main" id="{BA4E78AA-B74E-4C60-8692-50D4026944E1}"/>
+                <a16:creationId xmlns:a16="http://schemas.microsoft.com/office/drawing/2014/main" id="{81E92AC9-761E-4138-8D9F-D4FD7413324C}"/>
               </a:ext>
             </a:extLst>
           </p:cNvPr>
@@ -15119,7 +15119,7 @@
     </p:spTree>
     <p:extLst>
       <p:ext uri="{BB962C8B-B14F-4D97-AF65-F5344CB8AC3E}">
-        <p14:creationId xmlns:p14="http://schemas.microsoft.com/office/powerpoint/2010/main" val="288601407"/>
+        <p14:creationId xmlns:p14="http://schemas.microsoft.com/office/powerpoint/2010/main" val="454195878"/>
       </p:ext>
     </p:extLst>
   </p:cSld>
@@ -15150,7 +15150,7 @@
           <p:cNvPr id="8" name="">
             <a:extLst xmlns:a="http://schemas.openxmlformats.org/drawingml/2006/main">
               <a:ext uri="{FF2B5EF4-FFF2-40B4-BE49-F238E27FC236}">
-                <a16:creationId xmlns:a16="http://schemas.microsoft.com/office/drawing/2014/main" id="{1FC6005D-57A3-4B15-86E3-541EB7A83A7D}"/>
+                <a16:creationId xmlns:a16="http://schemas.microsoft.com/office/drawing/2014/main" id="{55FADD8C-7AA2-44F6-8961-53020E1954CF}"/>
               </a:ext>
             </a:extLst>
           </p:cNvPr>
@@ -15306,7 +15306,7 @@
           <p:cNvPr id="2" name="">
             <a:extLst xmlns:a="http://schemas.openxmlformats.org/drawingml/2006/main">
               <a:ext uri="{FF2B5EF4-FFF2-40B4-BE49-F238E27FC236}">
-                <a16:creationId xmlns:a16="http://schemas.microsoft.com/office/drawing/2014/main" id="{4935D9C7-3D08-4534-98CF-FAA83F8AF983}"/>
+                <a16:creationId xmlns:a16="http://schemas.microsoft.com/office/drawing/2014/main" id="{DF69E881-AC09-4E5B-89BA-C8C66E0C97C7}"/>
               </a:ext>
             </a:extLst>
           </p:cNvPr>
@@ -15462,7 +15462,7 @@
           <p:cNvPr id="3" name="">
             <a:extLst xmlns:a="http://schemas.openxmlformats.org/drawingml/2006/main">
               <a:ext uri="{FF2B5EF4-FFF2-40B4-BE49-F238E27FC236}">
-                <a16:creationId xmlns:a16="http://schemas.microsoft.com/office/drawing/2014/main" id="{562D9DDC-E455-4F7C-82FB-4A48B93D7593}"/>
+                <a16:creationId xmlns:a16="http://schemas.microsoft.com/office/drawing/2014/main" id="{6B3ED511-EDFC-4617-946B-C2A676C47BBE}"/>
               </a:ext>
             </a:extLst>
           </p:cNvPr>
@@ -15618,7 +15618,7 @@
           <p:cNvPr id="4" name="">
             <a:extLst xmlns:a="http://schemas.openxmlformats.org/drawingml/2006/main">
               <a:ext uri="{FF2B5EF4-FFF2-40B4-BE49-F238E27FC236}">
-                <a16:creationId xmlns:a16="http://schemas.microsoft.com/office/drawing/2014/main" id="{71A772DB-2E2C-4323-BC06-B4E5A86F8CC1}"/>
+                <a16:creationId xmlns:a16="http://schemas.microsoft.com/office/drawing/2014/main" id="{36851247-E794-421A-98BD-DC55FA0FC1FE}"/>
               </a:ext>
             </a:extLst>
           </p:cNvPr>
@@ -15774,7 +15774,7 @@
           <p:cNvPr id="5" name="">
             <a:extLst xmlns:a="http://schemas.openxmlformats.org/drawingml/2006/main">
               <a:ext uri="{FF2B5EF4-FFF2-40B4-BE49-F238E27FC236}">
-                <a16:creationId xmlns:a16="http://schemas.microsoft.com/office/drawing/2014/main" id="{14B6E0C6-0AFA-400D-8743-F87A932BBFA8}"/>
+                <a16:creationId xmlns:a16="http://schemas.microsoft.com/office/drawing/2014/main" id="{B1CEDBBA-4F3C-4A1B-A822-66CF80EB1AEA}"/>
               </a:ext>
             </a:extLst>
           </p:cNvPr>
@@ -15930,7 +15930,7 @@
           <p:cNvPr id="6" name="">
             <a:extLst xmlns:a="http://schemas.openxmlformats.org/drawingml/2006/main">
               <a:ext uri="{FF2B5EF4-FFF2-40B4-BE49-F238E27FC236}">
-                <a16:creationId xmlns:a16="http://schemas.microsoft.com/office/drawing/2014/main" id="{2BD5BD48-0840-4731-84F7-A47A990BF143}"/>
+                <a16:creationId xmlns:a16="http://schemas.microsoft.com/office/drawing/2014/main" id="{28D5A6E0-AD2A-4285-9BE6-ACFD74E3BEA6}"/>
               </a:ext>
             </a:extLst>
           </p:cNvPr>
@@ -16086,7 +16086,7 @@
           <p:cNvPr id="7" name="">
             <a:extLst xmlns:a="http://schemas.openxmlformats.org/drawingml/2006/main">
               <a:ext uri="{FF2B5EF4-FFF2-40B4-BE49-F238E27FC236}">
-                <a16:creationId xmlns:a16="http://schemas.microsoft.com/office/drawing/2014/main" id="{A96FCC6F-848B-4E47-A98F-4205B9C48272}"/>
+                <a16:creationId xmlns:a16="http://schemas.microsoft.com/office/drawing/2014/main" id="{E06FF255-583B-4CC6-9F57-EBC54D3671C2}"/>
               </a:ext>
             </a:extLst>
           </p:cNvPr>
@@ -16240,7 +16240,7 @@
     </p:spTree>
     <p:extLst>
       <p:ext uri="{BB962C8B-B14F-4D97-AF65-F5344CB8AC3E}">
-        <p14:creationId xmlns:p14="http://schemas.microsoft.com/office/powerpoint/2010/main" val="814217100"/>
+        <p14:creationId xmlns:p14="http://schemas.microsoft.com/office/powerpoint/2010/main" val="1193848902"/>
       </p:ext>
     </p:extLst>
   </p:cSld>
@@ -16271,7 +16271,7 @@
           <p:cNvPr id="7" name="">
             <a:extLst xmlns:a="http://schemas.openxmlformats.org/drawingml/2006/main">
               <a:ext uri="{FF2B5EF4-FFF2-40B4-BE49-F238E27FC236}">
-                <a16:creationId xmlns:a16="http://schemas.microsoft.com/office/drawing/2014/main" id="{9AC7EDE0-08B3-45D9-B4D9-917DF3FF3F05}"/>
+                <a16:creationId xmlns:a16="http://schemas.microsoft.com/office/drawing/2014/main" id="{55CF796B-7ED1-4922-B861-A6B6CDF8EE84}"/>
               </a:ext>
             </a:extLst>
           </p:cNvPr>
@@ -16427,7 +16427,7 @@
           <p:cNvPr id="2" name="">
             <a:extLst xmlns:a="http://schemas.openxmlformats.org/drawingml/2006/main">
               <a:ext uri="{FF2B5EF4-FFF2-40B4-BE49-F238E27FC236}">
-                <a16:creationId xmlns:a16="http://schemas.microsoft.com/office/drawing/2014/main" id="{B665C49E-35B1-4634-A89C-A931347B42AA}"/>
+                <a16:creationId xmlns:a16="http://schemas.microsoft.com/office/drawing/2014/main" id="{A0B0FDA3-8B09-4D5F-8121-E176D5FF0A02}"/>
               </a:ext>
             </a:extLst>
           </p:cNvPr>
@@ -16583,7 +16583,7 @@
           <p:cNvPr id="3" name="">
             <a:extLst xmlns:a="http://schemas.openxmlformats.org/drawingml/2006/main">
               <a:ext uri="{FF2B5EF4-FFF2-40B4-BE49-F238E27FC236}">
-                <a16:creationId xmlns:a16="http://schemas.microsoft.com/office/drawing/2014/main" id="{621B62DC-4C2E-4E24-B1CA-3D3A44598DE6}"/>
+                <a16:creationId xmlns:a16="http://schemas.microsoft.com/office/drawing/2014/main" id="{8E50EB4A-4C9F-4B94-A9D4-F3574B048745}"/>
               </a:ext>
             </a:extLst>
           </p:cNvPr>
@@ -16739,7 +16739,7 @@
           <p:cNvPr id="4" name="">
             <a:extLst xmlns:a="http://schemas.openxmlformats.org/drawingml/2006/main">
               <a:ext uri="{FF2B5EF4-FFF2-40B4-BE49-F238E27FC236}">
-                <a16:creationId xmlns:a16="http://schemas.microsoft.com/office/drawing/2014/main" id="{53BC6630-E7D8-4F38-A525-AAF75BD7751E}"/>
+                <a16:creationId xmlns:a16="http://schemas.microsoft.com/office/drawing/2014/main" id="{22FBC68A-8EED-4141-9FB3-CF8D228C7EB4}"/>
               </a:ext>
             </a:extLst>
           </p:cNvPr>
@@ -16895,7 +16895,7 @@
           <p:cNvPr id="5" name="">
             <a:extLst xmlns:a="http://schemas.openxmlformats.org/drawingml/2006/main">
               <a:ext uri="{FF2B5EF4-FFF2-40B4-BE49-F238E27FC236}">
-                <a16:creationId xmlns:a16="http://schemas.microsoft.com/office/drawing/2014/main" id="{C3D768D2-8B18-4A92-A557-85EE3CB078E0}"/>
+                <a16:creationId xmlns:a16="http://schemas.microsoft.com/office/drawing/2014/main" id="{74FBFFDA-5252-4408-BB35-C39ABEF9CA3B}"/>
               </a:ext>
             </a:extLst>
           </p:cNvPr>
@@ -17051,7 +17051,7 @@
           <p:cNvPr id="6" name="">
             <a:extLst xmlns:a="http://schemas.openxmlformats.org/drawingml/2006/main">
               <a:ext uri="{FF2B5EF4-FFF2-40B4-BE49-F238E27FC236}">
-                <a16:creationId xmlns:a16="http://schemas.microsoft.com/office/drawing/2014/main" id="{73DA91FC-AAA7-43AE-A469-46C4AB04C0EB}"/>
+                <a16:creationId xmlns:a16="http://schemas.microsoft.com/office/drawing/2014/main" id="{9B084901-5F74-4070-8614-98A0BA7D807F}"/>
               </a:ext>
             </a:extLst>
           </p:cNvPr>
@@ -17205,7 +17205,7 @@
     </p:spTree>
     <p:extLst>
       <p:ext uri="{BB962C8B-B14F-4D97-AF65-F5344CB8AC3E}">
-        <p14:creationId xmlns:p14="http://schemas.microsoft.com/office/powerpoint/2010/main" val="573882118"/>
+        <p14:creationId xmlns:p14="http://schemas.microsoft.com/office/powerpoint/2010/main" val="2047662667"/>
       </p:ext>
     </p:extLst>
   </p:cSld>
@@ -17236,7 +17236,7 @@
           <p:cNvPr id="12" name="">
             <a:extLst xmlns:a="http://schemas.openxmlformats.org/drawingml/2006/main">
               <a:ext uri="{FF2B5EF4-FFF2-40B4-BE49-F238E27FC236}">
-                <a16:creationId xmlns:a16="http://schemas.microsoft.com/office/drawing/2014/main" id="{D5ED5641-C685-4C22-962D-7DF05CEC50A9}"/>
+                <a16:creationId xmlns:a16="http://schemas.microsoft.com/office/drawing/2014/main" id="{ADB0CAE8-3398-4EFC-A789-79BD8A4E056E}"/>
               </a:ext>
             </a:extLst>
           </p:cNvPr>
@@ -17392,7 +17392,7 @@
           <p:cNvPr id="2" name="">
             <a:extLst xmlns:a="http://schemas.openxmlformats.org/drawingml/2006/main">
               <a:ext uri="{FF2B5EF4-FFF2-40B4-BE49-F238E27FC236}">
-                <a16:creationId xmlns:a16="http://schemas.microsoft.com/office/drawing/2014/main" id="{933208BB-CC2A-444D-A764-AEF47840397D}"/>
+                <a16:creationId xmlns:a16="http://schemas.microsoft.com/office/drawing/2014/main" id="{0DA75901-729C-4CCE-A9AC-FFBCE142AE63}"/>
               </a:ext>
             </a:extLst>
           </p:cNvPr>
@@ -17548,7 +17548,7 @@
           <p:cNvPr id="3" name="">
             <a:extLst xmlns:a="http://schemas.openxmlformats.org/drawingml/2006/main">
               <a:ext uri="{FF2B5EF4-FFF2-40B4-BE49-F238E27FC236}">
-                <a16:creationId xmlns:a16="http://schemas.microsoft.com/office/drawing/2014/main" id="{D5E9FE54-7FDF-477C-B926-5F0287B24D3F}"/>
+                <a16:creationId xmlns:a16="http://schemas.microsoft.com/office/drawing/2014/main" id="{2EEC1F8A-A14C-4354-917B-989F1BCFCC1D}"/>
               </a:ext>
             </a:extLst>
           </p:cNvPr>
@@ -17704,7 +17704,7 @@
           <p:cNvPr id="4" name="">
             <a:extLst xmlns:a="http://schemas.openxmlformats.org/drawingml/2006/main">
               <a:ext uri="{FF2B5EF4-FFF2-40B4-BE49-F238E27FC236}">
-                <a16:creationId xmlns:a16="http://schemas.microsoft.com/office/drawing/2014/main" id="{6824C1A5-43EE-46F2-96FF-F7165F535D30}"/>
+                <a16:creationId xmlns:a16="http://schemas.microsoft.com/office/drawing/2014/main" id="{54BA4648-81D1-4961-B1EE-C58D3CC9F186}"/>
               </a:ext>
             </a:extLst>
           </p:cNvPr>
@@ -17714,7 +17714,7 @@
           <p:nvPr/>
         </p:nvPicPr>
         <p:blipFill>
-          <a:blip xmlns:r="http://schemas.openxmlformats.org/officeDocument/2006/relationships" xmlns:a="http://schemas.openxmlformats.org/drawingml/2006/main" r:embed="R525717e770d54d68"/>
+          <a:blip xmlns:r="http://schemas.openxmlformats.org/officeDocument/2006/relationships" xmlns:a="http://schemas.openxmlformats.org/drawingml/2006/main" r:embed="Rb41e6278d1fb4dc8"/>
           <a:stretch xmlns:a="http://schemas.openxmlformats.org/drawingml/2006/main"/>
         </p:blipFill>
         <p:spPr>
@@ -17732,7 +17732,7 @@
           <p:cNvPr id="5" name="">
             <a:extLst xmlns:a="http://schemas.openxmlformats.org/drawingml/2006/main">
               <a:ext uri="{FF2B5EF4-FFF2-40B4-BE49-F238E27FC236}">
-                <a16:creationId xmlns:a16="http://schemas.microsoft.com/office/drawing/2014/main" id="{2547DEE6-6B9F-420B-BF17-1C1593BA2354}"/>
+                <a16:creationId xmlns:a16="http://schemas.microsoft.com/office/drawing/2014/main" id="{B8DCB3C8-3467-44BA-BBF5-668CDF58DE57}"/>
               </a:ext>
             </a:extLst>
           </p:cNvPr>
@@ -17888,7 +17888,7 @@
           <p:cNvPr id="6" name="">
             <a:extLst xmlns:a="http://schemas.openxmlformats.org/drawingml/2006/main">
               <a:ext uri="{FF2B5EF4-FFF2-40B4-BE49-F238E27FC236}">
-                <a16:creationId xmlns:a16="http://schemas.microsoft.com/office/drawing/2014/main" id="{C6EF63D5-0CAA-4070-9D82-878CD604D253}"/>
+                <a16:creationId xmlns:a16="http://schemas.microsoft.com/office/drawing/2014/main" id="{AF6C9EF9-909C-4ED1-A2BF-4976B6ACD316}"/>
               </a:ext>
             </a:extLst>
           </p:cNvPr>
@@ -18044,7 +18044,7 @@
           <p:cNvPr id="7" name="">
             <a:extLst xmlns:a="http://schemas.openxmlformats.org/drawingml/2006/main">
               <a:ext uri="{FF2B5EF4-FFF2-40B4-BE49-F238E27FC236}">
-                <a16:creationId xmlns:a16="http://schemas.microsoft.com/office/drawing/2014/main" id="{CD655C96-8388-4C28-A76F-C59487BA43A0}"/>
+                <a16:creationId xmlns:a16="http://schemas.microsoft.com/office/drawing/2014/main" id="{FE94EEA3-3435-45AF-87C5-09B39103BBF8}"/>
               </a:ext>
             </a:extLst>
           </p:cNvPr>
@@ -18200,7 +18200,7 @@
           <p:cNvPr id="8" name="">
             <a:extLst xmlns:a="http://schemas.openxmlformats.org/drawingml/2006/main">
               <a:ext uri="{FF2B5EF4-FFF2-40B4-BE49-F238E27FC236}">
-                <a16:creationId xmlns:a16="http://schemas.microsoft.com/office/drawing/2014/main" id="{9E401DA1-BEF6-4FD1-A347-0A213CB15389}"/>
+                <a16:creationId xmlns:a16="http://schemas.microsoft.com/office/drawing/2014/main" id="{4270ECD3-E46F-4A84-AC80-3F5B95F16481}"/>
               </a:ext>
             </a:extLst>
           </p:cNvPr>
@@ -18356,7 +18356,7 @@
           <p:cNvPr id="9" name="">
             <a:extLst xmlns:a="http://schemas.openxmlformats.org/drawingml/2006/main">
               <a:ext uri="{FF2B5EF4-FFF2-40B4-BE49-F238E27FC236}">
-                <a16:creationId xmlns:a16="http://schemas.microsoft.com/office/drawing/2014/main" id="{537D20C5-A3F3-4AF6-A2A6-799C848F04BD}"/>
+                <a16:creationId xmlns:a16="http://schemas.microsoft.com/office/drawing/2014/main" id="{D3292E97-CD33-4C90-B079-C43245FF403A}"/>
               </a:ext>
             </a:extLst>
           </p:cNvPr>
@@ -18512,7 +18512,7 @@
           <p:cNvPr id="10" name="">
             <a:extLst xmlns:a="http://schemas.openxmlformats.org/drawingml/2006/main">
               <a:ext uri="{FF2B5EF4-FFF2-40B4-BE49-F238E27FC236}">
-                <a16:creationId xmlns:a16="http://schemas.microsoft.com/office/drawing/2014/main" id="{4F9D809E-28F9-4C1D-8E7A-FDECBAEC89BD}"/>
+                <a16:creationId xmlns:a16="http://schemas.microsoft.com/office/drawing/2014/main" id="{982D4D52-1BD5-4F39-9182-215A9482AAEB}"/>
               </a:ext>
             </a:extLst>
           </p:cNvPr>
@@ -18668,7 +18668,7 @@
           <p:cNvPr id="11" name="">
             <a:extLst xmlns:a="http://schemas.openxmlformats.org/drawingml/2006/main">
               <a:ext uri="{FF2B5EF4-FFF2-40B4-BE49-F238E27FC236}">
-                <a16:creationId xmlns:a16="http://schemas.microsoft.com/office/drawing/2014/main" id="{9B082893-FBC9-4921-8248-D48FBD18574F}"/>
+                <a16:creationId xmlns:a16="http://schemas.microsoft.com/office/drawing/2014/main" id="{FC7319B9-CC2C-4FAA-B1C5-3E50818D44B0}"/>
               </a:ext>
             </a:extLst>
           </p:cNvPr>
@@ -18822,7 +18822,7 @@
     </p:spTree>
     <p:extLst>
       <p:ext uri="{BB962C8B-B14F-4D97-AF65-F5344CB8AC3E}">
-        <p14:creationId xmlns:p14="http://schemas.microsoft.com/office/powerpoint/2010/main" val="381143559"/>
+        <p14:creationId xmlns:p14="http://schemas.microsoft.com/office/powerpoint/2010/main" val="1106086905"/>
       </p:ext>
     </p:extLst>
   </p:cSld>
@@ -18853,7 +18853,7 @@
           <p:cNvPr id="20" name="">
             <a:extLst xmlns:a="http://schemas.openxmlformats.org/drawingml/2006/main">
               <a:ext uri="{FF2B5EF4-FFF2-40B4-BE49-F238E27FC236}">
-                <a16:creationId xmlns:a16="http://schemas.microsoft.com/office/drawing/2014/main" id="{4345BA3C-01E7-427E-942F-149C3BE3F385}"/>
+                <a16:creationId xmlns:a16="http://schemas.microsoft.com/office/drawing/2014/main" id="{5B8D6F7B-9E25-4B42-B51F-9497E189CD5B}"/>
               </a:ext>
             </a:extLst>
           </p:cNvPr>
@@ -19009,7 +19009,7 @@
           <p:cNvPr id="2" name="">
             <a:extLst xmlns:a="http://schemas.openxmlformats.org/drawingml/2006/main">
               <a:ext uri="{FF2B5EF4-FFF2-40B4-BE49-F238E27FC236}">
-                <a16:creationId xmlns:a16="http://schemas.microsoft.com/office/drawing/2014/main" id="{7F07A249-AF09-4889-AA9F-D89918945AA3}"/>
+                <a16:creationId xmlns:a16="http://schemas.microsoft.com/office/drawing/2014/main" id="{2FE07E8B-50ED-4922-A00D-83528C5C1E21}"/>
               </a:ext>
             </a:extLst>
           </p:cNvPr>
@@ -19165,7 +19165,7 @@
           <p:cNvPr id="3" name="">
             <a:extLst xmlns:a="http://schemas.openxmlformats.org/drawingml/2006/main">
               <a:ext uri="{FF2B5EF4-FFF2-40B4-BE49-F238E27FC236}">
-                <a16:creationId xmlns:a16="http://schemas.microsoft.com/office/drawing/2014/main" id="{C8BF3CF5-0C19-4751-9B27-7049826D91EA}"/>
+                <a16:creationId xmlns:a16="http://schemas.microsoft.com/office/drawing/2014/main" id="{0E9876E8-B430-4456-930C-688EA535269C}"/>
               </a:ext>
             </a:extLst>
           </p:cNvPr>
@@ -19321,7 +19321,7 @@
           <p:cNvPr id="4" name="">
             <a:extLst xmlns:a="http://schemas.openxmlformats.org/drawingml/2006/main">
               <a:ext uri="{FF2B5EF4-FFF2-40B4-BE49-F238E27FC236}">
-                <a16:creationId xmlns:a16="http://schemas.microsoft.com/office/drawing/2014/main" id="{AD1506E4-8C4E-4840-9663-3704C90EAB74}"/>
+                <a16:creationId xmlns:a16="http://schemas.microsoft.com/office/drawing/2014/main" id="{A86FDA98-616B-4160-A5DC-CD1B4F37ABBD}"/>
               </a:ext>
             </a:extLst>
           </p:cNvPr>
@@ -19477,7 +19477,7 @@
           <p:cNvPr id="5" name="">
             <a:extLst xmlns:a="http://schemas.openxmlformats.org/drawingml/2006/main">
               <a:ext uri="{FF2B5EF4-FFF2-40B4-BE49-F238E27FC236}">
-                <a16:creationId xmlns:a16="http://schemas.microsoft.com/office/drawing/2014/main" id="{F1495106-0CDB-4738-B9F9-9A0488BC87EE}"/>
+                <a16:creationId xmlns:a16="http://schemas.microsoft.com/office/drawing/2014/main" id="{0D271FE1-51E7-4339-AAAF-8161AF3562EF}"/>
               </a:ext>
             </a:extLst>
           </p:cNvPr>
@@ -19633,7 +19633,7 @@
           <p:cNvPr id="6" name="">
             <a:extLst xmlns:a="http://schemas.openxmlformats.org/drawingml/2006/main">
               <a:ext uri="{FF2B5EF4-FFF2-40B4-BE49-F238E27FC236}">
-                <a16:creationId xmlns:a16="http://schemas.microsoft.com/office/drawing/2014/main" id="{05E6FC85-3C13-4966-8541-718DE308C917}"/>
+                <a16:creationId xmlns:a16="http://schemas.microsoft.com/office/drawing/2014/main" id="{0420541E-E607-4DB9-8132-3171D7BB42EE}"/>
               </a:ext>
             </a:extLst>
           </p:cNvPr>
@@ -19789,7 +19789,7 @@
           <p:cNvPr id="7" name="">
             <a:extLst xmlns:a="http://schemas.openxmlformats.org/drawingml/2006/main">
               <a:ext uri="{FF2B5EF4-FFF2-40B4-BE49-F238E27FC236}">
-                <a16:creationId xmlns:a16="http://schemas.microsoft.com/office/drawing/2014/main" id="{51B06BCE-0F38-4677-BF53-EACC1C79441A}"/>
+                <a16:creationId xmlns:a16="http://schemas.microsoft.com/office/drawing/2014/main" id="{2BEE7CBB-4574-4E4C-83FF-920901E74A52}"/>
               </a:ext>
             </a:extLst>
           </p:cNvPr>
@@ -19945,7 +19945,7 @@
           <p:cNvPr id="8" name="">
             <a:extLst xmlns:a="http://schemas.openxmlformats.org/drawingml/2006/main">
               <a:ext uri="{FF2B5EF4-FFF2-40B4-BE49-F238E27FC236}">
-                <a16:creationId xmlns:a16="http://schemas.microsoft.com/office/drawing/2014/main" id="{7379C94A-C659-4C4F-98DF-447E56E98252}"/>
+                <a16:creationId xmlns:a16="http://schemas.microsoft.com/office/drawing/2014/main" id="{B9FB19D6-EF9F-45C2-B916-68D12F479A4C}"/>
               </a:ext>
             </a:extLst>
           </p:cNvPr>
@@ -20101,7 +20101,7 @@
           <p:cNvPr id="9" name="">
             <a:extLst xmlns:a="http://schemas.openxmlformats.org/drawingml/2006/main">
               <a:ext uri="{FF2B5EF4-FFF2-40B4-BE49-F238E27FC236}">
-                <a16:creationId xmlns:a16="http://schemas.microsoft.com/office/drawing/2014/main" id="{605D5543-FE2A-4D7B-9092-59614FC8C811}"/>
+                <a16:creationId xmlns:a16="http://schemas.microsoft.com/office/drawing/2014/main" id="{0F3C6DD5-690D-41A9-9E60-C248E7ECFC3D}"/>
               </a:ext>
             </a:extLst>
           </p:cNvPr>
@@ -20257,7 +20257,7 @@
           <p:cNvPr id="10" name="">
             <a:extLst xmlns:a="http://schemas.openxmlformats.org/drawingml/2006/main">
               <a:ext uri="{FF2B5EF4-FFF2-40B4-BE49-F238E27FC236}">
-                <a16:creationId xmlns:a16="http://schemas.microsoft.com/office/drawing/2014/main" id="{CCD15751-777D-443C-AAEC-6E5FA5EA061E}"/>
+                <a16:creationId xmlns:a16="http://schemas.microsoft.com/office/drawing/2014/main" id="{8254DD71-8D99-4321-B0D3-B2524C5B3FA5}"/>
               </a:ext>
             </a:extLst>
           </p:cNvPr>
@@ -20413,7 +20413,7 @@
           <p:cNvPr id="11" name="">
             <a:extLst xmlns:a="http://schemas.openxmlformats.org/drawingml/2006/main">
               <a:ext uri="{FF2B5EF4-FFF2-40B4-BE49-F238E27FC236}">
-                <a16:creationId xmlns:a16="http://schemas.microsoft.com/office/drawing/2014/main" id="{CE64FF27-BC94-45D0-8305-EC0FF0D70490}"/>
+                <a16:creationId xmlns:a16="http://schemas.microsoft.com/office/drawing/2014/main" id="{AE6C8AB1-4FDC-4B6D-9895-8AD705227469}"/>
               </a:ext>
             </a:extLst>
           </p:cNvPr>
@@ -20569,7 +20569,7 @@
           <p:cNvPr id="12" name="">
             <a:extLst xmlns:a="http://schemas.openxmlformats.org/drawingml/2006/main">
               <a:ext uri="{FF2B5EF4-FFF2-40B4-BE49-F238E27FC236}">
-                <a16:creationId xmlns:a16="http://schemas.microsoft.com/office/drawing/2014/main" id="{E2E07B00-700A-44F5-B18F-2578F93836AD}"/>
+                <a16:creationId xmlns:a16="http://schemas.microsoft.com/office/drawing/2014/main" id="{8754D7DA-E6CF-40B2-A76B-09A6345A6C61}"/>
               </a:ext>
             </a:extLst>
           </p:cNvPr>
@@ -20725,7 +20725,7 @@
           <p:cNvPr id="13" name="">
             <a:extLst xmlns:a="http://schemas.openxmlformats.org/drawingml/2006/main">
               <a:ext uri="{FF2B5EF4-FFF2-40B4-BE49-F238E27FC236}">
-                <a16:creationId xmlns:a16="http://schemas.microsoft.com/office/drawing/2014/main" id="{75ED2389-0E89-430C-BFAB-8C1939318267}"/>
+                <a16:creationId xmlns:a16="http://schemas.microsoft.com/office/drawing/2014/main" id="{8A3F83FC-C93E-4486-9E61-69251E10A725}"/>
               </a:ext>
             </a:extLst>
           </p:cNvPr>
@@ -20881,7 +20881,7 @@
           <p:cNvPr id="14" name="">
             <a:extLst xmlns:a="http://schemas.openxmlformats.org/drawingml/2006/main">
               <a:ext uri="{FF2B5EF4-FFF2-40B4-BE49-F238E27FC236}">
-                <a16:creationId xmlns:a16="http://schemas.microsoft.com/office/drawing/2014/main" id="{86A446CD-D363-4EE6-AC4F-7A26D4ADE448}"/>
+                <a16:creationId xmlns:a16="http://schemas.microsoft.com/office/drawing/2014/main" id="{CD391B3A-8053-4D02-823B-E458C894043D}"/>
               </a:ext>
             </a:extLst>
           </p:cNvPr>
@@ -21037,7 +21037,7 @@
           <p:cNvPr id="15" name="">
             <a:extLst xmlns:a="http://schemas.openxmlformats.org/drawingml/2006/main">
               <a:ext uri="{FF2B5EF4-FFF2-40B4-BE49-F238E27FC236}">
-                <a16:creationId xmlns:a16="http://schemas.microsoft.com/office/drawing/2014/main" id="{4ACA0DCB-33F8-46A0-9466-58AAE40AF8BB}"/>
+                <a16:creationId xmlns:a16="http://schemas.microsoft.com/office/drawing/2014/main" id="{63AEBB94-95F0-42BB-97CB-1C17A0103C1A}"/>
               </a:ext>
             </a:extLst>
           </p:cNvPr>
@@ -21193,7 +21193,7 @@
           <p:cNvPr id="16" name="">
             <a:extLst xmlns:a="http://schemas.openxmlformats.org/drawingml/2006/main">
               <a:ext uri="{FF2B5EF4-FFF2-40B4-BE49-F238E27FC236}">
-                <a16:creationId xmlns:a16="http://schemas.microsoft.com/office/drawing/2014/main" id="{F9440CF4-9BB4-4801-B7FC-A2004B07D7DA}"/>
+                <a16:creationId xmlns:a16="http://schemas.microsoft.com/office/drawing/2014/main" id="{FEC178B8-1D4A-4550-93E5-9E7334B29B7C}"/>
               </a:ext>
             </a:extLst>
           </p:cNvPr>
@@ -21349,7 +21349,7 @@
           <p:cNvPr id="17" name="">
             <a:extLst xmlns:a="http://schemas.openxmlformats.org/drawingml/2006/main">
               <a:ext uri="{FF2B5EF4-FFF2-40B4-BE49-F238E27FC236}">
-                <a16:creationId xmlns:a16="http://schemas.microsoft.com/office/drawing/2014/main" id="{E54851C6-74CC-4FFD-8DB6-EE82FF7FFA75}"/>
+                <a16:creationId xmlns:a16="http://schemas.microsoft.com/office/drawing/2014/main" id="{BEF8A8CF-AA48-4165-B71A-B90A0C6AF25F}"/>
               </a:ext>
             </a:extLst>
           </p:cNvPr>
@@ -21505,7 +21505,7 @@
           <p:cNvPr id="18" name="">
             <a:extLst xmlns:a="http://schemas.openxmlformats.org/drawingml/2006/main">
               <a:ext uri="{FF2B5EF4-FFF2-40B4-BE49-F238E27FC236}">
-                <a16:creationId xmlns:a16="http://schemas.microsoft.com/office/drawing/2014/main" id="{6B2B8EB9-EF04-4391-AC79-9793D86D0B2F}"/>
+                <a16:creationId xmlns:a16="http://schemas.microsoft.com/office/drawing/2014/main" id="{F0899422-0D02-4117-A28C-D07F2723A63F}"/>
               </a:ext>
             </a:extLst>
           </p:cNvPr>
@@ -21661,7 +21661,7 @@
           <p:cNvPr id="19" name="">
             <a:extLst xmlns:a="http://schemas.openxmlformats.org/drawingml/2006/main">
               <a:ext uri="{FF2B5EF4-FFF2-40B4-BE49-F238E27FC236}">
-                <a16:creationId xmlns:a16="http://schemas.microsoft.com/office/drawing/2014/main" id="{EEB17040-2153-4473-8334-BA862F5F7EEA}"/>
+                <a16:creationId xmlns:a16="http://schemas.microsoft.com/office/drawing/2014/main" id="{2119D272-0B22-42E1-8B3E-CA38F24DE5D1}"/>
               </a:ext>
             </a:extLst>
           </p:cNvPr>
@@ -21815,7 +21815,7 @@
     </p:spTree>
     <p:extLst>
       <p:ext uri="{BB962C8B-B14F-4D97-AF65-F5344CB8AC3E}">
-        <p14:creationId xmlns:p14="http://schemas.microsoft.com/office/powerpoint/2010/main" val="196944510"/>
+        <p14:creationId xmlns:p14="http://schemas.microsoft.com/office/powerpoint/2010/main" val="1700170172"/>
       </p:ext>
     </p:extLst>
   </p:cSld>
@@ -21846,7 +21846,7 @@
           <p:cNvPr id="8" name="">
             <a:extLst xmlns:a="http://schemas.openxmlformats.org/drawingml/2006/main">
               <a:ext uri="{FF2B5EF4-FFF2-40B4-BE49-F238E27FC236}">
-                <a16:creationId xmlns:a16="http://schemas.microsoft.com/office/drawing/2014/main" id="{30AEDCB0-6002-40DA-A817-C9ABCCACE473}"/>
+                <a16:creationId xmlns:a16="http://schemas.microsoft.com/office/drawing/2014/main" id="{91517C79-70E6-4142-A0ED-EC720FC6CBDA}"/>
               </a:ext>
             </a:extLst>
           </p:cNvPr>
@@ -22002,7 +22002,7 @@
           <p:cNvPr id="2" name="">
             <a:extLst xmlns:a="http://schemas.openxmlformats.org/drawingml/2006/main">
               <a:ext uri="{FF2B5EF4-FFF2-40B4-BE49-F238E27FC236}">
-                <a16:creationId xmlns:a16="http://schemas.microsoft.com/office/drawing/2014/main" id="{F1A6F1C8-90A1-4E9F-A99F-335BAA799EBF}"/>
+                <a16:creationId xmlns:a16="http://schemas.microsoft.com/office/drawing/2014/main" id="{EF5EAEDC-6506-4077-BDF9-B02FE6B18EF5}"/>
               </a:ext>
             </a:extLst>
           </p:cNvPr>
@@ -22158,7 +22158,7 @@
           <p:cNvPr id="3" name="">
             <a:extLst xmlns:a="http://schemas.openxmlformats.org/drawingml/2006/main">
               <a:ext uri="{FF2B5EF4-FFF2-40B4-BE49-F238E27FC236}">
-                <a16:creationId xmlns:a16="http://schemas.microsoft.com/office/drawing/2014/main" id="{A1EB6841-505F-4021-8CF2-97EC731FD3CF}"/>
+                <a16:creationId xmlns:a16="http://schemas.microsoft.com/office/drawing/2014/main" id="{50242C95-EECC-4E46-A921-45B6134CD0DE}"/>
               </a:ext>
             </a:extLst>
           </p:cNvPr>
@@ -22314,7 +22314,7 @@
           <p:cNvPr id="4" name="">
             <a:extLst xmlns:a="http://schemas.openxmlformats.org/drawingml/2006/main">
               <a:ext uri="{FF2B5EF4-FFF2-40B4-BE49-F238E27FC236}">
-                <a16:creationId xmlns:a16="http://schemas.microsoft.com/office/drawing/2014/main" id="{C56A1882-92B9-4E0E-81DC-47E515F64E1C}"/>
+                <a16:creationId xmlns:a16="http://schemas.microsoft.com/office/drawing/2014/main" id="{43A61ED8-A137-480A-BBE8-F9163BD0EC28}"/>
               </a:ext>
             </a:extLst>
           </p:cNvPr>
@@ -22324,13 +22324,13 @@
           <p:nvPr/>
         </p:nvPicPr>
         <p:blipFill>
-          <a:blip xmlns:r="http://schemas.openxmlformats.org/officeDocument/2006/relationships" xmlns:a="http://schemas.openxmlformats.org/drawingml/2006/main" r:embed="R6239ba764a834c4c"/>
+          <a:blip xmlns:r="http://schemas.openxmlformats.org/officeDocument/2006/relationships" xmlns:a="http://schemas.openxmlformats.org/drawingml/2006/main" r:embed="Rc3456b65bcae42bb"/>
           <a:stretch xmlns:a="http://schemas.openxmlformats.org/drawingml/2006/main"/>
         </p:blipFill>
         <p:spPr>
           <a:xfrm xmlns:a="http://schemas.openxmlformats.org/drawingml/2006/main">
-            <a:off x="962025" y="1428750"/>
-            <a:ext cx="7010400" cy="4381500"/>
+            <a:off x="1312545" y="1428750"/>
+            <a:ext cx="6309360" cy="4381500"/>
           </a:xfrm>
           <a:prstGeom xmlns:a="http://schemas.openxmlformats.org/drawingml/2006/main" prst="rect">
             <a:avLst/>
@@ -22342,7 +22342,7 @@
           <p:cNvPr id="5" name="">
             <a:extLst xmlns:a="http://schemas.openxmlformats.org/drawingml/2006/main">
               <a:ext uri="{FF2B5EF4-FFF2-40B4-BE49-F238E27FC236}">
-                <a16:creationId xmlns:a16="http://schemas.microsoft.com/office/drawing/2014/main" id="{94918BFC-4B7A-4C4A-BCCC-A93A74B13247}"/>
+                <a16:creationId xmlns:a16="http://schemas.microsoft.com/office/drawing/2014/main" id="{4455074E-E60D-493E-B354-F3258944CD16}"/>
               </a:ext>
             </a:extLst>
           </p:cNvPr>
@@ -22498,7 +22498,7 @@
           <p:cNvPr id="6" name="">
             <a:extLst xmlns:a="http://schemas.openxmlformats.org/drawingml/2006/main">
               <a:ext uri="{FF2B5EF4-FFF2-40B4-BE49-F238E27FC236}">
-                <a16:creationId xmlns:a16="http://schemas.microsoft.com/office/drawing/2014/main" id="{D26DF794-787F-45DC-925B-E9D5083D0D8A}"/>
+                <a16:creationId xmlns:a16="http://schemas.microsoft.com/office/drawing/2014/main" id="{E224A0C7-54AF-4306-BF05-1221FD6FAB2C}"/>
               </a:ext>
             </a:extLst>
           </p:cNvPr>
@@ -22700,7 +22700,7 @@
           <p:cNvPr id="7" name="">
             <a:extLst xmlns:a="http://schemas.openxmlformats.org/drawingml/2006/main">
               <a:ext uri="{FF2B5EF4-FFF2-40B4-BE49-F238E27FC236}">
-                <a16:creationId xmlns:a16="http://schemas.microsoft.com/office/drawing/2014/main" id="{CFE3FD04-847E-4324-9994-87F8FFB1911B}"/>
+                <a16:creationId xmlns:a16="http://schemas.microsoft.com/office/drawing/2014/main" id="{4CD4FA99-4828-4063-AD2C-36EF49E9DE53}"/>
               </a:ext>
             </a:extLst>
           </p:cNvPr>
@@ -22846,7 +22846,7 @@
                 <a:ea typeface="Arial"/>
                 <a:cs typeface="Arial"/>
               </a:rPr>
-              <a:t>Historical implemented UI evidence; final candidate capture pending.</a:t>
+              <a:t>Accepted local UI: independent challenge, explicit uncertainty and next action.</a:t>
             </a:r>
           </a:p>
         </p:txBody>
@@ -22854,7 +22854,7 @@
     </p:spTree>
     <p:extLst>
       <p:ext uri="{BB962C8B-B14F-4D97-AF65-F5344CB8AC3E}">
-        <p14:creationId xmlns:p14="http://schemas.microsoft.com/office/powerpoint/2010/main" val="202151969"/>
+        <p14:creationId xmlns:p14="http://schemas.microsoft.com/office/powerpoint/2010/main" val="1889983399"/>
       </p:ext>
     </p:extLst>
   </p:cSld>
@@ -22885,7 +22885,7 @@
           <p:cNvPr id="20" name="">
             <a:extLst xmlns:a="http://schemas.openxmlformats.org/drawingml/2006/main">
               <a:ext uri="{FF2B5EF4-FFF2-40B4-BE49-F238E27FC236}">
-                <a16:creationId xmlns:a16="http://schemas.microsoft.com/office/drawing/2014/main" id="{3B7776EE-9CE9-4836-ADBA-81C1E648A7EF}"/>
+                <a16:creationId xmlns:a16="http://schemas.microsoft.com/office/drawing/2014/main" id="{BDCFFB14-9A7E-4521-86EC-D74AA6A224B7}"/>
               </a:ext>
             </a:extLst>
           </p:cNvPr>
@@ -22916,7 +22916,7 @@
           <p:cNvPr id="19" name="">
             <a:extLst xmlns:a="http://schemas.openxmlformats.org/drawingml/2006/main">
               <a:ext uri="{FF2B5EF4-FFF2-40B4-BE49-F238E27FC236}">
-                <a16:creationId xmlns:a16="http://schemas.microsoft.com/office/drawing/2014/main" id="{9039F15E-BD87-4849-857C-C46149208BF0}"/>
+                <a16:creationId xmlns:a16="http://schemas.microsoft.com/office/drawing/2014/main" id="{9BB2C86A-4E87-46FD-BD51-1E7AB6D264E5}"/>
               </a:ext>
             </a:extLst>
           </p:cNvPr>
@@ -22947,7 +22947,7 @@
           <p:cNvPr id="18" name="">
             <a:extLst xmlns:a="http://schemas.openxmlformats.org/drawingml/2006/main">
               <a:ext uri="{FF2B5EF4-FFF2-40B4-BE49-F238E27FC236}">
-                <a16:creationId xmlns:a16="http://schemas.microsoft.com/office/drawing/2014/main" id="{BD9DA31F-EFE4-42CE-A4DD-E4A695F83072}"/>
+                <a16:creationId xmlns:a16="http://schemas.microsoft.com/office/drawing/2014/main" id="{787E0200-4A2B-4B6E-B087-9B4C4907905C}"/>
               </a:ext>
             </a:extLst>
           </p:cNvPr>
@@ -22978,7 +22978,7 @@
           <p:cNvPr id="17" name="">
             <a:extLst xmlns:a="http://schemas.openxmlformats.org/drawingml/2006/main">
               <a:ext uri="{FF2B5EF4-FFF2-40B4-BE49-F238E27FC236}">
-                <a16:creationId xmlns:a16="http://schemas.microsoft.com/office/drawing/2014/main" id="{CF5716E4-182A-4FA8-9586-FF46ED5C87A5}"/>
+                <a16:creationId xmlns:a16="http://schemas.microsoft.com/office/drawing/2014/main" id="{A6A7D3F8-1236-40EC-9D5B-2466B7BFAEDC}"/>
               </a:ext>
             </a:extLst>
           </p:cNvPr>
@@ -23009,7 +23009,7 @@
           <p:cNvPr id="16" name="">
             <a:extLst xmlns:a="http://schemas.openxmlformats.org/drawingml/2006/main">
               <a:ext uri="{FF2B5EF4-FFF2-40B4-BE49-F238E27FC236}">
-                <a16:creationId xmlns:a16="http://schemas.microsoft.com/office/drawing/2014/main" id="{F4840974-80DF-4863-A536-1102354E7EB3}"/>
+                <a16:creationId xmlns:a16="http://schemas.microsoft.com/office/drawing/2014/main" id="{968130BE-6A0E-4463-BE8A-2410B6EE28E9}"/>
               </a:ext>
             </a:extLst>
           </p:cNvPr>
@@ -23040,7 +23040,7 @@
           <p:cNvPr id="22" name="">
             <a:extLst xmlns:a="http://schemas.openxmlformats.org/drawingml/2006/main">
               <a:ext uri="{FF2B5EF4-FFF2-40B4-BE49-F238E27FC236}">
-                <a16:creationId xmlns:a16="http://schemas.microsoft.com/office/drawing/2014/main" id="{C7EF24C3-7425-408F-BD68-1244CE3D8AFB}"/>
+                <a16:creationId xmlns:a16="http://schemas.microsoft.com/office/drawing/2014/main" id="{BC170D9E-37FA-403A-BB72-D97382CE3105}"/>
               </a:ext>
             </a:extLst>
           </p:cNvPr>
@@ -23196,7 +23196,7 @@
           <p:cNvPr id="2" name="">
             <a:extLst xmlns:a="http://schemas.openxmlformats.org/drawingml/2006/main">
               <a:ext uri="{FF2B5EF4-FFF2-40B4-BE49-F238E27FC236}">
-                <a16:creationId xmlns:a16="http://schemas.microsoft.com/office/drawing/2014/main" id="{90962052-C036-48B1-97FE-6AAB7AC09614}"/>
+                <a16:creationId xmlns:a16="http://schemas.microsoft.com/office/drawing/2014/main" id="{7B75E9DC-40C7-4CC0-B2C4-F5FFFBFF1279}"/>
               </a:ext>
             </a:extLst>
           </p:cNvPr>
@@ -23352,7 +23352,7 @@
           <p:cNvPr id="3" name="">
             <a:extLst xmlns:a="http://schemas.openxmlformats.org/drawingml/2006/main">
               <a:ext uri="{FF2B5EF4-FFF2-40B4-BE49-F238E27FC236}">
-                <a16:creationId xmlns:a16="http://schemas.microsoft.com/office/drawing/2014/main" id="{51915157-EA45-4CE2-91E4-2AA62BC53EB7}"/>
+                <a16:creationId xmlns:a16="http://schemas.microsoft.com/office/drawing/2014/main" id="{453CC11F-D4EE-42E4-8AE0-90123663A41D}"/>
               </a:ext>
             </a:extLst>
           </p:cNvPr>
@@ -23508,7 +23508,7 @@
           <p:cNvPr id="4" name="">
             <a:extLst xmlns:a="http://schemas.openxmlformats.org/drawingml/2006/main">
               <a:ext uri="{FF2B5EF4-FFF2-40B4-BE49-F238E27FC236}">
-                <a16:creationId xmlns:a16="http://schemas.microsoft.com/office/drawing/2014/main" id="{70D81072-88D6-47C7-A83C-F5BD7434766B}"/>
+                <a16:creationId xmlns:a16="http://schemas.microsoft.com/office/drawing/2014/main" id="{6F59B31E-08AE-498D-9021-FBA0F7B19D46}"/>
               </a:ext>
             </a:extLst>
           </p:cNvPr>
@@ -23540,7 +23540,7 @@
           <p:cNvPr id="5" name="">
             <a:extLst xmlns:a="http://schemas.openxmlformats.org/drawingml/2006/main">
               <a:ext uri="{FF2B5EF4-FFF2-40B4-BE49-F238E27FC236}">
-                <a16:creationId xmlns:a16="http://schemas.microsoft.com/office/drawing/2014/main" id="{45F324B4-3C4B-4060-B66D-8FFAF8B65BBA}"/>
+                <a16:creationId xmlns:a16="http://schemas.microsoft.com/office/drawing/2014/main" id="{9254545A-C973-4A86-9960-EF946F5EF6E7}"/>
               </a:ext>
             </a:extLst>
           </p:cNvPr>
@@ -23696,7 +23696,7 @@
           <p:cNvPr id="6" name="">
             <a:extLst xmlns:a="http://schemas.openxmlformats.org/drawingml/2006/main">
               <a:ext uri="{FF2B5EF4-FFF2-40B4-BE49-F238E27FC236}">
-                <a16:creationId xmlns:a16="http://schemas.microsoft.com/office/drawing/2014/main" id="{D4BB757E-1A99-4261-AE76-23D5DA5F8151}"/>
+                <a16:creationId xmlns:a16="http://schemas.microsoft.com/office/drawing/2014/main" id="{5E53CBD5-D567-4966-BF3F-250BE07D12B4}"/>
               </a:ext>
             </a:extLst>
           </p:cNvPr>
@@ -23728,7 +23728,7 @@
           <p:cNvPr id="7" name="">
             <a:extLst xmlns:a="http://schemas.openxmlformats.org/drawingml/2006/main">
               <a:ext uri="{FF2B5EF4-FFF2-40B4-BE49-F238E27FC236}">
-                <a16:creationId xmlns:a16="http://schemas.microsoft.com/office/drawing/2014/main" id="{9B07EE06-F389-46A6-A9A1-71F5EA717AE2}"/>
+                <a16:creationId xmlns:a16="http://schemas.microsoft.com/office/drawing/2014/main" id="{4E84E5C6-5319-4709-AB33-ECFE36909244}"/>
               </a:ext>
             </a:extLst>
           </p:cNvPr>
@@ -23884,7 +23884,7 @@
           <p:cNvPr id="8" name="">
             <a:extLst xmlns:a="http://schemas.openxmlformats.org/drawingml/2006/main">
               <a:ext uri="{FF2B5EF4-FFF2-40B4-BE49-F238E27FC236}">
-                <a16:creationId xmlns:a16="http://schemas.microsoft.com/office/drawing/2014/main" id="{97B4B63B-19A9-4673-8BD6-AFD7E9F86B41}"/>
+                <a16:creationId xmlns:a16="http://schemas.microsoft.com/office/drawing/2014/main" id="{56438911-1C93-47C6-8BE8-5DFBB5A621FB}"/>
               </a:ext>
             </a:extLst>
           </p:cNvPr>
@@ -23916,7 +23916,7 @@
           <p:cNvPr id="9" name="">
             <a:extLst xmlns:a="http://schemas.openxmlformats.org/drawingml/2006/main">
               <a:ext uri="{FF2B5EF4-FFF2-40B4-BE49-F238E27FC236}">
-                <a16:creationId xmlns:a16="http://schemas.microsoft.com/office/drawing/2014/main" id="{CC8CCDC1-1722-4FF7-976D-802994F70957}"/>
+                <a16:creationId xmlns:a16="http://schemas.microsoft.com/office/drawing/2014/main" id="{944D383E-6EEB-4863-95FE-08A8504F5572}"/>
               </a:ext>
             </a:extLst>
           </p:cNvPr>
@@ -24072,7 +24072,7 @@
           <p:cNvPr id="10" name="">
             <a:extLst xmlns:a="http://schemas.openxmlformats.org/drawingml/2006/main">
               <a:ext uri="{FF2B5EF4-FFF2-40B4-BE49-F238E27FC236}">
-                <a16:creationId xmlns:a16="http://schemas.microsoft.com/office/drawing/2014/main" id="{B26ED066-1367-4FF6-98D0-CDFACA578C3A}"/>
+                <a16:creationId xmlns:a16="http://schemas.microsoft.com/office/drawing/2014/main" id="{2E3D17D7-FBE5-4A8E-AAB4-4E2176754979}"/>
               </a:ext>
             </a:extLst>
           </p:cNvPr>
@@ -24104,7 +24104,7 @@
           <p:cNvPr id="11" name="">
             <a:extLst xmlns:a="http://schemas.openxmlformats.org/drawingml/2006/main">
               <a:ext uri="{FF2B5EF4-FFF2-40B4-BE49-F238E27FC236}">
-                <a16:creationId xmlns:a16="http://schemas.microsoft.com/office/drawing/2014/main" id="{9B21276E-C06F-4064-88EB-30D0E13EC194}"/>
+                <a16:creationId xmlns:a16="http://schemas.microsoft.com/office/drawing/2014/main" id="{DBFBE254-C049-4057-9F99-4CCB9BE65624}"/>
               </a:ext>
             </a:extLst>
           </p:cNvPr>
@@ -24260,7 +24260,7 @@
           <p:cNvPr id="12" name="">
             <a:extLst xmlns:a="http://schemas.openxmlformats.org/drawingml/2006/main">
               <a:ext uri="{FF2B5EF4-FFF2-40B4-BE49-F238E27FC236}">
-                <a16:creationId xmlns:a16="http://schemas.microsoft.com/office/drawing/2014/main" id="{02A73700-60A1-4EAE-A227-F6461269B2ED}"/>
+                <a16:creationId xmlns:a16="http://schemas.microsoft.com/office/drawing/2014/main" id="{B9D8CBBB-04A6-424B-BCBC-4A923C95A215}"/>
               </a:ext>
             </a:extLst>
           </p:cNvPr>
@@ -24292,7 +24292,7 @@
           <p:cNvPr id="13" name="">
             <a:extLst xmlns:a="http://schemas.openxmlformats.org/drawingml/2006/main">
               <a:ext uri="{FF2B5EF4-FFF2-40B4-BE49-F238E27FC236}">
-                <a16:creationId xmlns:a16="http://schemas.microsoft.com/office/drawing/2014/main" id="{BBEC7264-4F23-4FA4-B4F1-D3F74451C706}"/>
+                <a16:creationId xmlns:a16="http://schemas.microsoft.com/office/drawing/2014/main" id="{EA09D1DC-71EF-482F-ACAD-91B0679ABE6F}"/>
               </a:ext>
             </a:extLst>
           </p:cNvPr>
@@ -24448,7 +24448,7 @@
           <p:cNvPr id="14" name="">
             <a:extLst xmlns:a="http://schemas.openxmlformats.org/drawingml/2006/main">
               <a:ext uri="{FF2B5EF4-FFF2-40B4-BE49-F238E27FC236}">
-                <a16:creationId xmlns:a16="http://schemas.microsoft.com/office/drawing/2014/main" id="{1682AC18-C548-4A53-AB81-1D8430E77C46}"/>
+                <a16:creationId xmlns:a16="http://schemas.microsoft.com/office/drawing/2014/main" id="{E5375912-5D8C-402B-A29B-0526DCC11FF4}"/>
               </a:ext>
             </a:extLst>
           </p:cNvPr>
@@ -24480,7 +24480,7 @@
           <p:cNvPr id="15" name="">
             <a:extLst xmlns:a="http://schemas.openxmlformats.org/drawingml/2006/main">
               <a:ext uri="{FF2B5EF4-FFF2-40B4-BE49-F238E27FC236}">
-                <a16:creationId xmlns:a16="http://schemas.microsoft.com/office/drawing/2014/main" id="{5E4C5AC3-1193-421F-BD97-6CCEC95F90FD}"/>
+                <a16:creationId xmlns:a16="http://schemas.microsoft.com/office/drawing/2014/main" id="{832027B9-B8E7-460D-AADF-C75C71400460}"/>
               </a:ext>
             </a:extLst>
           </p:cNvPr>
@@ -24636,7 +24636,7 @@
           <p:cNvPr id="21" name="">
             <a:extLst xmlns:a="http://schemas.openxmlformats.org/drawingml/2006/main">
               <a:ext uri="{FF2B5EF4-FFF2-40B4-BE49-F238E27FC236}">
-                <a16:creationId xmlns:a16="http://schemas.microsoft.com/office/drawing/2014/main" id="{65DAFB60-C8C7-4B84-A5DC-7DDDB4F809BB}"/>
+                <a16:creationId xmlns:a16="http://schemas.microsoft.com/office/drawing/2014/main" id="{4321EFED-8845-4D7E-BF3E-AC93CA23F35E}"/>
               </a:ext>
             </a:extLst>
           </p:cNvPr>
@@ -24790,7 +24790,7 @@
     </p:spTree>
     <p:extLst>
       <p:ext uri="{BB962C8B-B14F-4D97-AF65-F5344CB8AC3E}">
-        <p14:creationId xmlns:p14="http://schemas.microsoft.com/office/powerpoint/2010/main" val="1089689742"/>
+        <p14:creationId xmlns:p14="http://schemas.microsoft.com/office/powerpoint/2010/main" val="1573573007"/>
       </p:ext>
     </p:extLst>
   </p:cSld>

</xml_diff>